<commit_message>
fixing inprogress files from previous commit
</commit_message>
<xml_diff>
--- a/UT Robomasters – Supercap Power Stage Modeling.pptx
+++ b/UT Robomasters – Supercap Power Stage Modeling.pptx
@@ -9,6 +9,7 @@
     <p:sldId id="257" r:id="rId3"/>
     <p:sldId id="259" r:id="rId4"/>
     <p:sldId id="258" r:id="rId5"/>
+    <p:sldId id="260" r:id="rId6"/>
   </p:sldIdLst>
   <p:sldSz cx="12192000" cy="6858000"/>
   <p:notesSz cx="6858000" cy="9144000"/>
@@ -107,6 +108,11 @@
       </a:defRPr>
     </a:lvl9pPr>
   </p:defaultTextStyle>
+  <p:extLst>
+    <p:ext uri="{EFAFB233-063F-42B5-8137-9DF3F51BA10A}">
+      <p15:sldGuideLst xmlns:p15="http://schemas.microsoft.com/office/powerpoint/2012/main"/>
+    </p:ext>
+  </p:extLst>
 </p:presentation>
 </file>
 
@@ -2994,23 +3000,7 @@
           <a:p>
             <a:r>
               <a:rPr lang="en-US" dirty="0"/>
-              <a:t>UT </a:t>
-            </a:r>
-            <a:r>
-              <a:rPr lang="en-US" dirty="0" err="1"/>
-              <a:t>Robomasters</a:t>
-            </a:r>
-            <a:r>
-              <a:rPr lang="en-US" dirty="0"/>
-              <a:t> – </a:t>
-            </a:r>
-            <a:r>
-              <a:rPr lang="en-US" dirty="0" err="1"/>
-              <a:t>Supercap</a:t>
-            </a:r>
-            <a:r>
-              <a:rPr lang="en-US" dirty="0"/>
-              <a:t> Power Stage Modeling</a:t>
+              <a:t>UT Robomasters – Supercap Power Stage Modeling</a:t>
             </a:r>
           </a:p>
         </p:txBody>
@@ -3040,6 +3030,52 @@
               <a:rPr lang="en-US" dirty="0"/>
               <a:t>Egan Wang (ew23776)</a:t>
             </a:r>
+          </a:p>
+        </p:txBody>
+      </p:sp>
+      <p:sp>
+        <p:nvSpPr>
+          <p:cNvPr id="4" name="Rectangle 3">
+            <a:extLst>
+              <a:ext uri="{FF2B5EF4-FFF2-40B4-BE49-F238E27FC236}">
+                <a16:creationId xmlns:a16="http://schemas.microsoft.com/office/drawing/2014/main" id="{CAA97C4D-B769-304B-268F-0AFD0AA0623F}"/>
+              </a:ext>
+            </a:extLst>
+          </p:cNvPr>
+          <p:cNvSpPr/>
+          <p:nvPr/>
+        </p:nvSpPr>
+        <p:spPr>
+          <a:xfrm>
+            <a:off x="1445342" y="1740310"/>
+            <a:ext cx="9144000" cy="2300748"/>
+          </a:xfrm>
+          <a:prstGeom prst="rect">
+            <a:avLst/>
+          </a:prstGeom>
+        </p:spPr>
+        <p:style>
+          <a:lnRef idx="2">
+            <a:schemeClr val="accent1">
+              <a:shade val="15000"/>
+            </a:schemeClr>
+          </a:lnRef>
+          <a:fillRef idx="1">
+            <a:schemeClr val="accent1"/>
+          </a:fillRef>
+          <a:effectRef idx="0">
+            <a:schemeClr val="accent1"/>
+          </a:effectRef>
+          <a:fontRef idx="minor">
+            <a:schemeClr val="lt1"/>
+          </a:fontRef>
+        </p:style>
+        <p:txBody>
+          <a:bodyPr rtlCol="0" anchor="ctr"/>
+          <a:lstStyle/>
+          <a:p>
+            <a:pPr algn="ctr"/>
+            <a:endParaRPr lang="en-US"/>
           </a:p>
         </p:txBody>
       </p:sp>
@@ -5078,6 +5114,29 @@
               <a:t>H-bridge topology allows finer control</a:t>
             </a:r>
           </a:p>
+          <a:p>
+            <a:r>
+              <a:rPr lang="en-US" dirty="0"/>
+              <a:t>Control scheme shown on right</a:t>
+            </a:r>
+          </a:p>
+          <a:p>
+            <a:pPr marL="285750" indent="-285750">
+              <a:buFont typeface="Arial" panose="020B0604020202020204" pitchFamily="34" charset="0"/>
+              <a:buChar char="•"/>
+            </a:pPr>
+            <a:r>
+              <a:rPr lang="en-US" dirty="0"/>
+              <a:t>Duty cycle “seen” across switch nodes labelled as </a:t>
+            </a:r>
+            <a:r>
+              <a:rPr lang="en-US" dirty="0">
+                <a:latin typeface="Cambria Math" panose="02040503050406030204" pitchFamily="18" charset="0"/>
+                <a:ea typeface="Cambria Math" panose="02040503050406030204" pitchFamily="18" charset="0"/>
+              </a:rPr>
+              <a:t>M(t)</a:t>
+            </a:r>
+          </a:p>
         </p:txBody>
       </p:sp>
       <p:sp>
@@ -5675,9 +5734,32 @@
             </a:r>
           </a:p>
           <a:p>
+            <a:pPr marL="285750" indent="-285750">
+              <a:buFont typeface="Arial" panose="020B0604020202020204" pitchFamily="34" charset="0"/>
+              <a:buChar char="•"/>
+            </a:pPr>
             <a:r>
               <a:rPr lang="en-US" dirty="0"/>
-              <a:t>Convert into loops and create ideal transformer model of circuit</a:t>
+              <a:t>Convert into loops and create ideal transformer model of circuit with gain </a:t>
+            </a:r>
+            <a:r>
+              <a:rPr lang="en-US" dirty="0">
+                <a:latin typeface="Cambria Math" panose="02040503050406030204" pitchFamily="18" charset="0"/>
+                <a:ea typeface="Cambria Math" panose="02040503050406030204" pitchFamily="18" charset="0"/>
+              </a:rPr>
+              <a:t>1:M(t)</a:t>
+            </a:r>
+          </a:p>
+          <a:p>
+            <a:pPr marL="285750" indent="-285750">
+              <a:buFont typeface="Arial" panose="020B0604020202020204" pitchFamily="34" charset="0"/>
+              <a:buChar char="•"/>
+            </a:pPr>
+            <a:r>
+              <a:rPr lang="en-US" dirty="0">
+                <a:ea typeface="Cambria Math" panose="02040503050406030204" pitchFamily="18" charset="0"/>
+              </a:rPr>
+              <a:t>Transformer model will be useful for reflection</a:t>
             </a:r>
           </a:p>
         </p:txBody>
@@ -5704,7 +5786,7 @@
         </p:blipFill>
         <p:spPr>
           <a:xfrm>
-            <a:off x="5681134" y="3494457"/>
+            <a:off x="6081058" y="3490693"/>
             <a:ext cx="5173845" cy="1790575"/>
           </a:xfrm>
           <a:prstGeom prst="rect">
@@ -5734,7 +5816,7 @@
         </p:blipFill>
         <p:spPr>
           <a:xfrm>
-            <a:off x="5168900" y="1289164"/>
+            <a:off x="5955481" y="1711951"/>
             <a:ext cx="5299422" cy="1536471"/>
           </a:xfrm>
           <a:prstGeom prst="rect">
@@ -5746,6 +5828,173 @@
     <p:extLst>
       <p:ext uri="{BB962C8B-B14F-4D97-AF65-F5344CB8AC3E}">
         <p14:creationId xmlns:p14="http://schemas.microsoft.com/office/powerpoint/2010/main" val="3322298424"/>
+      </p:ext>
+    </p:extLst>
+  </p:cSld>
+  <p:clrMapOvr>
+    <a:masterClrMapping/>
+  </p:clrMapOvr>
+</p:sld>
+</file>
+
+<file path=ppt/slides/slide5.xml><?xml version="1.0" encoding="utf-8"?>
+<p:sld xmlns:a="http://schemas.openxmlformats.org/drawingml/2006/main" xmlns:r="http://schemas.openxmlformats.org/officeDocument/2006/relationships" xmlns:p="http://schemas.openxmlformats.org/presentationml/2006/main">
+  <p:cSld>
+    <p:spTree>
+      <p:nvGrpSpPr>
+        <p:cNvPr id="1" name=""/>
+        <p:cNvGrpSpPr/>
+        <p:nvPr/>
+      </p:nvGrpSpPr>
+      <p:grpSpPr>
+        <a:xfrm>
+          <a:off x="0" y="0"/>
+          <a:ext cx="0" cy="0"/>
+          <a:chOff x="0" y="0"/>
+          <a:chExt cx="0" cy="0"/>
+        </a:xfrm>
+      </p:grpSpPr>
+      <p:sp>
+        <p:nvSpPr>
+          <p:cNvPr id="2" name="Title 1">
+            <a:extLst>
+              <a:ext uri="{FF2B5EF4-FFF2-40B4-BE49-F238E27FC236}">
+                <a16:creationId xmlns:a16="http://schemas.microsoft.com/office/drawing/2014/main" id="{BA3F08C0-4C31-3258-538C-87F883D9B692}"/>
+              </a:ext>
+            </a:extLst>
+          </p:cNvPr>
+          <p:cNvSpPr>
+            <a:spLocks noGrp="1"/>
+          </p:cNvSpPr>
+          <p:nvPr>
+            <p:ph type="title"/>
+          </p:nvPr>
+        </p:nvSpPr>
+        <p:spPr/>
+        <p:txBody>
+          <a:bodyPr/>
+          <a:lstStyle/>
+          <a:p>
+            <a:r>
+              <a:rPr lang="en-US" dirty="0"/>
+              <a:t>Capacitor Feed-Forward Correction</a:t>
+            </a:r>
+          </a:p>
+        </p:txBody>
+      </p:sp>
+      <p:sp>
+        <p:nvSpPr>
+          <p:cNvPr id="4" name="Text Placeholder 3">
+            <a:extLst>
+              <a:ext uri="{FF2B5EF4-FFF2-40B4-BE49-F238E27FC236}">
+                <a16:creationId xmlns:a16="http://schemas.microsoft.com/office/drawing/2014/main" id="{C7B7F404-C6A8-F55C-599B-D49A63D125B6}"/>
+              </a:ext>
+            </a:extLst>
+          </p:cNvPr>
+          <p:cNvSpPr>
+            <a:spLocks noGrp="1"/>
+          </p:cNvSpPr>
+          <p:nvPr>
+            <p:ph type="body" sz="half" idx="2"/>
+          </p:nvPr>
+        </p:nvSpPr>
+        <p:spPr/>
+        <p:txBody>
+          <a:bodyPr/>
+          <a:lstStyle/>
+          <a:p>
+            <a:r>
+              <a:rPr lang="en-US" dirty="0"/>
+              <a:t>Split the voltage source on the right into a </a:t>
+            </a:r>
+            <a:r>
+              <a:rPr lang="en-US" dirty="0" err="1"/>
+              <a:t>V_c</a:t>
+            </a:r>
+            <a:r>
+              <a:rPr lang="en-US"/>
+              <a:t>(t) component and </a:t>
+            </a:r>
+            <a:endParaRPr lang="en-US" dirty="0"/>
+          </a:p>
+        </p:txBody>
+      </p:sp>
+      <p:pic>
+        <p:nvPicPr>
+          <p:cNvPr id="6" name="Picture 5">
+            <a:extLst>
+              <a:ext uri="{FF2B5EF4-FFF2-40B4-BE49-F238E27FC236}">
+                <a16:creationId xmlns:a16="http://schemas.microsoft.com/office/drawing/2014/main" id="{D518150B-BDB1-3F15-A03A-6552D64AF02A}"/>
+              </a:ext>
+            </a:extLst>
+          </p:cNvPr>
+          <p:cNvPicPr>
+            <a:picLocks noChangeAspect="1"/>
+          </p:cNvPicPr>
+          <p:nvPr/>
+        </p:nvPicPr>
+        <p:blipFill>
+          <a:blip r:embed="rId2"/>
+          <a:stretch>
+            <a:fillRect/>
+          </a:stretch>
+        </p:blipFill>
+        <p:spPr>
+          <a:xfrm>
+            <a:off x="5406297" y="582993"/>
+            <a:ext cx="5945915" cy="3409887"/>
+          </a:xfrm>
+          <a:prstGeom prst="rect">
+            <a:avLst/>
+          </a:prstGeom>
+        </p:spPr>
+      </p:pic>
+      <p:cxnSp>
+        <p:nvCxnSpPr>
+          <p:cNvPr id="8" name="Straight Connector 7">
+            <a:extLst>
+              <a:ext uri="{FF2B5EF4-FFF2-40B4-BE49-F238E27FC236}">
+                <a16:creationId xmlns:a16="http://schemas.microsoft.com/office/drawing/2014/main" id="{10EA1A0A-2DAA-6803-A020-E8C088E2DC6D}"/>
+              </a:ext>
+            </a:extLst>
+          </p:cNvPr>
+          <p:cNvCxnSpPr/>
+          <p:nvPr/>
+        </p:nvCxnSpPr>
+        <p:spPr>
+          <a:xfrm>
+            <a:off x="8379254" y="2834640"/>
+            <a:ext cx="2034746" cy="0"/>
+          </a:xfrm>
+          <a:prstGeom prst="line">
+            <a:avLst/>
+          </a:prstGeom>
+          <a:ln>
+            <a:solidFill>
+              <a:schemeClr val="tx1"/>
+            </a:solidFill>
+            <a:prstDash val="dash"/>
+          </a:ln>
+        </p:spPr>
+        <p:style>
+          <a:lnRef idx="2">
+            <a:schemeClr val="accent1"/>
+          </a:lnRef>
+          <a:fillRef idx="0">
+            <a:schemeClr val="accent1"/>
+          </a:fillRef>
+          <a:effectRef idx="1">
+            <a:schemeClr val="accent1"/>
+          </a:effectRef>
+          <a:fontRef idx="minor">
+            <a:schemeClr val="tx1"/>
+          </a:fontRef>
+        </p:style>
+      </p:cxnSp>
+    </p:spTree>
+    <p:extLst>
+      <p:ext uri="{BB962C8B-B14F-4D97-AF65-F5344CB8AC3E}">
+        <p14:creationId xmlns:p14="http://schemas.microsoft.com/office/powerpoint/2010/main" val="3781020942"/>
       </p:ext>
     </p:extLst>
   </p:cSld>

</xml_diff>

<commit_message>
large expansion to explanation powerpoint + some brushing up on toy model
</commit_message>
<xml_diff>
--- a/UT Robomasters – Supercap Power Stage Modeling.pptx
+++ b/UT Robomasters – Supercap Power Stage Modeling.pptx
@@ -13,6 +13,10 @@
     <p:sldId id="261" r:id="rId7"/>
     <p:sldId id="262" r:id="rId8"/>
     <p:sldId id="263" r:id="rId9"/>
+    <p:sldId id="264" r:id="rId10"/>
+    <p:sldId id="265" r:id="rId11"/>
+    <p:sldId id="266" r:id="rId12"/>
+    <p:sldId id="267" r:id="rId13"/>
   </p:sldIdLst>
   <p:sldSz cx="12192000" cy="6858000"/>
   <p:notesSz cx="6858000" cy="9144000"/>
@@ -250,7 +254,7 @@
           <a:p>
             <a:fld id="{116CDFA8-9B71-48D2-9BC8-093B5490E257}" type="datetimeFigureOut">
               <a:rPr lang="en-US" smtClean="0"/>
-              <a:t>3/11/2026</a:t>
+              <a:t>3/12/2026</a:t>
             </a:fld>
             <a:endParaRPr lang="en-US"/>
           </a:p>
@@ -420,7 +424,7 @@
           <a:p>
             <a:fld id="{116CDFA8-9B71-48D2-9BC8-093B5490E257}" type="datetimeFigureOut">
               <a:rPr lang="en-US" smtClean="0"/>
-              <a:t>3/11/2026</a:t>
+              <a:t>3/12/2026</a:t>
             </a:fld>
             <a:endParaRPr lang="en-US"/>
           </a:p>
@@ -600,7 +604,7 @@
           <a:p>
             <a:fld id="{116CDFA8-9B71-48D2-9BC8-093B5490E257}" type="datetimeFigureOut">
               <a:rPr lang="en-US" smtClean="0"/>
-              <a:t>3/11/2026</a:t>
+              <a:t>3/12/2026</a:t>
             </a:fld>
             <a:endParaRPr lang="en-US"/>
           </a:p>
@@ -770,7 +774,7 @@
           <a:p>
             <a:fld id="{116CDFA8-9B71-48D2-9BC8-093B5490E257}" type="datetimeFigureOut">
               <a:rPr lang="en-US" smtClean="0"/>
-              <a:t>3/11/2026</a:t>
+              <a:t>3/12/2026</a:t>
             </a:fld>
             <a:endParaRPr lang="en-US"/>
           </a:p>
@@ -1016,7 +1020,7 @@
           <a:p>
             <a:fld id="{116CDFA8-9B71-48D2-9BC8-093B5490E257}" type="datetimeFigureOut">
               <a:rPr lang="en-US" smtClean="0"/>
-              <a:t>3/11/2026</a:t>
+              <a:t>3/12/2026</a:t>
             </a:fld>
             <a:endParaRPr lang="en-US"/>
           </a:p>
@@ -1248,7 +1252,7 @@
           <a:p>
             <a:fld id="{116CDFA8-9B71-48D2-9BC8-093B5490E257}" type="datetimeFigureOut">
               <a:rPr lang="en-US" smtClean="0"/>
-              <a:t>3/11/2026</a:t>
+              <a:t>3/12/2026</a:t>
             </a:fld>
             <a:endParaRPr lang="en-US"/>
           </a:p>
@@ -1615,7 +1619,7 @@
           <a:p>
             <a:fld id="{116CDFA8-9B71-48D2-9BC8-093B5490E257}" type="datetimeFigureOut">
               <a:rPr lang="en-US" smtClean="0"/>
-              <a:t>3/11/2026</a:t>
+              <a:t>3/12/2026</a:t>
             </a:fld>
             <a:endParaRPr lang="en-US"/>
           </a:p>
@@ -1733,7 +1737,7 @@
           <a:p>
             <a:fld id="{116CDFA8-9B71-48D2-9BC8-093B5490E257}" type="datetimeFigureOut">
               <a:rPr lang="en-US" smtClean="0"/>
-              <a:t>3/11/2026</a:t>
+              <a:t>3/12/2026</a:t>
             </a:fld>
             <a:endParaRPr lang="en-US"/>
           </a:p>
@@ -1828,7 +1832,7 @@
           <a:p>
             <a:fld id="{116CDFA8-9B71-48D2-9BC8-093B5490E257}" type="datetimeFigureOut">
               <a:rPr lang="en-US" smtClean="0"/>
-              <a:t>3/11/2026</a:t>
+              <a:t>3/12/2026</a:t>
             </a:fld>
             <a:endParaRPr lang="en-US"/>
           </a:p>
@@ -2105,7 +2109,7 @@
           <a:p>
             <a:fld id="{116CDFA8-9B71-48D2-9BC8-093B5490E257}" type="datetimeFigureOut">
               <a:rPr lang="en-US" smtClean="0"/>
-              <a:t>3/11/2026</a:t>
+              <a:t>3/12/2026</a:t>
             </a:fld>
             <a:endParaRPr lang="en-US"/>
           </a:p>
@@ -2362,7 +2366,7 @@
           <a:p>
             <a:fld id="{116CDFA8-9B71-48D2-9BC8-093B5490E257}" type="datetimeFigureOut">
               <a:rPr lang="en-US" smtClean="0"/>
-              <a:t>3/11/2026</a:t>
+              <a:t>3/12/2026</a:t>
             </a:fld>
             <a:endParaRPr lang="en-US"/>
           </a:p>
@@ -2575,7 +2579,7 @@
           <a:p>
             <a:fld id="{116CDFA8-9B71-48D2-9BC8-093B5490E257}" type="datetimeFigureOut">
               <a:rPr lang="en-US" smtClean="0"/>
-              <a:t>3/11/2026</a:t>
+              <a:t>3/12/2026</a:t>
             </a:fld>
             <a:endParaRPr lang="en-US"/>
           </a:p>
@@ -3030,16 +3034,3045 @@
           <a:lstStyle/>
           <a:p>
             <a:r>
+              <a:rPr lang="en-US" dirty="0" err="1"/>
+              <a:t>Supercap</a:t>
+            </a:r>
+            <a:r>
               <a:rPr lang="en-US" dirty="0"/>
-              <a:t>Egan Wang (ew23776)</a:t>
-            </a:r>
+              <a:t> Technical Lead: Egan Wang (ew23776)</a:t>
+            </a:r>
+          </a:p>
+          <a:p>
+            <a:r>
+              <a:rPr lang="en-US" dirty="0"/>
+              <a:t>Contributing Members: []</a:t>
+            </a:r>
+          </a:p>
+        </p:txBody>
+      </p:sp>
+      <p:sp>
+        <p:nvSpPr>
+          <p:cNvPr id="4" name="Rectangle 3">
+            <a:extLst>
+              <a:ext uri="{FF2B5EF4-FFF2-40B4-BE49-F238E27FC236}">
+                <a16:creationId xmlns:a16="http://schemas.microsoft.com/office/drawing/2014/main" id="{A0949B7C-CD71-55A4-B144-0777F760504B}"/>
+              </a:ext>
+            </a:extLst>
+          </p:cNvPr>
+          <p:cNvSpPr/>
+          <p:nvPr/>
+        </p:nvSpPr>
+        <p:spPr>
+          <a:xfrm>
+            <a:off x="6442744" y="5134061"/>
+            <a:ext cx="4362275" cy="1111541"/>
+          </a:xfrm>
+          <a:prstGeom prst="rect">
+            <a:avLst/>
+          </a:prstGeom>
+          <a:noFill/>
+          <a:ln>
+            <a:solidFill>
+              <a:srgbClr val="FF0000"/>
+            </a:solidFill>
+          </a:ln>
+        </p:spPr>
+        <p:style>
+          <a:lnRef idx="2">
+            <a:schemeClr val="accent1">
+              <a:shade val="15000"/>
+            </a:schemeClr>
+          </a:lnRef>
+          <a:fillRef idx="1">
+            <a:schemeClr val="accent1"/>
+          </a:fillRef>
+          <a:effectRef idx="0">
+            <a:schemeClr val="accent1"/>
+          </a:effectRef>
+          <a:fontRef idx="minor">
+            <a:schemeClr val="lt1"/>
+          </a:fontRef>
+        </p:style>
+        <p:txBody>
+          <a:bodyPr rtlCol="0" anchor="ctr"/>
+          <a:lstStyle/>
+          <a:p>
+            <a:pPr algn="ctr"/>
+            <a:r>
+              <a:rPr lang="en-US" dirty="0"/>
+              <a:t>If you can see this, get your butt to work on disturbance rejection and robustness modeling so I can put your name on here</a:t>
+            </a:r>
+          </a:p>
+        </p:txBody>
+      </p:sp>
+      <p:cxnSp>
+        <p:nvCxnSpPr>
+          <p:cNvPr id="6" name="Straight Arrow Connector 5">
+            <a:extLst>
+              <a:ext uri="{FF2B5EF4-FFF2-40B4-BE49-F238E27FC236}">
+                <a16:creationId xmlns:a16="http://schemas.microsoft.com/office/drawing/2014/main" id="{B7341F1D-D4CF-FC90-4073-E1ADC43AFF15}"/>
+              </a:ext>
+            </a:extLst>
+          </p:cNvPr>
+          <p:cNvCxnSpPr>
+            <a:cxnSpLocks/>
+            <a:stCxn id="4" idx="0"/>
+          </p:cNvCxnSpPr>
+          <p:nvPr/>
+        </p:nvCxnSpPr>
+        <p:spPr>
+          <a:xfrm flipH="1" flipV="1">
+            <a:off x="7650760" y="4286774"/>
+            <a:ext cx="973122" cy="847287"/>
+          </a:xfrm>
+          <a:prstGeom prst="straightConnector1">
+            <a:avLst/>
+          </a:prstGeom>
+          <a:ln w="38100">
+            <a:solidFill>
+              <a:srgbClr val="FF0000"/>
+            </a:solidFill>
+            <a:tailEnd type="triangle"/>
+          </a:ln>
+        </p:spPr>
+        <p:style>
+          <a:lnRef idx="2">
+            <a:schemeClr val="accent1"/>
+          </a:lnRef>
+          <a:fillRef idx="0">
+            <a:schemeClr val="accent1"/>
+          </a:fillRef>
+          <a:effectRef idx="1">
+            <a:schemeClr val="accent1"/>
+          </a:effectRef>
+          <a:fontRef idx="minor">
+            <a:schemeClr val="tx1"/>
+          </a:fontRef>
+        </p:style>
+      </p:cxnSp>
+    </p:spTree>
+    <p:extLst>
+      <p:ext uri="{BB962C8B-B14F-4D97-AF65-F5344CB8AC3E}">
+        <p14:creationId xmlns:p14="http://schemas.microsoft.com/office/powerpoint/2010/main" val="3230319517"/>
+      </p:ext>
+    </p:extLst>
+  </p:cSld>
+  <p:clrMapOvr>
+    <a:masterClrMapping/>
+  </p:clrMapOvr>
+</p:sld>
+</file>
+
+<file path=ppt/slides/slide10.xml><?xml version="1.0" encoding="utf-8"?>
+<p:sld xmlns:a="http://schemas.openxmlformats.org/drawingml/2006/main" xmlns:r="http://schemas.openxmlformats.org/officeDocument/2006/relationships" xmlns:p="http://schemas.openxmlformats.org/presentationml/2006/main">
+  <p:cSld>
+    <p:spTree>
+      <p:nvGrpSpPr>
+        <p:cNvPr id="1" name="">
+          <a:extLst>
+            <a:ext uri="{FF2B5EF4-FFF2-40B4-BE49-F238E27FC236}">
+              <a16:creationId xmlns:a16="http://schemas.microsoft.com/office/drawing/2014/main" id="{382AD299-1EC8-3C9C-4C0C-BADD0575C07E}"/>
+            </a:ext>
+          </a:extLst>
+        </p:cNvPr>
+        <p:cNvGrpSpPr/>
+        <p:nvPr/>
+      </p:nvGrpSpPr>
+      <p:grpSpPr>
+        <a:xfrm>
+          <a:off x="0" y="0"/>
+          <a:ext cx="0" cy="0"/>
+          <a:chOff x="0" y="0"/>
+          <a:chExt cx="0" cy="0"/>
+        </a:xfrm>
+      </p:grpSpPr>
+      <p:sp>
+        <p:nvSpPr>
+          <p:cNvPr id="5" name="Title 4">
+            <a:extLst>
+              <a:ext uri="{FF2B5EF4-FFF2-40B4-BE49-F238E27FC236}">
+                <a16:creationId xmlns:a16="http://schemas.microsoft.com/office/drawing/2014/main" id="{8B64D800-531E-D987-D7DC-D8BB3D0A4E2A}"/>
+              </a:ext>
+            </a:extLst>
+          </p:cNvPr>
+          <p:cNvSpPr>
+            <a:spLocks noGrp="1"/>
+          </p:cNvSpPr>
+          <p:nvPr>
+            <p:ph type="title"/>
+          </p:nvPr>
+        </p:nvSpPr>
+        <p:spPr/>
+        <p:txBody>
+          <a:bodyPr/>
+          <a:lstStyle/>
+          <a:p>
+            <a:r>
+              <a:rPr lang="en-US" dirty="0"/>
+              <a:t>PI</a:t>
+            </a:r>
+            <a:r>
+              <a:rPr lang="en-US" baseline="30000" dirty="0"/>
+              <a:t>2</a:t>
+            </a:r>
+            <a:r>
+              <a:rPr lang="en-US" dirty="0"/>
+              <a:t> Control Linearization</a:t>
+            </a:r>
+          </a:p>
+        </p:txBody>
+      </p:sp>
+      <mc:AlternateContent xmlns:mc="http://schemas.openxmlformats.org/markup-compatibility/2006">
+        <mc:Choice xmlns:a14="http://schemas.microsoft.com/office/drawing/2010/main" Requires="a14">
+          <p:sp>
+            <p:nvSpPr>
+              <p:cNvPr id="7" name="TextBox 6">
+                <a:extLst>
+                  <a:ext uri="{FF2B5EF4-FFF2-40B4-BE49-F238E27FC236}">
+                    <a16:creationId xmlns:a16="http://schemas.microsoft.com/office/drawing/2014/main" id="{11BA93C1-3496-4F0D-76C1-0D2E2E8A1BFD}"/>
+                  </a:ext>
+                </a:extLst>
+              </p:cNvPr>
+              <p:cNvSpPr txBox="1"/>
+              <p:nvPr/>
+            </p:nvSpPr>
+            <p:spPr>
+              <a:xfrm>
+                <a:off x="325772" y="1497959"/>
+                <a:ext cx="5531135" cy="4686283"/>
+              </a:xfrm>
+              <a:prstGeom prst="rect">
+                <a:avLst/>
+              </a:prstGeom>
+              <a:noFill/>
+            </p:spPr>
+            <p:txBody>
+              <a:bodyPr wrap="square">
+                <a:spAutoFit/>
+              </a:bodyPr>
+              <a:lstStyle/>
+              <a:p>
+                <a:r>
+                  <a:rPr lang="en-US" dirty="0"/>
+                  <a:t>From the equation:</a:t>
+                </a:r>
+                <a:endParaRPr lang="en-US" b="0" dirty="0"/>
+              </a:p>
+              <a:p>
+                <a:pPr/>
+                <a14:m>
+                  <m:oMathPara xmlns:m="http://schemas.openxmlformats.org/officeDocument/2006/math">
+                    <m:oMathParaPr>
+                      <m:jc m:val="centerGroup"/>
+                    </m:oMathParaPr>
+                    <m:oMath xmlns:m="http://schemas.openxmlformats.org/officeDocument/2006/math">
+                      <m:r>
+                        <a:rPr lang="en-US" sz="1400" i="1">
+                          <a:latin typeface="Cambria Math" panose="02040503050406030204" pitchFamily="18" charset="0"/>
+                        </a:rPr>
+                        <m:t>𝑀</m:t>
+                      </m:r>
+                      <m:d>
+                        <m:dPr>
+                          <m:ctrlPr>
+                            <a:rPr lang="en-US" sz="1400" i="1">
+                              <a:latin typeface="Cambria Math" panose="02040503050406030204" pitchFamily="18" charset="0"/>
+                            </a:rPr>
+                          </m:ctrlPr>
+                        </m:dPr>
+                        <m:e>
+                          <m:r>
+                            <a:rPr lang="en-US" sz="1400" i="1">
+                              <a:latin typeface="Cambria Math" panose="02040503050406030204" pitchFamily="18" charset="0"/>
+                            </a:rPr>
+                            <m:t>𝑡</m:t>
+                          </m:r>
+                        </m:e>
+                      </m:d>
+                      <m:r>
+                        <a:rPr lang="en-US" sz="1400" i="1">
+                          <a:latin typeface="Cambria Math" panose="02040503050406030204" pitchFamily="18" charset="0"/>
+                        </a:rPr>
+                        <m:t>∗</m:t>
+                      </m:r>
+                      <m:sSub>
+                        <m:sSubPr>
+                          <m:ctrlPr>
+                            <a:rPr lang="en-US" sz="1400" i="1">
+                              <a:latin typeface="Cambria Math" panose="02040503050406030204" pitchFamily="18" charset="0"/>
+                            </a:rPr>
+                          </m:ctrlPr>
+                        </m:sSubPr>
+                        <m:e>
+                          <m:r>
+                            <a:rPr lang="en-US" sz="1400" i="1">
+                              <a:latin typeface="Cambria Math" panose="02040503050406030204" pitchFamily="18" charset="0"/>
+                            </a:rPr>
+                            <m:t>𝑉</m:t>
+                          </m:r>
+                        </m:e>
+                        <m:sub>
+                          <m:r>
+                            <a:rPr lang="en-US" sz="1400" i="1">
+                              <a:latin typeface="Cambria Math" panose="02040503050406030204" pitchFamily="18" charset="0"/>
+                            </a:rPr>
+                            <m:t>𝑔</m:t>
+                          </m:r>
+                        </m:sub>
+                      </m:sSub>
+                      <m:r>
+                        <a:rPr lang="en-US" sz="1400" i="1">
+                          <a:latin typeface="Cambria Math" panose="02040503050406030204" pitchFamily="18" charset="0"/>
+                        </a:rPr>
+                        <m:t>=</m:t>
+                      </m:r>
+                      <m:f>
+                        <m:fPr>
+                          <m:ctrlPr>
+                            <a:rPr lang="en-US" sz="1400" i="1">
+                              <a:latin typeface="Cambria Math" panose="02040503050406030204" pitchFamily="18" charset="0"/>
+                            </a:rPr>
+                          </m:ctrlPr>
+                        </m:fPr>
+                        <m:num>
+                          <m:sSub>
+                            <m:sSubPr>
+                              <m:ctrlPr>
+                                <a:rPr lang="en-US" sz="1400" i="1">
+                                  <a:latin typeface="Cambria Math" panose="02040503050406030204" pitchFamily="18" charset="0"/>
+                                </a:rPr>
+                              </m:ctrlPr>
+                            </m:sSubPr>
+                            <m:e>
+                              <m:r>
+                                <a:rPr lang="en-US" sz="1400" i="1">
+                                  <a:latin typeface="Cambria Math" panose="02040503050406030204" pitchFamily="18" charset="0"/>
+                                </a:rPr>
+                                <m:t>𝑅</m:t>
+                              </m:r>
+                            </m:e>
+                            <m:sub>
+                              <m:r>
+                                <a:rPr lang="en-US" sz="1400" i="1">
+                                  <a:latin typeface="Cambria Math" panose="02040503050406030204" pitchFamily="18" charset="0"/>
+                                </a:rPr>
+                                <m:t>𝐸𝑆𝑅</m:t>
+                              </m:r>
+                            </m:sub>
+                          </m:sSub>
+                        </m:num>
+                        <m:den>
+                          <m:r>
+                            <a:rPr lang="en-US" sz="1400" i="1">
+                              <a:latin typeface="Cambria Math" panose="02040503050406030204" pitchFamily="18" charset="0"/>
+                            </a:rPr>
+                            <m:t>𝑀</m:t>
+                          </m:r>
+                          <m:d>
+                            <m:dPr>
+                              <m:ctrlPr>
+                                <a:rPr lang="en-US" sz="1400" i="1">
+                                  <a:latin typeface="Cambria Math" panose="02040503050406030204" pitchFamily="18" charset="0"/>
+                                </a:rPr>
+                              </m:ctrlPr>
+                            </m:dPr>
+                            <m:e>
+                              <m:r>
+                                <a:rPr lang="en-US" sz="1400" i="1">
+                                  <a:latin typeface="Cambria Math" panose="02040503050406030204" pitchFamily="18" charset="0"/>
+                                </a:rPr>
+                                <m:t>𝑡</m:t>
+                              </m:r>
+                            </m:e>
+                          </m:d>
+                        </m:den>
+                      </m:f>
+                      <m:r>
+                        <a:rPr lang="en-US" sz="1400" i="1">
+                          <a:latin typeface="Cambria Math" panose="02040503050406030204" pitchFamily="18" charset="0"/>
+                        </a:rPr>
+                        <m:t>∗</m:t>
+                      </m:r>
+                      <m:sSub>
+                        <m:sSubPr>
+                          <m:ctrlPr>
+                            <a:rPr lang="en-US" sz="1400" i="1">
+                              <a:latin typeface="Cambria Math" panose="02040503050406030204" pitchFamily="18" charset="0"/>
+                            </a:rPr>
+                          </m:ctrlPr>
+                        </m:sSubPr>
+                        <m:e>
+                          <m:r>
+                            <a:rPr lang="en-US" sz="1400" i="1">
+                              <a:latin typeface="Cambria Math" panose="02040503050406030204" pitchFamily="18" charset="0"/>
+                            </a:rPr>
+                            <m:t>𝐼</m:t>
+                          </m:r>
+                        </m:e>
+                        <m:sub>
+                          <m:r>
+                            <a:rPr lang="en-US" sz="1400" i="1">
+                              <a:latin typeface="Cambria Math" panose="02040503050406030204" pitchFamily="18" charset="0"/>
+                            </a:rPr>
+                            <m:t>𝑏𝑎𝑡</m:t>
+                          </m:r>
+                        </m:sub>
+                      </m:sSub>
+                      <m:d>
+                        <m:dPr>
+                          <m:ctrlPr>
+                            <a:rPr lang="en-US" sz="1400" i="1">
+                              <a:latin typeface="Cambria Math" panose="02040503050406030204" pitchFamily="18" charset="0"/>
+                            </a:rPr>
+                          </m:ctrlPr>
+                        </m:dPr>
+                        <m:e>
+                          <m:r>
+                            <a:rPr lang="en-US" sz="1400" i="1">
+                              <a:latin typeface="Cambria Math" panose="02040503050406030204" pitchFamily="18" charset="0"/>
+                            </a:rPr>
+                            <m:t>𝑡</m:t>
+                          </m:r>
+                        </m:e>
+                      </m:d>
+                      <m:r>
+                        <a:rPr lang="en-US" sz="1400" i="1">
+                          <a:latin typeface="Cambria Math" panose="02040503050406030204" pitchFamily="18" charset="0"/>
+                        </a:rPr>
+                        <m:t>+</m:t>
+                      </m:r>
+                      <m:f>
+                        <m:fPr>
+                          <m:ctrlPr>
+                            <a:rPr lang="en-US" sz="1400" i="1">
+                              <a:latin typeface="Cambria Math" panose="02040503050406030204" pitchFamily="18" charset="0"/>
+                            </a:rPr>
+                          </m:ctrlPr>
+                        </m:fPr>
+                        <m:num>
+                          <m:r>
+                            <a:rPr lang="en-US" sz="1400" i="1">
+                              <a:latin typeface="Cambria Math" panose="02040503050406030204" pitchFamily="18" charset="0"/>
+                            </a:rPr>
+                            <m:t>𝐿</m:t>
+                          </m:r>
+                        </m:num>
+                        <m:den>
+                          <m:r>
+                            <a:rPr lang="en-US" sz="1400" i="1">
+                              <a:latin typeface="Cambria Math" panose="02040503050406030204" pitchFamily="18" charset="0"/>
+                            </a:rPr>
+                            <m:t>𝑀</m:t>
+                          </m:r>
+                          <m:d>
+                            <m:dPr>
+                              <m:ctrlPr>
+                                <a:rPr lang="en-US" sz="1400" i="1">
+                                  <a:latin typeface="Cambria Math" panose="02040503050406030204" pitchFamily="18" charset="0"/>
+                                </a:rPr>
+                              </m:ctrlPr>
+                            </m:dPr>
+                            <m:e>
+                              <m:r>
+                                <a:rPr lang="en-US" sz="1400" i="1">
+                                  <a:latin typeface="Cambria Math" panose="02040503050406030204" pitchFamily="18" charset="0"/>
+                                </a:rPr>
+                                <m:t>𝑡</m:t>
+                              </m:r>
+                            </m:e>
+                          </m:d>
+                        </m:den>
+                      </m:f>
+                      <m:r>
+                        <a:rPr lang="en-US" sz="1400" i="1">
+                          <a:latin typeface="Cambria Math" panose="02040503050406030204" pitchFamily="18" charset="0"/>
+                        </a:rPr>
+                        <m:t>∗</m:t>
+                      </m:r>
+                      <m:f>
+                        <m:fPr>
+                          <m:ctrlPr>
+                            <a:rPr lang="en-US" sz="1400" i="1">
+                              <a:latin typeface="Cambria Math" panose="02040503050406030204" pitchFamily="18" charset="0"/>
+                            </a:rPr>
+                          </m:ctrlPr>
+                        </m:fPr>
+                        <m:num>
+                          <m:r>
+                            <a:rPr lang="en-US" sz="1400" i="1">
+                              <a:latin typeface="Cambria Math" panose="02040503050406030204" pitchFamily="18" charset="0"/>
+                            </a:rPr>
+                            <m:t>𝑑</m:t>
+                          </m:r>
+                        </m:num>
+                        <m:den>
+                          <m:r>
+                            <a:rPr lang="en-US" sz="1400" i="1">
+                              <a:latin typeface="Cambria Math" panose="02040503050406030204" pitchFamily="18" charset="0"/>
+                            </a:rPr>
+                            <m:t>𝑑𝑡</m:t>
+                          </m:r>
+                        </m:den>
+                      </m:f>
+                      <m:sSub>
+                        <m:sSubPr>
+                          <m:ctrlPr>
+                            <a:rPr lang="en-US" sz="1400" i="1">
+                              <a:latin typeface="Cambria Math" panose="02040503050406030204" pitchFamily="18" charset="0"/>
+                            </a:rPr>
+                          </m:ctrlPr>
+                        </m:sSubPr>
+                        <m:e>
+                          <m:r>
+                            <a:rPr lang="en-US" sz="1400" i="1">
+                              <a:latin typeface="Cambria Math" panose="02040503050406030204" pitchFamily="18" charset="0"/>
+                            </a:rPr>
+                            <m:t>𝐼</m:t>
+                          </m:r>
+                        </m:e>
+                        <m:sub>
+                          <m:r>
+                            <a:rPr lang="en-US" sz="1400" i="1">
+                              <a:latin typeface="Cambria Math" panose="02040503050406030204" pitchFamily="18" charset="0"/>
+                            </a:rPr>
+                            <m:t>𝑏𝑎𝑡</m:t>
+                          </m:r>
+                        </m:sub>
+                      </m:sSub>
+                      <m:d>
+                        <m:dPr>
+                          <m:ctrlPr>
+                            <a:rPr lang="en-US" sz="1400" i="1">
+                              <a:latin typeface="Cambria Math" panose="02040503050406030204" pitchFamily="18" charset="0"/>
+                            </a:rPr>
+                          </m:ctrlPr>
+                        </m:dPr>
+                        <m:e>
+                          <m:r>
+                            <a:rPr lang="en-US" sz="1400" i="1">
+                              <a:latin typeface="Cambria Math" panose="02040503050406030204" pitchFamily="18" charset="0"/>
+                            </a:rPr>
+                            <m:t>𝑡</m:t>
+                          </m:r>
+                        </m:e>
+                      </m:d>
+                      <m:r>
+                        <a:rPr lang="en-US" sz="1400" i="1">
+                          <a:latin typeface="Cambria Math" panose="02040503050406030204" pitchFamily="18" charset="0"/>
+                        </a:rPr>
+                        <m:t>+</m:t>
+                      </m:r>
+                      <m:f>
+                        <m:fPr>
+                          <m:ctrlPr>
+                            <a:rPr lang="en-US" sz="1400" i="1">
+                              <a:latin typeface="Cambria Math" panose="02040503050406030204" pitchFamily="18" charset="0"/>
+                            </a:rPr>
+                          </m:ctrlPr>
+                        </m:fPr>
+                        <m:num>
+                          <m:r>
+                            <a:rPr lang="en-US" sz="1400" b="0" i="1" smtClean="0">
+                              <a:latin typeface="Cambria Math" panose="02040503050406030204" pitchFamily="18" charset="0"/>
+                            </a:rPr>
+                            <m:t>1</m:t>
+                          </m:r>
+                        </m:num>
+                        <m:den>
+                          <m:r>
+                            <a:rPr lang="en-US" sz="1400" b="0" i="1" smtClean="0">
+                              <a:latin typeface="Cambria Math" panose="02040503050406030204" pitchFamily="18" charset="0"/>
+                            </a:rPr>
+                            <m:t>𝐶</m:t>
+                          </m:r>
+                          <m:r>
+                            <a:rPr lang="en-US" sz="1400" b="0" i="1" smtClean="0">
+                              <a:latin typeface="Cambria Math" panose="02040503050406030204" pitchFamily="18" charset="0"/>
+                            </a:rPr>
+                            <m:t>∗</m:t>
+                          </m:r>
+                          <m:r>
+                            <a:rPr lang="en-US" sz="1400" i="1">
+                              <a:latin typeface="Cambria Math" panose="02040503050406030204" pitchFamily="18" charset="0"/>
+                            </a:rPr>
+                            <m:t>𝑀</m:t>
+                          </m:r>
+                          <m:r>
+                            <a:rPr lang="en-US" sz="1400" i="1">
+                              <a:latin typeface="Cambria Math" panose="02040503050406030204" pitchFamily="18" charset="0"/>
+                            </a:rPr>
+                            <m:t>(</m:t>
+                          </m:r>
+                          <m:r>
+                            <a:rPr lang="en-US" sz="1400" i="1">
+                              <a:latin typeface="Cambria Math" panose="02040503050406030204" pitchFamily="18" charset="0"/>
+                            </a:rPr>
+                            <m:t>𝑡</m:t>
+                          </m:r>
+                          <m:r>
+                            <a:rPr lang="en-US" sz="1400" i="1">
+                              <a:latin typeface="Cambria Math" panose="02040503050406030204" pitchFamily="18" charset="0"/>
+                            </a:rPr>
+                            <m:t>)</m:t>
+                          </m:r>
+                        </m:den>
+                      </m:f>
+                      <m:nary>
+                        <m:naryPr>
+                          <m:limLoc m:val="undOvr"/>
+                          <m:subHide m:val="on"/>
+                          <m:supHide m:val="on"/>
+                          <m:ctrlPr>
+                            <a:rPr lang="en-US" sz="1400" i="1">
+                              <a:latin typeface="Cambria Math" panose="02040503050406030204" pitchFamily="18" charset="0"/>
+                            </a:rPr>
+                          </m:ctrlPr>
+                        </m:naryPr>
+                        <m:sub/>
+                        <m:sup/>
+                        <m:e>
+                          <m:sSub>
+                            <m:sSubPr>
+                              <m:ctrlPr>
+                                <a:rPr lang="en-US" sz="1400" i="1">
+                                  <a:latin typeface="Cambria Math" panose="02040503050406030204" pitchFamily="18" charset="0"/>
+                                </a:rPr>
+                              </m:ctrlPr>
+                            </m:sSubPr>
+                            <m:e>
+                              <m:r>
+                                <a:rPr lang="en-US" sz="1400" i="1">
+                                  <a:latin typeface="Cambria Math" panose="02040503050406030204" pitchFamily="18" charset="0"/>
+                                </a:rPr>
+                                <m:t>𝐼</m:t>
+                              </m:r>
+                            </m:e>
+                            <m:sub>
+                              <m:r>
+                                <a:rPr lang="en-US" sz="1400" i="1">
+                                  <a:latin typeface="Cambria Math" panose="02040503050406030204" pitchFamily="18" charset="0"/>
+                                </a:rPr>
+                                <m:t>𝑏𝑎𝑡</m:t>
+                              </m:r>
+                            </m:sub>
+                          </m:sSub>
+                          <m:r>
+                            <a:rPr lang="en-US" sz="1400" i="1">
+                              <a:latin typeface="Cambria Math" panose="02040503050406030204" pitchFamily="18" charset="0"/>
+                            </a:rPr>
+                            <m:t>(</m:t>
+                          </m:r>
+                          <m:r>
+                            <a:rPr lang="en-US" sz="1400" i="1">
+                              <a:latin typeface="Cambria Math" panose="02040503050406030204" pitchFamily="18" charset="0"/>
+                            </a:rPr>
+                            <m:t>𝑡</m:t>
+                          </m:r>
+                          <m:r>
+                            <a:rPr lang="en-US" sz="1400" i="1">
+                              <a:latin typeface="Cambria Math" panose="02040503050406030204" pitchFamily="18" charset="0"/>
+                            </a:rPr>
+                            <m:t>)</m:t>
+                          </m:r>
+                        </m:e>
+                      </m:nary>
+                    </m:oMath>
+                  </m:oMathPara>
+                </a14:m>
+                <a:endParaRPr lang="en-US" dirty="0"/>
+              </a:p>
+              <a:p>
+                <a:pPr/>
+                <a:r>
+                  <a:rPr lang="en-US" dirty="0"/>
+                  <a:t>Multiply by </a:t>
+                </a:r>
+                <a:r>
+                  <a:rPr lang="en-US" dirty="0">
+                    <a:latin typeface="Cambria Math" panose="02040503050406030204" pitchFamily="18" charset="0"/>
+                    <a:ea typeface="Cambria Math" panose="02040503050406030204" pitchFamily="18" charset="0"/>
+                  </a:rPr>
+                  <a:t>M(t): </a:t>
+                </a:r>
+              </a:p>
+              <a:p>
+                <a:pPr/>
+                <a14:m>
+                  <m:oMathPara xmlns:m="http://schemas.openxmlformats.org/officeDocument/2006/math">
+                    <m:oMathParaPr>
+                      <m:jc m:val="centerGroup"/>
+                    </m:oMathParaPr>
+                    <m:oMath xmlns:m="http://schemas.openxmlformats.org/officeDocument/2006/math">
+                      <m:r>
+                        <a:rPr lang="en-US" sz="1600" i="1">
+                          <a:latin typeface="Cambria Math" panose="02040503050406030204" pitchFamily="18" charset="0"/>
+                        </a:rPr>
+                        <m:t>𝑀</m:t>
+                      </m:r>
+                      <m:sSup>
+                        <m:sSupPr>
+                          <m:ctrlPr>
+                            <a:rPr lang="en-US" sz="1600" b="0" i="1" smtClean="0">
+                              <a:latin typeface="Cambria Math" panose="02040503050406030204" pitchFamily="18" charset="0"/>
+                            </a:rPr>
+                          </m:ctrlPr>
+                        </m:sSupPr>
+                        <m:e>
+                          <m:d>
+                            <m:dPr>
+                              <m:ctrlPr>
+                                <a:rPr lang="en-US" sz="1600" i="1">
+                                  <a:latin typeface="Cambria Math" panose="02040503050406030204" pitchFamily="18" charset="0"/>
+                                </a:rPr>
+                              </m:ctrlPr>
+                            </m:dPr>
+                            <m:e>
+                              <m:r>
+                                <a:rPr lang="en-US" sz="1600" i="1">
+                                  <a:latin typeface="Cambria Math" panose="02040503050406030204" pitchFamily="18" charset="0"/>
+                                </a:rPr>
+                                <m:t>𝑡</m:t>
+                              </m:r>
+                            </m:e>
+                          </m:d>
+                        </m:e>
+                        <m:sup>
+                          <m:r>
+                            <a:rPr lang="en-US" sz="1600" b="0" i="1" smtClean="0">
+                              <a:latin typeface="Cambria Math" panose="02040503050406030204" pitchFamily="18" charset="0"/>
+                            </a:rPr>
+                            <m:t>2</m:t>
+                          </m:r>
+                        </m:sup>
+                      </m:sSup>
+                      <m:r>
+                        <a:rPr lang="en-US" sz="1600" i="1">
+                          <a:latin typeface="Cambria Math" panose="02040503050406030204" pitchFamily="18" charset="0"/>
+                        </a:rPr>
+                        <m:t>∗</m:t>
+                      </m:r>
+                      <m:sSub>
+                        <m:sSubPr>
+                          <m:ctrlPr>
+                            <a:rPr lang="en-US" sz="1600" i="1">
+                              <a:latin typeface="Cambria Math" panose="02040503050406030204" pitchFamily="18" charset="0"/>
+                            </a:rPr>
+                          </m:ctrlPr>
+                        </m:sSubPr>
+                        <m:e>
+                          <m:r>
+                            <a:rPr lang="en-US" sz="1600" i="1">
+                              <a:latin typeface="Cambria Math" panose="02040503050406030204" pitchFamily="18" charset="0"/>
+                            </a:rPr>
+                            <m:t>𝑉</m:t>
+                          </m:r>
+                        </m:e>
+                        <m:sub>
+                          <m:r>
+                            <a:rPr lang="en-US" sz="1600" i="1">
+                              <a:latin typeface="Cambria Math" panose="02040503050406030204" pitchFamily="18" charset="0"/>
+                            </a:rPr>
+                            <m:t>𝑔</m:t>
+                          </m:r>
+                        </m:sub>
+                      </m:sSub>
+                      <m:r>
+                        <a:rPr lang="en-US" sz="1600" i="1">
+                          <a:latin typeface="Cambria Math" panose="02040503050406030204" pitchFamily="18" charset="0"/>
+                        </a:rPr>
+                        <m:t>=</m:t>
+                      </m:r>
+                      <m:sSub>
+                        <m:sSubPr>
+                          <m:ctrlPr>
+                            <a:rPr lang="en-US" sz="1600" i="1">
+                              <a:latin typeface="Cambria Math" panose="02040503050406030204" pitchFamily="18" charset="0"/>
+                            </a:rPr>
+                          </m:ctrlPr>
+                        </m:sSubPr>
+                        <m:e>
+                          <m:r>
+                            <a:rPr lang="en-US" sz="1600" i="1">
+                              <a:latin typeface="Cambria Math" panose="02040503050406030204" pitchFamily="18" charset="0"/>
+                            </a:rPr>
+                            <m:t>𝑅</m:t>
+                          </m:r>
+                        </m:e>
+                        <m:sub>
+                          <m:r>
+                            <a:rPr lang="en-US" sz="1600" i="1">
+                              <a:latin typeface="Cambria Math" panose="02040503050406030204" pitchFamily="18" charset="0"/>
+                            </a:rPr>
+                            <m:t>𝐸𝑆𝑅</m:t>
+                          </m:r>
+                        </m:sub>
+                      </m:sSub>
+                      <m:r>
+                        <a:rPr lang="en-US" sz="1600" i="1">
+                          <a:latin typeface="Cambria Math" panose="02040503050406030204" pitchFamily="18" charset="0"/>
+                        </a:rPr>
+                        <m:t>∗</m:t>
+                      </m:r>
+                      <m:sSub>
+                        <m:sSubPr>
+                          <m:ctrlPr>
+                            <a:rPr lang="en-US" sz="1600" i="1">
+                              <a:latin typeface="Cambria Math" panose="02040503050406030204" pitchFamily="18" charset="0"/>
+                            </a:rPr>
+                          </m:ctrlPr>
+                        </m:sSubPr>
+                        <m:e>
+                          <m:r>
+                            <a:rPr lang="en-US" sz="1600" i="1">
+                              <a:latin typeface="Cambria Math" panose="02040503050406030204" pitchFamily="18" charset="0"/>
+                            </a:rPr>
+                            <m:t>𝐼</m:t>
+                          </m:r>
+                        </m:e>
+                        <m:sub>
+                          <m:r>
+                            <a:rPr lang="en-US" sz="1600" i="1">
+                              <a:latin typeface="Cambria Math" panose="02040503050406030204" pitchFamily="18" charset="0"/>
+                            </a:rPr>
+                            <m:t>𝑏𝑎𝑡</m:t>
+                          </m:r>
+                        </m:sub>
+                      </m:sSub>
+                      <m:d>
+                        <m:dPr>
+                          <m:ctrlPr>
+                            <a:rPr lang="en-US" sz="1600" i="1">
+                              <a:latin typeface="Cambria Math" panose="02040503050406030204" pitchFamily="18" charset="0"/>
+                            </a:rPr>
+                          </m:ctrlPr>
+                        </m:dPr>
+                        <m:e>
+                          <m:r>
+                            <a:rPr lang="en-US" sz="1600" i="1">
+                              <a:latin typeface="Cambria Math" panose="02040503050406030204" pitchFamily="18" charset="0"/>
+                            </a:rPr>
+                            <m:t>𝑡</m:t>
+                          </m:r>
+                        </m:e>
+                      </m:d>
+                      <m:r>
+                        <a:rPr lang="en-US" sz="1600" i="1">
+                          <a:latin typeface="Cambria Math" panose="02040503050406030204" pitchFamily="18" charset="0"/>
+                        </a:rPr>
+                        <m:t>+</m:t>
+                      </m:r>
+                      <m:r>
+                        <a:rPr lang="en-US" sz="1600" b="0" i="1" smtClean="0">
+                          <a:latin typeface="Cambria Math" panose="02040503050406030204" pitchFamily="18" charset="0"/>
+                        </a:rPr>
+                        <m:t>𝐿</m:t>
+                      </m:r>
+                      <m:r>
+                        <a:rPr lang="en-US" sz="1600" i="1">
+                          <a:latin typeface="Cambria Math" panose="02040503050406030204" pitchFamily="18" charset="0"/>
+                        </a:rPr>
+                        <m:t>∗</m:t>
+                      </m:r>
+                      <m:f>
+                        <m:fPr>
+                          <m:ctrlPr>
+                            <a:rPr lang="en-US" sz="1600" i="1">
+                              <a:latin typeface="Cambria Math" panose="02040503050406030204" pitchFamily="18" charset="0"/>
+                            </a:rPr>
+                          </m:ctrlPr>
+                        </m:fPr>
+                        <m:num>
+                          <m:r>
+                            <a:rPr lang="en-US" sz="1600" i="1">
+                              <a:latin typeface="Cambria Math" panose="02040503050406030204" pitchFamily="18" charset="0"/>
+                            </a:rPr>
+                            <m:t>𝑑</m:t>
+                          </m:r>
+                        </m:num>
+                        <m:den>
+                          <m:r>
+                            <a:rPr lang="en-US" sz="1600" i="1">
+                              <a:latin typeface="Cambria Math" panose="02040503050406030204" pitchFamily="18" charset="0"/>
+                            </a:rPr>
+                            <m:t>𝑑𝑡</m:t>
+                          </m:r>
+                        </m:den>
+                      </m:f>
+                      <m:sSub>
+                        <m:sSubPr>
+                          <m:ctrlPr>
+                            <a:rPr lang="en-US" sz="1600" i="1">
+                              <a:latin typeface="Cambria Math" panose="02040503050406030204" pitchFamily="18" charset="0"/>
+                            </a:rPr>
+                          </m:ctrlPr>
+                        </m:sSubPr>
+                        <m:e>
+                          <m:r>
+                            <a:rPr lang="en-US" sz="1600" i="1">
+                              <a:latin typeface="Cambria Math" panose="02040503050406030204" pitchFamily="18" charset="0"/>
+                            </a:rPr>
+                            <m:t>𝐼</m:t>
+                          </m:r>
+                        </m:e>
+                        <m:sub>
+                          <m:r>
+                            <a:rPr lang="en-US" sz="1600" i="1">
+                              <a:latin typeface="Cambria Math" panose="02040503050406030204" pitchFamily="18" charset="0"/>
+                            </a:rPr>
+                            <m:t>𝑏𝑎𝑡</m:t>
+                          </m:r>
+                        </m:sub>
+                      </m:sSub>
+                      <m:d>
+                        <m:dPr>
+                          <m:ctrlPr>
+                            <a:rPr lang="en-US" sz="1600" i="1">
+                              <a:latin typeface="Cambria Math" panose="02040503050406030204" pitchFamily="18" charset="0"/>
+                            </a:rPr>
+                          </m:ctrlPr>
+                        </m:dPr>
+                        <m:e>
+                          <m:r>
+                            <a:rPr lang="en-US" sz="1600" i="1">
+                              <a:latin typeface="Cambria Math" panose="02040503050406030204" pitchFamily="18" charset="0"/>
+                            </a:rPr>
+                            <m:t>𝑡</m:t>
+                          </m:r>
+                        </m:e>
+                      </m:d>
+                      <m:r>
+                        <a:rPr lang="en-US" sz="1600" b="0" i="1" smtClean="0">
+                          <a:latin typeface="Cambria Math" panose="02040503050406030204" pitchFamily="18" charset="0"/>
+                        </a:rPr>
+                        <m:t>+</m:t>
+                      </m:r>
+                      <m:f>
+                        <m:fPr>
+                          <m:ctrlPr>
+                            <a:rPr lang="en-US" sz="1600" b="0" i="1" smtClean="0">
+                              <a:latin typeface="Cambria Math" panose="02040503050406030204" pitchFamily="18" charset="0"/>
+                            </a:rPr>
+                          </m:ctrlPr>
+                        </m:fPr>
+                        <m:num>
+                          <m:r>
+                            <a:rPr lang="en-US" sz="1600" b="0" i="1" smtClean="0">
+                              <a:latin typeface="Cambria Math" panose="02040503050406030204" pitchFamily="18" charset="0"/>
+                            </a:rPr>
+                            <m:t>1</m:t>
+                          </m:r>
+                        </m:num>
+                        <m:den>
+                          <m:r>
+                            <a:rPr lang="en-US" sz="1600" b="0" i="1" smtClean="0">
+                              <a:latin typeface="Cambria Math" panose="02040503050406030204" pitchFamily="18" charset="0"/>
+                            </a:rPr>
+                            <m:t>𝐶</m:t>
+                          </m:r>
+                        </m:den>
+                      </m:f>
+                      <m:nary>
+                        <m:naryPr>
+                          <m:limLoc m:val="undOvr"/>
+                          <m:subHide m:val="on"/>
+                          <m:supHide m:val="on"/>
+                          <m:ctrlPr>
+                            <a:rPr lang="en-US" sz="1600" i="1">
+                              <a:latin typeface="Cambria Math" panose="02040503050406030204" pitchFamily="18" charset="0"/>
+                            </a:rPr>
+                          </m:ctrlPr>
+                        </m:naryPr>
+                        <m:sub/>
+                        <m:sup/>
+                        <m:e>
+                          <m:sSub>
+                            <m:sSubPr>
+                              <m:ctrlPr>
+                                <a:rPr lang="en-US" sz="1600" i="1">
+                                  <a:latin typeface="Cambria Math" panose="02040503050406030204" pitchFamily="18" charset="0"/>
+                                </a:rPr>
+                              </m:ctrlPr>
+                            </m:sSubPr>
+                            <m:e>
+                              <m:r>
+                                <a:rPr lang="en-US" sz="1600" i="1">
+                                  <a:latin typeface="Cambria Math" panose="02040503050406030204" pitchFamily="18" charset="0"/>
+                                </a:rPr>
+                                <m:t>𝐼</m:t>
+                              </m:r>
+                            </m:e>
+                            <m:sub>
+                              <m:r>
+                                <a:rPr lang="en-US" sz="1600" i="1">
+                                  <a:latin typeface="Cambria Math" panose="02040503050406030204" pitchFamily="18" charset="0"/>
+                                </a:rPr>
+                                <m:t>𝑏𝑎𝑡</m:t>
+                              </m:r>
+                            </m:sub>
+                          </m:sSub>
+                          <m:r>
+                            <a:rPr lang="en-US" sz="1600" i="1">
+                              <a:latin typeface="Cambria Math" panose="02040503050406030204" pitchFamily="18" charset="0"/>
+                            </a:rPr>
+                            <m:t>(</m:t>
+                          </m:r>
+                          <m:r>
+                            <a:rPr lang="en-US" sz="1600" i="1">
+                              <a:latin typeface="Cambria Math" panose="02040503050406030204" pitchFamily="18" charset="0"/>
+                            </a:rPr>
+                            <m:t>𝑡</m:t>
+                          </m:r>
+                          <m:r>
+                            <a:rPr lang="en-US" sz="1600" i="1">
+                              <a:latin typeface="Cambria Math" panose="02040503050406030204" pitchFamily="18" charset="0"/>
+                            </a:rPr>
+                            <m:t>)</m:t>
+                          </m:r>
+                        </m:e>
+                      </m:nary>
+                    </m:oMath>
+                  </m:oMathPara>
+                </a14:m>
+                <a:endParaRPr lang="en-US" dirty="0"/>
+              </a:p>
+              <a:p>
+                <a:r>
+                  <a:rPr lang="en-US" dirty="0"/>
+                  <a:t>Our algebra trick is a lot simpler now, and we don’t need to complete the square or define a new auxiliary variable:</a:t>
+                </a:r>
+              </a:p>
+              <a:p>
+                <a:pPr/>
+                <a14:m>
+                  <m:oMathPara xmlns:m="http://schemas.openxmlformats.org/officeDocument/2006/math">
+                    <m:oMathParaPr>
+                      <m:jc m:val="centerGroup"/>
+                    </m:oMathParaPr>
+                    <m:oMath xmlns:m="http://schemas.openxmlformats.org/officeDocument/2006/math">
+                      <m:sSub>
+                        <m:sSubPr>
+                          <m:ctrlPr>
+                            <a:rPr lang="en-US" b="0" i="1" smtClean="0">
+                              <a:latin typeface="Cambria Math" panose="02040503050406030204" pitchFamily="18" charset="0"/>
+                            </a:rPr>
+                          </m:ctrlPr>
+                        </m:sSubPr>
+                        <m:e>
+                          <m:r>
+                            <a:rPr lang="en-US" b="0" i="1" smtClean="0">
+                              <a:latin typeface="Cambria Math" panose="02040503050406030204" pitchFamily="18" charset="0"/>
+                            </a:rPr>
+                            <m:t>𝑀</m:t>
+                          </m:r>
+                        </m:e>
+                        <m:sub>
+                          <m:r>
+                            <a:rPr lang="en-US" b="0" i="1" smtClean="0">
+                              <a:latin typeface="Cambria Math" panose="02040503050406030204" pitchFamily="18" charset="0"/>
+                            </a:rPr>
+                            <m:t>𝑇</m:t>
+                          </m:r>
+                        </m:sub>
+                      </m:sSub>
+                      <m:d>
+                        <m:dPr>
+                          <m:ctrlPr>
+                            <a:rPr lang="en-US" b="0" i="1" smtClean="0">
+                              <a:latin typeface="Cambria Math" panose="02040503050406030204" pitchFamily="18" charset="0"/>
+                            </a:rPr>
+                          </m:ctrlPr>
+                        </m:dPr>
+                        <m:e>
+                          <m:r>
+                            <a:rPr lang="en-US" b="0" i="1" smtClean="0">
+                              <a:latin typeface="Cambria Math" panose="02040503050406030204" pitchFamily="18" charset="0"/>
+                            </a:rPr>
+                            <m:t>𝑡</m:t>
+                          </m:r>
+                        </m:e>
+                      </m:d>
+                      <m:r>
+                        <a:rPr lang="en-US" b="0" i="1" smtClean="0">
+                          <a:latin typeface="Cambria Math" panose="02040503050406030204" pitchFamily="18" charset="0"/>
+                        </a:rPr>
+                        <m:t>=</m:t>
+                      </m:r>
+                      <m:r>
+                        <a:rPr lang="en-US" i="1">
+                          <a:latin typeface="Cambria Math" panose="02040503050406030204" pitchFamily="18" charset="0"/>
+                        </a:rPr>
+                        <m:t>𝑀</m:t>
+                      </m:r>
+                      <m:sSup>
+                        <m:sSupPr>
+                          <m:ctrlPr>
+                            <a:rPr lang="en-US" i="1">
+                              <a:latin typeface="Cambria Math" panose="02040503050406030204" pitchFamily="18" charset="0"/>
+                            </a:rPr>
+                          </m:ctrlPr>
+                        </m:sSupPr>
+                        <m:e>
+                          <m:d>
+                            <m:dPr>
+                              <m:ctrlPr>
+                                <a:rPr lang="en-US" i="1">
+                                  <a:latin typeface="Cambria Math" panose="02040503050406030204" pitchFamily="18" charset="0"/>
+                                </a:rPr>
+                              </m:ctrlPr>
+                            </m:dPr>
+                            <m:e>
+                              <m:r>
+                                <a:rPr lang="en-US" i="1">
+                                  <a:latin typeface="Cambria Math" panose="02040503050406030204" pitchFamily="18" charset="0"/>
+                                </a:rPr>
+                                <m:t>𝑡</m:t>
+                              </m:r>
+                            </m:e>
+                          </m:d>
+                        </m:e>
+                        <m:sup>
+                          <m:r>
+                            <a:rPr lang="en-US" i="1">
+                              <a:latin typeface="Cambria Math" panose="02040503050406030204" pitchFamily="18" charset="0"/>
+                            </a:rPr>
+                            <m:t>2</m:t>
+                          </m:r>
+                        </m:sup>
+                      </m:sSup>
+                      <m:r>
+                        <a:rPr lang="en-US" b="0" i="1" smtClean="0">
+                          <a:latin typeface="Cambria Math" panose="02040503050406030204" pitchFamily="18" charset="0"/>
+                        </a:rPr>
+                        <m:t>, </m:t>
+                      </m:r>
+                      <m:r>
+                        <a:rPr lang="en-US" b="0" i="1" smtClean="0">
+                          <a:latin typeface="Cambria Math" panose="02040503050406030204" pitchFamily="18" charset="0"/>
+                        </a:rPr>
+                        <m:t>𝑀</m:t>
+                      </m:r>
+                      <m:d>
+                        <m:dPr>
+                          <m:ctrlPr>
+                            <a:rPr lang="en-US" b="0" i="1" smtClean="0">
+                              <a:latin typeface="Cambria Math" panose="02040503050406030204" pitchFamily="18" charset="0"/>
+                            </a:rPr>
+                          </m:ctrlPr>
+                        </m:dPr>
+                        <m:e>
+                          <m:r>
+                            <a:rPr lang="en-US" b="0" i="1" smtClean="0">
+                              <a:latin typeface="Cambria Math" panose="02040503050406030204" pitchFamily="18" charset="0"/>
+                            </a:rPr>
+                            <m:t>𝑡</m:t>
+                          </m:r>
+                        </m:e>
+                      </m:d>
+                      <m:r>
+                        <a:rPr lang="en-US" b="0" i="1" smtClean="0">
+                          <a:latin typeface="Cambria Math" panose="02040503050406030204" pitchFamily="18" charset="0"/>
+                        </a:rPr>
+                        <m:t>= </m:t>
+                      </m:r>
+                      <m:r>
+                        <a:rPr lang="en-US" b="0" i="1" smtClean="0">
+                          <a:latin typeface="Cambria Math" panose="02040503050406030204" pitchFamily="18" charset="0"/>
+                          <a:ea typeface="Cambria Math" panose="02040503050406030204" pitchFamily="18" charset="0"/>
+                        </a:rPr>
+                        <m:t>±</m:t>
+                      </m:r>
+                      <m:rad>
+                        <m:radPr>
+                          <m:degHide m:val="on"/>
+                          <m:ctrlPr>
+                            <a:rPr lang="en-US" b="0" i="1" smtClean="0">
+                              <a:latin typeface="Cambria Math" panose="02040503050406030204" pitchFamily="18" charset="0"/>
+                              <a:ea typeface="Cambria Math" panose="02040503050406030204" pitchFamily="18" charset="0"/>
+                            </a:rPr>
+                          </m:ctrlPr>
+                        </m:radPr>
+                        <m:deg/>
+                        <m:e>
+                          <m:sSub>
+                            <m:sSubPr>
+                              <m:ctrlPr>
+                                <a:rPr lang="en-US" i="1">
+                                  <a:latin typeface="Cambria Math" panose="02040503050406030204" pitchFamily="18" charset="0"/>
+                                </a:rPr>
+                              </m:ctrlPr>
+                            </m:sSubPr>
+                            <m:e>
+                              <m:r>
+                                <a:rPr lang="en-US" i="1">
+                                  <a:latin typeface="Cambria Math" panose="02040503050406030204" pitchFamily="18" charset="0"/>
+                                </a:rPr>
+                                <m:t>𝑀</m:t>
+                              </m:r>
+                            </m:e>
+                            <m:sub>
+                              <m:r>
+                                <a:rPr lang="en-US" i="1">
+                                  <a:latin typeface="Cambria Math" panose="02040503050406030204" pitchFamily="18" charset="0"/>
+                                </a:rPr>
+                                <m:t>𝑇</m:t>
+                              </m:r>
+                            </m:sub>
+                          </m:sSub>
+                          <m:d>
+                            <m:dPr>
+                              <m:ctrlPr>
+                                <a:rPr lang="en-US" i="1">
+                                  <a:latin typeface="Cambria Math" panose="02040503050406030204" pitchFamily="18" charset="0"/>
+                                </a:rPr>
+                              </m:ctrlPr>
+                            </m:dPr>
+                            <m:e>
+                              <m:r>
+                                <a:rPr lang="en-US" i="1">
+                                  <a:latin typeface="Cambria Math" panose="02040503050406030204" pitchFamily="18" charset="0"/>
+                                </a:rPr>
+                                <m:t>𝑡</m:t>
+                              </m:r>
+                            </m:e>
+                          </m:d>
+                        </m:e>
+                      </m:rad>
+                    </m:oMath>
+                  </m:oMathPara>
+                </a14:m>
+                <a:endParaRPr lang="en-US" dirty="0"/>
+              </a:p>
+              <a:p>
+                <a:r>
+                  <a:rPr lang="en-US" dirty="0"/>
+                  <a:t>Our KVL equation is now:</a:t>
+                </a:r>
+              </a:p>
+              <a:p>
+                <a14:m>
+                  <m:oMathPara xmlns:m="http://schemas.openxmlformats.org/officeDocument/2006/math">
+                    <m:oMathParaPr>
+                      <m:jc m:val="centerGroup"/>
+                    </m:oMathParaPr>
+                    <m:oMath xmlns:m="http://schemas.openxmlformats.org/officeDocument/2006/math">
+                      <m:sSub>
+                        <m:sSubPr>
+                          <m:ctrlPr>
+                            <a:rPr lang="en-US" sz="1600" i="1">
+                              <a:latin typeface="Cambria Math" panose="02040503050406030204" pitchFamily="18" charset="0"/>
+                            </a:rPr>
+                          </m:ctrlPr>
+                        </m:sSubPr>
+                        <m:e>
+                          <m:r>
+                            <a:rPr lang="en-US" sz="1600" i="1">
+                              <a:latin typeface="Cambria Math" panose="02040503050406030204" pitchFamily="18" charset="0"/>
+                            </a:rPr>
+                            <m:t>𝑉</m:t>
+                          </m:r>
+                        </m:e>
+                        <m:sub>
+                          <m:r>
+                            <a:rPr lang="en-US" sz="1600" i="1">
+                              <a:latin typeface="Cambria Math" panose="02040503050406030204" pitchFamily="18" charset="0"/>
+                            </a:rPr>
+                            <m:t>𝑔</m:t>
+                          </m:r>
+                        </m:sub>
+                      </m:sSub>
+                      <m:r>
+                        <a:rPr lang="en-US" sz="1600" i="1">
+                          <a:latin typeface="Cambria Math" panose="02040503050406030204" pitchFamily="18" charset="0"/>
+                        </a:rPr>
+                        <m:t>∗</m:t>
+                      </m:r>
+                      <m:sSub>
+                        <m:sSubPr>
+                          <m:ctrlPr>
+                            <a:rPr lang="en-US" sz="1600" i="1">
+                              <a:latin typeface="Cambria Math" panose="02040503050406030204" pitchFamily="18" charset="0"/>
+                            </a:rPr>
+                          </m:ctrlPr>
+                        </m:sSubPr>
+                        <m:e>
+                          <m:r>
+                            <a:rPr lang="en-US" sz="1600" i="1">
+                              <a:latin typeface="Cambria Math" panose="02040503050406030204" pitchFamily="18" charset="0"/>
+                            </a:rPr>
+                            <m:t>𝑀</m:t>
+                          </m:r>
+                        </m:e>
+                        <m:sub>
+                          <m:r>
+                            <a:rPr lang="en-US" sz="1600" i="1">
+                              <a:latin typeface="Cambria Math" panose="02040503050406030204" pitchFamily="18" charset="0"/>
+                            </a:rPr>
+                            <m:t>𝑇</m:t>
+                          </m:r>
+                        </m:sub>
+                      </m:sSub>
+                      <m:r>
+                        <a:rPr lang="en-US" sz="1600" i="1">
+                          <a:latin typeface="Cambria Math" panose="02040503050406030204" pitchFamily="18" charset="0"/>
+                        </a:rPr>
+                        <m:t>(</m:t>
+                      </m:r>
+                      <m:r>
+                        <a:rPr lang="en-US" sz="1600" i="1">
+                          <a:latin typeface="Cambria Math" panose="02040503050406030204" pitchFamily="18" charset="0"/>
+                        </a:rPr>
+                        <m:t>𝑡</m:t>
+                      </m:r>
+                      <m:r>
+                        <a:rPr lang="en-US" sz="1600" i="1">
+                          <a:latin typeface="Cambria Math" panose="02040503050406030204" pitchFamily="18" charset="0"/>
+                        </a:rPr>
+                        <m:t>)=</m:t>
+                      </m:r>
+                      <m:sSub>
+                        <m:sSubPr>
+                          <m:ctrlPr>
+                            <a:rPr lang="en-US" sz="1600" i="1">
+                              <a:latin typeface="Cambria Math" panose="02040503050406030204" pitchFamily="18" charset="0"/>
+                            </a:rPr>
+                          </m:ctrlPr>
+                        </m:sSubPr>
+                        <m:e>
+                          <m:r>
+                            <a:rPr lang="en-US" sz="1600" i="1">
+                              <a:latin typeface="Cambria Math" panose="02040503050406030204" pitchFamily="18" charset="0"/>
+                            </a:rPr>
+                            <m:t>𝑅</m:t>
+                          </m:r>
+                        </m:e>
+                        <m:sub>
+                          <m:r>
+                            <a:rPr lang="en-US" sz="1600" i="1">
+                              <a:latin typeface="Cambria Math" panose="02040503050406030204" pitchFamily="18" charset="0"/>
+                            </a:rPr>
+                            <m:t>𝐸𝑆𝑅</m:t>
+                          </m:r>
+                        </m:sub>
+                      </m:sSub>
+                      <m:r>
+                        <a:rPr lang="en-US" sz="1600" i="1">
+                          <a:latin typeface="Cambria Math" panose="02040503050406030204" pitchFamily="18" charset="0"/>
+                        </a:rPr>
+                        <m:t>∗</m:t>
+                      </m:r>
+                      <m:sSub>
+                        <m:sSubPr>
+                          <m:ctrlPr>
+                            <a:rPr lang="en-US" sz="1600" i="1">
+                              <a:latin typeface="Cambria Math" panose="02040503050406030204" pitchFamily="18" charset="0"/>
+                            </a:rPr>
+                          </m:ctrlPr>
+                        </m:sSubPr>
+                        <m:e>
+                          <m:r>
+                            <a:rPr lang="en-US" sz="1600" i="1">
+                              <a:latin typeface="Cambria Math" panose="02040503050406030204" pitchFamily="18" charset="0"/>
+                            </a:rPr>
+                            <m:t>𝐼</m:t>
+                          </m:r>
+                        </m:e>
+                        <m:sub>
+                          <m:r>
+                            <a:rPr lang="en-US" sz="1600" i="1">
+                              <a:latin typeface="Cambria Math" panose="02040503050406030204" pitchFamily="18" charset="0"/>
+                            </a:rPr>
+                            <m:t>𝑏𝑎𝑡</m:t>
+                          </m:r>
+                        </m:sub>
+                      </m:sSub>
+                      <m:d>
+                        <m:dPr>
+                          <m:ctrlPr>
+                            <a:rPr lang="en-US" sz="1600" i="1">
+                              <a:latin typeface="Cambria Math" panose="02040503050406030204" pitchFamily="18" charset="0"/>
+                            </a:rPr>
+                          </m:ctrlPr>
+                        </m:dPr>
+                        <m:e>
+                          <m:r>
+                            <a:rPr lang="en-US" sz="1600" i="1">
+                              <a:latin typeface="Cambria Math" panose="02040503050406030204" pitchFamily="18" charset="0"/>
+                            </a:rPr>
+                            <m:t>𝑡</m:t>
+                          </m:r>
+                        </m:e>
+                      </m:d>
+                      <m:r>
+                        <a:rPr lang="en-US" sz="1600" i="1">
+                          <a:latin typeface="Cambria Math" panose="02040503050406030204" pitchFamily="18" charset="0"/>
+                        </a:rPr>
+                        <m:t>+</m:t>
+                      </m:r>
+                      <m:r>
+                        <a:rPr lang="en-US" sz="1600" i="1">
+                          <a:latin typeface="Cambria Math" panose="02040503050406030204" pitchFamily="18" charset="0"/>
+                        </a:rPr>
+                        <m:t>𝐿</m:t>
+                      </m:r>
+                      <m:r>
+                        <a:rPr lang="en-US" sz="1600" i="1">
+                          <a:latin typeface="Cambria Math" panose="02040503050406030204" pitchFamily="18" charset="0"/>
+                        </a:rPr>
+                        <m:t>∗</m:t>
+                      </m:r>
+                      <m:f>
+                        <m:fPr>
+                          <m:ctrlPr>
+                            <a:rPr lang="en-US" sz="1600" i="1">
+                              <a:latin typeface="Cambria Math" panose="02040503050406030204" pitchFamily="18" charset="0"/>
+                            </a:rPr>
+                          </m:ctrlPr>
+                        </m:fPr>
+                        <m:num>
+                          <m:r>
+                            <a:rPr lang="en-US" sz="1600" i="1">
+                              <a:latin typeface="Cambria Math" panose="02040503050406030204" pitchFamily="18" charset="0"/>
+                            </a:rPr>
+                            <m:t>𝑑</m:t>
+                          </m:r>
+                        </m:num>
+                        <m:den>
+                          <m:r>
+                            <a:rPr lang="en-US" sz="1600" i="1">
+                              <a:latin typeface="Cambria Math" panose="02040503050406030204" pitchFamily="18" charset="0"/>
+                            </a:rPr>
+                            <m:t>𝑑𝑡</m:t>
+                          </m:r>
+                        </m:den>
+                      </m:f>
+                      <m:sSub>
+                        <m:sSubPr>
+                          <m:ctrlPr>
+                            <a:rPr lang="en-US" sz="1600" i="1">
+                              <a:latin typeface="Cambria Math" panose="02040503050406030204" pitchFamily="18" charset="0"/>
+                            </a:rPr>
+                          </m:ctrlPr>
+                        </m:sSubPr>
+                        <m:e>
+                          <m:r>
+                            <a:rPr lang="en-US" sz="1600" i="1">
+                              <a:latin typeface="Cambria Math" panose="02040503050406030204" pitchFamily="18" charset="0"/>
+                            </a:rPr>
+                            <m:t>𝐼</m:t>
+                          </m:r>
+                        </m:e>
+                        <m:sub>
+                          <m:r>
+                            <a:rPr lang="en-US" sz="1600" i="1">
+                              <a:latin typeface="Cambria Math" panose="02040503050406030204" pitchFamily="18" charset="0"/>
+                            </a:rPr>
+                            <m:t>𝑏𝑎𝑡</m:t>
+                          </m:r>
+                        </m:sub>
+                      </m:sSub>
+                      <m:r>
+                        <a:rPr lang="en-US" sz="1600" i="1">
+                          <a:latin typeface="Cambria Math" panose="02040503050406030204" pitchFamily="18" charset="0"/>
+                        </a:rPr>
+                        <m:t>(</m:t>
+                      </m:r>
+                      <m:r>
+                        <a:rPr lang="en-US" sz="1600" i="1">
+                          <a:latin typeface="Cambria Math" panose="02040503050406030204" pitchFamily="18" charset="0"/>
+                        </a:rPr>
+                        <m:t>𝑡</m:t>
+                      </m:r>
+                      <m:r>
+                        <a:rPr lang="en-US" sz="1600" i="1">
+                          <a:latin typeface="Cambria Math" panose="02040503050406030204" pitchFamily="18" charset="0"/>
+                        </a:rPr>
+                        <m:t>)+</m:t>
+                      </m:r>
+                      <m:f>
+                        <m:fPr>
+                          <m:ctrlPr>
+                            <a:rPr lang="en-US" sz="1600" b="0" i="1" smtClean="0">
+                              <a:latin typeface="Cambria Math" panose="02040503050406030204" pitchFamily="18" charset="0"/>
+                            </a:rPr>
+                          </m:ctrlPr>
+                        </m:fPr>
+                        <m:num>
+                          <m:r>
+                            <a:rPr lang="en-US" sz="1600" b="0" i="1" smtClean="0">
+                              <a:latin typeface="Cambria Math" panose="02040503050406030204" pitchFamily="18" charset="0"/>
+                            </a:rPr>
+                            <m:t>1</m:t>
+                          </m:r>
+                        </m:num>
+                        <m:den>
+                          <m:r>
+                            <a:rPr lang="en-US" sz="1600" i="1">
+                              <a:latin typeface="Cambria Math" panose="02040503050406030204" pitchFamily="18" charset="0"/>
+                            </a:rPr>
+                            <m:t>𝐶</m:t>
+                          </m:r>
+                        </m:den>
+                      </m:f>
+                      <m:nary>
+                        <m:naryPr>
+                          <m:limLoc m:val="undOvr"/>
+                          <m:subHide m:val="on"/>
+                          <m:supHide m:val="on"/>
+                          <m:ctrlPr>
+                            <a:rPr lang="en-US" sz="1600" i="1">
+                              <a:latin typeface="Cambria Math" panose="02040503050406030204" pitchFamily="18" charset="0"/>
+                            </a:rPr>
+                          </m:ctrlPr>
+                        </m:naryPr>
+                        <m:sub/>
+                        <m:sup/>
+                        <m:e>
+                          <m:sSub>
+                            <m:sSubPr>
+                              <m:ctrlPr>
+                                <a:rPr lang="en-US" sz="1600" i="1">
+                                  <a:latin typeface="Cambria Math" panose="02040503050406030204" pitchFamily="18" charset="0"/>
+                                </a:rPr>
+                              </m:ctrlPr>
+                            </m:sSubPr>
+                            <m:e>
+                              <m:r>
+                                <a:rPr lang="en-US" sz="1600" i="1">
+                                  <a:latin typeface="Cambria Math" panose="02040503050406030204" pitchFamily="18" charset="0"/>
+                                </a:rPr>
+                                <m:t>𝐼</m:t>
+                              </m:r>
+                            </m:e>
+                            <m:sub>
+                              <m:r>
+                                <a:rPr lang="en-US" sz="1600" i="1">
+                                  <a:latin typeface="Cambria Math" panose="02040503050406030204" pitchFamily="18" charset="0"/>
+                                </a:rPr>
+                                <m:t>𝑏𝑎𝑡</m:t>
+                              </m:r>
+                            </m:sub>
+                          </m:sSub>
+                          <m:r>
+                            <a:rPr lang="en-US" sz="1600" i="1">
+                              <a:latin typeface="Cambria Math" panose="02040503050406030204" pitchFamily="18" charset="0"/>
+                            </a:rPr>
+                            <m:t>(</m:t>
+                          </m:r>
+                          <m:r>
+                            <a:rPr lang="en-US" sz="1600" i="1">
+                              <a:latin typeface="Cambria Math" panose="02040503050406030204" pitchFamily="18" charset="0"/>
+                            </a:rPr>
+                            <m:t>𝑡</m:t>
+                          </m:r>
+                          <m:r>
+                            <a:rPr lang="en-US" sz="1600" i="1">
+                              <a:latin typeface="Cambria Math" panose="02040503050406030204" pitchFamily="18" charset="0"/>
+                            </a:rPr>
+                            <m:t>)</m:t>
+                          </m:r>
+                        </m:e>
+                      </m:nary>
+                    </m:oMath>
+                  </m:oMathPara>
+                </a14:m>
+                <a:endParaRPr lang="en-US" dirty="0"/>
+              </a:p>
+              <a:p>
+                <a:r>
+                  <a:rPr lang="en-US" dirty="0">
+                    <a:ea typeface="Cambria Math" panose="02040503050406030204" pitchFamily="18" charset="0"/>
+                  </a:rPr>
+                  <a:t>Converting to s-domain:</a:t>
+                </a:r>
+              </a:p>
+              <a:p>
+                <a14:m>
+                  <m:oMathPara xmlns:m="http://schemas.openxmlformats.org/officeDocument/2006/math">
+                    <m:oMathParaPr>
+                      <m:jc m:val="centerGroup"/>
+                    </m:oMathParaPr>
+                    <m:oMath xmlns:m="http://schemas.openxmlformats.org/officeDocument/2006/math">
+                      <m:sSub>
+                        <m:sSubPr>
+                          <m:ctrlPr>
+                            <a:rPr lang="en-US" sz="1600" i="1">
+                              <a:latin typeface="Cambria Math" panose="02040503050406030204" pitchFamily="18" charset="0"/>
+                            </a:rPr>
+                          </m:ctrlPr>
+                        </m:sSubPr>
+                        <m:e>
+                          <m:r>
+                            <a:rPr lang="en-US" sz="1600" i="1">
+                              <a:latin typeface="Cambria Math" panose="02040503050406030204" pitchFamily="18" charset="0"/>
+                            </a:rPr>
+                            <m:t>𝑉</m:t>
+                          </m:r>
+                        </m:e>
+                        <m:sub>
+                          <m:r>
+                            <a:rPr lang="en-US" sz="1600" i="1">
+                              <a:latin typeface="Cambria Math" panose="02040503050406030204" pitchFamily="18" charset="0"/>
+                            </a:rPr>
+                            <m:t>𝑔</m:t>
+                          </m:r>
+                        </m:sub>
+                      </m:sSub>
+                      <m:r>
+                        <a:rPr lang="en-US" sz="1600" i="1">
+                          <a:latin typeface="Cambria Math" panose="02040503050406030204" pitchFamily="18" charset="0"/>
+                        </a:rPr>
+                        <m:t>∗</m:t>
+                      </m:r>
+                      <m:sSub>
+                        <m:sSubPr>
+                          <m:ctrlPr>
+                            <a:rPr lang="en-US" sz="1600" i="1">
+                              <a:latin typeface="Cambria Math" panose="02040503050406030204" pitchFamily="18" charset="0"/>
+                            </a:rPr>
+                          </m:ctrlPr>
+                        </m:sSubPr>
+                        <m:e>
+                          <m:r>
+                            <a:rPr lang="en-US" sz="1600" i="1">
+                              <a:latin typeface="Cambria Math" panose="02040503050406030204" pitchFamily="18" charset="0"/>
+                            </a:rPr>
+                            <m:t>𝑀</m:t>
+                          </m:r>
+                        </m:e>
+                        <m:sub>
+                          <m:r>
+                            <a:rPr lang="en-US" sz="1600" i="1">
+                              <a:latin typeface="Cambria Math" panose="02040503050406030204" pitchFamily="18" charset="0"/>
+                            </a:rPr>
+                            <m:t>𝑇</m:t>
+                          </m:r>
+                        </m:sub>
+                      </m:sSub>
+                      <m:d>
+                        <m:dPr>
+                          <m:ctrlPr>
+                            <a:rPr lang="en-US" sz="1600" i="1">
+                              <a:latin typeface="Cambria Math" panose="02040503050406030204" pitchFamily="18" charset="0"/>
+                            </a:rPr>
+                          </m:ctrlPr>
+                        </m:dPr>
+                        <m:e>
+                          <m:r>
+                            <a:rPr lang="en-US" sz="1600" i="1">
+                              <a:latin typeface="Cambria Math" panose="02040503050406030204" pitchFamily="18" charset="0"/>
+                            </a:rPr>
+                            <m:t>𝑠</m:t>
+                          </m:r>
+                        </m:e>
+                      </m:d>
+                      <m:r>
+                        <a:rPr lang="en-US" sz="1600" i="1">
+                          <a:latin typeface="Cambria Math" panose="02040503050406030204" pitchFamily="18" charset="0"/>
+                        </a:rPr>
+                        <m:t>=</m:t>
+                      </m:r>
+                      <m:sSub>
+                        <m:sSubPr>
+                          <m:ctrlPr>
+                            <a:rPr lang="en-US" sz="1600" i="1">
+                              <a:latin typeface="Cambria Math" panose="02040503050406030204" pitchFamily="18" charset="0"/>
+                            </a:rPr>
+                          </m:ctrlPr>
+                        </m:sSubPr>
+                        <m:e>
+                          <m:r>
+                            <a:rPr lang="en-US" sz="1600" i="1">
+                              <a:latin typeface="Cambria Math" panose="02040503050406030204" pitchFamily="18" charset="0"/>
+                            </a:rPr>
+                            <m:t>𝑅</m:t>
+                          </m:r>
+                        </m:e>
+                        <m:sub>
+                          <m:r>
+                            <a:rPr lang="en-US" sz="1600" i="1">
+                              <a:latin typeface="Cambria Math" panose="02040503050406030204" pitchFamily="18" charset="0"/>
+                            </a:rPr>
+                            <m:t>𝐸𝑆𝑅</m:t>
+                          </m:r>
+                        </m:sub>
+                      </m:sSub>
+                      <m:r>
+                        <a:rPr lang="en-US" sz="1600" i="1">
+                          <a:latin typeface="Cambria Math" panose="02040503050406030204" pitchFamily="18" charset="0"/>
+                        </a:rPr>
+                        <m:t>∗</m:t>
+                      </m:r>
+                      <m:sSub>
+                        <m:sSubPr>
+                          <m:ctrlPr>
+                            <a:rPr lang="en-US" sz="1600" i="1">
+                              <a:latin typeface="Cambria Math" panose="02040503050406030204" pitchFamily="18" charset="0"/>
+                            </a:rPr>
+                          </m:ctrlPr>
+                        </m:sSubPr>
+                        <m:e>
+                          <m:r>
+                            <a:rPr lang="en-US" sz="1600" i="1">
+                              <a:latin typeface="Cambria Math" panose="02040503050406030204" pitchFamily="18" charset="0"/>
+                            </a:rPr>
+                            <m:t>𝐼</m:t>
+                          </m:r>
+                        </m:e>
+                        <m:sub>
+                          <m:r>
+                            <a:rPr lang="en-US" sz="1600" i="1">
+                              <a:latin typeface="Cambria Math" panose="02040503050406030204" pitchFamily="18" charset="0"/>
+                            </a:rPr>
+                            <m:t>𝑏𝑎𝑡</m:t>
+                          </m:r>
+                        </m:sub>
+                      </m:sSub>
+                      <m:d>
+                        <m:dPr>
+                          <m:ctrlPr>
+                            <a:rPr lang="en-US" sz="1600" i="1">
+                              <a:latin typeface="Cambria Math" panose="02040503050406030204" pitchFamily="18" charset="0"/>
+                            </a:rPr>
+                          </m:ctrlPr>
+                        </m:dPr>
+                        <m:e>
+                          <m:r>
+                            <a:rPr lang="en-US" sz="1600" i="1">
+                              <a:latin typeface="Cambria Math" panose="02040503050406030204" pitchFamily="18" charset="0"/>
+                            </a:rPr>
+                            <m:t>𝑠</m:t>
+                          </m:r>
+                        </m:e>
+                      </m:d>
+                      <m:r>
+                        <a:rPr lang="en-US" sz="1600" i="1">
+                          <a:latin typeface="Cambria Math" panose="02040503050406030204" pitchFamily="18" charset="0"/>
+                        </a:rPr>
+                        <m:t>+</m:t>
+                      </m:r>
+                      <m:r>
+                        <a:rPr lang="en-US" sz="1600" i="1">
+                          <a:latin typeface="Cambria Math" panose="02040503050406030204" pitchFamily="18" charset="0"/>
+                        </a:rPr>
+                        <m:t>𝑠</m:t>
+                      </m:r>
+                      <m:r>
+                        <a:rPr lang="en-US" sz="1600" i="1">
+                          <a:latin typeface="Cambria Math" panose="02040503050406030204" pitchFamily="18" charset="0"/>
+                        </a:rPr>
+                        <m:t>𝐿</m:t>
+                      </m:r>
+                      <m:r>
+                        <a:rPr lang="en-US" sz="1600" i="1">
+                          <a:latin typeface="Cambria Math" panose="02040503050406030204" pitchFamily="18" charset="0"/>
+                        </a:rPr>
+                        <m:t>∗</m:t>
+                      </m:r>
+                      <m:sSub>
+                        <m:sSubPr>
+                          <m:ctrlPr>
+                            <a:rPr lang="en-US" sz="1600" i="1">
+                              <a:latin typeface="Cambria Math" panose="02040503050406030204" pitchFamily="18" charset="0"/>
+                            </a:rPr>
+                          </m:ctrlPr>
+                        </m:sSubPr>
+                        <m:e>
+                          <m:r>
+                            <a:rPr lang="en-US" sz="1600" i="1">
+                              <a:latin typeface="Cambria Math" panose="02040503050406030204" pitchFamily="18" charset="0"/>
+                            </a:rPr>
+                            <m:t>𝐼</m:t>
+                          </m:r>
+                        </m:e>
+                        <m:sub>
+                          <m:r>
+                            <a:rPr lang="en-US" sz="1600" i="1">
+                              <a:latin typeface="Cambria Math" panose="02040503050406030204" pitchFamily="18" charset="0"/>
+                            </a:rPr>
+                            <m:t>𝑏𝑎𝑡</m:t>
+                          </m:r>
+                        </m:sub>
+                      </m:sSub>
+                      <m:d>
+                        <m:dPr>
+                          <m:ctrlPr>
+                            <a:rPr lang="en-US" sz="1600" i="1">
+                              <a:latin typeface="Cambria Math" panose="02040503050406030204" pitchFamily="18" charset="0"/>
+                            </a:rPr>
+                          </m:ctrlPr>
+                        </m:dPr>
+                        <m:e>
+                          <m:r>
+                            <a:rPr lang="en-US" sz="1600" i="1">
+                              <a:latin typeface="Cambria Math" panose="02040503050406030204" pitchFamily="18" charset="0"/>
+                            </a:rPr>
+                            <m:t>𝑠</m:t>
+                          </m:r>
+                        </m:e>
+                      </m:d>
+                      <m:r>
+                        <a:rPr lang="en-US" sz="1600" b="0" i="1" smtClean="0">
+                          <a:latin typeface="Cambria Math" panose="02040503050406030204" pitchFamily="18" charset="0"/>
+                        </a:rPr>
+                        <m:t>+</m:t>
+                      </m:r>
+                      <m:f>
+                        <m:fPr>
+                          <m:ctrlPr>
+                            <a:rPr lang="en-US" sz="1600" b="0" i="1" smtClean="0">
+                              <a:latin typeface="Cambria Math" panose="02040503050406030204" pitchFamily="18" charset="0"/>
+                            </a:rPr>
+                          </m:ctrlPr>
+                        </m:fPr>
+                        <m:num>
+                          <m:r>
+                            <a:rPr lang="en-US" sz="1600" b="0" i="1" smtClean="0">
+                              <a:latin typeface="Cambria Math" panose="02040503050406030204" pitchFamily="18" charset="0"/>
+                            </a:rPr>
+                            <m:t>1</m:t>
+                          </m:r>
+                        </m:num>
+                        <m:den>
+                          <m:r>
+                            <a:rPr lang="en-US" sz="1600" b="0" i="1" smtClean="0">
+                              <a:latin typeface="Cambria Math" panose="02040503050406030204" pitchFamily="18" charset="0"/>
+                            </a:rPr>
+                            <m:t>𝑠𝐶</m:t>
+                          </m:r>
+                        </m:den>
+                      </m:f>
+                      <m:r>
+                        <a:rPr lang="en-US" sz="1600" b="0" i="1" smtClean="0">
+                          <a:latin typeface="Cambria Math" panose="02040503050406030204" pitchFamily="18" charset="0"/>
+                        </a:rPr>
+                        <m:t>∗</m:t>
+                      </m:r>
+                      <m:sSub>
+                        <m:sSubPr>
+                          <m:ctrlPr>
+                            <a:rPr lang="en-US" sz="1600" i="1">
+                              <a:latin typeface="Cambria Math" panose="02040503050406030204" pitchFamily="18" charset="0"/>
+                            </a:rPr>
+                          </m:ctrlPr>
+                        </m:sSubPr>
+                        <m:e>
+                          <m:r>
+                            <a:rPr lang="en-US" sz="1600" i="1">
+                              <a:latin typeface="Cambria Math" panose="02040503050406030204" pitchFamily="18" charset="0"/>
+                            </a:rPr>
+                            <m:t>𝐼</m:t>
+                          </m:r>
+                        </m:e>
+                        <m:sub>
+                          <m:r>
+                            <a:rPr lang="en-US" sz="1600" i="1">
+                              <a:latin typeface="Cambria Math" panose="02040503050406030204" pitchFamily="18" charset="0"/>
+                            </a:rPr>
+                            <m:t>𝑏𝑎𝑡</m:t>
+                          </m:r>
+                        </m:sub>
+                      </m:sSub>
+                      <m:d>
+                        <m:dPr>
+                          <m:ctrlPr>
+                            <a:rPr lang="en-US" sz="1600" i="1">
+                              <a:latin typeface="Cambria Math" panose="02040503050406030204" pitchFamily="18" charset="0"/>
+                            </a:rPr>
+                          </m:ctrlPr>
+                        </m:dPr>
+                        <m:e>
+                          <m:r>
+                            <a:rPr lang="en-US" sz="1600" i="1">
+                              <a:latin typeface="Cambria Math" panose="02040503050406030204" pitchFamily="18" charset="0"/>
+                            </a:rPr>
+                            <m:t>𝑠</m:t>
+                          </m:r>
+                        </m:e>
+                      </m:d>
+                    </m:oMath>
+                  </m:oMathPara>
+                </a14:m>
+                <a:endParaRPr lang="en-US" dirty="0"/>
+              </a:p>
+            </p:txBody>
+          </p:sp>
+        </mc:Choice>
+        <mc:Fallback>
+          <p:sp>
+            <p:nvSpPr>
+              <p:cNvPr id="7" name="TextBox 6">
+                <a:extLst>
+                  <a:ext uri="{FF2B5EF4-FFF2-40B4-BE49-F238E27FC236}">
+                    <a16:creationId xmlns:a16="http://schemas.microsoft.com/office/drawing/2014/main" id="{11BA93C1-3496-4F0D-76C1-0D2E2E8A1BFD}"/>
+                  </a:ext>
+                </a:extLst>
+              </p:cNvPr>
+              <p:cNvSpPr txBox="1">
+                <a:spLocks noRot="1" noChangeAspect="1" noMove="1" noResize="1" noEditPoints="1" noAdjustHandles="1" noChangeArrowheads="1" noChangeShapeType="1" noTextEdit="1"/>
+              </p:cNvSpPr>
+              <p:nvPr/>
+            </p:nvSpPr>
+            <p:spPr>
+              <a:xfrm>
+                <a:off x="325772" y="1497959"/>
+                <a:ext cx="5531135" cy="4686283"/>
+              </a:xfrm>
+              <a:prstGeom prst="rect">
+                <a:avLst/>
+              </a:prstGeom>
+              <a:blipFill>
+                <a:blip r:embed="rId2"/>
+                <a:stretch>
+                  <a:fillRect l="-881" t="-651"/>
+                </a:stretch>
+              </a:blipFill>
+            </p:spPr>
+            <p:txBody>
+              <a:bodyPr/>
+              <a:lstStyle/>
+              <a:p>
+                <a:r>
+                  <a:rPr lang="en-US">
+                    <a:noFill/>
+                  </a:rPr>
+                  <a:t> </a:t>
+                </a:r>
+              </a:p>
+            </p:txBody>
+          </p:sp>
+        </mc:Fallback>
+      </mc:AlternateContent>
+      <p:cxnSp>
+        <p:nvCxnSpPr>
+          <p:cNvPr id="9" name="Straight Connector 8">
+            <a:extLst>
+              <a:ext uri="{FF2B5EF4-FFF2-40B4-BE49-F238E27FC236}">
+                <a16:creationId xmlns:a16="http://schemas.microsoft.com/office/drawing/2014/main" id="{8DAC2D66-50C1-F0A9-1FC6-16809A242364}"/>
+              </a:ext>
+            </a:extLst>
+          </p:cNvPr>
+          <p:cNvCxnSpPr>
+            <a:stCxn id="5" idx="2"/>
+          </p:cNvCxnSpPr>
+          <p:nvPr/>
+        </p:nvCxnSpPr>
+        <p:spPr>
+          <a:xfrm>
+            <a:off x="6096000" y="1690688"/>
+            <a:ext cx="0" cy="4856919"/>
+          </a:xfrm>
+          <a:prstGeom prst="line">
+            <a:avLst/>
+          </a:prstGeom>
+          <a:ln>
+            <a:solidFill>
+              <a:schemeClr val="tx1"/>
+            </a:solidFill>
+          </a:ln>
+        </p:spPr>
+        <p:style>
+          <a:lnRef idx="2">
+            <a:schemeClr val="accent1"/>
+          </a:lnRef>
+          <a:fillRef idx="0">
+            <a:schemeClr val="accent1"/>
+          </a:fillRef>
+          <a:effectRef idx="1">
+            <a:schemeClr val="accent1"/>
+          </a:effectRef>
+          <a:fontRef idx="minor">
+            <a:schemeClr val="tx1"/>
+          </a:fontRef>
+        </p:style>
+      </p:cxnSp>
+      <mc:AlternateContent xmlns:mc="http://schemas.openxmlformats.org/markup-compatibility/2006">
+        <mc:Choice xmlns:a14="http://schemas.microsoft.com/office/drawing/2010/main" Requires="a14">
+          <p:sp>
+            <p:nvSpPr>
+              <p:cNvPr id="10" name="TextBox 9">
+                <a:extLst>
+                  <a:ext uri="{FF2B5EF4-FFF2-40B4-BE49-F238E27FC236}">
+                    <a16:creationId xmlns:a16="http://schemas.microsoft.com/office/drawing/2014/main" id="{9CC2C2A0-1288-55C5-849F-32904003E740}"/>
+                  </a:ext>
+                </a:extLst>
+              </p:cNvPr>
+              <p:cNvSpPr txBox="1"/>
+              <p:nvPr/>
+            </p:nvSpPr>
+            <p:spPr>
+              <a:xfrm>
+                <a:off x="6335093" y="1497959"/>
+                <a:ext cx="5531135" cy="4780539"/>
+              </a:xfrm>
+              <a:prstGeom prst="rect">
+                <a:avLst/>
+              </a:prstGeom>
+              <a:noFill/>
+            </p:spPr>
+            <p:txBody>
+              <a:bodyPr wrap="square">
+                <a:spAutoFit/>
+              </a:bodyPr>
+              <a:lstStyle/>
+              <a:p>
+                <a:r>
+                  <a:rPr lang="en-US" dirty="0"/>
+                  <a:t>Rewrite as a transfer function:</a:t>
+                </a:r>
+              </a:p>
+              <a:p>
+                <a:endParaRPr lang="en-US" dirty="0">
+                  <a:ea typeface="Cambria Math" panose="02040503050406030204" pitchFamily="18" charset="0"/>
+                </a:endParaRPr>
+              </a:p>
+              <a:p>
+                <a:pPr/>
+                <a14:m>
+                  <m:oMathPara xmlns:m="http://schemas.openxmlformats.org/officeDocument/2006/math">
+                    <m:oMathParaPr>
+                      <m:jc m:val="centerGroup"/>
+                    </m:oMathParaPr>
+                    <m:oMath xmlns:m="http://schemas.openxmlformats.org/officeDocument/2006/math">
+                      <m:sSub>
+                        <m:sSubPr>
+                          <m:ctrlPr>
+                            <a:rPr lang="en-US" b="0" i="1" smtClean="0">
+                              <a:latin typeface="Cambria Math" panose="02040503050406030204" pitchFamily="18" charset="0"/>
+                            </a:rPr>
+                          </m:ctrlPr>
+                        </m:sSubPr>
+                        <m:e>
+                          <m:r>
+                            <a:rPr lang="en-US" i="1" smtClean="0">
+                              <a:latin typeface="Cambria Math" panose="02040503050406030204" pitchFamily="18" charset="0"/>
+                            </a:rPr>
+                            <m:t>𝐺</m:t>
+                          </m:r>
+                        </m:e>
+                        <m:sub>
+                          <m:sSub>
+                            <m:sSubPr>
+                              <m:ctrlPr>
+                                <a:rPr lang="en-US" b="0" i="1" smtClean="0">
+                                  <a:latin typeface="Cambria Math" panose="02040503050406030204" pitchFamily="18" charset="0"/>
+                                </a:rPr>
+                              </m:ctrlPr>
+                            </m:sSubPr>
+                            <m:e>
+                              <m:r>
+                                <a:rPr lang="en-US" b="0" i="1" smtClean="0">
+                                  <a:latin typeface="Cambria Math" panose="02040503050406030204" pitchFamily="18" charset="0"/>
+                                </a:rPr>
+                                <m:t>𝐼</m:t>
+                              </m:r>
+                            </m:e>
+                            <m:sub>
+                              <m:r>
+                                <a:rPr lang="en-US" b="0" i="1" smtClean="0">
+                                  <a:latin typeface="Cambria Math" panose="02040503050406030204" pitchFamily="18" charset="0"/>
+                                </a:rPr>
+                                <m:t>𝑏𝑎𝑡</m:t>
+                              </m:r>
+                            </m:sub>
+                          </m:sSub>
+                          <m:r>
+                            <a:rPr lang="en-US" b="0" i="1" smtClean="0">
+                              <a:latin typeface="Cambria Math" panose="02040503050406030204" pitchFamily="18" charset="0"/>
+                            </a:rPr>
+                            <m:t>,</m:t>
+                          </m:r>
+                          <m:sSub>
+                            <m:sSubPr>
+                              <m:ctrlPr>
+                                <a:rPr lang="en-US" b="0" i="1" smtClean="0">
+                                  <a:latin typeface="Cambria Math" panose="02040503050406030204" pitchFamily="18" charset="0"/>
+                                </a:rPr>
+                              </m:ctrlPr>
+                            </m:sSubPr>
+                            <m:e>
+                              <m:r>
+                                <a:rPr lang="en-US" b="0" i="1" smtClean="0">
+                                  <a:latin typeface="Cambria Math" panose="02040503050406030204" pitchFamily="18" charset="0"/>
+                                </a:rPr>
+                                <m:t>𝑀</m:t>
+                              </m:r>
+                            </m:e>
+                            <m:sub>
+                              <m:r>
+                                <a:rPr lang="en-US" b="0" i="1" smtClean="0">
+                                  <a:latin typeface="Cambria Math" panose="02040503050406030204" pitchFamily="18" charset="0"/>
+                                </a:rPr>
+                                <m:t>𝑇</m:t>
+                              </m:r>
+                            </m:sub>
+                          </m:sSub>
+                        </m:sub>
+                      </m:sSub>
+                      <m:d>
+                        <m:dPr>
+                          <m:ctrlPr>
+                            <a:rPr lang="en-US" b="0" i="1" smtClean="0">
+                              <a:latin typeface="Cambria Math" panose="02040503050406030204" pitchFamily="18" charset="0"/>
+                            </a:rPr>
+                          </m:ctrlPr>
+                        </m:dPr>
+                        <m:e>
+                          <m:r>
+                            <a:rPr lang="en-US" b="0" i="1" smtClean="0">
+                              <a:latin typeface="Cambria Math" panose="02040503050406030204" pitchFamily="18" charset="0"/>
+                            </a:rPr>
+                            <m:t>𝑠</m:t>
+                          </m:r>
+                        </m:e>
+                      </m:d>
+                      <m:r>
+                        <a:rPr lang="en-US" b="0" i="1" smtClean="0">
+                          <a:latin typeface="Cambria Math" panose="02040503050406030204" pitchFamily="18" charset="0"/>
+                        </a:rPr>
+                        <m:t>=</m:t>
+                      </m:r>
+                      <m:f>
+                        <m:fPr>
+                          <m:ctrlPr>
+                            <a:rPr lang="en-US" b="0" i="1" smtClean="0">
+                              <a:latin typeface="Cambria Math" panose="02040503050406030204" pitchFamily="18" charset="0"/>
+                            </a:rPr>
+                          </m:ctrlPr>
+                        </m:fPr>
+                        <m:num>
+                          <m:r>
+                            <a:rPr lang="en-US" b="0" i="1" smtClean="0">
+                              <a:latin typeface="Cambria Math" panose="02040503050406030204" pitchFamily="18" charset="0"/>
+                            </a:rPr>
+                            <m:t>𝑠</m:t>
+                          </m:r>
+                          <m:sSub>
+                            <m:sSubPr>
+                              <m:ctrlPr>
+                                <a:rPr lang="en-US" b="0" i="1" smtClean="0">
+                                  <a:latin typeface="Cambria Math" panose="02040503050406030204" pitchFamily="18" charset="0"/>
+                                </a:rPr>
+                              </m:ctrlPr>
+                            </m:sSubPr>
+                            <m:e>
+                              <m:r>
+                                <a:rPr lang="en-US" b="0" i="1" smtClean="0">
+                                  <a:latin typeface="Cambria Math" panose="02040503050406030204" pitchFamily="18" charset="0"/>
+                                </a:rPr>
+                                <m:t>𝑉</m:t>
+                              </m:r>
+                            </m:e>
+                            <m:sub>
+                              <m:r>
+                                <a:rPr lang="en-US" b="0" i="1" smtClean="0">
+                                  <a:latin typeface="Cambria Math" panose="02040503050406030204" pitchFamily="18" charset="0"/>
+                                </a:rPr>
+                                <m:t>𝑔</m:t>
+                              </m:r>
+                            </m:sub>
+                          </m:sSub>
+                          <m:r>
+                            <a:rPr lang="en-US" b="0" i="1" smtClean="0">
+                              <a:latin typeface="Cambria Math" panose="02040503050406030204" pitchFamily="18" charset="0"/>
+                            </a:rPr>
+                            <m:t>𝐶</m:t>
+                          </m:r>
+                        </m:num>
+                        <m:den>
+                          <m:sSup>
+                            <m:sSupPr>
+                              <m:ctrlPr>
+                                <a:rPr lang="en-US" b="0" i="1" smtClean="0">
+                                  <a:latin typeface="Cambria Math" panose="02040503050406030204" pitchFamily="18" charset="0"/>
+                                </a:rPr>
+                              </m:ctrlPr>
+                            </m:sSupPr>
+                            <m:e>
+                              <m:r>
+                                <a:rPr lang="en-US" b="0" i="1" smtClean="0">
+                                  <a:latin typeface="Cambria Math" panose="02040503050406030204" pitchFamily="18" charset="0"/>
+                                </a:rPr>
+                                <m:t>𝑠</m:t>
+                              </m:r>
+                            </m:e>
+                            <m:sup>
+                              <m:r>
+                                <a:rPr lang="en-US" b="0" i="1" smtClean="0">
+                                  <a:latin typeface="Cambria Math" panose="02040503050406030204" pitchFamily="18" charset="0"/>
+                                </a:rPr>
+                                <m:t>2</m:t>
+                              </m:r>
+                            </m:sup>
+                          </m:sSup>
+                          <m:r>
+                            <a:rPr lang="en-US" b="0" i="1" smtClean="0">
+                              <a:latin typeface="Cambria Math" panose="02040503050406030204" pitchFamily="18" charset="0"/>
+                            </a:rPr>
+                            <m:t>𝐿</m:t>
+                          </m:r>
+                          <m:r>
+                            <a:rPr lang="en-US" b="0" i="1" smtClean="0">
+                              <a:latin typeface="Cambria Math" panose="02040503050406030204" pitchFamily="18" charset="0"/>
+                            </a:rPr>
+                            <m:t>𝐶</m:t>
+                          </m:r>
+                          <m:r>
+                            <a:rPr lang="en-US" b="0" i="1" smtClean="0">
+                              <a:latin typeface="Cambria Math" panose="02040503050406030204" pitchFamily="18" charset="0"/>
+                            </a:rPr>
+                            <m:t>+</m:t>
+                          </m:r>
+                          <m:r>
+                            <a:rPr lang="en-US" b="0" i="1" smtClean="0">
+                              <a:latin typeface="Cambria Math" panose="02040503050406030204" pitchFamily="18" charset="0"/>
+                            </a:rPr>
+                            <m:t>𝑠</m:t>
+                          </m:r>
+                          <m:r>
+                            <a:rPr lang="en-US" b="0" i="1" smtClean="0">
+                              <a:latin typeface="Cambria Math" panose="02040503050406030204" pitchFamily="18" charset="0"/>
+                            </a:rPr>
+                            <m:t>𝑅</m:t>
+                          </m:r>
+                          <m:r>
+                            <a:rPr lang="en-US" b="0" i="1" smtClean="0">
+                              <a:latin typeface="Cambria Math" panose="02040503050406030204" pitchFamily="18" charset="0"/>
+                            </a:rPr>
+                            <m:t>𝐶</m:t>
+                          </m:r>
+                          <m:r>
+                            <a:rPr lang="en-US" b="0" i="1" smtClean="0">
+                              <a:latin typeface="Cambria Math" panose="02040503050406030204" pitchFamily="18" charset="0"/>
+                            </a:rPr>
+                            <m:t>+1</m:t>
+                          </m:r>
+                        </m:den>
+                      </m:f>
+                    </m:oMath>
+                  </m:oMathPara>
+                </a14:m>
+                <a:endParaRPr lang="en-US" dirty="0">
+                  <a:latin typeface="Cambria Math" panose="02040503050406030204" pitchFamily="18" charset="0"/>
+                  <a:ea typeface="Cambria Math" panose="02040503050406030204" pitchFamily="18" charset="0"/>
+                </a:endParaRPr>
+              </a:p>
+              <a:p>
+                <a:endParaRPr lang="en-US" dirty="0">
+                  <a:ea typeface="Cambria Math" panose="02040503050406030204" pitchFamily="18" charset="0"/>
+                </a:endParaRPr>
+              </a:p>
+              <a:p>
+                <a:r>
+                  <a:rPr lang="en-US" dirty="0">
+                    <a:ea typeface="Cambria Math" panose="02040503050406030204" pitchFamily="18" charset="0"/>
+                  </a:rPr>
+                  <a:t>A little messier, but  this is once again a proper transfer function. Note the factor of </a:t>
+                </a:r>
+                <a:r>
+                  <a:rPr lang="en-US" dirty="0">
+                    <a:latin typeface="Cambria Math" panose="02040503050406030204" pitchFamily="18" charset="0"/>
+                    <a:ea typeface="Cambria Math" panose="02040503050406030204" pitchFamily="18" charset="0"/>
+                  </a:rPr>
+                  <a:t>s</a:t>
+                </a:r>
+                <a:r>
+                  <a:rPr lang="en-US" dirty="0">
+                    <a:ea typeface="Cambria Math" panose="02040503050406030204" pitchFamily="18" charset="0"/>
+                  </a:rPr>
+                  <a:t> in the numerator.</a:t>
+                </a:r>
+              </a:p>
+              <a:p>
+                <a:endParaRPr lang="en-US" dirty="0">
+                  <a:ea typeface="Cambria Math" panose="02040503050406030204" pitchFamily="18" charset="0"/>
+                </a:endParaRPr>
+              </a:p>
+              <a:p>
+                <a:r>
+                  <a:rPr lang="en-US" dirty="0">
+                    <a:ea typeface="Cambria Math" panose="02040503050406030204" pitchFamily="18" charset="0"/>
+                  </a:rPr>
+                  <a:t>Once again, we can combine the MT(t) to M(t) transformation and the electrical circuitry together and treat it as a singular linear system.</a:t>
+                </a:r>
+              </a:p>
+              <a:p>
+                <a:endParaRPr lang="en-US" dirty="0">
+                  <a:ea typeface="Cambria Math" panose="02040503050406030204" pitchFamily="18" charset="0"/>
+                </a:endParaRPr>
+              </a:p>
+              <a:p>
+                <a:r>
+                  <a:rPr lang="en-US" dirty="0">
+                    <a:ea typeface="Cambria Math" panose="02040503050406030204" pitchFamily="18" charset="0"/>
+                  </a:rPr>
+                  <a:t>While I was able to skip over many steps since the approach is similar, this idea of PI2 control seems to be significantly simpler, even if the transfer function looks more complicated. So why not use this method? Let’s test them out…</a:t>
+                </a:r>
+              </a:p>
+            </p:txBody>
+          </p:sp>
+        </mc:Choice>
+        <mc:Fallback>
+          <p:sp>
+            <p:nvSpPr>
+              <p:cNvPr id="10" name="TextBox 9">
+                <a:extLst>
+                  <a:ext uri="{FF2B5EF4-FFF2-40B4-BE49-F238E27FC236}">
+                    <a16:creationId xmlns:a16="http://schemas.microsoft.com/office/drawing/2014/main" id="{9CC2C2A0-1288-55C5-849F-32904003E740}"/>
+                  </a:ext>
+                </a:extLst>
+              </p:cNvPr>
+              <p:cNvSpPr txBox="1">
+                <a:spLocks noRot="1" noChangeAspect="1" noMove="1" noResize="1" noEditPoints="1" noAdjustHandles="1" noChangeArrowheads="1" noChangeShapeType="1" noTextEdit="1"/>
+              </p:cNvSpPr>
+              <p:nvPr/>
+            </p:nvSpPr>
+            <p:spPr>
+              <a:xfrm>
+                <a:off x="6335093" y="1497959"/>
+                <a:ext cx="5531135" cy="4780539"/>
+              </a:xfrm>
+              <a:prstGeom prst="rect">
+                <a:avLst/>
+              </a:prstGeom>
+              <a:blipFill>
+                <a:blip r:embed="rId3"/>
+                <a:stretch>
+                  <a:fillRect l="-881" t="-638" r="-1542" b="-1148"/>
+                </a:stretch>
+              </a:blipFill>
+            </p:spPr>
+            <p:txBody>
+              <a:bodyPr/>
+              <a:lstStyle/>
+              <a:p>
+                <a:r>
+                  <a:rPr lang="en-US">
+                    <a:noFill/>
+                  </a:rPr>
+                  <a:t> </a:t>
+                </a:r>
+              </a:p>
+            </p:txBody>
+          </p:sp>
+        </mc:Fallback>
+      </mc:AlternateContent>
+      <p:sp>
+        <p:nvSpPr>
+          <p:cNvPr id="11" name="Rectangle 10">
+            <a:extLst>
+              <a:ext uri="{FF2B5EF4-FFF2-40B4-BE49-F238E27FC236}">
+                <a16:creationId xmlns:a16="http://schemas.microsoft.com/office/drawing/2014/main" id="{1E82F90F-1E75-FED1-B98D-0D2AF13FDAFF}"/>
+              </a:ext>
+            </a:extLst>
+          </p:cNvPr>
+          <p:cNvSpPr/>
+          <p:nvPr/>
+        </p:nvSpPr>
+        <p:spPr>
+          <a:xfrm>
+            <a:off x="7558480" y="2009162"/>
+            <a:ext cx="3095537" cy="814359"/>
+          </a:xfrm>
+          <a:prstGeom prst="rect">
+            <a:avLst/>
+          </a:prstGeom>
+          <a:noFill/>
+          <a:ln>
+            <a:solidFill>
+              <a:schemeClr val="tx1"/>
+            </a:solidFill>
+          </a:ln>
+        </p:spPr>
+        <p:style>
+          <a:lnRef idx="2">
+            <a:schemeClr val="accent1">
+              <a:shade val="15000"/>
+            </a:schemeClr>
+          </a:lnRef>
+          <a:fillRef idx="1">
+            <a:schemeClr val="accent1"/>
+          </a:fillRef>
+          <a:effectRef idx="0">
+            <a:schemeClr val="accent1"/>
+          </a:effectRef>
+          <a:fontRef idx="minor">
+            <a:schemeClr val="lt1"/>
+          </a:fontRef>
+        </p:style>
+        <p:txBody>
+          <a:bodyPr rtlCol="0" anchor="ctr"/>
+          <a:lstStyle/>
+          <a:p>
+            <a:pPr algn="ctr"/>
+            <a:endParaRPr lang="en-US"/>
           </a:p>
         </p:txBody>
       </p:sp>
     </p:spTree>
     <p:extLst>
       <p:ext uri="{BB962C8B-B14F-4D97-AF65-F5344CB8AC3E}">
-        <p14:creationId xmlns:p14="http://schemas.microsoft.com/office/powerpoint/2010/main" val="3230319517"/>
+        <p14:creationId xmlns:p14="http://schemas.microsoft.com/office/powerpoint/2010/main" val="768466325"/>
+      </p:ext>
+    </p:extLst>
+  </p:cSld>
+  <p:clrMapOvr>
+    <a:masterClrMapping/>
+  </p:clrMapOvr>
+</p:sld>
+</file>
+
+<file path=ppt/slides/slide11.xml><?xml version="1.0" encoding="utf-8"?>
+<p:sld xmlns:a="http://schemas.openxmlformats.org/drawingml/2006/main" xmlns:r="http://schemas.openxmlformats.org/officeDocument/2006/relationships" xmlns:p="http://schemas.openxmlformats.org/presentationml/2006/main">
+  <p:cSld>
+    <p:spTree>
+      <p:nvGrpSpPr>
+        <p:cNvPr id="1" name=""/>
+        <p:cNvGrpSpPr/>
+        <p:nvPr/>
+      </p:nvGrpSpPr>
+      <p:grpSpPr>
+        <a:xfrm>
+          <a:off x="0" y="0"/>
+          <a:ext cx="0" cy="0"/>
+          <a:chOff x="0" y="0"/>
+          <a:chExt cx="0" cy="0"/>
+        </a:xfrm>
+      </p:grpSpPr>
+      <p:sp>
+        <p:nvSpPr>
+          <p:cNvPr id="2" name="Title 1">
+            <a:extLst>
+              <a:ext uri="{FF2B5EF4-FFF2-40B4-BE49-F238E27FC236}">
+                <a16:creationId xmlns:a16="http://schemas.microsoft.com/office/drawing/2014/main" id="{28E3391F-3485-155F-C93A-C476DA50C062}"/>
+              </a:ext>
+            </a:extLst>
+          </p:cNvPr>
+          <p:cNvSpPr>
+            <a:spLocks noGrp="1"/>
+          </p:cNvSpPr>
+          <p:nvPr>
+            <p:ph type="title"/>
+          </p:nvPr>
+        </p:nvSpPr>
+        <p:spPr/>
+        <p:txBody>
+          <a:bodyPr/>
+          <a:lstStyle/>
+          <a:p>
+            <a:r>
+              <a:rPr lang="en-US" dirty="0"/>
+              <a:t>PLECS Analysis: Toy Models</a:t>
+            </a:r>
+          </a:p>
+        </p:txBody>
+      </p:sp>
+      <p:sp>
+        <p:nvSpPr>
+          <p:cNvPr id="5" name="Rectangle: Rounded Corners 4">
+            <a:extLst>
+              <a:ext uri="{FF2B5EF4-FFF2-40B4-BE49-F238E27FC236}">
+                <a16:creationId xmlns:a16="http://schemas.microsoft.com/office/drawing/2014/main" id="{2317F896-A6A8-7396-0E56-9C521DD695E8}"/>
+              </a:ext>
+            </a:extLst>
+          </p:cNvPr>
+          <p:cNvSpPr/>
+          <p:nvPr/>
+        </p:nvSpPr>
+        <p:spPr>
+          <a:xfrm>
+            <a:off x="3171265" y="1573306"/>
+            <a:ext cx="5849471" cy="3953435"/>
+          </a:xfrm>
+          <a:prstGeom prst="roundRect">
+            <a:avLst>
+              <a:gd name="adj" fmla="val 3299"/>
+            </a:avLst>
+          </a:prstGeom>
+          <a:noFill/>
+          <a:ln w="38100">
+            <a:solidFill>
+              <a:schemeClr val="tx1"/>
+            </a:solidFill>
+          </a:ln>
+        </p:spPr>
+        <p:style>
+          <a:lnRef idx="2">
+            <a:schemeClr val="accent1">
+              <a:shade val="15000"/>
+            </a:schemeClr>
+          </a:lnRef>
+          <a:fillRef idx="1">
+            <a:schemeClr val="accent1"/>
+          </a:fillRef>
+          <a:effectRef idx="0">
+            <a:schemeClr val="accent1"/>
+          </a:effectRef>
+          <a:fontRef idx="minor">
+            <a:schemeClr val="lt1"/>
+          </a:fontRef>
+        </p:style>
+        <p:txBody>
+          <a:bodyPr rtlCol="0" anchor="ctr"/>
+          <a:lstStyle/>
+          <a:p>
+            <a:pPr algn="ctr"/>
+            <a:endParaRPr lang="en-US"/>
+          </a:p>
+        </p:txBody>
+      </p:sp>
+      <p:grpSp>
+        <p:nvGrpSpPr>
+          <p:cNvPr id="12" name="Group 11">
+            <a:extLst>
+              <a:ext uri="{FF2B5EF4-FFF2-40B4-BE49-F238E27FC236}">
+                <a16:creationId xmlns:a16="http://schemas.microsoft.com/office/drawing/2014/main" id="{0A0FBBB6-6D20-DB02-303F-5CE62C56D1B9}"/>
+              </a:ext>
+            </a:extLst>
+          </p:cNvPr>
+          <p:cNvGrpSpPr/>
+          <p:nvPr/>
+        </p:nvGrpSpPr>
+        <p:grpSpPr>
+          <a:xfrm>
+            <a:off x="3237262" y="1573306"/>
+            <a:ext cx="5717477" cy="3827928"/>
+            <a:chOff x="3092822" y="1573306"/>
+            <a:chExt cx="5717477" cy="3827928"/>
+          </a:xfrm>
+        </p:grpSpPr>
+        <p:pic>
+          <p:nvPicPr>
+            <p:cNvPr id="4" name="Picture 3">
+              <a:extLst>
+                <a:ext uri="{FF2B5EF4-FFF2-40B4-BE49-F238E27FC236}">
+                  <a16:creationId xmlns:a16="http://schemas.microsoft.com/office/drawing/2014/main" id="{B6DA89FE-6DB1-A429-3010-B776E4A75C82}"/>
+                </a:ext>
+              </a:extLst>
+            </p:cNvPr>
+            <p:cNvPicPr>
+              <a:picLocks noChangeAspect="1"/>
+            </p:cNvPicPr>
+            <p:nvPr/>
+          </p:nvPicPr>
+          <p:blipFill>
+            <a:blip r:embed="rId2"/>
+            <a:stretch>
+              <a:fillRect/>
+            </a:stretch>
+          </p:blipFill>
+          <p:spPr>
+            <a:xfrm>
+              <a:off x="3092822" y="1883997"/>
+              <a:ext cx="5717477" cy="3517237"/>
+            </a:xfrm>
+            <a:prstGeom prst="rect">
+              <a:avLst/>
+            </a:prstGeom>
+          </p:spPr>
+        </p:pic>
+        <p:sp>
+          <p:nvSpPr>
+            <p:cNvPr id="6" name="TextBox 5">
+              <a:extLst>
+                <a:ext uri="{FF2B5EF4-FFF2-40B4-BE49-F238E27FC236}">
+                  <a16:creationId xmlns:a16="http://schemas.microsoft.com/office/drawing/2014/main" id="{B6C71747-CF38-A3D3-CA88-83400E2578CC}"/>
+                </a:ext>
+              </a:extLst>
+            </p:cNvPr>
+            <p:cNvSpPr txBox="1"/>
+            <p:nvPr/>
+          </p:nvSpPr>
+          <p:spPr>
+            <a:xfrm>
+              <a:off x="4217342" y="1573306"/>
+              <a:ext cx="4586064" cy="338554"/>
+            </a:xfrm>
+            <a:prstGeom prst="rect">
+              <a:avLst/>
+            </a:prstGeom>
+            <a:noFill/>
+          </p:spPr>
+          <p:txBody>
+            <a:bodyPr wrap="none" rtlCol="0">
+              <a:spAutoFit/>
+            </a:bodyPr>
+            <a:lstStyle/>
+            <a:p>
+              <a:pPr algn="r"/>
+              <a:r>
+                <a:rPr lang="en-US" sz="1600" b="1" dirty="0"/>
+                <a:t>Toy Model Simulation as of Making These Slides</a:t>
+              </a:r>
+            </a:p>
+          </p:txBody>
+        </p:sp>
+      </p:grpSp>
+      <p:sp>
+        <p:nvSpPr>
+          <p:cNvPr id="7" name="TextBox 6">
+            <a:extLst>
+              <a:ext uri="{FF2B5EF4-FFF2-40B4-BE49-F238E27FC236}">
+                <a16:creationId xmlns:a16="http://schemas.microsoft.com/office/drawing/2014/main" id="{4DDFF5B0-E04B-2C23-D363-89A00A0FA365}"/>
+              </a:ext>
+            </a:extLst>
+          </p:cNvPr>
+          <p:cNvSpPr txBox="1"/>
+          <p:nvPr/>
+        </p:nvSpPr>
+        <p:spPr>
+          <a:xfrm>
+            <a:off x="9119162" y="1690688"/>
+            <a:ext cx="2900082" cy="923330"/>
+          </a:xfrm>
+          <a:prstGeom prst="rect">
+            <a:avLst/>
+          </a:prstGeom>
+          <a:noFill/>
+        </p:spPr>
+        <p:txBody>
+          <a:bodyPr wrap="square" rtlCol="0">
+            <a:spAutoFit/>
+          </a:bodyPr>
+          <a:lstStyle/>
+          <a:p>
+            <a:r>
+              <a:rPr lang="en-US" dirty="0"/>
+              <a:t>In GitHub repository, under </a:t>
+            </a:r>
+            <a:r>
+              <a:rPr lang="en-US" dirty="0" err="1">
+                <a:latin typeface="Courier New" panose="02070309020205020404" pitchFamily="49" charset="0"/>
+                <a:cs typeface="Courier New" panose="02070309020205020404" pitchFamily="49" charset="0"/>
+              </a:rPr>
+              <a:t>Sims_and_Design</a:t>
+            </a:r>
+            <a:r>
+              <a:rPr lang="en-US" dirty="0">
+                <a:latin typeface="Courier New" panose="02070309020205020404" pitchFamily="49" charset="0"/>
+                <a:cs typeface="Courier New" panose="02070309020205020404" pitchFamily="49" charset="0"/>
+              </a:rPr>
+              <a:t> </a:t>
+            </a:r>
+            <a:r>
+              <a:rPr lang="en-US" dirty="0"/>
+              <a:t>folder</a:t>
+            </a:r>
+          </a:p>
+        </p:txBody>
+      </p:sp>
+      <p:cxnSp>
+        <p:nvCxnSpPr>
+          <p:cNvPr id="8" name="Connector: Elbow 7">
+            <a:extLst>
+              <a:ext uri="{FF2B5EF4-FFF2-40B4-BE49-F238E27FC236}">
+                <a16:creationId xmlns:a16="http://schemas.microsoft.com/office/drawing/2014/main" id="{551E9B59-2240-158E-FBB0-5E62D8FF27B7}"/>
+              </a:ext>
+            </a:extLst>
+          </p:cNvPr>
+          <p:cNvCxnSpPr>
+            <a:cxnSpLocks/>
+          </p:cNvCxnSpPr>
+          <p:nvPr/>
+        </p:nvCxnSpPr>
+        <p:spPr>
+          <a:xfrm rot="16200000" flipH="1" flipV="1">
+            <a:off x="9122089" y="2623824"/>
+            <a:ext cx="298948" cy="298948"/>
+          </a:xfrm>
+          <a:prstGeom prst="bentConnector2">
+            <a:avLst/>
+          </a:prstGeom>
+          <a:ln>
+            <a:solidFill>
+              <a:schemeClr val="tx1"/>
+            </a:solidFill>
+            <a:tailEnd type="triangle"/>
+          </a:ln>
+        </p:spPr>
+        <p:style>
+          <a:lnRef idx="2">
+            <a:schemeClr val="accent1"/>
+          </a:lnRef>
+          <a:fillRef idx="0">
+            <a:schemeClr val="accent1"/>
+          </a:fillRef>
+          <a:effectRef idx="1">
+            <a:schemeClr val="accent1"/>
+          </a:effectRef>
+          <a:fontRef idx="minor">
+            <a:schemeClr val="tx1"/>
+          </a:fontRef>
+        </p:style>
+      </p:cxnSp>
+      <p:sp>
+        <p:nvSpPr>
+          <p:cNvPr id="9" name="TextBox 8">
+            <a:extLst>
+              <a:ext uri="{FF2B5EF4-FFF2-40B4-BE49-F238E27FC236}">
+                <a16:creationId xmlns:a16="http://schemas.microsoft.com/office/drawing/2014/main" id="{10C1C7D6-2CC5-B797-3DAC-2A911FA9AE01}"/>
+              </a:ext>
+            </a:extLst>
+          </p:cNvPr>
+          <p:cNvSpPr txBox="1"/>
+          <p:nvPr/>
+        </p:nvSpPr>
+        <p:spPr>
+          <a:xfrm>
+            <a:off x="1489002" y="5969655"/>
+            <a:ext cx="9213997" cy="523220"/>
+          </a:xfrm>
+          <a:prstGeom prst="rect">
+            <a:avLst/>
+          </a:prstGeom>
+          <a:noFill/>
+        </p:spPr>
+        <p:txBody>
+          <a:bodyPr wrap="none" rtlCol="0">
+            <a:spAutoFit/>
+          </a:bodyPr>
+          <a:lstStyle/>
+          <a:p>
+            <a:r>
+              <a:rPr lang="en-US" sz="2800" u="sng" dirty="0"/>
+              <a:t>In case you didn’t know yet, this is what everything is about</a:t>
+            </a:r>
+          </a:p>
+        </p:txBody>
+      </p:sp>
+      <p:sp>
+        <p:nvSpPr>
+          <p:cNvPr id="11" name="TextBox 10">
+            <a:extLst>
+              <a:ext uri="{FF2B5EF4-FFF2-40B4-BE49-F238E27FC236}">
+                <a16:creationId xmlns:a16="http://schemas.microsoft.com/office/drawing/2014/main" id="{9EA43E05-B3F0-A174-1F5B-FCDA0FBD5A90}"/>
+              </a:ext>
+            </a:extLst>
+          </p:cNvPr>
+          <p:cNvSpPr txBox="1"/>
+          <p:nvPr/>
+        </p:nvSpPr>
+        <p:spPr>
+          <a:xfrm>
+            <a:off x="3956108" y="5659482"/>
+            <a:ext cx="4279784" cy="369332"/>
+          </a:xfrm>
+          <a:prstGeom prst="rect">
+            <a:avLst/>
+          </a:prstGeom>
+          <a:noFill/>
+        </p:spPr>
+        <p:txBody>
+          <a:bodyPr wrap="square">
+            <a:spAutoFit/>
+          </a:bodyPr>
+          <a:lstStyle/>
+          <a:p>
+            <a:pPr algn="ctr"/>
+            <a:r>
+              <a:rPr lang="en-US" dirty="0"/>
+              <a:t>Power Stage Simulation - Toy </a:t>
+            </a:r>
+            <a:r>
+              <a:rPr lang="en-US" dirty="0" err="1"/>
+              <a:t>Model.plecs</a:t>
+            </a:r>
+            <a:endParaRPr lang="en-US" dirty="0"/>
+          </a:p>
+        </p:txBody>
+      </p:sp>
+      <p:sp>
+        <p:nvSpPr>
+          <p:cNvPr id="13" name="TextBox 12">
+            <a:extLst>
+              <a:ext uri="{FF2B5EF4-FFF2-40B4-BE49-F238E27FC236}">
+                <a16:creationId xmlns:a16="http://schemas.microsoft.com/office/drawing/2014/main" id="{4D9623C1-D480-BBC5-9C30-937B59B6200D}"/>
+              </a:ext>
+            </a:extLst>
+          </p:cNvPr>
+          <p:cNvSpPr txBox="1"/>
+          <p:nvPr/>
+        </p:nvSpPr>
+        <p:spPr>
+          <a:xfrm>
+            <a:off x="251668" y="2967335"/>
+            <a:ext cx="2676089" cy="923330"/>
+          </a:xfrm>
+          <a:prstGeom prst="rect">
+            <a:avLst/>
+          </a:prstGeom>
+          <a:noFill/>
+        </p:spPr>
+        <p:txBody>
+          <a:bodyPr wrap="square" rtlCol="0">
+            <a:spAutoFit/>
+          </a:bodyPr>
+          <a:lstStyle/>
+          <a:p>
+            <a:r>
+              <a:rPr lang="en-US" dirty="0"/>
+              <a:t>Message me (Egan) if you don’t understand a section of this model</a:t>
+            </a:r>
+          </a:p>
+        </p:txBody>
+      </p:sp>
+    </p:spTree>
+    <p:extLst>
+      <p:ext uri="{BB962C8B-B14F-4D97-AF65-F5344CB8AC3E}">
+        <p14:creationId xmlns:p14="http://schemas.microsoft.com/office/powerpoint/2010/main" val="1204917875"/>
+      </p:ext>
+    </p:extLst>
+  </p:cSld>
+  <p:clrMapOvr>
+    <a:masterClrMapping/>
+  </p:clrMapOvr>
+</p:sld>
+</file>
+
+<file path=ppt/slides/slide12.xml><?xml version="1.0" encoding="utf-8"?>
+<p:sld xmlns:a="http://schemas.openxmlformats.org/drawingml/2006/main" xmlns:r="http://schemas.openxmlformats.org/officeDocument/2006/relationships" xmlns:p="http://schemas.openxmlformats.org/presentationml/2006/main">
+  <p:cSld>
+    <p:spTree>
+      <p:nvGrpSpPr>
+        <p:cNvPr id="1" name=""/>
+        <p:cNvGrpSpPr/>
+        <p:nvPr/>
+      </p:nvGrpSpPr>
+      <p:grpSpPr>
+        <a:xfrm>
+          <a:off x="0" y="0"/>
+          <a:ext cx="0" cy="0"/>
+          <a:chOff x="0" y="0"/>
+          <a:chExt cx="0" cy="0"/>
+        </a:xfrm>
+      </p:grpSpPr>
+      <p:sp>
+        <p:nvSpPr>
+          <p:cNvPr id="2" name="Title 1">
+            <a:extLst>
+              <a:ext uri="{FF2B5EF4-FFF2-40B4-BE49-F238E27FC236}">
+                <a16:creationId xmlns:a16="http://schemas.microsoft.com/office/drawing/2014/main" id="{1B0D5010-5C1B-5283-9C9F-83368CF66D34}"/>
+              </a:ext>
+            </a:extLst>
+          </p:cNvPr>
+          <p:cNvSpPr>
+            <a:spLocks noGrp="1"/>
+          </p:cNvSpPr>
+          <p:nvPr>
+            <p:ph type="title"/>
+          </p:nvPr>
+        </p:nvSpPr>
+        <p:spPr/>
+        <p:txBody>
+          <a:bodyPr/>
+          <a:lstStyle/>
+          <a:p>
+            <a:r>
+              <a:rPr lang="en-US" dirty="0"/>
+              <a:t>Time-Domain Analysis</a:t>
+            </a:r>
+          </a:p>
+        </p:txBody>
+      </p:sp>
+      <p:pic>
+        <p:nvPicPr>
+          <p:cNvPr id="12" name="Picture 11">
+            <a:extLst>
+              <a:ext uri="{FF2B5EF4-FFF2-40B4-BE49-F238E27FC236}">
+                <a16:creationId xmlns:a16="http://schemas.microsoft.com/office/drawing/2014/main" id="{BB053A28-FC77-FB2C-FFBB-56E0D89968FB}"/>
+              </a:ext>
+            </a:extLst>
+          </p:cNvPr>
+          <p:cNvPicPr>
+            <a:picLocks noChangeAspect="1"/>
+          </p:cNvPicPr>
+          <p:nvPr/>
+        </p:nvPicPr>
+        <p:blipFill>
+          <a:blip r:embed="rId2"/>
+          <a:stretch>
+            <a:fillRect/>
+          </a:stretch>
+        </p:blipFill>
+        <p:spPr>
+          <a:xfrm>
+            <a:off x="739589" y="1402976"/>
+            <a:ext cx="10910047" cy="5285931"/>
+          </a:xfrm>
+          <a:prstGeom prst="rect">
+            <a:avLst/>
+          </a:prstGeom>
+        </p:spPr>
+      </p:pic>
+      <p:sp>
+        <p:nvSpPr>
+          <p:cNvPr id="13" name="TextBox 12">
+            <a:extLst>
+              <a:ext uri="{FF2B5EF4-FFF2-40B4-BE49-F238E27FC236}">
+                <a16:creationId xmlns:a16="http://schemas.microsoft.com/office/drawing/2014/main" id="{03DD057F-5EED-B2E4-67A4-3B6F26E9A445}"/>
+              </a:ext>
+            </a:extLst>
+          </p:cNvPr>
+          <p:cNvSpPr txBox="1"/>
+          <p:nvPr/>
+        </p:nvSpPr>
+        <p:spPr>
+          <a:xfrm>
+            <a:off x="9082425" y="1581071"/>
+            <a:ext cx="2562305" cy="369332"/>
+          </a:xfrm>
+          <a:prstGeom prst="rect">
+            <a:avLst/>
+          </a:prstGeom>
+          <a:noFill/>
+        </p:spPr>
+        <p:txBody>
+          <a:bodyPr wrap="none" rtlCol="0">
+            <a:spAutoFit/>
+          </a:bodyPr>
+          <a:lstStyle/>
+          <a:p>
+            <a:r>
+              <a:rPr lang="en-US" dirty="0">
+                <a:solidFill>
+                  <a:srgbClr val="00A3EB"/>
+                </a:solidFill>
+              </a:rPr>
+              <a:t>Constant Target Current</a:t>
+            </a:r>
+          </a:p>
+        </p:txBody>
+      </p:sp>
+      <p:sp>
+        <p:nvSpPr>
+          <p:cNvPr id="14" name="TextBox 13">
+            <a:extLst>
+              <a:ext uri="{FF2B5EF4-FFF2-40B4-BE49-F238E27FC236}">
+                <a16:creationId xmlns:a16="http://schemas.microsoft.com/office/drawing/2014/main" id="{5B62A6E5-7064-6B33-6E4D-B02F14A0CF56}"/>
+              </a:ext>
+            </a:extLst>
+          </p:cNvPr>
+          <p:cNvSpPr txBox="1"/>
+          <p:nvPr/>
+        </p:nvSpPr>
+        <p:spPr>
+          <a:xfrm>
+            <a:off x="8526089" y="624840"/>
+            <a:ext cx="3123547" cy="646331"/>
+          </a:xfrm>
+          <a:prstGeom prst="rect">
+            <a:avLst/>
+          </a:prstGeom>
+          <a:noFill/>
+        </p:spPr>
+        <p:txBody>
+          <a:bodyPr wrap="none" rtlCol="0">
+            <a:spAutoFit/>
+          </a:bodyPr>
+          <a:lstStyle/>
+          <a:p>
+            <a:pPr algn="r"/>
+            <a:r>
+              <a:rPr lang="en-US" dirty="0"/>
+              <a:t>FF+PI performance is in </a:t>
+            </a:r>
+            <a:r>
+              <a:rPr lang="en-US" dirty="0">
+                <a:solidFill>
+                  <a:srgbClr val="00B050"/>
+                </a:solidFill>
+              </a:rPr>
+              <a:t>green</a:t>
+            </a:r>
+          </a:p>
+          <a:p>
+            <a:pPr algn="r"/>
+            <a:r>
+              <a:rPr lang="en-US" dirty="0"/>
+              <a:t>PI</a:t>
+            </a:r>
+            <a:r>
+              <a:rPr lang="en-US" baseline="30000" dirty="0"/>
+              <a:t>2</a:t>
+            </a:r>
+            <a:r>
+              <a:rPr lang="en-US" dirty="0"/>
+              <a:t> performance is in </a:t>
+            </a:r>
+            <a:r>
+              <a:rPr lang="en-US" dirty="0">
+                <a:solidFill>
+                  <a:srgbClr val="FF0000"/>
+                </a:solidFill>
+              </a:rPr>
+              <a:t>red</a:t>
+            </a:r>
+          </a:p>
+        </p:txBody>
+      </p:sp>
+      <p:sp>
+        <p:nvSpPr>
+          <p:cNvPr id="15" name="TextBox 14">
+            <a:extLst>
+              <a:ext uri="{FF2B5EF4-FFF2-40B4-BE49-F238E27FC236}">
+                <a16:creationId xmlns:a16="http://schemas.microsoft.com/office/drawing/2014/main" id="{7ED8E646-A6E0-8BD1-91DE-71F759A6219B}"/>
+              </a:ext>
+            </a:extLst>
+          </p:cNvPr>
+          <p:cNvSpPr txBox="1"/>
+          <p:nvPr/>
+        </p:nvSpPr>
+        <p:spPr>
+          <a:xfrm>
+            <a:off x="5790318" y="1666833"/>
+            <a:ext cx="3286760" cy="923330"/>
+          </a:xfrm>
+          <a:prstGeom prst="rect">
+            <a:avLst/>
+          </a:prstGeom>
+          <a:noFill/>
+          <a:ln>
+            <a:solidFill>
+              <a:schemeClr val="tx1"/>
+            </a:solidFill>
+          </a:ln>
+        </p:spPr>
+        <p:txBody>
+          <a:bodyPr wrap="square" rtlCol="0">
+            <a:spAutoFit/>
+          </a:bodyPr>
+          <a:lstStyle/>
+          <a:p>
+            <a:r>
+              <a:rPr lang="en-US" dirty="0"/>
+              <a:t>You can’t see it here, but the </a:t>
+            </a:r>
+            <a:r>
+              <a:rPr lang="en-US" dirty="0">
+                <a:solidFill>
+                  <a:srgbClr val="00B050"/>
+                </a:solidFill>
+              </a:rPr>
+              <a:t>FF+PI current waveform </a:t>
+            </a:r>
+            <a:r>
+              <a:rPr lang="en-US" dirty="0"/>
+              <a:t>is overlapping the </a:t>
+            </a:r>
+            <a:r>
+              <a:rPr lang="en-US" dirty="0">
+                <a:solidFill>
+                  <a:srgbClr val="00A3EB"/>
+                </a:solidFill>
+              </a:rPr>
+              <a:t>target current </a:t>
+            </a:r>
+          </a:p>
+        </p:txBody>
+      </p:sp>
+    </p:spTree>
+    <p:extLst>
+      <p:ext uri="{BB962C8B-B14F-4D97-AF65-F5344CB8AC3E}">
+        <p14:creationId xmlns:p14="http://schemas.microsoft.com/office/powerpoint/2010/main" val="1141221441"/>
       </p:ext>
     </p:extLst>
   </p:cSld>
@@ -6638,8 +9671,8 @@
           </a:p>
         </p:txBody>
       </p:sp>
-      <mc:AlternateContent xmlns:mc="http://schemas.openxmlformats.org/markup-compatibility/2006" xmlns:a14="http://schemas.microsoft.com/office/drawing/2010/main">
-        <mc:Choice Requires="a14">
+      <mc:AlternateContent xmlns:mc="http://schemas.openxmlformats.org/markup-compatibility/2006">
+        <mc:Choice xmlns:a14="http://schemas.microsoft.com/office/drawing/2010/main" Requires="a14">
           <p:sp>
             <p:nvSpPr>
               <p:cNvPr id="4" name="Text Placeholder 3">
@@ -6700,7 +9733,7 @@
               <a:p>
                 <a:r>
                   <a:rPr lang="en-US" dirty="0"/>
-                  <a:t>Write the equation:</a:t>
+                  <a:t>Write the KVL equation*:</a:t>
                 </a:r>
               </a:p>
               <a:p>
@@ -7041,10 +10074,148 @@
                 </a14:m>
                 <a:endParaRPr lang="en-US" dirty="0"/>
               </a:p>
+              <a:p>
+                <a:pPr/>
+                <a:endParaRPr lang="en-US" dirty="0"/>
+              </a:p>
+              <a:p>
+                <a:pPr/>
+                <a:r>
+                  <a:rPr lang="en-US" sz="800" dirty="0"/>
+                  <a:t>*before you ask, yes, this calculation ignores the </a:t>
+                </a:r>
+                <a14:m>
+                  <m:oMath xmlns:m="http://schemas.openxmlformats.org/officeDocument/2006/math">
+                    <m:f>
+                      <m:fPr>
+                        <m:ctrlPr>
+                          <a:rPr lang="en-US" sz="800" i="1">
+                            <a:latin typeface="Cambria Math" panose="02040503050406030204" pitchFamily="18" charset="0"/>
+                          </a:rPr>
+                        </m:ctrlPr>
+                      </m:fPr>
+                      <m:num>
+                        <m:r>
+                          <a:rPr lang="en-US" sz="800" i="1">
+                            <a:latin typeface="Cambria Math" panose="02040503050406030204" pitchFamily="18" charset="0"/>
+                          </a:rPr>
+                          <m:t>𝑑𝑀</m:t>
+                        </m:r>
+                        <m:r>
+                          <a:rPr lang="en-US" sz="800" i="1">
+                            <a:latin typeface="Cambria Math" panose="02040503050406030204" pitchFamily="18" charset="0"/>
+                          </a:rPr>
+                          <m:t>(</m:t>
+                        </m:r>
+                        <m:r>
+                          <a:rPr lang="en-US" sz="800" i="1">
+                            <a:latin typeface="Cambria Math" panose="02040503050406030204" pitchFamily="18" charset="0"/>
+                          </a:rPr>
+                          <m:t>𝑡</m:t>
+                        </m:r>
+                        <m:r>
+                          <a:rPr lang="en-US" sz="800" i="1">
+                            <a:latin typeface="Cambria Math" panose="02040503050406030204" pitchFamily="18" charset="0"/>
+                          </a:rPr>
+                          <m:t>)</m:t>
+                        </m:r>
+                      </m:num>
+                      <m:den>
+                        <m:r>
+                          <a:rPr lang="en-US" sz="800" i="1">
+                            <a:latin typeface="Cambria Math" panose="02040503050406030204" pitchFamily="18" charset="0"/>
+                          </a:rPr>
+                          <m:t>𝑑𝑡</m:t>
+                        </m:r>
+                      </m:den>
+                    </m:f>
+                  </m:oMath>
+                </a14:m>
+                <a:r>
+                  <a:rPr lang="en-US" sz="800" dirty="0"/>
+                  <a:t> term that appears when doing the product rule for </a:t>
+                </a:r>
+                <a14:m>
+                  <m:oMath xmlns:m="http://schemas.openxmlformats.org/officeDocument/2006/math">
+                    <m:f>
+                      <m:fPr>
+                        <m:ctrlPr>
+                          <a:rPr lang="en-US" sz="800" i="1">
+                            <a:latin typeface="Cambria Math" panose="02040503050406030204" pitchFamily="18" charset="0"/>
+                          </a:rPr>
+                        </m:ctrlPr>
+                      </m:fPr>
+                      <m:num>
+                        <m:r>
+                          <a:rPr lang="en-US" sz="800" i="1">
+                            <a:latin typeface="Cambria Math" panose="02040503050406030204" pitchFamily="18" charset="0"/>
+                          </a:rPr>
+                          <m:t>𝑑</m:t>
+                        </m:r>
+                      </m:num>
+                      <m:den>
+                        <m:r>
+                          <a:rPr lang="en-US" sz="800" i="1">
+                            <a:latin typeface="Cambria Math" panose="02040503050406030204" pitchFamily="18" charset="0"/>
+                          </a:rPr>
+                          <m:t>𝑑𝑡</m:t>
+                        </m:r>
+                      </m:den>
+                    </m:f>
+                    <m:sSub>
+                      <m:sSubPr>
+                        <m:ctrlPr>
+                          <a:rPr lang="en-US" sz="800" b="0" i="1" smtClean="0">
+                            <a:latin typeface="Cambria Math" panose="02040503050406030204" pitchFamily="18" charset="0"/>
+                          </a:rPr>
+                        </m:ctrlPr>
+                      </m:sSubPr>
+                      <m:e>
+                        <m:r>
+                          <a:rPr lang="en-US" sz="800" b="0" i="1" smtClean="0">
+                            <a:latin typeface="Cambria Math" panose="02040503050406030204" pitchFamily="18" charset="0"/>
+                          </a:rPr>
+                          <m:t>𝐼</m:t>
+                        </m:r>
+                      </m:e>
+                      <m:sub>
+                        <m:r>
+                          <a:rPr lang="en-US" sz="800" b="0" i="1" smtClean="0">
+                            <a:latin typeface="Cambria Math" panose="02040503050406030204" pitchFamily="18" charset="0"/>
+                          </a:rPr>
+                          <m:t>𝑅𝐿</m:t>
+                        </m:r>
+                      </m:sub>
+                    </m:sSub>
+                    <m:r>
+                      <a:rPr lang="en-US" sz="800" b="0" i="1" smtClean="0">
+                        <a:latin typeface="Cambria Math" panose="02040503050406030204" pitchFamily="18" charset="0"/>
+                      </a:rPr>
+                      <m:t>(</m:t>
+                    </m:r>
+                    <m:r>
+                      <a:rPr lang="en-US" sz="800" b="0" i="1" smtClean="0">
+                        <a:latin typeface="Cambria Math" panose="02040503050406030204" pitchFamily="18" charset="0"/>
+                      </a:rPr>
+                      <m:t>𝑡</m:t>
+                    </m:r>
+                    <m:r>
+                      <a:rPr lang="en-US" sz="800" b="0" i="1" smtClean="0">
+                        <a:latin typeface="Cambria Math" panose="02040503050406030204" pitchFamily="18" charset="0"/>
+                      </a:rPr>
+                      <m:t>)</m:t>
+                    </m:r>
+                  </m:oMath>
+                </a14:m>
+                <a:r>
+                  <a:rPr lang="en-US" sz="800" dirty="0"/>
+                  <a:t>. It is possible to account for this by doing another pair of transformer voltage/current reflections, but this presentation is long enough anyway, and the term can be concluded to be negligible. Consider it an exercise for the reader, if you will. </a:t>
+                </a:r>
+              </a:p>
             </p:txBody>
           </p:sp>
         </mc:Choice>
-        <mc:Fallback xmlns="">
+        <mc:Fallback>
           <p:sp>
             <p:nvSpPr>
               <p:cNvPr id="4" name="Text Placeholder 3">
@@ -7293,6 +10464,53 @@
           </a:p>
         </p:txBody>
       </p:sp>
+      <p:pic>
+        <p:nvPicPr>
+          <p:cNvPr id="1026" name="Picture 2" descr="trollface - Wiktionary, the free dictionary">
+            <a:extLst>
+              <a:ext uri="{FF2B5EF4-FFF2-40B4-BE49-F238E27FC236}">
+                <a16:creationId xmlns:a16="http://schemas.microsoft.com/office/drawing/2014/main" id="{C5AE7DEA-780D-1951-6336-A6AA170E1EFD}"/>
+              </a:ext>
+            </a:extLst>
+          </p:cNvPr>
+          <p:cNvPicPr>
+            <a:picLocks noChangeAspect="1" noChangeArrowheads="1"/>
+          </p:cNvPicPr>
+          <p:nvPr/>
+        </p:nvPicPr>
+        <p:blipFill>
+          <a:blip r:embed="rId4">
+            <a:extLst>
+              <a:ext uri="{28A0092B-C50C-407E-A947-70E740481C1C}">
+                <a14:useLocalDpi xmlns:a14="http://schemas.microsoft.com/office/drawing/2010/main" val="0"/>
+              </a:ext>
+            </a:extLst>
+          </a:blip>
+          <a:srcRect/>
+          <a:stretch>
+            <a:fillRect/>
+          </a:stretch>
+        </p:blipFill>
+        <p:spPr bwMode="auto">
+          <a:xfrm>
+            <a:off x="2530724" y="5612235"/>
+            <a:ext cx="138980" cy="115349"/>
+          </a:xfrm>
+          <a:prstGeom prst="rect">
+            <a:avLst/>
+          </a:prstGeom>
+          <a:noFill/>
+          <a:extLst>
+            <a:ext uri="{909E8E84-426E-40DD-AFC4-6F175D3DCCD1}">
+              <a14:hiddenFill xmlns:a14="http://schemas.microsoft.com/office/drawing/2010/main">
+                <a:solidFill>
+                  <a:srgbClr val="FFFFFF"/>
+                </a:solidFill>
+              </a14:hiddenFill>
+            </a:ext>
+          </a:extLst>
+        </p:spPr>
+      </p:pic>
     </p:spTree>
     <p:extLst>
       <p:ext uri="{BB962C8B-B14F-4D97-AF65-F5344CB8AC3E}">
@@ -9649,19 +12867,19 @@
                             <a:rPr lang="en-US" b="0" i="1" smtClean="0">
                               <a:latin typeface="Cambria Math" panose="02040503050406030204" pitchFamily="18" charset="0"/>
                             </a:rPr>
+                            <m:t>𝑠𝐿</m:t>
+                          </m:r>
+                          <m:r>
+                            <a:rPr lang="en-US" b="0" i="1" smtClean="0">
+                              <a:latin typeface="Cambria Math" panose="02040503050406030204" pitchFamily="18" charset="0"/>
+                            </a:rPr>
+                            <m:t>+</m:t>
+                          </m:r>
+                          <m:r>
+                            <a:rPr lang="en-US" b="0" i="1" smtClean="0">
+                              <a:latin typeface="Cambria Math" panose="02040503050406030204" pitchFamily="18" charset="0"/>
+                            </a:rPr>
                             <m:t>𝑅</m:t>
-                          </m:r>
-                          <m:r>
-                            <a:rPr lang="en-US" b="0" i="1" smtClean="0">
-                              <a:latin typeface="Cambria Math" panose="02040503050406030204" pitchFamily="18" charset="0"/>
-                            </a:rPr>
-                            <m:t>+</m:t>
-                          </m:r>
-                          <m:r>
-                            <a:rPr lang="en-US" b="0" i="1" smtClean="0">
-                              <a:latin typeface="Cambria Math" panose="02040503050406030204" pitchFamily="18" charset="0"/>
-                            </a:rPr>
-                            <m:t>𝑠𝐿</m:t>
                           </m:r>
                         </m:den>
                       </m:f>
@@ -9839,7 +13057,7 @@
           <a:p>
             <a:r>
               <a:rPr lang="en-US" dirty="0"/>
-              <a:t>Overall System Design</a:t>
+              <a:t>Overall System Design – FF+PI</a:t>
             </a:r>
           </a:p>
         </p:txBody>
@@ -10325,7 +13543,7 @@
               <a:p>
                 <a:r>
                   <a:rPr lang="en-US" dirty="0"/>
-                  <a:t>We will be using the solution with both terms added. (The subtractive solution corresponds to charging the capacitor in reverse, flipping terminal sign polarities.)</a:t>
+                  <a:t>We will be using the solution with both terms added. (The subtractive solution produces identical behavior. Proof is left as exercise to the reader.)</a:t>
                 </a:r>
               </a:p>
               <a:p>
@@ -10419,7 +13637,7 @@
         </p:blipFill>
         <p:spPr>
           <a:xfrm>
-            <a:off x="7443568" y="1978620"/>
+            <a:off x="7737183" y="2372456"/>
             <a:ext cx="3036250" cy="2369671"/>
           </a:xfrm>
           <a:prstGeom prst="rect">
@@ -10441,7 +13659,7 @@
         </p:nvSpPr>
         <p:spPr>
           <a:xfrm>
-            <a:off x="7083764" y="1539426"/>
+            <a:off x="7377379" y="1933262"/>
             <a:ext cx="3755858" cy="2991476"/>
           </a:xfrm>
           <a:prstGeom prst="roundRect">
@@ -10495,7 +13713,7 @@
         </p:nvSpPr>
         <p:spPr>
           <a:xfrm>
-            <a:off x="8623759" y="1562705"/>
+            <a:off x="8917374" y="1956541"/>
             <a:ext cx="2215863" cy="338554"/>
           </a:xfrm>
           <a:prstGeom prst="rect">
@@ -10517,8 +13735,8 @@
           </a:p>
         </p:txBody>
       </p:sp>
-      <mc:AlternateContent xmlns:mc="http://schemas.openxmlformats.org/markup-compatibility/2006" xmlns:a14="http://schemas.microsoft.com/office/drawing/2010/main">
-        <mc:Choice Requires="a14">
+      <mc:AlternateContent xmlns:mc="http://schemas.openxmlformats.org/markup-compatibility/2006">
+        <mc:Choice xmlns:a14="http://schemas.microsoft.com/office/drawing/2010/main" Requires="a14">
           <p:sp>
             <p:nvSpPr>
               <p:cNvPr id="12" name="TextBox 11">
@@ -10533,7 +13751,7 @@
             </p:nvSpPr>
             <p:spPr>
               <a:xfrm>
-                <a:off x="7861597" y="997068"/>
+                <a:off x="8155212" y="1390904"/>
                 <a:ext cx="1939505" cy="369332"/>
               </a:xfrm>
               <a:prstGeom prst="rect">
@@ -10640,7 +13858,7 @@
             </p:txBody>
           </p:sp>
         </mc:Choice>
-        <mc:Fallback xmlns="">
+        <mc:Fallback>
           <p:sp>
             <p:nvSpPr>
               <p:cNvPr id="12" name="TextBox 11">
@@ -10657,7 +13875,7 @@
             </p:nvSpPr>
             <p:spPr>
               <a:xfrm>
-                <a:off x="7861597" y="997068"/>
+                <a:off x="8155212" y="1390904"/>
                 <a:ext cx="1939505" cy="369332"/>
               </a:xfrm>
               <a:prstGeom prst="rect">
@@ -10666,7 +13884,7 @@
               <a:blipFill>
                 <a:blip r:embed="rId4"/>
                 <a:stretch>
-                  <a:fillRect l="-1563" r="-5000" b="-30645"/>
+                  <a:fillRect l="-1563" r="-5000" b="-30159"/>
                 </a:stretch>
               </a:blipFill>
               <a:ln>
@@ -10706,7 +13924,7 @@
         </p:nvCxnSpPr>
         <p:spPr>
           <a:xfrm rot="16200000" flipH="1">
-            <a:off x="7184432" y="4638011"/>
+            <a:off x="7478047" y="5031847"/>
             <a:ext cx="298948" cy="298948"/>
           </a:xfrm>
           <a:prstGeom prst="bentConnector2">
@@ -10734,8 +13952,8 @@
           </a:fontRef>
         </p:style>
       </p:cxnSp>
-      <mc:AlternateContent xmlns:mc="http://schemas.openxmlformats.org/markup-compatibility/2006" xmlns:a14="http://schemas.microsoft.com/office/drawing/2010/main">
-        <mc:Choice Requires="a14">
+      <mc:AlternateContent xmlns:mc="http://schemas.openxmlformats.org/markup-compatibility/2006">
+        <mc:Choice xmlns:a14="http://schemas.microsoft.com/office/drawing/2010/main" Requires="a14">
           <p:sp>
             <p:nvSpPr>
               <p:cNvPr id="18" name="TextBox 17">
@@ -10750,7 +13968,7 @@
             </p:nvSpPr>
             <p:spPr>
               <a:xfrm>
-                <a:off x="7514502" y="4645184"/>
+                <a:off x="7808117" y="5039020"/>
                 <a:ext cx="2894382" cy="1481881"/>
               </a:xfrm>
               <a:prstGeom prst="rect">
@@ -11045,22 +14263,22 @@
                         </m:num>
                         <m:den>
                           <m:r>
-                            <a:rPr lang="en-US" sz="2400" i="1">
+                            <a:rPr lang="en-US" sz="2400" b="0" i="1" smtClean="0">
+                              <a:latin typeface="Cambria Math" panose="02040503050406030204" pitchFamily="18" charset="0"/>
+                            </a:rPr>
+                            <m:t>𝑠𝐿</m:t>
+                          </m:r>
+                          <m:r>
+                            <a:rPr lang="en-US" sz="2400" b="0" i="1" smtClean="0">
+                              <a:latin typeface="Cambria Math" panose="02040503050406030204" pitchFamily="18" charset="0"/>
+                            </a:rPr>
+                            <m:t>+</m:t>
+                          </m:r>
+                          <m:r>
+                            <a:rPr lang="en-US" sz="2400" b="0" i="1" smtClean="0">
                               <a:latin typeface="Cambria Math" panose="02040503050406030204" pitchFamily="18" charset="0"/>
                             </a:rPr>
                             <m:t>𝑅</m:t>
-                          </m:r>
-                          <m:r>
-                            <a:rPr lang="en-US" sz="2400" i="1">
-                              <a:latin typeface="Cambria Math" panose="02040503050406030204" pitchFamily="18" charset="0"/>
-                            </a:rPr>
-                            <m:t>+</m:t>
-                          </m:r>
-                          <m:r>
-                            <a:rPr lang="en-US" sz="2400" i="1">
-                              <a:latin typeface="Cambria Math" panose="02040503050406030204" pitchFamily="18" charset="0"/>
-                            </a:rPr>
-                            <m:t>𝑠𝐿</m:t>
                           </m:r>
                         </m:den>
                       </m:f>
@@ -11115,7 +14333,7 @@
             </p:txBody>
           </p:sp>
         </mc:Choice>
-        <mc:Fallback xmlns="">
+        <mc:Fallback>
           <p:sp>
             <p:nvSpPr>
               <p:cNvPr id="18" name="TextBox 17">
@@ -11132,7 +14350,7 @@
             </p:nvSpPr>
             <p:spPr>
               <a:xfrm>
-                <a:off x="7514502" y="4645184"/>
+                <a:off x="7808117" y="5039020"/>
                 <a:ext cx="2894382" cy="1481881"/>
               </a:xfrm>
               <a:prstGeom prst="rect">
@@ -11141,7 +14359,7 @@
               <a:blipFill>
                 <a:blip r:embed="rId5"/>
                 <a:stretch>
-                  <a:fillRect l="-420" r="-3151"/>
+                  <a:fillRect l="-419" r="-2935"/>
                 </a:stretch>
               </a:blipFill>
               <a:ln>
@@ -11181,7 +14399,7 @@
         </p:nvCxnSpPr>
         <p:spPr>
           <a:xfrm rot="10800000" flipH="1" flipV="1">
-            <a:off x="9888960" y="1179750"/>
+            <a:off x="10182575" y="1573586"/>
             <a:ext cx="298948" cy="298948"/>
           </a:xfrm>
           <a:prstGeom prst="bentConnector2">
@@ -11213,6 +14431,1032 @@
     <p:extLst>
       <p:ext uri="{BB962C8B-B14F-4D97-AF65-F5344CB8AC3E}">
         <p14:creationId xmlns:p14="http://schemas.microsoft.com/office/powerpoint/2010/main" val="434788447"/>
+      </p:ext>
+    </p:extLst>
+  </p:cSld>
+  <p:clrMapOvr>
+    <a:masterClrMapping/>
+  </p:clrMapOvr>
+</p:sld>
+</file>
+
+<file path=ppt/slides/slide9.xml><?xml version="1.0" encoding="utf-8"?>
+<p:sld xmlns:a="http://schemas.openxmlformats.org/drawingml/2006/main" xmlns:r="http://schemas.openxmlformats.org/officeDocument/2006/relationships" xmlns:p="http://schemas.openxmlformats.org/presentationml/2006/main">
+  <p:cSld>
+    <p:spTree>
+      <p:nvGrpSpPr>
+        <p:cNvPr id="1" name=""/>
+        <p:cNvGrpSpPr/>
+        <p:nvPr/>
+      </p:nvGrpSpPr>
+      <p:grpSpPr>
+        <a:xfrm>
+          <a:off x="0" y="0"/>
+          <a:ext cx="0" cy="0"/>
+          <a:chOff x="0" y="0"/>
+          <a:chExt cx="0" cy="0"/>
+        </a:xfrm>
+      </p:grpSpPr>
+      <p:sp>
+        <p:nvSpPr>
+          <p:cNvPr id="3" name="Title 2">
+            <a:extLst>
+              <a:ext uri="{FF2B5EF4-FFF2-40B4-BE49-F238E27FC236}">
+                <a16:creationId xmlns:a16="http://schemas.microsoft.com/office/drawing/2014/main" id="{5BDCB649-67A2-B5C8-336A-3EEBEFB45428}"/>
+              </a:ext>
+            </a:extLst>
+          </p:cNvPr>
+          <p:cNvSpPr>
+            <a:spLocks noGrp="1"/>
+          </p:cNvSpPr>
+          <p:nvPr>
+            <p:ph type="title"/>
+          </p:nvPr>
+        </p:nvSpPr>
+        <p:spPr/>
+        <p:txBody>
+          <a:bodyPr/>
+          <a:lstStyle/>
+          <a:p>
+            <a:r>
+              <a:rPr lang="en-US" dirty="0"/>
+              <a:t>Alternative Design – PI</a:t>
+            </a:r>
+            <a:r>
+              <a:rPr lang="en-US" baseline="30000" dirty="0"/>
+              <a:t>2</a:t>
+            </a:r>
+            <a:r>
+              <a:rPr lang="en-US" dirty="0"/>
+              <a:t> Control</a:t>
+            </a:r>
+          </a:p>
+        </p:txBody>
+      </p:sp>
+      <mc:AlternateContent xmlns:mc="http://schemas.openxmlformats.org/markup-compatibility/2006">
+        <mc:Choice xmlns:a14="http://schemas.microsoft.com/office/drawing/2010/main" Requires="a14">
+          <p:sp>
+            <p:nvSpPr>
+              <p:cNvPr id="5" name="Text Placeholder 4">
+                <a:extLst>
+                  <a:ext uri="{FF2B5EF4-FFF2-40B4-BE49-F238E27FC236}">
+                    <a16:creationId xmlns:a16="http://schemas.microsoft.com/office/drawing/2014/main" id="{CCC0E295-6D80-4650-C064-30DBEF50D957}"/>
+                  </a:ext>
+                </a:extLst>
+              </p:cNvPr>
+              <p:cNvSpPr>
+                <a:spLocks noGrp="1"/>
+              </p:cNvSpPr>
+              <p:nvPr>
+                <p:ph type="body" sz="half" idx="2"/>
+              </p:nvPr>
+            </p:nvSpPr>
+            <p:spPr>
+              <a:xfrm>
+                <a:off x="167780" y="2057400"/>
+                <a:ext cx="4927013" cy="4314039"/>
+              </a:xfrm>
+            </p:spPr>
+            <p:txBody>
+              <a:bodyPr>
+                <a:normAutofit/>
+              </a:bodyPr>
+              <a:lstStyle/>
+              <a:p>
+                <a:r>
+                  <a:rPr lang="en-US" dirty="0"/>
+                  <a:t>Math trick of defining auxiliary variable can be done earlier</a:t>
+                </a:r>
+              </a:p>
+              <a:p>
+                <a:pPr marL="285750" indent="-285750">
+                  <a:buFont typeface="Arial" panose="020B0604020202020204" pitchFamily="34" charset="0"/>
+                  <a:buChar char="•"/>
+                </a:pPr>
+                <a:r>
+                  <a:rPr lang="en-US" dirty="0"/>
+                  <a:t>No need to split apart voltage source on right side of transformer</a:t>
+                </a:r>
+              </a:p>
+              <a:p>
+                <a:r>
+                  <a:rPr lang="en-US" dirty="0"/>
+                  <a:t>Reflect battery current to right side once again</a:t>
+                </a:r>
+              </a:p>
+              <a:p>
+                <a:pPr marL="285750" indent="-285750">
+                  <a:buFont typeface="Arial" panose="020B0604020202020204" pitchFamily="34" charset="0"/>
+                  <a:buChar char="•"/>
+                </a:pPr>
+                <a:r>
+                  <a:rPr lang="en-US" dirty="0"/>
+                  <a:t>New toy model appears analogous to the one in the FF+PI model</a:t>
+                </a:r>
+              </a:p>
+              <a:p>
+                <a:r>
+                  <a:rPr lang="en-US" dirty="0"/>
+                  <a:t>Write new KVL loop equation*:</a:t>
+                </a:r>
+              </a:p>
+              <a:p>
+                <a:endParaRPr lang="en-US" dirty="0"/>
+              </a:p>
+              <a:p>
+                <a14:m>
+                  <m:oMathPara xmlns:m="http://schemas.openxmlformats.org/officeDocument/2006/math">
+                    <m:oMathParaPr>
+                      <m:jc m:val="centerGroup"/>
+                    </m:oMathParaPr>
+                    <m:oMath xmlns:m="http://schemas.openxmlformats.org/officeDocument/2006/math">
+                      <m:r>
+                        <a:rPr lang="en-US" sz="1200" i="1">
+                          <a:latin typeface="Cambria Math" panose="02040503050406030204" pitchFamily="18" charset="0"/>
+                        </a:rPr>
+                        <m:t>𝑀</m:t>
+                      </m:r>
+                      <m:d>
+                        <m:dPr>
+                          <m:ctrlPr>
+                            <a:rPr lang="en-US" sz="1200" i="1">
+                              <a:latin typeface="Cambria Math" panose="02040503050406030204" pitchFamily="18" charset="0"/>
+                            </a:rPr>
+                          </m:ctrlPr>
+                        </m:dPr>
+                        <m:e>
+                          <m:r>
+                            <a:rPr lang="en-US" sz="1200" i="1">
+                              <a:latin typeface="Cambria Math" panose="02040503050406030204" pitchFamily="18" charset="0"/>
+                            </a:rPr>
+                            <m:t>𝑡</m:t>
+                          </m:r>
+                        </m:e>
+                      </m:d>
+                      <m:r>
+                        <a:rPr lang="en-US" sz="1200" i="1">
+                          <a:latin typeface="Cambria Math" panose="02040503050406030204" pitchFamily="18" charset="0"/>
+                        </a:rPr>
+                        <m:t>∗</m:t>
+                      </m:r>
+                      <m:sSub>
+                        <m:sSubPr>
+                          <m:ctrlPr>
+                            <a:rPr lang="en-US" sz="1200" i="1">
+                              <a:latin typeface="Cambria Math" panose="02040503050406030204" pitchFamily="18" charset="0"/>
+                            </a:rPr>
+                          </m:ctrlPr>
+                        </m:sSubPr>
+                        <m:e>
+                          <m:r>
+                            <a:rPr lang="en-US" sz="1200" i="1">
+                              <a:latin typeface="Cambria Math" panose="02040503050406030204" pitchFamily="18" charset="0"/>
+                            </a:rPr>
+                            <m:t>𝑉</m:t>
+                          </m:r>
+                        </m:e>
+                        <m:sub>
+                          <m:r>
+                            <a:rPr lang="en-US" sz="1200" i="1">
+                              <a:latin typeface="Cambria Math" panose="02040503050406030204" pitchFamily="18" charset="0"/>
+                            </a:rPr>
+                            <m:t>𝑔</m:t>
+                          </m:r>
+                        </m:sub>
+                      </m:sSub>
+                      <m:r>
+                        <a:rPr lang="en-US" sz="1200" i="1">
+                          <a:latin typeface="Cambria Math" panose="02040503050406030204" pitchFamily="18" charset="0"/>
+                        </a:rPr>
+                        <m:t>=</m:t>
+                      </m:r>
+                      <m:f>
+                        <m:fPr>
+                          <m:ctrlPr>
+                            <a:rPr lang="en-US" sz="1200" i="1">
+                              <a:latin typeface="Cambria Math" panose="02040503050406030204" pitchFamily="18" charset="0"/>
+                            </a:rPr>
+                          </m:ctrlPr>
+                        </m:fPr>
+                        <m:num>
+                          <m:sSub>
+                            <m:sSubPr>
+                              <m:ctrlPr>
+                                <a:rPr lang="en-US" sz="1200" i="1">
+                                  <a:latin typeface="Cambria Math" panose="02040503050406030204" pitchFamily="18" charset="0"/>
+                                </a:rPr>
+                              </m:ctrlPr>
+                            </m:sSubPr>
+                            <m:e>
+                              <m:r>
+                                <a:rPr lang="en-US" sz="1200" i="1">
+                                  <a:latin typeface="Cambria Math" panose="02040503050406030204" pitchFamily="18" charset="0"/>
+                                </a:rPr>
+                                <m:t>𝑅</m:t>
+                              </m:r>
+                            </m:e>
+                            <m:sub>
+                              <m:r>
+                                <a:rPr lang="en-US" sz="1200" i="1">
+                                  <a:latin typeface="Cambria Math" panose="02040503050406030204" pitchFamily="18" charset="0"/>
+                                </a:rPr>
+                                <m:t>𝐸𝑆𝑅</m:t>
+                              </m:r>
+                            </m:sub>
+                          </m:sSub>
+                        </m:num>
+                        <m:den>
+                          <m:r>
+                            <a:rPr lang="en-US" sz="1200" i="1">
+                              <a:latin typeface="Cambria Math" panose="02040503050406030204" pitchFamily="18" charset="0"/>
+                            </a:rPr>
+                            <m:t>𝑀</m:t>
+                          </m:r>
+                          <m:d>
+                            <m:dPr>
+                              <m:ctrlPr>
+                                <a:rPr lang="en-US" sz="1200" i="1">
+                                  <a:latin typeface="Cambria Math" panose="02040503050406030204" pitchFamily="18" charset="0"/>
+                                </a:rPr>
+                              </m:ctrlPr>
+                            </m:dPr>
+                            <m:e>
+                              <m:r>
+                                <a:rPr lang="en-US" sz="1200" i="1">
+                                  <a:latin typeface="Cambria Math" panose="02040503050406030204" pitchFamily="18" charset="0"/>
+                                </a:rPr>
+                                <m:t>𝑡</m:t>
+                              </m:r>
+                            </m:e>
+                          </m:d>
+                        </m:den>
+                      </m:f>
+                      <m:r>
+                        <a:rPr lang="en-US" sz="1200" i="1">
+                          <a:latin typeface="Cambria Math" panose="02040503050406030204" pitchFamily="18" charset="0"/>
+                        </a:rPr>
+                        <m:t>∗</m:t>
+                      </m:r>
+                      <m:sSub>
+                        <m:sSubPr>
+                          <m:ctrlPr>
+                            <a:rPr lang="en-US" sz="1200" i="1">
+                              <a:latin typeface="Cambria Math" panose="02040503050406030204" pitchFamily="18" charset="0"/>
+                            </a:rPr>
+                          </m:ctrlPr>
+                        </m:sSubPr>
+                        <m:e>
+                          <m:r>
+                            <a:rPr lang="en-US" sz="1200" i="1">
+                              <a:latin typeface="Cambria Math" panose="02040503050406030204" pitchFamily="18" charset="0"/>
+                            </a:rPr>
+                            <m:t>𝐼</m:t>
+                          </m:r>
+                        </m:e>
+                        <m:sub>
+                          <m:r>
+                            <a:rPr lang="en-US" sz="1200" i="1">
+                              <a:latin typeface="Cambria Math" panose="02040503050406030204" pitchFamily="18" charset="0"/>
+                            </a:rPr>
+                            <m:t>𝑏𝑎𝑡</m:t>
+                          </m:r>
+                        </m:sub>
+                      </m:sSub>
+                      <m:d>
+                        <m:dPr>
+                          <m:ctrlPr>
+                            <a:rPr lang="en-US" sz="1200" i="1">
+                              <a:latin typeface="Cambria Math" panose="02040503050406030204" pitchFamily="18" charset="0"/>
+                            </a:rPr>
+                          </m:ctrlPr>
+                        </m:dPr>
+                        <m:e>
+                          <m:r>
+                            <a:rPr lang="en-US" sz="1200" i="1">
+                              <a:latin typeface="Cambria Math" panose="02040503050406030204" pitchFamily="18" charset="0"/>
+                            </a:rPr>
+                            <m:t>𝑡</m:t>
+                          </m:r>
+                        </m:e>
+                      </m:d>
+                      <m:r>
+                        <a:rPr lang="en-US" sz="1200" i="1">
+                          <a:latin typeface="Cambria Math" panose="02040503050406030204" pitchFamily="18" charset="0"/>
+                        </a:rPr>
+                        <m:t>+</m:t>
+                      </m:r>
+                      <m:f>
+                        <m:fPr>
+                          <m:ctrlPr>
+                            <a:rPr lang="en-US" sz="1200" i="1">
+                              <a:latin typeface="Cambria Math" panose="02040503050406030204" pitchFamily="18" charset="0"/>
+                            </a:rPr>
+                          </m:ctrlPr>
+                        </m:fPr>
+                        <m:num>
+                          <m:r>
+                            <a:rPr lang="en-US" sz="1200" i="1">
+                              <a:latin typeface="Cambria Math" panose="02040503050406030204" pitchFamily="18" charset="0"/>
+                            </a:rPr>
+                            <m:t>𝐿</m:t>
+                          </m:r>
+                        </m:num>
+                        <m:den>
+                          <m:r>
+                            <a:rPr lang="en-US" sz="1200" i="1">
+                              <a:latin typeface="Cambria Math" panose="02040503050406030204" pitchFamily="18" charset="0"/>
+                            </a:rPr>
+                            <m:t>𝑀</m:t>
+                          </m:r>
+                          <m:d>
+                            <m:dPr>
+                              <m:ctrlPr>
+                                <a:rPr lang="en-US" sz="1200" i="1">
+                                  <a:latin typeface="Cambria Math" panose="02040503050406030204" pitchFamily="18" charset="0"/>
+                                </a:rPr>
+                              </m:ctrlPr>
+                            </m:dPr>
+                            <m:e>
+                              <m:r>
+                                <a:rPr lang="en-US" sz="1200" i="1">
+                                  <a:latin typeface="Cambria Math" panose="02040503050406030204" pitchFamily="18" charset="0"/>
+                                </a:rPr>
+                                <m:t>𝑡</m:t>
+                              </m:r>
+                            </m:e>
+                          </m:d>
+                        </m:den>
+                      </m:f>
+                      <m:r>
+                        <a:rPr lang="en-US" sz="1200" i="1">
+                          <a:latin typeface="Cambria Math" panose="02040503050406030204" pitchFamily="18" charset="0"/>
+                        </a:rPr>
+                        <m:t>∗</m:t>
+                      </m:r>
+                      <m:f>
+                        <m:fPr>
+                          <m:ctrlPr>
+                            <a:rPr lang="en-US" sz="1200" i="1">
+                              <a:latin typeface="Cambria Math" panose="02040503050406030204" pitchFamily="18" charset="0"/>
+                            </a:rPr>
+                          </m:ctrlPr>
+                        </m:fPr>
+                        <m:num>
+                          <m:r>
+                            <a:rPr lang="en-US" sz="1200" i="1">
+                              <a:latin typeface="Cambria Math" panose="02040503050406030204" pitchFamily="18" charset="0"/>
+                            </a:rPr>
+                            <m:t>𝑑</m:t>
+                          </m:r>
+                        </m:num>
+                        <m:den>
+                          <m:r>
+                            <a:rPr lang="en-US" sz="1200" i="1">
+                              <a:latin typeface="Cambria Math" panose="02040503050406030204" pitchFamily="18" charset="0"/>
+                            </a:rPr>
+                            <m:t>𝑑𝑡</m:t>
+                          </m:r>
+                        </m:den>
+                      </m:f>
+                      <m:sSub>
+                        <m:sSubPr>
+                          <m:ctrlPr>
+                            <a:rPr lang="en-US" sz="1200" i="1">
+                              <a:latin typeface="Cambria Math" panose="02040503050406030204" pitchFamily="18" charset="0"/>
+                            </a:rPr>
+                          </m:ctrlPr>
+                        </m:sSubPr>
+                        <m:e>
+                          <m:r>
+                            <a:rPr lang="en-US" sz="1200" i="1">
+                              <a:latin typeface="Cambria Math" panose="02040503050406030204" pitchFamily="18" charset="0"/>
+                            </a:rPr>
+                            <m:t>𝐼</m:t>
+                          </m:r>
+                        </m:e>
+                        <m:sub>
+                          <m:r>
+                            <a:rPr lang="en-US" sz="1200" i="1">
+                              <a:latin typeface="Cambria Math" panose="02040503050406030204" pitchFamily="18" charset="0"/>
+                            </a:rPr>
+                            <m:t>𝑏𝑎𝑡</m:t>
+                          </m:r>
+                        </m:sub>
+                      </m:sSub>
+                      <m:d>
+                        <m:dPr>
+                          <m:ctrlPr>
+                            <a:rPr lang="en-US" sz="1200" i="1">
+                              <a:latin typeface="Cambria Math" panose="02040503050406030204" pitchFamily="18" charset="0"/>
+                            </a:rPr>
+                          </m:ctrlPr>
+                        </m:dPr>
+                        <m:e>
+                          <m:r>
+                            <a:rPr lang="en-US" sz="1200" i="1">
+                              <a:latin typeface="Cambria Math" panose="02040503050406030204" pitchFamily="18" charset="0"/>
+                            </a:rPr>
+                            <m:t>𝑡</m:t>
+                          </m:r>
+                        </m:e>
+                      </m:d>
+                      <m:r>
+                        <a:rPr lang="en-US" sz="1200" b="0" i="1" smtClean="0">
+                          <a:latin typeface="Cambria Math" panose="02040503050406030204" pitchFamily="18" charset="0"/>
+                        </a:rPr>
+                        <m:t>+</m:t>
+                      </m:r>
+                      <m:f>
+                        <m:fPr>
+                          <m:ctrlPr>
+                            <a:rPr lang="en-US" sz="1200" b="0" i="1" smtClean="0">
+                              <a:latin typeface="Cambria Math" panose="02040503050406030204" pitchFamily="18" charset="0"/>
+                            </a:rPr>
+                          </m:ctrlPr>
+                        </m:fPr>
+                        <m:num>
+                          <m:r>
+                            <a:rPr lang="en-US" sz="1200" b="0" i="1" smtClean="0">
+                              <a:latin typeface="Cambria Math" panose="02040503050406030204" pitchFamily="18" charset="0"/>
+                            </a:rPr>
+                            <m:t>1</m:t>
+                          </m:r>
+                        </m:num>
+                        <m:den>
+                          <m:r>
+                            <a:rPr lang="en-US" sz="1200" b="0" i="1" smtClean="0">
+                              <a:latin typeface="Cambria Math" panose="02040503050406030204" pitchFamily="18" charset="0"/>
+                            </a:rPr>
+                            <m:t>𝐶</m:t>
+                          </m:r>
+                          <m:r>
+                            <a:rPr lang="en-US" sz="1200" b="0" i="1" smtClean="0">
+                              <a:latin typeface="Cambria Math" panose="02040503050406030204" pitchFamily="18" charset="0"/>
+                            </a:rPr>
+                            <m:t>∗</m:t>
+                          </m:r>
+                          <m:r>
+                            <a:rPr lang="en-US" sz="1200" b="0" i="1" smtClean="0">
+                              <a:latin typeface="Cambria Math" panose="02040503050406030204" pitchFamily="18" charset="0"/>
+                            </a:rPr>
+                            <m:t>𝑀</m:t>
+                          </m:r>
+                          <m:r>
+                            <a:rPr lang="en-US" sz="1200" b="0" i="1" smtClean="0">
+                              <a:latin typeface="Cambria Math" panose="02040503050406030204" pitchFamily="18" charset="0"/>
+                            </a:rPr>
+                            <m:t>(</m:t>
+                          </m:r>
+                          <m:r>
+                            <a:rPr lang="en-US" sz="1200" b="0" i="1" smtClean="0">
+                              <a:latin typeface="Cambria Math" panose="02040503050406030204" pitchFamily="18" charset="0"/>
+                            </a:rPr>
+                            <m:t>𝑡</m:t>
+                          </m:r>
+                          <m:r>
+                            <a:rPr lang="en-US" sz="1200" b="0" i="1" smtClean="0">
+                              <a:latin typeface="Cambria Math" panose="02040503050406030204" pitchFamily="18" charset="0"/>
+                            </a:rPr>
+                            <m:t>)</m:t>
+                          </m:r>
+                        </m:den>
+                      </m:f>
+                      <m:nary>
+                        <m:naryPr>
+                          <m:limLoc m:val="undOvr"/>
+                          <m:subHide m:val="on"/>
+                          <m:supHide m:val="on"/>
+                          <m:ctrlPr>
+                            <a:rPr lang="en-US" sz="1200" b="0" i="1" smtClean="0">
+                              <a:latin typeface="Cambria Math" panose="02040503050406030204" pitchFamily="18" charset="0"/>
+                            </a:rPr>
+                          </m:ctrlPr>
+                        </m:naryPr>
+                        <m:sub/>
+                        <m:sup/>
+                        <m:e>
+                          <m:sSub>
+                            <m:sSubPr>
+                              <m:ctrlPr>
+                                <a:rPr lang="en-US" sz="1200" b="0" i="1" smtClean="0">
+                                  <a:latin typeface="Cambria Math" panose="02040503050406030204" pitchFamily="18" charset="0"/>
+                                </a:rPr>
+                              </m:ctrlPr>
+                            </m:sSubPr>
+                            <m:e>
+                              <m:r>
+                                <a:rPr lang="en-US" sz="1200" b="0" i="1" smtClean="0">
+                                  <a:latin typeface="Cambria Math" panose="02040503050406030204" pitchFamily="18" charset="0"/>
+                                </a:rPr>
+                                <m:t>𝐼</m:t>
+                              </m:r>
+                            </m:e>
+                            <m:sub>
+                              <m:r>
+                                <a:rPr lang="en-US" sz="1200" b="0" i="1" smtClean="0">
+                                  <a:latin typeface="Cambria Math" panose="02040503050406030204" pitchFamily="18" charset="0"/>
+                                </a:rPr>
+                                <m:t>𝑏𝑎𝑡</m:t>
+                              </m:r>
+                            </m:sub>
+                          </m:sSub>
+                          <m:r>
+                            <a:rPr lang="en-US" sz="1200" b="0" i="1" smtClean="0">
+                              <a:latin typeface="Cambria Math" panose="02040503050406030204" pitchFamily="18" charset="0"/>
+                            </a:rPr>
+                            <m:t>(</m:t>
+                          </m:r>
+                          <m:r>
+                            <a:rPr lang="en-US" sz="1200" b="0" i="1" smtClean="0">
+                              <a:latin typeface="Cambria Math" panose="02040503050406030204" pitchFamily="18" charset="0"/>
+                            </a:rPr>
+                            <m:t>𝑡</m:t>
+                          </m:r>
+                          <m:r>
+                            <a:rPr lang="en-US" sz="1200" b="0" i="1" smtClean="0">
+                              <a:latin typeface="Cambria Math" panose="02040503050406030204" pitchFamily="18" charset="0"/>
+                            </a:rPr>
+                            <m:t>)</m:t>
+                          </m:r>
+                        </m:e>
+                      </m:nary>
+                    </m:oMath>
+                  </m:oMathPara>
+                </a14:m>
+                <a:endParaRPr lang="en-US" dirty="0"/>
+              </a:p>
+              <a:p>
+                <a:endParaRPr lang="en-US" dirty="0"/>
+              </a:p>
+              <a:p>
+                <a:r>
+                  <a:rPr lang="en-US" dirty="0"/>
+                  <a:t>*Remember that caveat in small print from before? Exercise for the reader: can we ignore this imperfection in our calculus now?</a:t>
+                </a:r>
+              </a:p>
+            </p:txBody>
+          </p:sp>
+        </mc:Choice>
+        <mc:Fallback>
+          <p:sp>
+            <p:nvSpPr>
+              <p:cNvPr id="5" name="Text Placeholder 4">
+                <a:extLst>
+                  <a:ext uri="{FF2B5EF4-FFF2-40B4-BE49-F238E27FC236}">
+                    <a16:creationId xmlns:a16="http://schemas.microsoft.com/office/drawing/2014/main" id="{CCC0E295-6D80-4650-C064-30DBEF50D957}"/>
+                  </a:ext>
+                </a:extLst>
+              </p:cNvPr>
+              <p:cNvSpPr>
+                <a:spLocks noGrp="1" noRot="1" noChangeAspect="1" noMove="1" noResize="1" noEditPoints="1" noAdjustHandles="1" noChangeArrowheads="1" noChangeShapeType="1" noTextEdit="1"/>
+              </p:cNvSpPr>
+              <p:nvPr>
+                <p:ph type="body" sz="half" idx="2"/>
+              </p:nvPr>
+            </p:nvSpPr>
+            <p:spPr>
+              <a:xfrm>
+                <a:off x="167780" y="2057400"/>
+                <a:ext cx="4927013" cy="4314039"/>
+              </a:xfrm>
+              <a:blipFill>
+                <a:blip r:embed="rId2"/>
+                <a:stretch>
+                  <a:fillRect l="-743" t="-990" r="-3713" b="-707"/>
+                </a:stretch>
+              </a:blipFill>
+            </p:spPr>
+            <p:txBody>
+              <a:bodyPr/>
+              <a:lstStyle/>
+              <a:p>
+                <a:r>
+                  <a:rPr lang="en-US">
+                    <a:noFill/>
+                  </a:rPr>
+                  <a:t> </a:t>
+                </a:r>
+              </a:p>
+            </p:txBody>
+          </p:sp>
+        </mc:Fallback>
+      </mc:AlternateContent>
+      <p:pic>
+        <p:nvPicPr>
+          <p:cNvPr id="7" name="Picture 6">
+            <a:extLst>
+              <a:ext uri="{FF2B5EF4-FFF2-40B4-BE49-F238E27FC236}">
+                <a16:creationId xmlns:a16="http://schemas.microsoft.com/office/drawing/2014/main" id="{BC03E0CC-0F5C-2B82-A8F9-69B5D45FCA10}"/>
+              </a:ext>
+            </a:extLst>
+          </p:cNvPr>
+          <p:cNvPicPr>
+            <a:picLocks noChangeAspect="1"/>
+          </p:cNvPicPr>
+          <p:nvPr/>
+        </p:nvPicPr>
+        <p:blipFill>
+          <a:blip r:embed="rId3">
+            <a:extLst>
+              <a:ext uri="{28A0092B-C50C-407E-A947-70E740481C1C}">
+                <a14:useLocalDpi xmlns:a14="http://schemas.microsoft.com/office/drawing/2010/main" val="0"/>
+              </a:ext>
+            </a:extLst>
+          </a:blip>
+          <a:srcRect/>
+          <a:stretch/>
+        </p:blipFill>
+        <p:spPr>
+          <a:xfrm>
+            <a:off x="5966887" y="457200"/>
+            <a:ext cx="5173861" cy="3167953"/>
+          </a:xfrm>
+          <a:prstGeom prst="rect">
+            <a:avLst/>
+          </a:prstGeom>
+        </p:spPr>
+      </p:pic>
+      <p:sp>
+        <p:nvSpPr>
+          <p:cNvPr id="9" name="Rectangle: Rounded Corners 8">
+            <a:extLst>
+              <a:ext uri="{FF2B5EF4-FFF2-40B4-BE49-F238E27FC236}">
+                <a16:creationId xmlns:a16="http://schemas.microsoft.com/office/drawing/2014/main" id="{BE4666EC-9049-EFF0-9C5D-6B0300E4CB9E}"/>
+              </a:ext>
+            </a:extLst>
+          </p:cNvPr>
+          <p:cNvSpPr/>
+          <p:nvPr/>
+        </p:nvSpPr>
+        <p:spPr>
+          <a:xfrm>
+            <a:off x="5171813" y="224509"/>
+            <a:ext cx="6673171" cy="3400644"/>
+          </a:xfrm>
+          <a:prstGeom prst="roundRect">
+            <a:avLst>
+              <a:gd name="adj" fmla="val 3299"/>
+            </a:avLst>
+          </a:prstGeom>
+          <a:noFill/>
+          <a:ln w="38100">
+            <a:solidFill>
+              <a:schemeClr val="tx1"/>
+            </a:solidFill>
+          </a:ln>
+        </p:spPr>
+        <p:style>
+          <a:lnRef idx="2">
+            <a:schemeClr val="accent1">
+              <a:shade val="15000"/>
+            </a:schemeClr>
+          </a:lnRef>
+          <a:fillRef idx="1">
+            <a:schemeClr val="accent1"/>
+          </a:fillRef>
+          <a:effectRef idx="0">
+            <a:schemeClr val="accent1"/>
+          </a:effectRef>
+          <a:fontRef idx="minor">
+            <a:schemeClr val="lt1"/>
+          </a:fontRef>
+        </p:style>
+        <p:txBody>
+          <a:bodyPr rtlCol="0" anchor="ctr"/>
+          <a:lstStyle/>
+          <a:p>
+            <a:pPr algn="ctr"/>
+            <a:endParaRPr lang="en-US"/>
+          </a:p>
+        </p:txBody>
+      </p:sp>
+      <p:sp>
+        <p:nvSpPr>
+          <p:cNvPr id="10" name="TextBox 9">
+            <a:extLst>
+              <a:ext uri="{FF2B5EF4-FFF2-40B4-BE49-F238E27FC236}">
+                <a16:creationId xmlns:a16="http://schemas.microsoft.com/office/drawing/2014/main" id="{298C199B-C6D4-1ACA-FF24-DD101B0E5772}"/>
+              </a:ext>
+            </a:extLst>
+          </p:cNvPr>
+          <p:cNvSpPr txBox="1"/>
+          <p:nvPr/>
+        </p:nvSpPr>
+        <p:spPr>
+          <a:xfrm>
+            <a:off x="9773134" y="215829"/>
+            <a:ext cx="2071850" cy="338554"/>
+          </a:xfrm>
+          <a:prstGeom prst="rect">
+            <a:avLst/>
+          </a:prstGeom>
+          <a:noFill/>
+        </p:spPr>
+        <p:txBody>
+          <a:bodyPr wrap="none" rtlCol="0">
+            <a:spAutoFit/>
+          </a:bodyPr>
+          <a:lstStyle/>
+          <a:p>
+            <a:pPr algn="r"/>
+            <a:r>
+              <a:rPr lang="en-US" sz="1600" b="1" dirty="0"/>
+              <a:t>Singular RLC Branch</a:t>
+            </a:r>
+          </a:p>
+        </p:txBody>
+      </p:sp>
+      <p:pic>
+        <p:nvPicPr>
+          <p:cNvPr id="11" name="Picture 10">
+            <a:extLst>
+              <a:ext uri="{FF2B5EF4-FFF2-40B4-BE49-F238E27FC236}">
+                <a16:creationId xmlns:a16="http://schemas.microsoft.com/office/drawing/2014/main" id="{B6E6B413-D3FE-5290-CEE9-03A0BE540F66}"/>
+              </a:ext>
+            </a:extLst>
+          </p:cNvPr>
+          <p:cNvPicPr>
+            <a:picLocks noChangeAspect="1"/>
+          </p:cNvPicPr>
+          <p:nvPr/>
+        </p:nvPicPr>
+        <p:blipFill>
+          <a:blip r:embed="rId4">
+            <a:extLst>
+              <a:ext uri="{28A0092B-C50C-407E-A947-70E740481C1C}">
+                <a14:useLocalDpi xmlns:a14="http://schemas.microsoft.com/office/drawing/2010/main" val="0"/>
+              </a:ext>
+            </a:extLst>
+          </a:blip>
+          <a:srcRect/>
+          <a:stretch/>
+        </p:blipFill>
+        <p:spPr>
+          <a:xfrm>
+            <a:off x="6559201" y="4157981"/>
+            <a:ext cx="3847339" cy="2390733"/>
+          </a:xfrm>
+          <a:prstGeom prst="rect">
+            <a:avLst/>
+          </a:prstGeom>
+        </p:spPr>
+      </p:pic>
+      <p:cxnSp>
+        <p:nvCxnSpPr>
+          <p:cNvPr id="12" name="Straight Arrow Connector 11">
+            <a:extLst>
+              <a:ext uri="{FF2B5EF4-FFF2-40B4-BE49-F238E27FC236}">
+                <a16:creationId xmlns:a16="http://schemas.microsoft.com/office/drawing/2014/main" id="{AEB0BB3A-84CC-22D4-4AB5-DBE74C3157F3}"/>
+              </a:ext>
+            </a:extLst>
+          </p:cNvPr>
+          <p:cNvCxnSpPr/>
+          <p:nvPr/>
+        </p:nvCxnSpPr>
+        <p:spPr>
+          <a:xfrm flipV="1">
+            <a:off x="7645951" y="4550361"/>
+            <a:ext cx="0" cy="553571"/>
+          </a:xfrm>
+          <a:prstGeom prst="straightConnector1">
+            <a:avLst/>
+          </a:prstGeom>
+          <a:ln>
+            <a:solidFill>
+              <a:schemeClr val="tx1"/>
+            </a:solidFill>
+            <a:tailEnd type="triangle"/>
+          </a:ln>
+        </p:spPr>
+        <p:style>
+          <a:lnRef idx="2">
+            <a:schemeClr val="accent1"/>
+          </a:lnRef>
+          <a:fillRef idx="0">
+            <a:schemeClr val="accent1"/>
+          </a:fillRef>
+          <a:effectRef idx="1">
+            <a:schemeClr val="accent1"/>
+          </a:effectRef>
+          <a:fontRef idx="minor">
+            <a:schemeClr val="tx1"/>
+          </a:fontRef>
+        </p:style>
+      </p:cxnSp>
+      <p:sp>
+        <p:nvSpPr>
+          <p:cNvPr id="13" name="TextBox 12">
+            <a:extLst>
+              <a:ext uri="{FF2B5EF4-FFF2-40B4-BE49-F238E27FC236}">
+                <a16:creationId xmlns:a16="http://schemas.microsoft.com/office/drawing/2014/main" id="{90EFA22D-691F-5092-A2E6-7261946CFB23}"/>
+              </a:ext>
+            </a:extLst>
+          </p:cNvPr>
+          <p:cNvSpPr txBox="1"/>
+          <p:nvPr/>
+        </p:nvSpPr>
+        <p:spPr>
+          <a:xfrm>
+            <a:off x="7645951" y="4673257"/>
+            <a:ext cx="1675459" cy="307777"/>
+          </a:xfrm>
+          <a:prstGeom prst="rect">
+            <a:avLst/>
+          </a:prstGeom>
+          <a:noFill/>
+        </p:spPr>
+        <p:txBody>
+          <a:bodyPr wrap="none" rtlCol="0">
+            <a:spAutoFit/>
+          </a:bodyPr>
+          <a:lstStyle/>
+          <a:p>
+            <a:r>
+              <a:rPr lang="en-US" sz="1400" dirty="0">
+                <a:latin typeface="Cambria Math" panose="02040503050406030204" pitchFamily="18" charset="0"/>
+                <a:ea typeface="Cambria Math" panose="02040503050406030204" pitchFamily="18" charset="0"/>
+              </a:rPr>
+              <a:t>I</a:t>
+            </a:r>
+            <a:r>
+              <a:rPr lang="en-US" sz="1400" baseline="-25000" dirty="0">
+                <a:latin typeface="Cambria Math" panose="02040503050406030204" pitchFamily="18" charset="0"/>
+                <a:ea typeface="Cambria Math" panose="02040503050406030204" pitchFamily="18" charset="0"/>
+              </a:rPr>
+              <a:t>RL</a:t>
+            </a:r>
+            <a:r>
+              <a:rPr lang="en-US" sz="1400" dirty="0">
+                <a:latin typeface="Cambria Math" panose="02040503050406030204" pitchFamily="18" charset="0"/>
+                <a:ea typeface="Cambria Math" panose="02040503050406030204" pitchFamily="18" charset="0"/>
+              </a:rPr>
+              <a:t>(t) = </a:t>
+            </a:r>
+            <a:r>
+              <a:rPr lang="en-US" sz="1400" dirty="0" err="1">
+                <a:latin typeface="Cambria Math" panose="02040503050406030204" pitchFamily="18" charset="0"/>
+                <a:ea typeface="Cambria Math" panose="02040503050406030204" pitchFamily="18" charset="0"/>
+              </a:rPr>
+              <a:t>I</a:t>
+            </a:r>
+            <a:r>
+              <a:rPr lang="en-US" sz="1400" baseline="-25000" dirty="0" err="1">
+                <a:latin typeface="Cambria Math" panose="02040503050406030204" pitchFamily="18" charset="0"/>
+                <a:ea typeface="Cambria Math" panose="02040503050406030204" pitchFamily="18" charset="0"/>
+              </a:rPr>
+              <a:t>bat</a:t>
+            </a:r>
+            <a:r>
+              <a:rPr lang="en-US" sz="1400" dirty="0">
+                <a:latin typeface="Cambria Math" panose="02040503050406030204" pitchFamily="18" charset="0"/>
+                <a:ea typeface="Cambria Math" panose="02040503050406030204" pitchFamily="18" charset="0"/>
+              </a:rPr>
+              <a:t>(t)/M(t)</a:t>
+            </a:r>
+          </a:p>
+        </p:txBody>
+      </p:sp>
+      <p:sp>
+        <p:nvSpPr>
+          <p:cNvPr id="14" name="Rectangle: Rounded Corners 13">
+            <a:extLst>
+              <a:ext uri="{FF2B5EF4-FFF2-40B4-BE49-F238E27FC236}">
+                <a16:creationId xmlns:a16="http://schemas.microsoft.com/office/drawing/2014/main" id="{89566021-6822-F762-FA36-D50EFA599B1C}"/>
+              </a:ext>
+            </a:extLst>
+          </p:cNvPr>
+          <p:cNvSpPr/>
+          <p:nvPr/>
+        </p:nvSpPr>
+        <p:spPr>
+          <a:xfrm>
+            <a:off x="5171813" y="3866524"/>
+            <a:ext cx="6673171" cy="2766967"/>
+          </a:xfrm>
+          <a:prstGeom prst="roundRect">
+            <a:avLst>
+              <a:gd name="adj" fmla="val 3299"/>
+            </a:avLst>
+          </a:prstGeom>
+          <a:noFill/>
+          <a:ln w="38100">
+            <a:solidFill>
+              <a:schemeClr val="tx1"/>
+            </a:solidFill>
+          </a:ln>
+        </p:spPr>
+        <p:style>
+          <a:lnRef idx="2">
+            <a:schemeClr val="accent1">
+              <a:shade val="15000"/>
+            </a:schemeClr>
+          </a:lnRef>
+          <a:fillRef idx="1">
+            <a:schemeClr val="accent1"/>
+          </a:fillRef>
+          <a:effectRef idx="0">
+            <a:schemeClr val="accent1"/>
+          </a:effectRef>
+          <a:fontRef idx="minor">
+            <a:schemeClr val="lt1"/>
+          </a:fontRef>
+        </p:style>
+        <p:txBody>
+          <a:bodyPr rtlCol="0" anchor="ctr"/>
+          <a:lstStyle/>
+          <a:p>
+            <a:pPr algn="ctr"/>
+            <a:endParaRPr lang="en-US"/>
+          </a:p>
+        </p:txBody>
+      </p:sp>
+      <p:sp>
+        <p:nvSpPr>
+          <p:cNvPr id="15" name="TextBox 14">
+            <a:extLst>
+              <a:ext uri="{FF2B5EF4-FFF2-40B4-BE49-F238E27FC236}">
+                <a16:creationId xmlns:a16="http://schemas.microsoft.com/office/drawing/2014/main" id="{BE224596-7B31-273C-9A3D-5BB3C8FB6CAE}"/>
+              </a:ext>
+            </a:extLst>
+          </p:cNvPr>
+          <p:cNvSpPr txBox="1"/>
+          <p:nvPr/>
+        </p:nvSpPr>
+        <p:spPr>
+          <a:xfrm>
+            <a:off x="9690343" y="3857844"/>
+            <a:ext cx="2077621" cy="338554"/>
+          </a:xfrm>
+          <a:prstGeom prst="rect">
+            <a:avLst/>
+          </a:prstGeom>
+          <a:noFill/>
+        </p:spPr>
+        <p:txBody>
+          <a:bodyPr wrap="none" rtlCol="0">
+            <a:spAutoFit/>
+          </a:bodyPr>
+          <a:lstStyle/>
+          <a:p>
+            <a:pPr algn="r"/>
+            <a:r>
+              <a:rPr lang="en-US" sz="1600" b="1" dirty="0"/>
+              <a:t>Complete Toy Model</a:t>
+            </a:r>
+          </a:p>
+        </p:txBody>
+      </p:sp>
+      <p:pic>
+        <p:nvPicPr>
+          <p:cNvPr id="2050" name="Picture 2" descr="Stream i miss LSDvlad trolldespair (old hardtekk mix) by Flerian | Listen  online for free on SoundCloud">
+            <a:extLst>
+              <a:ext uri="{FF2B5EF4-FFF2-40B4-BE49-F238E27FC236}">
+                <a16:creationId xmlns:a16="http://schemas.microsoft.com/office/drawing/2014/main" id="{85468E18-1CEF-64A2-99F1-089D6936D096}"/>
+              </a:ext>
+            </a:extLst>
+          </p:cNvPr>
+          <p:cNvPicPr>
+            <a:picLocks noChangeAspect="1" noChangeArrowheads="1"/>
+          </p:cNvPicPr>
+          <p:nvPr/>
+        </p:nvPicPr>
+        <p:blipFill>
+          <a:blip r:embed="rId5">
+            <a:extLst>
+              <a:ext uri="{28A0092B-C50C-407E-A947-70E740481C1C}">
+                <a14:useLocalDpi xmlns:a14="http://schemas.microsoft.com/office/drawing/2010/main" val="0"/>
+              </a:ext>
+            </a:extLst>
+          </a:blip>
+          <a:srcRect/>
+          <a:stretch>
+            <a:fillRect/>
+          </a:stretch>
+        </p:blipFill>
+        <p:spPr bwMode="auto">
+          <a:xfrm>
+            <a:off x="3257172" y="6046510"/>
+            <a:ext cx="190704" cy="190704"/>
+          </a:xfrm>
+          <a:prstGeom prst="rect">
+            <a:avLst/>
+          </a:prstGeom>
+          <a:noFill/>
+          <a:extLst>
+            <a:ext uri="{909E8E84-426E-40DD-AFC4-6F175D3DCCD1}">
+              <a14:hiddenFill xmlns:a14="http://schemas.microsoft.com/office/drawing/2010/main">
+                <a:solidFill>
+                  <a:srgbClr val="FFFFFF"/>
+                </a:solidFill>
+              </a14:hiddenFill>
+            </a:ext>
+          </a:extLst>
+        </p:spPr>
+      </p:pic>
+    </p:spTree>
+    <p:extLst>
+      <p:ext uri="{BB962C8B-B14F-4D97-AF65-F5344CB8AC3E}">
+        <p14:creationId xmlns:p14="http://schemas.microsoft.com/office/powerpoint/2010/main" val="4224601815"/>
       </p:ext>
     </p:extLst>
   </p:cSld>

</xml_diff>

<commit_message>
evil and intimidating file embed
</commit_message>
<xml_diff>
--- a/UT Robomasters – Supercap Power Stage Modeling.pptx
+++ b/UT Robomasters – Supercap Power Stage Modeling.pptx
@@ -3239,7 +3239,7 @@
             <p:spPr>
               <a:xfrm>
                 <a:off x="325772" y="1497959"/>
-                <a:ext cx="5531135" cy="4686283"/>
+                <a:ext cx="5531135" cy="4286173"/>
               </a:xfrm>
               <a:prstGeom prst="rect">
                 <a:avLst/>
@@ -3253,10 +3253,10 @@
               <a:lstStyle/>
               <a:p>
                 <a:r>
-                  <a:rPr lang="en-US" dirty="0"/>
+                  <a:rPr lang="en-US" sz="1600" dirty="0"/>
                   <a:t>From the equation:</a:t>
                 </a:r>
-                <a:endParaRPr lang="en-US" b="0" dirty="0"/>
+                <a:endParaRPr lang="en-US" sz="1600" b="0" dirty="0"/>
               </a:p>
               <a:p>
                 <a:pPr/>
@@ -3682,13 +3682,12 @@
                 <a:endParaRPr lang="en-US" dirty="0"/>
               </a:p>
               <a:p>
-                <a:pPr/>
                 <a:r>
-                  <a:rPr lang="en-US" dirty="0"/>
+                  <a:rPr lang="en-US" sz="1600" dirty="0"/>
                   <a:t>Multiply by </a:t>
                 </a:r>
                 <a:r>
-                  <a:rPr lang="en-US" dirty="0">
+                  <a:rPr lang="en-US" sz="1600" dirty="0">
                     <a:latin typeface="Cambria Math" panose="02040503050406030204" pitchFamily="18" charset="0"/>
                     <a:ea typeface="Cambria Math" panose="02040503050406030204" pitchFamily="18" charset="0"/>
                   </a:rPr>
@@ -4037,7 +4036,7 @@
               </a:p>
               <a:p>
                 <a:r>
-                  <a:rPr lang="en-US" dirty="0"/>
+                  <a:rPr lang="en-US" sz="1600" dirty="0"/>
                   <a:t>Our algebra trick is a lot simpler now, and we don’t need to complete the square or define a new auxiliary variable:</a:t>
                 </a:r>
               </a:p>
@@ -4244,11 +4243,12 @@
               </a:p>
               <a:p>
                 <a:r>
-                  <a:rPr lang="en-US" dirty="0"/>
+                  <a:rPr lang="en-US" sz="1600" dirty="0"/>
                   <a:t>Our KVL equation is now:</a:t>
                 </a:r>
               </a:p>
               <a:p>
+                <a:pPr/>
                 <a14:m>
                   <m:oMathPara xmlns:m="http://schemas.openxmlformats.org/officeDocument/2006/math">
                     <m:oMathParaPr>
@@ -4579,13 +4579,14 @@
               </a:p>
               <a:p>
                 <a:r>
-                  <a:rPr lang="en-US" dirty="0">
+                  <a:rPr lang="en-US" sz="1600" dirty="0">
                     <a:ea typeface="Cambria Math" panose="02040503050406030204" pitchFamily="18" charset="0"/>
                   </a:rPr>
                   <a:t>Converting to s-domain:</a:t>
                 </a:r>
               </a:p>
               <a:p>
+                <a:pPr/>
                 <a14:m>
                   <m:oMathPara xmlns:m="http://schemas.openxmlformats.org/officeDocument/2006/math">
                     <m:oMathParaPr>
@@ -4754,13 +4755,7 @@
                         <a:rPr lang="en-US" sz="1600" i="1">
                           <a:latin typeface="Cambria Math" panose="02040503050406030204" pitchFamily="18" charset="0"/>
                         </a:rPr>
-                        <m:t>𝑠</m:t>
-                      </m:r>
-                      <m:r>
-                        <a:rPr lang="en-US" sz="1600" i="1">
-                          <a:latin typeface="Cambria Math" panose="02040503050406030204" pitchFamily="18" charset="0"/>
-                        </a:rPr>
-                        <m:t>𝐿</m:t>
+                        <m:t>𝑠𝐿</m:t>
                       </m:r>
                       <m:r>
                         <a:rPr lang="en-US" sz="1600" i="1">
@@ -4915,7 +4910,7 @@
             <p:spPr>
               <a:xfrm>
                 <a:off x="325772" y="1497959"/>
-                <a:ext cx="5531135" cy="4686283"/>
+                <a:ext cx="5531135" cy="4286173"/>
               </a:xfrm>
               <a:prstGeom prst="rect">
                 <a:avLst/>
@@ -4923,7 +4918,7 @@
               <a:blipFill>
                 <a:blip r:embed="rId2"/>
                 <a:stretch>
-                  <a:fillRect l="-881" t="-651"/>
+                  <a:fillRect l="-551" t="-427"/>
                 </a:stretch>
               </a:blipFill>
             </p:spPr>
@@ -5002,7 +4997,7 @@
             <p:spPr>
               <a:xfrm>
                 <a:off x="6335093" y="1497959"/>
-                <a:ext cx="5531135" cy="4780539"/>
+                <a:ext cx="5531135" cy="4380430"/>
               </a:xfrm>
               <a:prstGeom prst="rect">
                 <a:avLst/>
@@ -5016,7 +5011,7 @@
               <a:lstStyle/>
               <a:p>
                 <a:r>
-                  <a:rPr lang="en-US" dirty="0"/>
+                  <a:rPr lang="en-US" sz="1600" dirty="0"/>
                   <a:t>Rewrite as a transfer function:</a:t>
                 </a:r>
               </a:p>
@@ -5208,37 +5203,19 @@
                             <a:rPr lang="en-US" b="0" i="1" smtClean="0">
                               <a:latin typeface="Cambria Math" panose="02040503050406030204" pitchFamily="18" charset="0"/>
                             </a:rPr>
-                            <m:t>𝐿</m:t>
+                            <m:t>𝐿𝐶</m:t>
                           </m:r>
                           <m:r>
                             <a:rPr lang="en-US" b="0" i="1" smtClean="0">
                               <a:latin typeface="Cambria Math" panose="02040503050406030204" pitchFamily="18" charset="0"/>
                             </a:rPr>
-                            <m:t>𝐶</m:t>
+                            <m:t>+</m:t>
                           </m:r>
                           <m:r>
                             <a:rPr lang="en-US" b="0" i="1" smtClean="0">
                               <a:latin typeface="Cambria Math" panose="02040503050406030204" pitchFamily="18" charset="0"/>
                             </a:rPr>
-                            <m:t>+</m:t>
-                          </m:r>
-                          <m:r>
-                            <a:rPr lang="en-US" b="0" i="1" smtClean="0">
-                              <a:latin typeface="Cambria Math" panose="02040503050406030204" pitchFamily="18" charset="0"/>
-                            </a:rPr>
-                            <m:t>𝑠</m:t>
-                          </m:r>
-                          <m:r>
-                            <a:rPr lang="en-US" b="0" i="1" smtClean="0">
-                              <a:latin typeface="Cambria Math" panose="02040503050406030204" pitchFamily="18" charset="0"/>
-                            </a:rPr>
-                            <m:t>𝑅</m:t>
-                          </m:r>
-                          <m:r>
-                            <a:rPr lang="en-US" b="0" i="1" smtClean="0">
-                              <a:latin typeface="Cambria Math" panose="02040503050406030204" pitchFamily="18" charset="0"/>
-                            </a:rPr>
-                            <m:t>𝐶</m:t>
+                            <m:t>𝑠𝑅𝐶</m:t>
                           </m:r>
                           <m:r>
                             <a:rPr lang="en-US" b="0" i="1" smtClean="0">
@@ -5263,49 +5240,73 @@
               </a:p>
               <a:p>
                 <a:r>
-                  <a:rPr lang="en-US" dirty="0">
+                  <a:rPr lang="en-US" sz="1600" dirty="0">
                     <a:ea typeface="Cambria Math" panose="02040503050406030204" pitchFamily="18" charset="0"/>
                   </a:rPr>
                   <a:t>A little messier, but  this is once again a proper transfer function. Note the factor of </a:t>
                 </a:r>
                 <a:r>
-                  <a:rPr lang="en-US" dirty="0">
+                  <a:rPr lang="en-US" sz="1600" dirty="0">
                     <a:latin typeface="Cambria Math" panose="02040503050406030204" pitchFamily="18" charset="0"/>
                     <a:ea typeface="Cambria Math" panose="02040503050406030204" pitchFamily="18" charset="0"/>
                   </a:rPr>
                   <a:t>s</a:t>
                 </a:r>
                 <a:r>
-                  <a:rPr lang="en-US" dirty="0">
+                  <a:rPr lang="en-US" sz="1600" dirty="0">
                     <a:ea typeface="Cambria Math" panose="02040503050406030204" pitchFamily="18" charset="0"/>
                   </a:rPr>
                   <a:t> in the numerator.</a:t>
                 </a:r>
               </a:p>
               <a:p>
-                <a:endParaRPr lang="en-US" dirty="0">
+                <a:endParaRPr lang="en-US" sz="1600" dirty="0">
                   <a:ea typeface="Cambria Math" panose="02040503050406030204" pitchFamily="18" charset="0"/>
                 </a:endParaRPr>
               </a:p>
               <a:p>
                 <a:r>
-                  <a:rPr lang="en-US" dirty="0">
+                  <a:rPr lang="en-US" sz="1600" dirty="0">
                     <a:ea typeface="Cambria Math" panose="02040503050406030204" pitchFamily="18" charset="0"/>
                   </a:rPr>
-                  <a:t>Once again, we can combine the MT(t) to M(t) transformation and the electrical circuitry together and treat it as a singular linear system.</a:t>
+                  <a:t>Once again, we can combine the M</a:t>
+                </a:r>
+                <a:r>
+                  <a:rPr lang="en-US" sz="1600" baseline="-25000" dirty="0">
+                    <a:ea typeface="Cambria Math" panose="02040503050406030204" pitchFamily="18" charset="0"/>
+                  </a:rPr>
+                  <a:t>T</a:t>
+                </a:r>
+                <a:r>
+                  <a:rPr lang="en-US" sz="1600" dirty="0">
+                    <a:ea typeface="Cambria Math" panose="02040503050406030204" pitchFamily="18" charset="0"/>
+                  </a:rPr>
+                  <a:t>(t) to M(t) transformation and the electrical circuitry together and treat it as a singular linear system.</a:t>
                 </a:r>
               </a:p>
               <a:p>
-                <a:endParaRPr lang="en-US" dirty="0">
+                <a:endParaRPr lang="en-US" sz="1600" dirty="0">
                   <a:ea typeface="Cambria Math" panose="02040503050406030204" pitchFamily="18" charset="0"/>
                 </a:endParaRPr>
               </a:p>
               <a:p>
                 <a:r>
-                  <a:rPr lang="en-US" dirty="0">
+                  <a:rPr lang="en-US" sz="1600" dirty="0">
                     <a:ea typeface="Cambria Math" panose="02040503050406030204" pitchFamily="18" charset="0"/>
                   </a:rPr>
-                  <a:t>While I was able to skip over many steps since the approach is similar, this idea of PI2 control seems to be significantly simpler, even if the transfer function looks more complicated. So why not use this method? Let’s test them out…</a:t>
+                  <a:t>While I was able to skip over many steps since the approach is similar, this idea of PI</a:t>
+                </a:r>
+                <a:r>
+                  <a:rPr lang="en-US" sz="1600" baseline="30000" dirty="0">
+                    <a:ea typeface="Cambria Math" panose="02040503050406030204" pitchFamily="18" charset="0"/>
+                  </a:rPr>
+                  <a:t>2</a:t>
+                </a:r>
+                <a:r>
+                  <a:rPr lang="en-US" sz="1600" dirty="0">
+                    <a:ea typeface="Cambria Math" panose="02040503050406030204" pitchFamily="18" charset="0"/>
+                  </a:rPr>
+                  <a:t> control seems to be significantly simpler, even if the transfer function looks more complicated. So why not use this method? Let’s test them out…</a:t>
                 </a:r>
               </a:p>
             </p:txBody>
@@ -5329,7 +5330,7 @@
             <p:spPr>
               <a:xfrm>
                 <a:off x="6335093" y="1497959"/>
-                <a:ext cx="5531135" cy="4780539"/>
+                <a:ext cx="5531135" cy="4380430"/>
               </a:xfrm>
               <a:prstGeom prst="rect">
                 <a:avLst/>
@@ -5337,7 +5338,7 @@
               <a:blipFill>
                 <a:blip r:embed="rId3"/>
                 <a:stretch>
-                  <a:fillRect l="-881" t="-638" r="-1542" b="-1148"/>
+                  <a:fillRect l="-551" t="-418" b="-836"/>
                 </a:stretch>
               </a:blipFill>
             </p:spPr>
@@ -5640,18 +5641,11 @@
               <a:t>In GitHub repository, under </a:t>
             </a:r>
             <a:r>
-              <a:rPr lang="en-US" dirty="0" err="1">
-                <a:latin typeface="Courier New" panose="02070309020205020404" pitchFamily="49" charset="0"/>
-                <a:cs typeface="Courier New" panose="02070309020205020404" pitchFamily="49" charset="0"/>
-              </a:rPr>
-              <a:t>Sims_and_Design</a:t>
-            </a:r>
-            <a:r>
               <a:rPr lang="en-US" dirty="0">
                 <a:latin typeface="Courier New" panose="02070309020205020404" pitchFamily="49" charset="0"/>
                 <a:cs typeface="Courier New" panose="02070309020205020404" pitchFamily="49" charset="0"/>
               </a:rPr>
-              <a:t> </a:t>
+              <a:t>Sims_and_Design </a:t>
             </a:r>
             <a:r>
               <a:rPr lang="en-US" dirty="0"/>
@@ -5863,12 +5857,14 @@
         </p:nvSpPr>
         <p:spPr/>
         <p:txBody>
-          <a:bodyPr/>
+          <a:bodyPr>
+            <a:normAutofit/>
+          </a:bodyPr>
           <a:lstStyle/>
           <a:p>
             <a:r>
-              <a:rPr lang="en-US" dirty="0"/>
-              <a:t>Time-Domain Analysis</a:t>
+              <a:rPr lang="en-US" sz="4000" dirty="0"/>
+              <a:t>Time-Domain Analysis (0s&lt;t&lt;100s)</a:t>
             </a:r>
           </a:p>
         </p:txBody>
@@ -8091,7 +8087,7 @@
             </a:pPr>
             <a:r>
               <a:rPr lang="en-US" dirty="0"/>
-              <a:t>Duty ratios &lt;2.5% and &gt;97.5% are risky</a:t>
+              <a:t>Duty ratios &lt;2.5% and &gt;97.5% are risky because MOSFETs take time to turn on and off</a:t>
             </a:r>
           </a:p>
           <a:p>
@@ -8459,8 +8455,8 @@
         </p:nvSpPr>
         <p:spPr>
           <a:xfrm>
-            <a:off x="7588488" y="3672632"/>
-            <a:ext cx="1556067" cy="369332"/>
+            <a:off x="6750728" y="3672632"/>
+            <a:ext cx="3231590" cy="369332"/>
           </a:xfrm>
           <a:prstGeom prst="rect">
             <a:avLst/>
@@ -8473,9 +8469,10 @@
           </a:bodyPr>
           <a:lstStyle/>
           <a:p>
+            <a:pPr algn="ctr"/>
             <a:r>
               <a:rPr lang="en-US" dirty="0"/>
-              <a:t>Halfway point</a:t>
+              <a:t>Halfway point (50% duty cycle)</a:t>
             </a:r>
           </a:p>
         </p:txBody>
@@ -8496,8 +8493,8 @@
         </p:nvCxnSpPr>
         <p:spPr>
           <a:xfrm flipV="1">
-            <a:off x="8366522" y="3481168"/>
-            <a:ext cx="3192" cy="191464"/>
+            <a:off x="8366523" y="3481168"/>
+            <a:ext cx="3191" cy="191464"/>
           </a:xfrm>
           <a:prstGeom prst="straightConnector1">
             <a:avLst/>
@@ -8839,7 +8836,7 @@
               <a:rPr lang="en-US" dirty="0">
                 <a:ea typeface="Cambria Math" panose="02040503050406030204" pitchFamily="18" charset="0"/>
               </a:rPr>
-              <a:t>Transformer model will be useful for reflection</a:t>
+              <a:t>Transformer model will be useful for reflection math tricks</a:t>
             </a:r>
           </a:p>
         </p:txBody>
@@ -9080,6 +9077,150 @@
             <a:r>
               <a:rPr lang="en-US" sz="1600" b="1" dirty="0"/>
               <a:t>Voltage/Current Source Model</a:t>
+            </a:r>
+          </a:p>
+        </p:txBody>
+      </p:sp>
+      <p:graphicFrame>
+        <p:nvGraphicFramePr>
+          <p:cNvPr id="10" name="Object 9">
+            <a:extLst>
+              <a:ext uri="{FF2B5EF4-FFF2-40B4-BE49-F238E27FC236}">
+                <a16:creationId xmlns:a16="http://schemas.microsoft.com/office/drawing/2014/main" id="{1560186C-8A67-3086-4138-91BD34B6C9CD}"/>
+              </a:ext>
+            </a:extLst>
+          </p:cNvPr>
+          <p:cNvGraphicFramePr>
+            <a:graphicFrameLocks noChangeAspect="1"/>
+          </p:cNvGraphicFramePr>
+          <p:nvPr>
+            <p:extLst>
+              <p:ext uri="{D42A27DB-BD31-4B8C-83A1-F6EECF244321}">
+                <p14:modId xmlns:p14="http://schemas.microsoft.com/office/powerpoint/2010/main" val="2326973494"/>
+              </p:ext>
+            </p:extLst>
+          </p:nvPr>
+        </p:nvGraphicFramePr>
+        <p:xfrm>
+          <a:off x="1046365" y="4356726"/>
+          <a:ext cx="3519082" cy="841740"/>
+        </p:xfrm>
+        <a:graphic>
+          <a:graphicData uri="http://schemas.openxmlformats.org/presentationml/2006/ole">
+            <mc:AlternateContent xmlns:mc="http://schemas.openxmlformats.org/markup-compatibility/2006">
+              <mc:Choice xmlns:v="urn:schemas-microsoft-com:vml" Requires="v">
+                <p:oleObj name="Packager Shell Object" showAsIcon="1" r:id="rId4" imgW="2203306" imgH="526946" progId="Package">
+                  <p:embed/>
+                </p:oleObj>
+              </mc:Choice>
+              <mc:Fallback>
+                <p:oleObj name="Packager Shell Object" showAsIcon="1" r:id="rId4" imgW="2203306" imgH="526946" progId="Package">
+                  <p:embed/>
+                  <p:pic>
+                    <p:nvPicPr>
+                      <p:cNvPr id="0" name=""/>
+                      <p:cNvPicPr/>
+                      <p:nvPr/>
+                    </p:nvPicPr>
+                    <p:blipFill>
+                      <a:blip r:embed="rId5"/>
+                      <a:stretch>
+                        <a:fillRect/>
+                      </a:stretch>
+                    </p:blipFill>
+                    <p:spPr>
+                      <a:xfrm>
+                        <a:off x="1046365" y="4356726"/>
+                        <a:ext cx="3519082" cy="841740"/>
+                      </a:xfrm>
+                      <a:prstGeom prst="rect">
+                        <a:avLst/>
+                      </a:prstGeom>
+                      <a:solidFill>
+                        <a:schemeClr val="tx1"/>
+                      </a:solidFill>
+                    </p:spPr>
+                  </p:pic>
+                </p:oleObj>
+              </mc:Fallback>
+            </mc:AlternateContent>
+          </a:graphicData>
+        </a:graphic>
+      </p:graphicFrame>
+      <p:cxnSp>
+        <p:nvCxnSpPr>
+          <p:cNvPr id="12" name="Straight Arrow Connector 11">
+            <a:extLst>
+              <a:ext uri="{FF2B5EF4-FFF2-40B4-BE49-F238E27FC236}">
+                <a16:creationId xmlns:a16="http://schemas.microsoft.com/office/drawing/2014/main" id="{A1214E82-520D-662C-8CFB-4799E01F806E}"/>
+              </a:ext>
+            </a:extLst>
+          </p:cNvPr>
+          <p:cNvCxnSpPr/>
+          <p:nvPr/>
+        </p:nvCxnSpPr>
+        <p:spPr>
+          <a:xfrm>
+            <a:off x="2805906" y="3963194"/>
+            <a:ext cx="0" cy="317536"/>
+          </a:xfrm>
+          <a:prstGeom prst="straightConnector1">
+            <a:avLst/>
+          </a:prstGeom>
+          <a:ln>
+            <a:solidFill>
+              <a:schemeClr val="tx1"/>
+            </a:solidFill>
+            <a:tailEnd type="triangle"/>
+          </a:ln>
+        </p:spPr>
+        <p:style>
+          <a:lnRef idx="2">
+            <a:schemeClr val="accent1"/>
+          </a:lnRef>
+          <a:fillRef idx="0">
+            <a:schemeClr val="accent1"/>
+          </a:fillRef>
+          <a:effectRef idx="1">
+            <a:schemeClr val="accent1"/>
+          </a:effectRef>
+          <a:fontRef idx="minor">
+            <a:schemeClr val="tx1"/>
+          </a:fontRef>
+        </p:style>
+      </p:cxnSp>
+      <p:sp>
+        <p:nvSpPr>
+          <p:cNvPr id="13" name="TextBox 12">
+            <a:extLst>
+              <a:ext uri="{FF2B5EF4-FFF2-40B4-BE49-F238E27FC236}">
+                <a16:creationId xmlns:a16="http://schemas.microsoft.com/office/drawing/2014/main" id="{F9D3EF73-7794-51D2-F203-EEC3543BE6C9}"/>
+              </a:ext>
+            </a:extLst>
+          </p:cNvPr>
+          <p:cNvSpPr txBox="1"/>
+          <p:nvPr/>
+        </p:nvSpPr>
+        <p:spPr>
+          <a:xfrm>
+            <a:off x="1080914" y="5198466"/>
+            <a:ext cx="3449983" cy="261610"/>
+          </a:xfrm>
+          <a:prstGeom prst="rect">
+            <a:avLst/>
+          </a:prstGeom>
+          <a:noFill/>
+        </p:spPr>
+        <p:txBody>
+          <a:bodyPr wrap="none" rtlCol="0">
+            <a:spAutoFit/>
+          </a:bodyPr>
+          <a:lstStyle/>
+          <a:p>
+            <a:pPr algn="ctr"/>
+            <a:r>
+              <a:rPr lang="en-US" sz="1100" dirty="0"/>
+              <a:t>read it if you don’t know what transformer reflection is</a:t>
             </a:r>
           </a:p>
         </p:txBody>
@@ -10075,11 +10216,9 @@
                 <a:endParaRPr lang="en-US" dirty="0"/>
               </a:p>
               <a:p>
-                <a:pPr/>
                 <a:endParaRPr lang="en-US" dirty="0"/>
               </a:p>
               <a:p>
-                <a:pPr/>
                 <a:r>
                   <a:rPr lang="en-US" sz="800" dirty="0"/>
                   <a:t>*before you ask, yes, this calculation ignores the </a:t>
@@ -10209,7 +10348,7 @@
                 </a14:m>
                 <a:r>
                   <a:rPr lang="en-US" sz="800" dirty="0"/>
-                  <a:t>. It is possible to account for this by doing another pair of transformer voltage/current reflections, but this presentation is long enough anyway, and the term can be concluded to be negligible. Consider it an exercise for the reader, if you will. </a:t>
+                  <a:t>. It is possible to account for this by doing another pair of transformer voltage/current reflections, but this presentation is long enough, and the we find out that the term is negligible anyway. Consider it an exercise for the reader to prove this, if you will. </a:t>
                 </a:r>
               </a:p>
             </p:txBody>
@@ -10493,7 +10632,7 @@
         </p:blipFill>
         <p:spPr bwMode="auto">
           <a:xfrm>
-            <a:off x="2530724" y="5612235"/>
+            <a:off x="2957152" y="5612235"/>
             <a:ext cx="138980" cy="115349"/>
           </a:xfrm>
           <a:prstGeom prst="rect">
@@ -10569,8 +10708,8 @@
           </a:p>
         </p:txBody>
       </p:sp>
-      <mc:AlternateContent xmlns:mc="http://schemas.openxmlformats.org/markup-compatibility/2006" xmlns:a14="http://schemas.microsoft.com/office/drawing/2010/main">
-        <mc:Choice Requires="a14">
+      <mc:AlternateContent xmlns:mc="http://schemas.openxmlformats.org/markup-compatibility/2006">
+        <mc:Choice xmlns:a14="http://schemas.microsoft.com/office/drawing/2010/main" Requires="a14">
           <p:sp>
             <p:nvSpPr>
               <p:cNvPr id="7" name="TextBox 6">
@@ -10586,7 +10725,7 @@
             <p:spPr>
               <a:xfrm>
                 <a:off x="325772" y="1497959"/>
-                <a:ext cx="5531135" cy="4769447"/>
+                <a:ext cx="5531135" cy="4525726"/>
               </a:xfrm>
               <a:prstGeom prst="rect">
                 <a:avLst/>
@@ -10600,10 +10739,10 @@
               <a:lstStyle/>
               <a:p>
                 <a:r>
-                  <a:rPr lang="en-US" dirty="0"/>
+                  <a:rPr lang="en-US" sz="1600" dirty="0"/>
                   <a:t>From the equation:</a:t>
                 </a:r>
-                <a:endParaRPr lang="en-US" b="0" dirty="0"/>
+                <a:endParaRPr lang="en-US" sz="1600" b="0" dirty="0"/>
               </a:p>
               <a:p>
                 <a:pPr/>
@@ -10942,11 +11081,11 @@
               </a:p>
               <a:p>
                 <a:r>
-                  <a:rPr lang="en-US" dirty="0"/>
+                  <a:rPr lang="en-US" sz="1600" dirty="0"/>
                   <a:t>Multiply by </a:t>
                 </a:r>
                 <a:r>
-                  <a:rPr lang="en-US" dirty="0">
+                  <a:rPr lang="en-US" sz="1600" dirty="0">
                     <a:latin typeface="Cambria Math" panose="02040503050406030204" pitchFamily="18" charset="0"/>
                     <a:ea typeface="Cambria Math" panose="02040503050406030204" pitchFamily="18" charset="0"/>
                   </a:rPr>
@@ -11266,7 +11405,7 @@
               </a:p>
               <a:p>
                 <a:r>
-                  <a:rPr lang="en-US" dirty="0"/>
+                  <a:rPr lang="en-US" sz="1600" dirty="0"/>
                   <a:t>This is quite the nasty equation. It has quadratic terms and a derivative. Let’s define a new variable for the LHS of the equation,</a:t>
                 </a:r>
               </a:p>
@@ -11473,45 +11612,45 @@
               </a:p>
               <a:p>
                 <a:r>
-                  <a:rPr lang="en-US" dirty="0"/>
+                  <a:rPr lang="en-US" sz="1600" dirty="0"/>
                   <a:t>labelled </a:t>
                 </a:r>
                 <a:r>
-                  <a:rPr lang="en-US" dirty="0">
+                  <a:rPr lang="en-US" sz="1600" dirty="0">
                     <a:latin typeface="Cambria Math" panose="02040503050406030204" pitchFamily="18" charset="0"/>
                     <a:ea typeface="Cambria Math" panose="02040503050406030204" pitchFamily="18" charset="0"/>
                   </a:rPr>
                   <a:t>M</a:t>
                 </a:r>
                 <a:r>
-                  <a:rPr lang="en-US" baseline="-25000" dirty="0">
+                  <a:rPr lang="en-US" sz="1600" baseline="-25000" dirty="0">
                     <a:latin typeface="Cambria Math" panose="02040503050406030204" pitchFamily="18" charset="0"/>
                     <a:ea typeface="Cambria Math" panose="02040503050406030204" pitchFamily="18" charset="0"/>
                   </a:rPr>
                   <a:t>T</a:t>
                 </a:r>
                 <a:r>
-                  <a:rPr lang="en-US" dirty="0">
+                  <a:rPr lang="en-US" sz="1600" dirty="0">
                     <a:latin typeface="Cambria Math" panose="02040503050406030204" pitchFamily="18" charset="0"/>
                     <a:ea typeface="Cambria Math" panose="02040503050406030204" pitchFamily="18" charset="0"/>
                   </a:rPr>
                   <a:t>(t) </a:t>
                 </a:r>
                 <a:r>
-                  <a:rPr lang="en-US" dirty="0">
+                  <a:rPr lang="en-US" sz="1600" dirty="0">
                     <a:ea typeface="Cambria Math" panose="02040503050406030204" pitchFamily="18" charset="0"/>
                   </a:rPr>
                   <a:t>due to being roughly equivalent to the “transformer reflection” of the voltage gain </a:t>
                 </a:r>
                 <a:r>
-                  <a:rPr lang="en-US" dirty="0">
+                  <a:rPr lang="en-US" sz="1600" dirty="0">
                     <a:latin typeface="Cambria Math" panose="02040503050406030204" pitchFamily="18" charset="0"/>
                     <a:ea typeface="Cambria Math" panose="02040503050406030204" pitchFamily="18" charset="0"/>
                   </a:rPr>
                   <a:t>M(t)</a:t>
                 </a:r>
                 <a:r>
-                  <a:rPr lang="en-US" dirty="0">
+                  <a:rPr lang="en-US" sz="1600" dirty="0">
                     <a:ea typeface="Cambria Math" panose="02040503050406030204" pitchFamily="18" charset="0"/>
                   </a:rPr>
                   <a:t>. </a:t>
@@ -11519,7 +11658,7 @@
               </a:p>
               <a:p>
                 <a:r>
-                  <a:rPr lang="en-US" dirty="0">
+                  <a:rPr lang="en-US" sz="1600" dirty="0">
                     <a:ea typeface="Cambria Math" panose="02040503050406030204" pitchFamily="18" charset="0"/>
                   </a:rPr>
                   <a:t>We complete the square and rewrite:</a:t>
@@ -11825,7 +11964,7 @@
             </p:txBody>
           </p:sp>
         </mc:Choice>
-        <mc:Fallback xmlns="">
+        <mc:Fallback>
           <p:sp>
             <p:nvSpPr>
               <p:cNvPr id="7" name="TextBox 6">
@@ -11843,7 +11982,7 @@
             <p:spPr>
               <a:xfrm>
                 <a:off x="325772" y="1497959"/>
-                <a:ext cx="5531135" cy="4769447"/>
+                <a:ext cx="5531135" cy="4525726"/>
               </a:xfrm>
               <a:prstGeom prst="rect">
                 <a:avLst/>
@@ -11851,7 +11990,7 @@
               <a:blipFill>
                 <a:blip r:embed="rId2"/>
                 <a:stretch>
-                  <a:fillRect l="-881" t="-639" r="-771"/>
+                  <a:fillRect l="-551" t="-404"/>
                 </a:stretch>
               </a:blipFill>
             </p:spPr>
@@ -11913,8 +12052,8 @@
           </a:fontRef>
         </p:style>
       </p:cxnSp>
-      <mc:AlternateContent xmlns:mc="http://schemas.openxmlformats.org/markup-compatibility/2006" xmlns:a14="http://schemas.microsoft.com/office/drawing/2010/main">
-        <mc:Choice Requires="a14">
+      <mc:AlternateContent xmlns:mc="http://schemas.openxmlformats.org/markup-compatibility/2006">
+        <mc:Choice xmlns:a14="http://schemas.microsoft.com/office/drawing/2010/main" Requires="a14">
           <p:sp>
             <p:nvSpPr>
               <p:cNvPr id="10" name="TextBox 9">
@@ -11930,7 +12069,7 @@
             <p:spPr>
               <a:xfrm>
                 <a:off x="6335093" y="1497959"/>
-                <a:ext cx="5531135" cy="4816127"/>
+                <a:ext cx="5531135" cy="4631461"/>
               </a:xfrm>
               <a:prstGeom prst="rect">
                 <a:avLst/>
@@ -11944,14 +12083,14 @@
               <a:lstStyle/>
               <a:p>
                 <a:r>
-                  <a:rPr lang="en-US" b="0" dirty="0"/>
+                  <a:rPr lang="en-US" sz="1600" b="0" dirty="0"/>
                   <a:t>We can the</a:t>
                 </a:r>
                 <a:r>
-                  <a:rPr lang="en-US" dirty="0"/>
+                  <a:rPr lang="en-US" sz="1600" dirty="0"/>
                   <a:t>n define an auxiliary variable:</a:t>
                 </a:r>
-                <a:endParaRPr lang="en-US" b="0" dirty="0"/>
+                <a:endParaRPr lang="en-US" sz="1600" b="0" dirty="0"/>
               </a:p>
               <a:p>
                 <a:pPr/>
@@ -12056,12 +12195,31 @@
                                 </a:rPr>
                                 <m:t>−</m:t>
                               </m:r>
-                              <m:r>
-                                <a:rPr lang="en-US" b="0" i="1" smtClean="0">
-                                  <a:latin typeface="Cambria Math" panose="02040503050406030204" pitchFamily="18" charset="0"/>
-                                </a:rPr>
-                                <m:t>𝐾</m:t>
-                              </m:r>
+                              <m:sSub>
+                                <m:sSubPr>
+                                  <m:ctrlPr>
+                                    <a:rPr lang="en-US" b="0" i="1" smtClean="0">
+                                      <a:latin typeface="Cambria Math" panose="02040503050406030204" pitchFamily="18" charset="0"/>
+                                    </a:rPr>
+                                  </m:ctrlPr>
+                                </m:sSubPr>
+                                <m:e>
+                                  <m:r>
+                                    <a:rPr lang="en-US" b="0" i="1" smtClean="0">
+                                      <a:latin typeface="Cambria Math" panose="02040503050406030204" pitchFamily="18" charset="0"/>
+                                    </a:rPr>
+                                    <m:t>𝐾</m:t>
+                                  </m:r>
+                                </m:e>
+                                <m:sub>
+                                  <m:r>
+                                    <a:rPr lang="en-US" b="0" i="1" smtClean="0">
+                                      <a:latin typeface="Cambria Math" panose="02040503050406030204" pitchFamily="18" charset="0"/>
+                                    </a:rPr>
+                                    <m:t>𝑇</m:t>
+                                  </m:r>
+                                </m:sub>
+                              </m:sSub>
                             </m:e>
                           </m:d>
                         </m:e>
@@ -12080,31 +12238,39 @@
                         </a:rPr>
                         <m:t>−</m:t>
                       </m:r>
-                      <m:sSup>
-                        <m:sSupPr>
+                      <m:sSubSup>
+                        <m:sSubSupPr>
                           <m:ctrlPr>
+                            <a:rPr lang="en-US" b="0" i="1" smtClean="0">
+                              <a:latin typeface="Cambria Math" panose="02040503050406030204" pitchFamily="18" charset="0"/>
+                            </a:rPr>
+                          </m:ctrlPr>
+                        </m:sSubSupPr>
+                        <m:e>
+                          <m:r>
+                            <a:rPr lang="en-US" b="0" i="1" smtClean="0">
+                              <a:latin typeface="Cambria Math" panose="02040503050406030204" pitchFamily="18" charset="0"/>
+                            </a:rPr>
+                            <m:t>𝐾</m:t>
+                          </m:r>
+                        </m:e>
+                        <m:sub>
+                          <m:r>
+                            <a:rPr lang="en-US" b="0" i="1" smtClean="0">
+                              <a:latin typeface="Cambria Math" panose="02040503050406030204" pitchFamily="18" charset="0"/>
+                            </a:rPr>
+                            <m:t>𝑇</m:t>
+                          </m:r>
+                        </m:sub>
+                        <m:sup>
+                          <m:r>
                             <a:rPr lang="en-US" i="1">
                               <a:latin typeface="Cambria Math" panose="02040503050406030204" pitchFamily="18" charset="0"/>
                             </a:rPr>
-                          </m:ctrlPr>
-                        </m:sSupPr>
-                        <m:e>
-                          <m:r>
-                            <a:rPr lang="en-US" b="0" i="1" smtClean="0">
-                              <a:latin typeface="Cambria Math" panose="02040503050406030204" pitchFamily="18" charset="0"/>
-                            </a:rPr>
-                            <m:t>𝐾</m:t>
-                          </m:r>
-                        </m:e>
-                        <m:sup>
-                          <m:r>
-                            <a:rPr lang="en-US" i="1">
-                              <a:latin typeface="Cambria Math" panose="02040503050406030204" pitchFamily="18" charset="0"/>
-                            </a:rPr>
                             <m:t>2</m:t>
                           </m:r>
                         </m:sup>
-                      </m:sSup>
+                      </m:sSubSup>
                       <m:r>
                         <a:rPr lang="en-US" b="0" i="1" smtClean="0">
                           <a:latin typeface="Cambria Math" panose="02040503050406030204" pitchFamily="18" charset="0"/>
@@ -12218,10 +12384,10 @@
               </a:p>
               <a:p>
                 <a:r>
-                  <a:rPr lang="en-US" dirty="0"/>
+                  <a:rPr lang="en-US" sz="1600" dirty="0"/>
                   <a:t>Rewrite the KVL equation:</a:t>
                 </a:r>
-                <a:endParaRPr lang="en-US" dirty="0">
+                <a:endParaRPr lang="en-US" sz="1600" dirty="0">
                   <a:latin typeface="Cambria Math" panose="02040503050406030204" pitchFamily="18" charset="0"/>
                   <a:ea typeface="Cambria Math" panose="02040503050406030204" pitchFamily="18" charset="0"/>
                 </a:endParaRPr>
@@ -12474,7 +12640,7 @@
               </a:p>
               <a:p>
                 <a:r>
-                  <a:rPr lang="en-US" dirty="0"/>
+                  <a:rPr lang="en-US" sz="1600" dirty="0"/>
                   <a:t>By encapsulating the quadratic term within a new variable, we now have only additions, scalar multiplications, and derivatives – the equation is linear! We can now convert to s-domain:</a:t>
                 </a:r>
               </a:p>
@@ -12712,7 +12878,7 @@
               </a:p>
               <a:p>
                 <a:r>
-                  <a:rPr lang="en-US" dirty="0"/>
+                  <a:rPr lang="en-US" sz="1600" dirty="0"/>
                   <a:t>Rewrite as a transfer function:</a:t>
                 </a:r>
               </a:p>
@@ -12898,7 +13064,7 @@
               </a:p>
               <a:p>
                 <a:r>
-                  <a:rPr lang="en-US" dirty="0">
+                  <a:rPr lang="en-US" sz="1600" dirty="0">
                     <a:ea typeface="Cambria Math" panose="02040503050406030204" pitchFamily="18" charset="0"/>
                   </a:rPr>
                   <a:t>We have a proper transfer function now!</a:t>
@@ -12907,7 +13073,7 @@
             </p:txBody>
           </p:sp>
         </mc:Choice>
-        <mc:Fallback xmlns="">
+        <mc:Fallback>
           <p:sp>
             <p:nvSpPr>
               <p:cNvPr id="10" name="TextBox 9">
@@ -12925,7 +13091,7 @@
             <p:spPr>
               <a:xfrm>
                 <a:off x="6335093" y="1497959"/>
-                <a:ext cx="5531135" cy="4816127"/>
+                <a:ext cx="5531135" cy="4631461"/>
               </a:xfrm>
               <a:prstGeom prst="rect">
                 <a:avLst/>
@@ -12933,7 +13099,7 @@
               <a:blipFill>
                 <a:blip r:embed="rId3"/>
                 <a:stretch>
-                  <a:fillRect l="-881" t="-633" b="-1139"/>
+                  <a:fillRect l="-551" t="-395"/>
                 </a:stretch>
               </a:blipFill>
             </p:spPr>
@@ -12966,7 +13132,7 @@
         </p:nvSpPr>
         <p:spPr>
           <a:xfrm>
-            <a:off x="7868873" y="5004033"/>
+            <a:off x="7850700" y="4806206"/>
             <a:ext cx="2499920" cy="864066"/>
           </a:xfrm>
           <a:prstGeom prst="rect">
@@ -13735,8 +13901,8 @@
           </a:p>
         </p:txBody>
       </p:sp>
-      <mc:AlternateContent xmlns:mc="http://schemas.openxmlformats.org/markup-compatibility/2006">
-        <mc:Choice xmlns:a14="http://schemas.microsoft.com/office/drawing/2010/main" Requires="a14">
+      <mc:AlternateContent xmlns:mc="http://schemas.openxmlformats.org/markup-compatibility/2006" xmlns:a14="http://schemas.microsoft.com/office/drawing/2010/main">
+        <mc:Choice Requires="a14">
           <p:sp>
             <p:nvSpPr>
               <p:cNvPr id="12" name="TextBox 11">
@@ -13858,7 +14024,7 @@
             </p:txBody>
           </p:sp>
         </mc:Choice>
-        <mc:Fallback>
+        <mc:Fallback xmlns="">
           <p:sp>
             <p:nvSpPr>
               <p:cNvPr id="12" name="TextBox 11">
@@ -13952,8 +14118,8 @@
           </a:fontRef>
         </p:style>
       </p:cxnSp>
-      <mc:AlternateContent xmlns:mc="http://schemas.openxmlformats.org/markup-compatibility/2006">
-        <mc:Choice xmlns:a14="http://schemas.microsoft.com/office/drawing/2010/main" Requires="a14">
+      <mc:AlternateContent xmlns:mc="http://schemas.openxmlformats.org/markup-compatibility/2006" xmlns:a14="http://schemas.microsoft.com/office/drawing/2010/main">
+        <mc:Choice Requires="a14">
           <p:sp>
             <p:nvSpPr>
               <p:cNvPr id="18" name="TextBox 17">
@@ -14333,7 +14499,7 @@
             </p:txBody>
           </p:sp>
         </mc:Choice>
-        <mc:Fallback>
+        <mc:Fallback xmlns="">
           <p:sp>
             <p:nvSpPr>
               <p:cNvPr id="18" name="TextBox 17">
@@ -14493,8 +14659,8 @@
           </a:p>
         </p:txBody>
       </p:sp>
-      <mc:AlternateContent xmlns:mc="http://schemas.openxmlformats.org/markup-compatibility/2006">
-        <mc:Choice xmlns:a14="http://schemas.microsoft.com/office/drawing/2010/main" Requires="a14">
+      <mc:AlternateContent xmlns:mc="http://schemas.openxmlformats.org/markup-compatibility/2006" xmlns:a14="http://schemas.microsoft.com/office/drawing/2010/main">
+        <mc:Choice Requires="a14">
           <p:sp>
             <p:nvSpPr>
               <p:cNvPr id="5" name="Text Placeholder 4">
@@ -14564,6 +14730,7 @@
                 <a:endParaRPr lang="en-US" dirty="0"/>
               </a:p>
               <a:p>
+                <a:pPr/>
                 <a14:m>
                   <m:oMathPara xmlns:m="http://schemas.openxmlformats.org/officeDocument/2006/math">
                     <m:oMathParaPr>
@@ -14997,7 +15164,7 @@
             </p:txBody>
           </p:sp>
         </mc:Choice>
-        <mc:Fallback>
+        <mc:Fallback xmlns="">
           <p:sp>
             <p:nvSpPr>
               <p:cNvPr id="5" name="Text Placeholder 4">

</xml_diff>

<commit_message>
big progress on layout
</commit_message>
<xml_diff>
--- a/UT Robomasters – Supercap Power Stage Modeling.pptx
+++ b/UT Robomasters – Supercap Power Stage Modeling.pptx
@@ -19,8 +19,10 @@
     <p:sldId id="265" r:id="rId13"/>
     <p:sldId id="267" r:id="rId14"/>
     <p:sldId id="268" r:id="rId15"/>
-    <p:sldId id="270" r:id="rId16"/>
-    <p:sldId id="272" r:id="rId17"/>
+    <p:sldId id="273" r:id="rId16"/>
+    <p:sldId id="270" r:id="rId17"/>
+    <p:sldId id="274" r:id="rId18"/>
+    <p:sldId id="272" r:id="rId19"/>
   </p:sldIdLst>
   <p:sldSz cx="12192000" cy="6858000"/>
   <p:notesSz cx="6858000" cy="9144000"/>
@@ -258,7 +260,7 @@
           <a:p>
             <a:fld id="{116CDFA8-9B71-48D2-9BC8-093B5490E257}" type="datetimeFigureOut">
               <a:rPr lang="en-US" smtClean="0"/>
-              <a:t>3/12/2026</a:t>
+              <a:t>3/17/2026</a:t>
             </a:fld>
             <a:endParaRPr lang="en-US"/>
           </a:p>
@@ -428,7 +430,7 @@
           <a:p>
             <a:fld id="{116CDFA8-9B71-48D2-9BC8-093B5490E257}" type="datetimeFigureOut">
               <a:rPr lang="en-US" smtClean="0"/>
-              <a:t>3/12/2026</a:t>
+              <a:t>3/17/2026</a:t>
             </a:fld>
             <a:endParaRPr lang="en-US"/>
           </a:p>
@@ -608,7 +610,7 @@
           <a:p>
             <a:fld id="{116CDFA8-9B71-48D2-9BC8-093B5490E257}" type="datetimeFigureOut">
               <a:rPr lang="en-US" smtClean="0"/>
-              <a:t>3/12/2026</a:t>
+              <a:t>3/17/2026</a:t>
             </a:fld>
             <a:endParaRPr lang="en-US"/>
           </a:p>
@@ -778,7 +780,7 @@
           <a:p>
             <a:fld id="{116CDFA8-9B71-48D2-9BC8-093B5490E257}" type="datetimeFigureOut">
               <a:rPr lang="en-US" smtClean="0"/>
-              <a:t>3/12/2026</a:t>
+              <a:t>3/17/2026</a:t>
             </a:fld>
             <a:endParaRPr lang="en-US"/>
           </a:p>
@@ -1024,7 +1026,7 @@
           <a:p>
             <a:fld id="{116CDFA8-9B71-48D2-9BC8-093B5490E257}" type="datetimeFigureOut">
               <a:rPr lang="en-US" smtClean="0"/>
-              <a:t>3/12/2026</a:t>
+              <a:t>3/17/2026</a:t>
             </a:fld>
             <a:endParaRPr lang="en-US"/>
           </a:p>
@@ -1256,7 +1258,7 @@
           <a:p>
             <a:fld id="{116CDFA8-9B71-48D2-9BC8-093B5490E257}" type="datetimeFigureOut">
               <a:rPr lang="en-US" smtClean="0"/>
-              <a:t>3/12/2026</a:t>
+              <a:t>3/17/2026</a:t>
             </a:fld>
             <a:endParaRPr lang="en-US"/>
           </a:p>
@@ -1623,7 +1625,7 @@
           <a:p>
             <a:fld id="{116CDFA8-9B71-48D2-9BC8-093B5490E257}" type="datetimeFigureOut">
               <a:rPr lang="en-US" smtClean="0"/>
-              <a:t>3/12/2026</a:t>
+              <a:t>3/17/2026</a:t>
             </a:fld>
             <a:endParaRPr lang="en-US"/>
           </a:p>
@@ -1741,7 +1743,7 @@
           <a:p>
             <a:fld id="{116CDFA8-9B71-48D2-9BC8-093B5490E257}" type="datetimeFigureOut">
               <a:rPr lang="en-US" smtClean="0"/>
-              <a:t>3/12/2026</a:t>
+              <a:t>3/17/2026</a:t>
             </a:fld>
             <a:endParaRPr lang="en-US"/>
           </a:p>
@@ -1836,7 +1838,7 @@
           <a:p>
             <a:fld id="{116CDFA8-9B71-48D2-9BC8-093B5490E257}" type="datetimeFigureOut">
               <a:rPr lang="en-US" smtClean="0"/>
-              <a:t>3/12/2026</a:t>
+              <a:t>3/17/2026</a:t>
             </a:fld>
             <a:endParaRPr lang="en-US"/>
           </a:p>
@@ -2113,7 +2115,7 @@
           <a:p>
             <a:fld id="{116CDFA8-9B71-48D2-9BC8-093B5490E257}" type="datetimeFigureOut">
               <a:rPr lang="en-US" smtClean="0"/>
-              <a:t>3/12/2026</a:t>
+              <a:t>3/17/2026</a:t>
             </a:fld>
             <a:endParaRPr lang="en-US"/>
           </a:p>
@@ -2370,7 +2372,7 @@
           <a:p>
             <a:fld id="{116CDFA8-9B71-48D2-9BC8-093B5490E257}" type="datetimeFigureOut">
               <a:rPr lang="en-US" smtClean="0"/>
-              <a:t>3/12/2026</a:t>
+              <a:t>3/17/2026</a:t>
             </a:fld>
             <a:endParaRPr lang="en-US"/>
           </a:p>
@@ -2583,7 +2585,7 @@
           <a:p>
             <a:fld id="{116CDFA8-9B71-48D2-9BC8-093B5490E257}" type="datetimeFigureOut">
               <a:rPr lang="en-US" smtClean="0"/>
-              <a:t>3/12/2026</a:t>
+              <a:t>3/17/2026</a:t>
             </a:fld>
             <a:endParaRPr lang="en-US"/>
           </a:p>
@@ -3229,7 +3231,7 @@
             <p:spPr>
               <a:xfrm>
                 <a:off x="883299" y="1546789"/>
-                <a:ext cx="5531135" cy="3240695"/>
+                <a:ext cx="5531135" cy="3468963"/>
               </a:xfrm>
               <a:prstGeom prst="rect">
                 <a:avLst/>
@@ -3376,12 +3378,31 @@
                                 </a:rPr>
                                 <m:t>−</m:t>
                               </m:r>
-                              <m:r>
-                                <a:rPr lang="en-US" i="1">
-                                  <a:latin typeface="Cambria Math" panose="02040503050406030204" pitchFamily="18" charset="0"/>
-                                </a:rPr>
-                                <m:t>𝐾</m:t>
-                              </m:r>
+                              <m:sSub>
+                                <m:sSubPr>
+                                  <m:ctrlPr>
+                                    <a:rPr lang="en-US" b="0" i="1" smtClean="0">
+                                      <a:latin typeface="Cambria Math" panose="02040503050406030204" pitchFamily="18" charset="0"/>
+                                    </a:rPr>
+                                  </m:ctrlPr>
+                                </m:sSubPr>
+                                <m:e>
+                                  <m:r>
+                                    <a:rPr lang="en-US" i="1">
+                                      <a:latin typeface="Cambria Math" panose="02040503050406030204" pitchFamily="18" charset="0"/>
+                                    </a:rPr>
+                                    <m:t>𝐾</m:t>
+                                  </m:r>
+                                </m:e>
+                                <m:sub>
+                                  <m:r>
+                                    <a:rPr lang="en-US" b="0" i="1" smtClean="0">
+                                      <a:latin typeface="Cambria Math" panose="02040503050406030204" pitchFamily="18" charset="0"/>
+                                    </a:rPr>
+                                    <m:t>𝑇</m:t>
+                                  </m:r>
+                                </m:sub>
+                              </m:sSub>
                             </m:e>
                           </m:d>
                         </m:e>
@@ -3400,31 +3421,39 @@
                         </a:rPr>
                         <m:t>−</m:t>
                       </m:r>
-                      <m:sSup>
-                        <m:sSupPr>
+                      <m:sSubSup>
+                        <m:sSubSupPr>
                           <m:ctrlPr>
+                            <a:rPr lang="en-US" b="0" i="1" smtClean="0">
+                              <a:latin typeface="Cambria Math" panose="02040503050406030204" pitchFamily="18" charset="0"/>
+                            </a:rPr>
+                          </m:ctrlPr>
+                        </m:sSubSupPr>
+                        <m:e>
+                          <m:r>
                             <a:rPr lang="en-US" i="1">
                               <a:latin typeface="Cambria Math" panose="02040503050406030204" pitchFamily="18" charset="0"/>
                             </a:rPr>
-                          </m:ctrlPr>
-                        </m:sSupPr>
-                        <m:e>
+                            <m:t>𝐾</m:t>
+                          </m:r>
+                        </m:e>
+                        <m:sub>
+                          <m:r>
+                            <a:rPr lang="en-US" b="0" i="1" smtClean="0">
+                              <a:latin typeface="Cambria Math" panose="02040503050406030204" pitchFamily="18" charset="0"/>
+                            </a:rPr>
+                            <m:t>𝑇</m:t>
+                          </m:r>
+                        </m:sub>
+                        <m:sup>
                           <m:r>
                             <a:rPr lang="en-US" i="1">
                               <a:latin typeface="Cambria Math" panose="02040503050406030204" pitchFamily="18" charset="0"/>
                             </a:rPr>
-                            <m:t>𝐾</m:t>
-                          </m:r>
-                        </m:e>
-                        <m:sup>
-                          <m:r>
-                            <a:rPr lang="en-US" i="1">
-                              <a:latin typeface="Cambria Math" panose="02040503050406030204" pitchFamily="18" charset="0"/>
-                            </a:rPr>
                             <m:t>2</m:t>
                           </m:r>
                         </m:sup>
-                      </m:sSup>
+                      </m:sSubSup>
                       <m:r>
                         <a:rPr lang="en-US" i="1">
                           <a:latin typeface="Cambria Math" panose="02040503050406030204" pitchFamily="18" charset="0"/>
@@ -3586,14 +3615,14 @@
                         </a:rPr>
                         <m:t>=</m:t>
                       </m:r>
-                      <m:sSup>
-                        <m:sSupPr>
+                      <m:sSub>
+                        <m:sSubPr>
                           <m:ctrlPr>
                             <a:rPr lang="en-US" b="0" i="1" smtClean="0">
                               <a:latin typeface="Cambria Math" panose="02040503050406030204" pitchFamily="18" charset="0"/>
                             </a:rPr>
                           </m:ctrlPr>
-                        </m:sSupPr>
+                        </m:sSubPr>
                         <m:e>
                           <m:r>
                             <a:rPr lang="en-US" b="0" i="1" smtClean="0">
@@ -3602,15 +3631,15 @@
                             <m:t>𝐾</m:t>
                           </m:r>
                         </m:e>
-                        <m:sup>
+                        <m:sub>
                           <m:r>
                             <a:rPr lang="en-US" b="0" i="1" smtClean="0">
                               <a:latin typeface="Cambria Math" panose="02040503050406030204" pitchFamily="18" charset="0"/>
                             </a:rPr>
-                            <m:t>2</m:t>
-                          </m:r>
-                        </m:sup>
-                      </m:sSup>
+                            <m:t>𝑇</m:t>
+                          </m:r>
+                        </m:sub>
+                      </m:sSub>
                       <m:r>
                         <a:rPr lang="en-US" i="1" smtClean="0">
                           <a:latin typeface="Cambria Math" panose="02040503050406030204" pitchFamily="18" charset="0"/>
@@ -3677,12 +3706,39 @@
                             </a:rPr>
                             <m:t>+</m:t>
                           </m:r>
-                          <m:r>
-                            <a:rPr lang="en-US" i="1">
-                              <a:latin typeface="Cambria Math" panose="02040503050406030204" pitchFamily="18" charset="0"/>
-                            </a:rPr>
-                            <m:t>𝐾</m:t>
-                          </m:r>
+                          <m:sSubSup>
+                            <m:sSubSupPr>
+                              <m:ctrlPr>
+                                <a:rPr lang="en-US" b="0" i="1" smtClean="0">
+                                  <a:latin typeface="Cambria Math" panose="02040503050406030204" pitchFamily="18" charset="0"/>
+                                </a:rPr>
+                              </m:ctrlPr>
+                            </m:sSubSupPr>
+                            <m:e>
+                              <m:r>
+                                <a:rPr lang="en-US" i="1">
+                                  <a:latin typeface="Cambria Math" panose="02040503050406030204" pitchFamily="18" charset="0"/>
+                                </a:rPr>
+                                <m:t>𝐾</m:t>
+                              </m:r>
+                            </m:e>
+                            <m:sub>
+                              <m:r>
+                                <a:rPr lang="en-US" b="0" i="1" smtClean="0">
+                                  <a:latin typeface="Cambria Math" panose="02040503050406030204" pitchFamily="18" charset="0"/>
+                                </a:rPr>
+                                <m:t>𝑇</m:t>
+                              </m:r>
+                            </m:sub>
+                            <m:sup>
+                              <m:r>
+                                <a:rPr lang="en-US" b="0" i="1" smtClean="0">
+                                  <a:latin typeface="Cambria Math" panose="02040503050406030204" pitchFamily="18" charset="0"/>
+                                </a:rPr>
+                                <m:t>2</m:t>
+                              </m:r>
+                            </m:sup>
+                          </m:sSubSup>
                         </m:e>
                       </m:rad>
                     </m:oMath>
@@ -3733,7 +3789,7 @@
             <p:spPr>
               <a:xfrm>
                 <a:off x="883299" y="1546789"/>
-                <a:ext cx="5531135" cy="3240695"/>
+                <a:ext cx="5531135" cy="3468963"/>
               </a:xfrm>
               <a:prstGeom prst="rect">
                 <a:avLst/>
@@ -3741,7 +3797,7 @@
               <a:blipFill>
                 <a:blip r:embed="rId2"/>
                 <a:stretch>
-                  <a:fillRect l="-992" t="-1507" b="-2260"/>
+                  <a:fillRect l="-992" t="-1406" b="-2109"/>
                 </a:stretch>
               </a:blipFill>
             </p:spPr>
@@ -8185,7 +8241,12 @@
             <p:ph type="title"/>
           </p:nvPr>
         </p:nvSpPr>
-        <p:spPr/>
+        <p:spPr>
+          <a:xfrm>
+            <a:off x="839788" y="403123"/>
+            <a:ext cx="3932237" cy="848032"/>
+          </a:xfrm>
+        </p:spPr>
         <p:txBody>
           <a:bodyPr/>
           <a:lstStyle/>
@@ -8215,9 +8276,16 @@
                 <p:ph type="body" sz="half" idx="2"/>
               </p:nvPr>
             </p:nvSpPr>
-            <p:spPr/>
+            <p:spPr>
+              <a:xfrm>
+                <a:off x="839788" y="1251155"/>
+                <a:ext cx="3932237" cy="4490884"/>
+              </a:xfrm>
+            </p:spPr>
             <p:txBody>
-              <a:bodyPr/>
+              <a:bodyPr>
+                <a:normAutofit/>
+              </a:bodyPr>
               <a:lstStyle/>
               <a:p>
                 <a:r>
@@ -8508,6 +8576,26 @@
                   <a:t> is not a scalar value, and this has come back to bite us in the back. Notice that this integral term corresponds precisely to the voltage term that was accounted for with a feed-forward signal! </a:t>
                 </a:r>
               </a:p>
+              <a:p>
+                <a:r>
+                  <a:rPr lang="en-US" dirty="0"/>
+                  <a:t>Therefore, going forward, our best bet is to stick with FF+PI control. </a:t>
+                </a:r>
+              </a:p>
+              <a:p>
+                <a:r>
+                  <a:rPr lang="en-US" dirty="0"/>
+                  <a:t>Note: If y’all can figure out a way to get a more accurate representation of the system and get a feasible implementation of PI</a:t>
+                </a:r>
+                <a:r>
+                  <a:rPr lang="en-US" baseline="30000" dirty="0"/>
+                  <a:t>2</a:t>
+                </a:r>
+                <a:r>
+                  <a:rPr lang="en-US" dirty="0"/>
+                  <a:t> control, please let me know</a:t>
+                </a:r>
+              </a:p>
             </p:txBody>
           </p:sp>
         </mc:Choice>
@@ -8529,10 +8617,14 @@
               </p:nvPr>
             </p:nvSpPr>
             <p:spPr>
+              <a:xfrm>
+                <a:off x="839788" y="1251155"/>
+                <a:ext cx="3932237" cy="4490884"/>
+              </a:xfrm>
               <a:blipFill>
                 <a:blip r:embed="rId2"/>
                 <a:stretch>
-                  <a:fillRect l="-9302" t="-14560" r="-2326"/>
+                  <a:fillRect l="-9302" t="-12347" r="-2326"/>
                 </a:stretch>
               </a:blipFill>
             </p:spPr>
@@ -8573,7 +8665,7 @@
         </p:blipFill>
         <p:spPr>
           <a:xfrm>
-            <a:off x="4945613" y="1387848"/>
+            <a:off x="4955445" y="1251155"/>
             <a:ext cx="7108607" cy="3444129"/>
           </a:xfrm>
           <a:prstGeom prst="rect">
@@ -8616,6 +8708,117 @@
           <p:cNvPr id="2" name="Title 1">
             <a:extLst>
               <a:ext uri="{FF2B5EF4-FFF2-40B4-BE49-F238E27FC236}">
+                <a16:creationId xmlns:a16="http://schemas.microsoft.com/office/drawing/2014/main" id="{FBAB8E09-6462-C114-BB7E-1DA5A04BEAB9}"/>
+              </a:ext>
+            </a:extLst>
+          </p:cNvPr>
+          <p:cNvSpPr>
+            <a:spLocks noGrp="1"/>
+          </p:cNvSpPr>
+          <p:nvPr>
+            <p:ph type="title"/>
+          </p:nvPr>
+        </p:nvSpPr>
+        <p:spPr/>
+        <p:txBody>
+          <a:bodyPr/>
+          <a:lstStyle/>
+          <a:p>
+            <a:r>
+              <a:rPr lang="en-US" dirty="0"/>
+              <a:t>Addendum: On Feed-Forward Systems</a:t>
+            </a:r>
+          </a:p>
+        </p:txBody>
+      </p:sp>
+      <p:sp>
+        <p:nvSpPr>
+          <p:cNvPr id="3" name="Content Placeholder 2">
+            <a:extLst>
+              <a:ext uri="{FF2B5EF4-FFF2-40B4-BE49-F238E27FC236}">
+                <a16:creationId xmlns:a16="http://schemas.microsoft.com/office/drawing/2014/main" id="{333F89A1-3EA7-E57C-621F-60AFC6CB7643}"/>
+              </a:ext>
+            </a:extLst>
+          </p:cNvPr>
+          <p:cNvSpPr>
+            <a:spLocks noGrp="1"/>
+          </p:cNvSpPr>
+          <p:nvPr>
+            <p:ph idx="1"/>
+          </p:nvPr>
+        </p:nvSpPr>
+        <p:spPr/>
+        <p:txBody>
+          <a:bodyPr/>
+          <a:lstStyle/>
+          <a:p>
+            <a:pPr marL="0" indent="0">
+              <a:buNone/>
+            </a:pPr>
+            <a:r>
+              <a:rPr lang="en-US" dirty="0"/>
+              <a:t>In general, feed-forward systems are a way to perform </a:t>
+            </a:r>
+            <a:r>
+              <a:rPr lang="en-US" i="1" dirty="0"/>
+              <a:t>disturbance rejection</a:t>
+            </a:r>
+            <a:r>
+              <a:rPr lang="en-US" dirty="0"/>
+              <a:t>, where extraneous signals that result from interactions of the system with itself and surroundings (known as disturbances) have their undesirable effects minimized. This particular approach directly measures the quantity in question (capacitor voltage) and subtracts it – pretty intuitive. </a:t>
+            </a:r>
+          </a:p>
+          <a:p>
+            <a:pPr marL="0" indent="0">
+              <a:buNone/>
+            </a:pPr>
+            <a:r>
+              <a:rPr lang="en-US" dirty="0"/>
+              <a:t>A question that may rise up: Why </a:t>
+            </a:r>
+            <a:r>
+              <a:rPr lang="en-US"/>
+              <a:t>not feed-forward</a:t>
+            </a:r>
+            <a:endParaRPr lang="en-US" dirty="0"/>
+          </a:p>
+        </p:txBody>
+      </p:sp>
+    </p:spTree>
+    <p:extLst>
+      <p:ext uri="{BB962C8B-B14F-4D97-AF65-F5344CB8AC3E}">
+        <p14:creationId xmlns:p14="http://schemas.microsoft.com/office/powerpoint/2010/main" val="3866866915"/>
+      </p:ext>
+    </p:extLst>
+  </p:cSld>
+  <p:clrMapOvr>
+    <a:masterClrMapping/>
+  </p:clrMapOvr>
+</p:sld>
+</file>
+
+<file path=ppt/slides/slide16.xml><?xml version="1.0" encoding="utf-8"?>
+<p:sld xmlns:a="http://schemas.openxmlformats.org/drawingml/2006/main" xmlns:r="http://schemas.openxmlformats.org/officeDocument/2006/relationships" xmlns:p="http://schemas.openxmlformats.org/presentationml/2006/main">
+  <p:cSld>
+    <p:spTree>
+      <p:nvGrpSpPr>
+        <p:cNvPr id="1" name=""/>
+        <p:cNvGrpSpPr/>
+        <p:nvPr/>
+      </p:nvGrpSpPr>
+      <p:grpSpPr>
+        <a:xfrm>
+          <a:off x="0" y="0"/>
+          <a:ext cx="0" cy="0"/>
+          <a:chOff x="0" y="0"/>
+          <a:chExt cx="0" cy="0"/>
+        </a:xfrm>
+      </p:grpSpPr>
+      <p:sp>
+        <p:nvSpPr>
+          <p:cNvPr id="2" name="Title 1">
+            <a:extLst>
+              <a:ext uri="{FF2B5EF4-FFF2-40B4-BE49-F238E27FC236}">
                 <a16:creationId xmlns:a16="http://schemas.microsoft.com/office/drawing/2014/main" id="{C2289A3D-D927-CD28-04C2-6773BAFAD05E}"/>
               </a:ext>
             </a:extLst>
@@ -8634,7 +8837,7 @@
           <a:p>
             <a:r>
               <a:rPr lang="en-US" dirty="0"/>
-              <a:t>Section 2: Disturbance Rejection &amp; Robustness</a:t>
+              <a:t>Section 2: Reverse Charging and Boost Mode</a:t>
             </a:r>
           </a:p>
         </p:txBody>
@@ -8662,15 +8865,15 @@
           <a:p>
             <a:r>
               <a:rPr lang="en-US" dirty="0"/>
-              <a:t>alright guys ill need </a:t>
+              <a:t>PLECs I </a:t>
             </a:r>
             <a:r>
               <a:rPr lang="en-US" dirty="0" err="1"/>
-              <a:t>yall</a:t>
+              <a:t>neeeeeed</a:t>
             </a:r>
             <a:r>
               <a:rPr lang="en-US" dirty="0"/>
-              <a:t> to pitch in now</a:t>
+              <a:t> this my transformer is kinda lossless</a:t>
             </a:r>
           </a:p>
         </p:txBody>
@@ -8688,7 +8891,107 @@
 </p:sld>
 </file>
 
-<file path=ppt/slides/slide16.xml><?xml version="1.0" encoding="utf-8"?>
+<file path=ppt/slides/slide17.xml><?xml version="1.0" encoding="utf-8"?>
+<p:sld xmlns:a="http://schemas.openxmlformats.org/drawingml/2006/main" xmlns:r="http://schemas.openxmlformats.org/officeDocument/2006/relationships" xmlns:p="http://schemas.openxmlformats.org/presentationml/2006/main">
+  <p:cSld>
+    <p:spTree>
+      <p:nvGrpSpPr>
+        <p:cNvPr id="1" name="">
+          <a:extLst>
+            <a:ext uri="{FF2B5EF4-FFF2-40B4-BE49-F238E27FC236}">
+              <a16:creationId xmlns:a16="http://schemas.microsoft.com/office/drawing/2014/main" id="{B7350BB5-4C83-F743-B01B-F9CDC2372D05}"/>
+            </a:ext>
+          </a:extLst>
+        </p:cNvPr>
+        <p:cNvGrpSpPr/>
+        <p:nvPr/>
+      </p:nvGrpSpPr>
+      <p:grpSpPr>
+        <a:xfrm>
+          <a:off x="0" y="0"/>
+          <a:ext cx="0" cy="0"/>
+          <a:chOff x="0" y="0"/>
+          <a:chExt cx="0" cy="0"/>
+        </a:xfrm>
+      </p:grpSpPr>
+      <p:sp>
+        <p:nvSpPr>
+          <p:cNvPr id="2" name="Title 1">
+            <a:extLst>
+              <a:ext uri="{FF2B5EF4-FFF2-40B4-BE49-F238E27FC236}">
+                <a16:creationId xmlns:a16="http://schemas.microsoft.com/office/drawing/2014/main" id="{0535F886-F4AC-B6CB-4CEC-424A3051C91F}"/>
+              </a:ext>
+            </a:extLst>
+          </p:cNvPr>
+          <p:cNvSpPr>
+            <a:spLocks noGrp="1"/>
+          </p:cNvSpPr>
+          <p:nvPr>
+            <p:ph type="title"/>
+          </p:nvPr>
+        </p:nvSpPr>
+        <p:spPr/>
+        <p:txBody>
+          <a:bodyPr/>
+          <a:lstStyle/>
+          <a:p>
+            <a:r>
+              <a:rPr lang="en-US" dirty="0"/>
+              <a:t>Section 3: Disturbance Rejection &amp; Robustness</a:t>
+            </a:r>
+          </a:p>
+        </p:txBody>
+      </p:sp>
+      <p:sp>
+        <p:nvSpPr>
+          <p:cNvPr id="3" name="Text Placeholder 2">
+            <a:extLst>
+              <a:ext uri="{FF2B5EF4-FFF2-40B4-BE49-F238E27FC236}">
+                <a16:creationId xmlns:a16="http://schemas.microsoft.com/office/drawing/2014/main" id="{7EB6D585-CEE8-3232-E327-916DC11A63D9}"/>
+              </a:ext>
+            </a:extLst>
+          </p:cNvPr>
+          <p:cNvSpPr>
+            <a:spLocks noGrp="1"/>
+          </p:cNvSpPr>
+          <p:nvPr>
+            <p:ph type="body" idx="1"/>
+          </p:nvPr>
+        </p:nvSpPr>
+        <p:spPr/>
+        <p:txBody>
+          <a:bodyPr/>
+          <a:lstStyle/>
+          <a:p>
+            <a:r>
+              <a:rPr lang="en-US" dirty="0"/>
+              <a:t>alright guys ill need </a:t>
+            </a:r>
+            <a:r>
+              <a:rPr lang="en-US" dirty="0" err="1"/>
+              <a:t>yall</a:t>
+            </a:r>
+            <a:r>
+              <a:rPr lang="en-US" dirty="0"/>
+              <a:t> to pitch in now</a:t>
+            </a:r>
+          </a:p>
+        </p:txBody>
+      </p:sp>
+    </p:spTree>
+    <p:extLst>
+      <p:ext uri="{BB962C8B-B14F-4D97-AF65-F5344CB8AC3E}">
+        <p14:creationId xmlns:p14="http://schemas.microsoft.com/office/powerpoint/2010/main" val="1839338892"/>
+      </p:ext>
+    </p:extLst>
+  </p:cSld>
+  <p:clrMapOvr>
+    <a:masterClrMapping/>
+  </p:clrMapOvr>
+</p:sld>
+</file>
+
+<file path=ppt/slides/slide18.xml><?xml version="1.0" encoding="utf-8"?>
 <p:sld xmlns:a="http://schemas.openxmlformats.org/drawingml/2006/main" xmlns:r="http://schemas.openxmlformats.org/officeDocument/2006/relationships" xmlns:p="http://schemas.openxmlformats.org/presentationml/2006/main">
   <p:cSld>
     <p:spTree>
@@ -9184,7 +9487,7 @@
           <a:p>
             <a:r>
               <a:rPr lang="en-US" dirty="0"/>
-              <a:t>Section 1: The Converter</a:t>
+              <a:t>Section 1: Basics of The Converter</a:t>
             </a:r>
           </a:p>
         </p:txBody>
@@ -12248,7 +12551,7 @@
           <p:nvPr>
             <p:extLst>
               <p:ext uri="{D42A27DB-BD31-4B8C-83A1-F6EECF244321}">
-                <p14:modId xmlns:p14="http://schemas.microsoft.com/office/powerpoint/2010/main" val="1950976721"/>
+                <p14:modId xmlns:p14="http://schemas.microsoft.com/office/powerpoint/2010/main" val="3850045786"/>
               </p:ext>
             </p:extLst>
           </p:nvPr>
@@ -13860,8 +14163,8 @@
           </a:p>
         </p:txBody>
       </p:sp>
-      <mc:AlternateContent xmlns:mc="http://schemas.openxmlformats.org/markup-compatibility/2006">
-        <mc:Choice xmlns:a14="http://schemas.microsoft.com/office/drawing/2010/main" Requires="a14">
+      <mc:AlternateContent xmlns:mc="http://schemas.openxmlformats.org/markup-compatibility/2006" xmlns:a14="http://schemas.microsoft.com/office/drawing/2010/main">
+        <mc:Choice Requires="a14">
           <p:sp>
             <p:nvSpPr>
               <p:cNvPr id="7" name="TextBox 6">
@@ -15116,7 +15419,7 @@
             </p:txBody>
           </p:sp>
         </mc:Choice>
-        <mc:Fallback>
+        <mc:Fallback xmlns="">
           <p:sp>
             <p:nvSpPr>
               <p:cNvPr id="7" name="TextBox 6">

</xml_diff>

<commit_message>
Added sensitivity to last slide
</commit_message>
<xml_diff>
--- a/UT Robomasters – Supercap Power Stage Modeling.pptx
+++ b/UT Robomasters – Supercap Power Stage Modeling.pptx
@@ -270,7 +270,7 @@
           <a:p>
             <a:fld id="{116CDFA8-9B71-48D2-9BC8-093B5490E257}" type="datetimeFigureOut">
               <a:rPr lang="en-US" smtClean="0"/>
-              <a:t>3/28/2026</a:t>
+              <a:t>3/29/2026</a:t>
             </a:fld>
             <a:endParaRPr lang="en-US"/>
           </a:p>
@@ -440,7 +440,7 @@
           <a:p>
             <a:fld id="{116CDFA8-9B71-48D2-9BC8-093B5490E257}" type="datetimeFigureOut">
               <a:rPr lang="en-US" smtClean="0"/>
-              <a:t>3/28/2026</a:t>
+              <a:t>3/29/2026</a:t>
             </a:fld>
             <a:endParaRPr lang="en-US"/>
           </a:p>
@@ -620,7 +620,7 @@
           <a:p>
             <a:fld id="{116CDFA8-9B71-48D2-9BC8-093B5490E257}" type="datetimeFigureOut">
               <a:rPr lang="en-US" smtClean="0"/>
-              <a:t>3/28/2026</a:t>
+              <a:t>3/29/2026</a:t>
             </a:fld>
             <a:endParaRPr lang="en-US"/>
           </a:p>
@@ -790,7 +790,7 @@
           <a:p>
             <a:fld id="{116CDFA8-9B71-48D2-9BC8-093B5490E257}" type="datetimeFigureOut">
               <a:rPr lang="en-US" smtClean="0"/>
-              <a:t>3/28/2026</a:t>
+              <a:t>3/29/2026</a:t>
             </a:fld>
             <a:endParaRPr lang="en-US"/>
           </a:p>
@@ -1036,7 +1036,7 @@
           <a:p>
             <a:fld id="{116CDFA8-9B71-48D2-9BC8-093B5490E257}" type="datetimeFigureOut">
               <a:rPr lang="en-US" smtClean="0"/>
-              <a:t>3/28/2026</a:t>
+              <a:t>3/29/2026</a:t>
             </a:fld>
             <a:endParaRPr lang="en-US"/>
           </a:p>
@@ -1268,7 +1268,7 @@
           <a:p>
             <a:fld id="{116CDFA8-9B71-48D2-9BC8-093B5490E257}" type="datetimeFigureOut">
               <a:rPr lang="en-US" smtClean="0"/>
-              <a:t>3/28/2026</a:t>
+              <a:t>3/29/2026</a:t>
             </a:fld>
             <a:endParaRPr lang="en-US"/>
           </a:p>
@@ -1635,7 +1635,7 @@
           <a:p>
             <a:fld id="{116CDFA8-9B71-48D2-9BC8-093B5490E257}" type="datetimeFigureOut">
               <a:rPr lang="en-US" smtClean="0"/>
-              <a:t>3/28/2026</a:t>
+              <a:t>3/29/2026</a:t>
             </a:fld>
             <a:endParaRPr lang="en-US"/>
           </a:p>
@@ -1753,7 +1753,7 @@
           <a:p>
             <a:fld id="{116CDFA8-9B71-48D2-9BC8-093B5490E257}" type="datetimeFigureOut">
               <a:rPr lang="en-US" smtClean="0"/>
-              <a:t>3/28/2026</a:t>
+              <a:t>3/29/2026</a:t>
             </a:fld>
             <a:endParaRPr lang="en-US"/>
           </a:p>
@@ -1848,7 +1848,7 @@
           <a:p>
             <a:fld id="{116CDFA8-9B71-48D2-9BC8-093B5490E257}" type="datetimeFigureOut">
               <a:rPr lang="en-US" smtClean="0"/>
-              <a:t>3/28/2026</a:t>
+              <a:t>3/29/2026</a:t>
             </a:fld>
             <a:endParaRPr lang="en-US"/>
           </a:p>
@@ -2125,7 +2125,7 @@
           <a:p>
             <a:fld id="{116CDFA8-9B71-48D2-9BC8-093B5490E257}" type="datetimeFigureOut">
               <a:rPr lang="en-US" smtClean="0"/>
-              <a:t>3/28/2026</a:t>
+              <a:t>3/29/2026</a:t>
             </a:fld>
             <a:endParaRPr lang="en-US"/>
           </a:p>
@@ -2382,7 +2382,7 @@
           <a:p>
             <a:fld id="{116CDFA8-9B71-48D2-9BC8-093B5490E257}" type="datetimeFigureOut">
               <a:rPr lang="en-US" smtClean="0"/>
-              <a:t>3/28/2026</a:t>
+              <a:t>3/29/2026</a:t>
             </a:fld>
             <a:endParaRPr lang="en-US"/>
           </a:p>
@@ -2595,7 +2595,7 @@
           <a:p>
             <a:fld id="{116CDFA8-9B71-48D2-9BC8-093B5490E257}" type="datetimeFigureOut">
               <a:rPr lang="en-US" smtClean="0"/>
-              <a:t>3/28/2026</a:t>
+              <a:t>3/29/2026</a:t>
             </a:fld>
             <a:endParaRPr lang="en-US"/>
           </a:p>
@@ -3061,7 +3061,15 @@
           <a:p>
             <a:r>
               <a:rPr lang="en-US" dirty="0"/>
-              <a:t>Contributing Members: []</a:t>
+              <a:t>Contributing Members: [Timothy Yeap, Ethan Chu, Heath </a:t>
+            </a:r>
+            <a:r>
+              <a:rPr lang="en-US" dirty="0" err="1"/>
+              <a:t>Luebsen</a:t>
+            </a:r>
+            <a:r>
+              <a:rPr lang="en-US" dirty="0"/>
+              <a:t>]</a:t>
             </a:r>
           </a:p>
         </p:txBody>
@@ -21364,8 +21372,8 @@
           </a:p>
         </p:txBody>
       </p:sp>
-      <mc:AlternateContent xmlns:mc="http://schemas.openxmlformats.org/markup-compatibility/2006">
-        <mc:Choice xmlns:a14="http://schemas.microsoft.com/office/drawing/2010/main" Requires="a14">
+      <mc:AlternateContent xmlns:mc="http://schemas.openxmlformats.org/markup-compatibility/2006" xmlns:a14="http://schemas.microsoft.com/office/drawing/2010/main">
+        <mc:Choice Requires="a14">
           <p:sp>
             <p:nvSpPr>
               <p:cNvPr id="4" name="Text Placeholder 3">
@@ -21627,7 +21635,7 @@
             </p:txBody>
           </p:sp>
         </mc:Choice>
-        <mc:Fallback>
+        <mc:Fallback xmlns="">
           <p:sp>
             <p:nvSpPr>
               <p:cNvPr id="4" name="Text Placeholder 3">
@@ -21667,8 +21675,8 @@
           </p:sp>
         </mc:Fallback>
       </mc:AlternateContent>
-      <mc:AlternateContent xmlns:mc="http://schemas.openxmlformats.org/markup-compatibility/2006">
-        <mc:Choice xmlns:a14="http://schemas.microsoft.com/office/drawing/2010/main" Requires="a14">
+      <mc:AlternateContent xmlns:mc="http://schemas.openxmlformats.org/markup-compatibility/2006" xmlns:a14="http://schemas.microsoft.com/office/drawing/2010/main">
+        <mc:Choice Requires="a14">
           <p:sp>
             <p:nvSpPr>
               <p:cNvPr id="57" name="Rectangle 56">
@@ -21764,7 +21772,7 @@
             </p:txBody>
           </p:sp>
         </mc:Choice>
-        <mc:Fallback>
+        <mc:Fallback xmlns="">
           <p:sp>
             <p:nvSpPr>
               <p:cNvPr id="57" name="Rectangle 56">
@@ -21814,8 +21822,8 @@
           </p:sp>
         </mc:Fallback>
       </mc:AlternateContent>
-      <mc:AlternateContent xmlns:mc="http://schemas.openxmlformats.org/markup-compatibility/2006">
-        <mc:Choice xmlns:a14="http://schemas.microsoft.com/office/drawing/2010/main" Requires="a14">
+      <mc:AlternateContent xmlns:mc="http://schemas.openxmlformats.org/markup-compatibility/2006" xmlns:a14="http://schemas.microsoft.com/office/drawing/2010/main">
+        <mc:Choice Requires="a14">
           <p:sp>
             <p:nvSpPr>
               <p:cNvPr id="58" name="Rectangle 57">
@@ -21911,7 +21919,7 @@
             </p:txBody>
           </p:sp>
         </mc:Choice>
-        <mc:Fallback>
+        <mc:Fallback xmlns="">
           <p:sp>
             <p:nvSpPr>
               <p:cNvPr id="58" name="Rectangle 57">
@@ -22065,8 +22073,8 @@
           </a:p>
         </p:txBody>
       </p:sp>
-      <mc:AlternateContent xmlns:mc="http://schemas.openxmlformats.org/markup-compatibility/2006">
-        <mc:Choice xmlns:a14="http://schemas.microsoft.com/office/drawing/2010/main" Requires="a14">
+      <mc:AlternateContent xmlns:mc="http://schemas.openxmlformats.org/markup-compatibility/2006" xmlns:a14="http://schemas.microsoft.com/office/drawing/2010/main">
+        <mc:Choice Requires="a14">
           <p:sp>
             <p:nvSpPr>
               <p:cNvPr id="67" name="Rectangle 66">
@@ -22181,7 +22189,7 @@
             </p:txBody>
           </p:sp>
         </mc:Choice>
-        <mc:Fallback>
+        <mc:Fallback xmlns="">
           <p:sp>
             <p:nvSpPr>
               <p:cNvPr id="67" name="Rectangle 66">
@@ -22231,8 +22239,8 @@
           </p:sp>
         </mc:Fallback>
       </mc:AlternateContent>
-      <mc:AlternateContent xmlns:mc="http://schemas.openxmlformats.org/markup-compatibility/2006">
-        <mc:Choice xmlns:a14="http://schemas.microsoft.com/office/drawing/2010/main" Requires="a14">
+      <mc:AlternateContent xmlns:mc="http://schemas.openxmlformats.org/markup-compatibility/2006" xmlns:a14="http://schemas.microsoft.com/office/drawing/2010/main">
+        <mc:Choice Requires="a14">
           <p:sp>
             <p:nvSpPr>
               <p:cNvPr id="71" name="TextBox 70">
@@ -22261,6 +22269,7 @@
               </a:bodyPr>
               <a:lstStyle/>
               <a:p>
+                <a:pPr/>
                 <a14:m>
                   <m:oMathPara xmlns:m="http://schemas.openxmlformats.org/officeDocument/2006/math">
                     <m:oMathParaPr>
@@ -22299,7 +22308,7 @@
             </p:txBody>
           </p:sp>
         </mc:Choice>
-        <mc:Fallback>
+        <mc:Fallback xmlns="">
           <p:sp>
             <p:nvSpPr>
               <p:cNvPr id="71" name="TextBox 70">
@@ -22344,8 +22353,8 @@
           </p:sp>
         </mc:Fallback>
       </mc:AlternateContent>
-      <mc:AlternateContent xmlns:mc="http://schemas.openxmlformats.org/markup-compatibility/2006">
-        <mc:Choice xmlns:a14="http://schemas.microsoft.com/office/drawing/2010/main" Requires="a14">
+      <mc:AlternateContent xmlns:mc="http://schemas.openxmlformats.org/markup-compatibility/2006" xmlns:a14="http://schemas.microsoft.com/office/drawing/2010/main">
+        <mc:Choice Requires="a14">
           <p:sp>
             <p:nvSpPr>
               <p:cNvPr id="72" name="TextBox 71">
@@ -22374,6 +22383,7 @@
               </a:bodyPr>
               <a:lstStyle/>
               <a:p>
+                <a:pPr/>
                 <a14:m>
                   <m:oMathPara xmlns:m="http://schemas.openxmlformats.org/officeDocument/2006/math">
                     <m:oMathParaPr>
@@ -22412,7 +22422,7 @@
             </p:txBody>
           </p:sp>
         </mc:Choice>
-        <mc:Fallback>
+        <mc:Fallback xmlns="">
           <p:sp>
             <p:nvSpPr>
               <p:cNvPr id="72" name="TextBox 71">
@@ -22659,8 +22669,8 @@
           </a:p>
         </p:txBody>
       </p:sp>
-      <mc:AlternateContent xmlns:mc="http://schemas.openxmlformats.org/markup-compatibility/2006">
-        <mc:Choice xmlns:a14="http://schemas.microsoft.com/office/drawing/2010/main" Requires="a14">
+      <mc:AlternateContent xmlns:mc="http://schemas.openxmlformats.org/markup-compatibility/2006" xmlns:a14="http://schemas.microsoft.com/office/drawing/2010/main">
+        <mc:Choice Requires="a14">
           <p:sp>
             <p:nvSpPr>
               <p:cNvPr id="100" name="Rectangle 99">
@@ -22760,7 +22770,7 @@
             </p:txBody>
           </p:sp>
         </mc:Choice>
-        <mc:Fallback>
+        <mc:Fallback xmlns="">
           <p:sp>
             <p:nvSpPr>
               <p:cNvPr id="100" name="Rectangle 99">
@@ -23595,8 +23605,8 @@
           </a:fontRef>
         </p:style>
       </p:cxnSp>
-      <mc:AlternateContent xmlns:mc="http://schemas.openxmlformats.org/markup-compatibility/2006">
-        <mc:Choice xmlns:a14="http://schemas.microsoft.com/office/drawing/2010/main" Requires="a14">
+      <mc:AlternateContent xmlns:mc="http://schemas.openxmlformats.org/markup-compatibility/2006" xmlns:a14="http://schemas.microsoft.com/office/drawing/2010/main">
+        <mc:Choice Requires="a14">
           <p:sp>
             <p:nvSpPr>
               <p:cNvPr id="141" name="TextBox 140">
@@ -23625,6 +23635,7 @@
               </a:bodyPr>
               <a:lstStyle/>
               <a:p>
+                <a:pPr/>
                 <a14:m>
                   <m:oMathPara xmlns:m="http://schemas.openxmlformats.org/officeDocument/2006/math">
                     <m:oMathParaPr>
@@ -23663,7 +23674,7 @@
             </p:txBody>
           </p:sp>
         </mc:Choice>
-        <mc:Fallback>
+        <mc:Fallback xmlns="">
           <p:sp>
             <p:nvSpPr>
               <p:cNvPr id="141" name="TextBox 140">
@@ -23708,8 +23719,8 @@
           </p:sp>
         </mc:Fallback>
       </mc:AlternateContent>
-      <mc:AlternateContent xmlns:mc="http://schemas.openxmlformats.org/markup-compatibility/2006">
-        <mc:Choice xmlns:a14="http://schemas.microsoft.com/office/drawing/2010/main" Requires="a14">
+      <mc:AlternateContent xmlns:mc="http://schemas.openxmlformats.org/markup-compatibility/2006" xmlns:a14="http://schemas.microsoft.com/office/drawing/2010/main">
+        <mc:Choice Requires="a14">
           <p:sp>
             <p:nvSpPr>
               <p:cNvPr id="142" name="TextBox 141">
@@ -23738,6 +23749,7 @@
               </a:bodyPr>
               <a:lstStyle/>
               <a:p>
+                <a:pPr/>
                 <a14:m>
                   <m:oMathPara xmlns:m="http://schemas.openxmlformats.org/officeDocument/2006/math">
                     <m:oMathParaPr>
@@ -23776,7 +23788,7 @@
             </p:txBody>
           </p:sp>
         </mc:Choice>
-        <mc:Fallback>
+        <mc:Fallback xmlns="">
           <p:sp>
             <p:nvSpPr>
               <p:cNvPr id="142" name="TextBox 141">
@@ -23973,8 +23985,8 @@
           </a:fontRef>
         </p:style>
       </p:cxnSp>
-      <mc:AlternateContent xmlns:mc="http://schemas.openxmlformats.org/markup-compatibility/2006">
-        <mc:Choice xmlns:a14="http://schemas.microsoft.com/office/drawing/2010/main" Requires="a14">
+      <mc:AlternateContent xmlns:mc="http://schemas.openxmlformats.org/markup-compatibility/2006" xmlns:a14="http://schemas.microsoft.com/office/drawing/2010/main">
+        <mc:Choice Requires="a14">
           <p:sp>
             <p:nvSpPr>
               <p:cNvPr id="150" name="TextBox 149">
@@ -24003,6 +24015,7 @@
               </a:bodyPr>
               <a:lstStyle/>
               <a:p>
+                <a:pPr/>
                 <a14:m>
                   <m:oMathPara xmlns:m="http://schemas.openxmlformats.org/officeDocument/2006/math">
                     <m:oMathParaPr>
@@ -24041,7 +24054,7 @@
             </p:txBody>
           </p:sp>
         </mc:Choice>
-        <mc:Fallback>
+        <mc:Fallback xmlns="">
           <p:sp>
             <p:nvSpPr>
               <p:cNvPr id="150" name="TextBox 149">
@@ -24086,8 +24099,8 @@
           </p:sp>
         </mc:Fallback>
       </mc:AlternateContent>
-      <mc:AlternateContent xmlns:mc="http://schemas.openxmlformats.org/markup-compatibility/2006">
-        <mc:Choice xmlns:a14="http://schemas.microsoft.com/office/drawing/2010/main" Requires="a14">
+      <mc:AlternateContent xmlns:mc="http://schemas.openxmlformats.org/markup-compatibility/2006" xmlns:a14="http://schemas.microsoft.com/office/drawing/2010/main">
+        <mc:Choice Requires="a14">
           <p:sp>
             <p:nvSpPr>
               <p:cNvPr id="151" name="Rectangle 150">
@@ -24183,7 +24196,7 @@
             </p:txBody>
           </p:sp>
         </mc:Choice>
-        <mc:Fallback>
+        <mc:Fallback xmlns="">
           <p:sp>
             <p:nvSpPr>
               <p:cNvPr id="151" name="Rectangle 150">
@@ -24233,8 +24246,8 @@
           </p:sp>
         </mc:Fallback>
       </mc:AlternateContent>
-      <mc:AlternateContent xmlns:mc="http://schemas.openxmlformats.org/markup-compatibility/2006">
-        <mc:Choice xmlns:a14="http://schemas.microsoft.com/office/drawing/2010/main" Requires="a14">
+      <mc:AlternateContent xmlns:mc="http://schemas.openxmlformats.org/markup-compatibility/2006" xmlns:a14="http://schemas.microsoft.com/office/drawing/2010/main">
+        <mc:Choice Requires="a14">
           <p:sp>
             <p:nvSpPr>
               <p:cNvPr id="152" name="Rectangle 151">
@@ -24330,7 +24343,7 @@
             </p:txBody>
           </p:sp>
         </mc:Choice>
-        <mc:Fallback>
+        <mc:Fallback xmlns="">
           <p:sp>
             <p:nvSpPr>
               <p:cNvPr id="152" name="Rectangle 151">
@@ -24484,8 +24497,8 @@
           </a:p>
         </p:txBody>
       </p:sp>
-      <mc:AlternateContent xmlns:mc="http://schemas.openxmlformats.org/markup-compatibility/2006">
-        <mc:Choice xmlns:a14="http://schemas.microsoft.com/office/drawing/2010/main" Requires="a14">
+      <mc:AlternateContent xmlns:mc="http://schemas.openxmlformats.org/markup-compatibility/2006" xmlns:a14="http://schemas.microsoft.com/office/drawing/2010/main">
+        <mc:Choice Requires="a14">
           <p:sp>
             <p:nvSpPr>
               <p:cNvPr id="156" name="TextBox 155">
@@ -24514,6 +24527,7 @@
               </a:bodyPr>
               <a:lstStyle/>
               <a:p>
+                <a:pPr/>
                 <a14:m>
                   <m:oMathPara xmlns:m="http://schemas.openxmlformats.org/officeDocument/2006/math">
                     <m:oMathParaPr>
@@ -24552,7 +24566,7 @@
             </p:txBody>
           </p:sp>
         </mc:Choice>
-        <mc:Fallback>
+        <mc:Fallback xmlns="">
           <p:sp>
             <p:nvSpPr>
               <p:cNvPr id="156" name="TextBox 155">
@@ -24597,8 +24611,8 @@
           </p:sp>
         </mc:Fallback>
       </mc:AlternateContent>
-      <mc:AlternateContent xmlns:mc="http://schemas.openxmlformats.org/markup-compatibility/2006">
-        <mc:Choice xmlns:a14="http://schemas.microsoft.com/office/drawing/2010/main" Requires="a14">
+      <mc:AlternateContent xmlns:mc="http://schemas.openxmlformats.org/markup-compatibility/2006" xmlns:a14="http://schemas.microsoft.com/office/drawing/2010/main">
+        <mc:Choice Requires="a14">
           <p:sp>
             <p:nvSpPr>
               <p:cNvPr id="157" name="TextBox 156">
@@ -24627,6 +24641,7 @@
               </a:bodyPr>
               <a:lstStyle/>
               <a:p>
+                <a:pPr/>
                 <a14:m>
                   <m:oMathPara xmlns:m="http://schemas.openxmlformats.org/officeDocument/2006/math">
                     <m:oMathParaPr>
@@ -24665,7 +24680,7 @@
             </p:txBody>
           </p:sp>
         </mc:Choice>
-        <mc:Fallback>
+        <mc:Fallback xmlns="">
           <p:sp>
             <p:nvSpPr>
               <p:cNvPr id="157" name="TextBox 156">
@@ -25517,8 +25532,8 @@
           </a:fontRef>
         </p:style>
       </p:cxnSp>
-      <mc:AlternateContent xmlns:mc="http://schemas.openxmlformats.org/markup-compatibility/2006">
-        <mc:Choice xmlns:a14="http://schemas.microsoft.com/office/drawing/2010/main" Requires="a14">
+      <mc:AlternateContent xmlns:mc="http://schemas.openxmlformats.org/markup-compatibility/2006" xmlns:a14="http://schemas.microsoft.com/office/drawing/2010/main">
+        <mc:Choice Requires="a14">
           <p:sp>
             <p:nvSpPr>
               <p:cNvPr id="180" name="TextBox 179">
@@ -25547,6 +25562,7 @@
               </a:bodyPr>
               <a:lstStyle/>
               <a:p>
+                <a:pPr/>
                 <a14:m>
                   <m:oMathPara xmlns:m="http://schemas.openxmlformats.org/officeDocument/2006/math">
                     <m:oMathParaPr>
@@ -25585,7 +25601,7 @@
             </p:txBody>
           </p:sp>
         </mc:Choice>
-        <mc:Fallback>
+        <mc:Fallback xmlns="">
           <p:sp>
             <p:nvSpPr>
               <p:cNvPr id="180" name="TextBox 179">
@@ -25630,8 +25646,8 @@
           </p:sp>
         </mc:Fallback>
       </mc:AlternateContent>
-      <mc:AlternateContent xmlns:mc="http://schemas.openxmlformats.org/markup-compatibility/2006">
-        <mc:Choice xmlns:a14="http://schemas.microsoft.com/office/drawing/2010/main" Requires="a14">
+      <mc:AlternateContent xmlns:mc="http://schemas.openxmlformats.org/markup-compatibility/2006" xmlns:a14="http://schemas.microsoft.com/office/drawing/2010/main">
+        <mc:Choice Requires="a14">
           <p:sp>
             <p:nvSpPr>
               <p:cNvPr id="181" name="TextBox 180">
@@ -25728,7 +25744,7 @@
             </p:txBody>
           </p:sp>
         </mc:Choice>
-        <mc:Fallback>
+        <mc:Fallback xmlns="">
           <p:sp>
             <p:nvSpPr>
               <p:cNvPr id="181" name="TextBox 180">
@@ -25896,8 +25912,8 @@
             <a:chExt cx="9837127" cy="3396555"/>
           </a:xfrm>
         </p:grpSpPr>
-        <mc:AlternateContent xmlns:mc="http://schemas.openxmlformats.org/markup-compatibility/2006">
-          <mc:Choice xmlns:a14="http://schemas.microsoft.com/office/drawing/2010/main" Requires="a14">
+        <mc:AlternateContent xmlns:mc="http://schemas.openxmlformats.org/markup-compatibility/2006" xmlns:a14="http://schemas.microsoft.com/office/drawing/2010/main">
+          <mc:Choice Requires="a14">
             <p:sp>
               <p:nvSpPr>
                 <p:cNvPr id="3" name="Rectangle 2">
@@ -25993,7 +26009,7 @@
               </p:txBody>
             </p:sp>
           </mc:Choice>
-          <mc:Fallback>
+          <mc:Fallback xmlns="">
             <p:sp>
               <p:nvSpPr>
                 <p:cNvPr id="3" name="Rectangle 2">
@@ -26043,8 +26059,8 @@
             </p:sp>
           </mc:Fallback>
         </mc:AlternateContent>
-        <mc:AlternateContent xmlns:mc="http://schemas.openxmlformats.org/markup-compatibility/2006">
-          <mc:Choice xmlns:a14="http://schemas.microsoft.com/office/drawing/2010/main" Requires="a14">
+        <mc:AlternateContent xmlns:mc="http://schemas.openxmlformats.org/markup-compatibility/2006" xmlns:a14="http://schemas.microsoft.com/office/drawing/2010/main">
+          <mc:Choice Requires="a14">
             <p:sp>
               <p:nvSpPr>
                 <p:cNvPr id="4" name="Rectangle 3">
@@ -26159,7 +26175,7 @@
               </p:txBody>
             </p:sp>
           </mc:Choice>
-          <mc:Fallback>
+          <mc:Fallback xmlns="">
             <p:sp>
               <p:nvSpPr>
                 <p:cNvPr id="4" name="Rectangle 3">
@@ -26313,8 +26329,8 @@
             </a:p>
           </p:txBody>
         </p:sp>
-        <mc:AlternateContent xmlns:mc="http://schemas.openxmlformats.org/markup-compatibility/2006">
-          <mc:Choice xmlns:a14="http://schemas.microsoft.com/office/drawing/2010/main" Requires="a14">
+        <mc:AlternateContent xmlns:mc="http://schemas.openxmlformats.org/markup-compatibility/2006" xmlns:a14="http://schemas.microsoft.com/office/drawing/2010/main">
+          <mc:Choice Requires="a14">
             <p:sp>
               <p:nvSpPr>
                 <p:cNvPr id="7" name="TextBox 6">
@@ -26343,6 +26359,7 @@
                 </a:bodyPr>
                 <a:lstStyle/>
                 <a:p>
+                  <a:pPr/>
                   <a14:m>
                     <m:oMathPara xmlns:m="http://schemas.openxmlformats.org/officeDocument/2006/math">
                       <m:oMathParaPr>
@@ -26400,7 +26417,7 @@
               </p:txBody>
             </p:sp>
           </mc:Choice>
-          <mc:Fallback>
+          <mc:Fallback xmlns="">
             <p:sp>
               <p:nvSpPr>
                 <p:cNvPr id="7" name="TextBox 6">
@@ -26445,8 +26462,8 @@
             </p:sp>
           </mc:Fallback>
         </mc:AlternateContent>
-        <mc:AlternateContent xmlns:mc="http://schemas.openxmlformats.org/markup-compatibility/2006">
-          <mc:Choice xmlns:a14="http://schemas.microsoft.com/office/drawing/2010/main" Requires="a14">
+        <mc:AlternateContent xmlns:mc="http://schemas.openxmlformats.org/markup-compatibility/2006" xmlns:a14="http://schemas.microsoft.com/office/drawing/2010/main">
+          <mc:Choice Requires="a14">
             <p:sp>
               <p:nvSpPr>
                 <p:cNvPr id="8" name="TextBox 7">
@@ -26475,6 +26492,7 @@
                 </a:bodyPr>
                 <a:lstStyle/>
                 <a:p>
+                  <a:pPr/>
                   <a14:m>
                     <m:oMathPara xmlns:m="http://schemas.openxmlformats.org/officeDocument/2006/math">
                       <m:oMathParaPr>
@@ -26532,7 +26550,7 @@
               </p:txBody>
             </p:sp>
           </mc:Choice>
-          <mc:Fallback>
+          <mc:Fallback xmlns="">
             <p:sp>
               <p:nvSpPr>
                 <p:cNvPr id="8" name="TextBox 7">
@@ -27053,8 +27071,8 @@
             </a:fontRef>
           </p:style>
         </p:cxnSp>
-        <mc:AlternateContent xmlns:mc="http://schemas.openxmlformats.org/markup-compatibility/2006">
-          <mc:Choice xmlns:a14="http://schemas.microsoft.com/office/drawing/2010/main" Requires="a14">
+        <mc:AlternateContent xmlns:mc="http://schemas.openxmlformats.org/markup-compatibility/2006" xmlns:a14="http://schemas.microsoft.com/office/drawing/2010/main">
+          <mc:Choice Requires="a14">
             <p:sp>
               <p:nvSpPr>
                 <p:cNvPr id="26" name="TextBox 25">
@@ -27083,6 +27101,7 @@
                 </a:bodyPr>
                 <a:lstStyle/>
                 <a:p>
+                  <a:pPr/>
                   <a14:m>
                     <m:oMathPara xmlns:m="http://schemas.openxmlformats.org/officeDocument/2006/math">
                       <m:oMathParaPr>
@@ -27121,7 +27140,7 @@
               </p:txBody>
             </p:sp>
           </mc:Choice>
-          <mc:Fallback>
+          <mc:Fallback xmlns="">
             <p:sp>
               <p:nvSpPr>
                 <p:cNvPr id="26" name="TextBox 25">
@@ -27166,8 +27185,8 @@
             </p:sp>
           </mc:Fallback>
         </mc:AlternateContent>
-        <mc:AlternateContent xmlns:mc="http://schemas.openxmlformats.org/markup-compatibility/2006">
-          <mc:Choice xmlns:a14="http://schemas.microsoft.com/office/drawing/2010/main" Requires="a14">
+        <mc:AlternateContent xmlns:mc="http://schemas.openxmlformats.org/markup-compatibility/2006" xmlns:a14="http://schemas.microsoft.com/office/drawing/2010/main">
+          <mc:Choice Requires="a14">
             <p:sp>
               <p:nvSpPr>
                 <p:cNvPr id="27" name="TextBox 26">
@@ -27264,7 +27283,7 @@
               </p:txBody>
             </p:sp>
           </mc:Choice>
-          <mc:Fallback>
+          <mc:Fallback xmlns="">
             <p:sp>
               <p:nvSpPr>
                 <p:cNvPr id="27" name="TextBox 26">
@@ -27362,8 +27381,8 @@
             </a:p>
           </p:txBody>
         </p:sp>
-        <mc:AlternateContent xmlns:mc="http://schemas.openxmlformats.org/markup-compatibility/2006">
-          <mc:Choice xmlns:a14="http://schemas.microsoft.com/office/drawing/2010/main" Requires="a14">
+        <mc:AlternateContent xmlns:mc="http://schemas.openxmlformats.org/markup-compatibility/2006" xmlns:a14="http://schemas.microsoft.com/office/drawing/2010/main">
+          <mc:Choice Requires="a14">
             <p:sp>
               <p:nvSpPr>
                 <p:cNvPr id="31" name="Rectangle 30">
@@ -27506,7 +27525,7 @@
               </p:txBody>
             </p:sp>
           </mc:Choice>
-          <mc:Fallback>
+          <mc:Fallback xmlns="">
             <p:sp>
               <p:nvSpPr>
                 <p:cNvPr id="31" name="Rectangle 30">
@@ -27556,8 +27575,8 @@
             </p:sp>
           </mc:Fallback>
         </mc:AlternateContent>
-        <mc:AlternateContent xmlns:mc="http://schemas.openxmlformats.org/markup-compatibility/2006">
-          <mc:Choice xmlns:a14="http://schemas.microsoft.com/office/drawing/2010/main" Requires="a14">
+        <mc:AlternateContent xmlns:mc="http://schemas.openxmlformats.org/markup-compatibility/2006" xmlns:a14="http://schemas.microsoft.com/office/drawing/2010/main">
+          <mc:Choice Requires="a14">
             <p:sp>
               <p:nvSpPr>
                 <p:cNvPr id="35" name="TextBox 34">
@@ -27678,7 +27697,7 @@
               </p:txBody>
             </p:sp>
           </mc:Choice>
-          <mc:Fallback>
+          <mc:Fallback xmlns="">
             <p:sp>
               <p:nvSpPr>
                 <p:cNvPr id="35" name="TextBox 34">
@@ -28140,8 +28159,8 @@
             </a:fontRef>
           </p:style>
         </p:cxnSp>
-        <mc:AlternateContent xmlns:mc="http://schemas.openxmlformats.org/markup-compatibility/2006">
-          <mc:Choice xmlns:a14="http://schemas.microsoft.com/office/drawing/2010/main" Requires="a14">
+        <mc:AlternateContent xmlns:mc="http://schemas.openxmlformats.org/markup-compatibility/2006" xmlns:a14="http://schemas.microsoft.com/office/drawing/2010/main">
+          <mc:Choice Requires="a14">
             <p:sp>
               <p:nvSpPr>
                 <p:cNvPr id="60" name="TextBox 59">
@@ -28170,6 +28189,7 @@
                 </a:bodyPr>
                 <a:lstStyle/>
                 <a:p>
+                  <a:pPr/>
                   <a14:m>
                     <m:oMathPara xmlns:m="http://schemas.openxmlformats.org/officeDocument/2006/math">
                       <m:oMathParaPr>
@@ -28208,7 +28228,7 @@
               </p:txBody>
             </p:sp>
           </mc:Choice>
-          <mc:Fallback>
+          <mc:Fallback xmlns="">
             <p:sp>
               <p:nvSpPr>
                 <p:cNvPr id="60" name="TextBox 59">
@@ -28253,8 +28273,8 @@
             </p:sp>
           </mc:Fallback>
         </mc:AlternateContent>
-        <mc:AlternateContent xmlns:mc="http://schemas.openxmlformats.org/markup-compatibility/2006">
-          <mc:Choice xmlns:a14="http://schemas.microsoft.com/office/drawing/2010/main" Requires="a14">
+        <mc:AlternateContent xmlns:mc="http://schemas.openxmlformats.org/markup-compatibility/2006" xmlns:a14="http://schemas.microsoft.com/office/drawing/2010/main">
+          <mc:Choice Requires="a14">
             <p:sp>
               <p:nvSpPr>
                 <p:cNvPr id="61" name="TextBox 60">
@@ -28283,6 +28303,7 @@
                 </a:bodyPr>
                 <a:lstStyle/>
                 <a:p>
+                  <a:pPr/>
                   <a14:m>
                     <m:oMathPara xmlns:m="http://schemas.openxmlformats.org/officeDocument/2006/math">
                       <m:oMathParaPr>
@@ -28352,7 +28373,7 @@
               </p:txBody>
             </p:sp>
           </mc:Choice>
-          <mc:Fallback>
+          <mc:Fallback xmlns="">
             <p:sp>
               <p:nvSpPr>
                 <p:cNvPr id="61" name="TextBox 60">
@@ -28397,8 +28418,8 @@
             </p:sp>
           </mc:Fallback>
         </mc:AlternateContent>
-        <mc:AlternateContent xmlns:mc="http://schemas.openxmlformats.org/markup-compatibility/2006">
-          <mc:Choice xmlns:a14="http://schemas.microsoft.com/office/drawing/2010/main" Requires="a14">
+        <mc:AlternateContent xmlns:mc="http://schemas.openxmlformats.org/markup-compatibility/2006" xmlns:a14="http://schemas.microsoft.com/office/drawing/2010/main">
+          <mc:Choice Requires="a14">
             <p:sp>
               <p:nvSpPr>
                 <p:cNvPr id="64" name="TextBox 63">
@@ -28427,6 +28448,7 @@
                 </a:bodyPr>
                 <a:lstStyle/>
                 <a:p>
+                  <a:pPr/>
                   <a14:m>
                     <m:oMathPara xmlns:m="http://schemas.openxmlformats.org/officeDocument/2006/math">
                       <m:oMathParaPr>
@@ -28484,7 +28506,7 @@
               </p:txBody>
             </p:sp>
           </mc:Choice>
-          <mc:Fallback>
+          <mc:Fallback xmlns="">
             <p:sp>
               <p:nvSpPr>
                 <p:cNvPr id="64" name="TextBox 63">
@@ -28529,8 +28551,8 @@
             </p:sp>
           </mc:Fallback>
         </mc:AlternateContent>
-        <mc:AlternateContent xmlns:mc="http://schemas.openxmlformats.org/markup-compatibility/2006">
-          <mc:Choice xmlns:a14="http://schemas.microsoft.com/office/drawing/2010/main" Requires="a14">
+        <mc:AlternateContent xmlns:mc="http://schemas.openxmlformats.org/markup-compatibility/2006" xmlns:a14="http://schemas.microsoft.com/office/drawing/2010/main">
+          <mc:Choice Requires="a14">
             <p:sp>
               <p:nvSpPr>
                 <p:cNvPr id="67" name="TextBox 66">
@@ -28559,6 +28581,7 @@
                 </a:bodyPr>
                 <a:lstStyle/>
                 <a:p>
+                  <a:pPr/>
                   <a14:m>
                     <m:oMathPara xmlns:m="http://schemas.openxmlformats.org/officeDocument/2006/math">
                       <m:oMathParaPr>
@@ -28597,7 +28620,7 @@
               </p:txBody>
             </p:sp>
           </mc:Choice>
-          <mc:Fallback>
+          <mc:Fallback xmlns="">
             <p:sp>
               <p:nvSpPr>
                 <p:cNvPr id="67" name="TextBox 66">
@@ -28643,8 +28666,8 @@
           </mc:Fallback>
         </mc:AlternateContent>
       </p:grpSp>
-      <mc:AlternateContent xmlns:mc="http://schemas.openxmlformats.org/markup-compatibility/2006">
-        <mc:Choice xmlns:a14="http://schemas.microsoft.com/office/drawing/2010/main" Requires="a14">
+      <mc:AlternateContent xmlns:mc="http://schemas.openxmlformats.org/markup-compatibility/2006" xmlns:a14="http://schemas.microsoft.com/office/drawing/2010/main">
+        <mc:Choice Requires="a14">
           <p:sp>
             <p:nvSpPr>
               <p:cNvPr id="70" name="TextBox 69">
@@ -29076,7 +29099,7 @@
             </p:txBody>
           </p:sp>
         </mc:Choice>
-        <mc:Fallback>
+        <mc:Fallback xmlns="">
           <p:sp>
             <p:nvSpPr>
               <p:cNvPr id="70" name="TextBox 69">
@@ -29243,8 +29266,8 @@
           </a:p>
         </p:txBody>
       </p:sp>
-      <mc:AlternateContent xmlns:mc="http://schemas.openxmlformats.org/markup-compatibility/2006">
-        <mc:Choice xmlns:a14="http://schemas.microsoft.com/office/drawing/2010/main" Requires="a14">
+      <mc:AlternateContent xmlns:mc="http://schemas.openxmlformats.org/markup-compatibility/2006" xmlns:a14="http://schemas.microsoft.com/office/drawing/2010/main">
+        <mc:Choice Requires="a14">
           <p:sp>
             <p:nvSpPr>
               <p:cNvPr id="3" name="TextBox 2">
@@ -29273,6 +29296,7 @@
               </a:bodyPr>
               <a:lstStyle/>
               <a:p>
+                <a:pPr/>
                 <a14:m>
                   <m:oMathPara xmlns:m="http://schemas.openxmlformats.org/officeDocument/2006/math">
                     <m:oMathParaPr>
@@ -29414,6 +29438,7 @@
                 </a:endParaRPr>
               </a:p>
               <a:p>
+                <a:pPr/>
                 <a14:m>
                   <m:oMathPara xmlns:m="http://schemas.openxmlformats.org/officeDocument/2006/math">
                     <m:oMathParaPr>
@@ -29548,6 +29573,7 @@
                 </a:endParaRPr>
               </a:p>
               <a:p>
+                <a:pPr/>
                 <a14:m>
                   <m:oMathPara xmlns:m="http://schemas.openxmlformats.org/officeDocument/2006/math">
                     <m:oMathParaPr>
@@ -29657,7 +29683,7 @@
             </p:txBody>
           </p:sp>
         </mc:Choice>
-        <mc:Fallback>
+        <mc:Fallback xmlns="">
           <p:sp>
             <p:nvSpPr>
               <p:cNvPr id="3" name="TextBox 2">
@@ -29737,8 +29763,8 @@
           </a:p>
         </p:txBody>
       </p:sp>
-      <mc:AlternateContent xmlns:mc="http://schemas.openxmlformats.org/markup-compatibility/2006">
-        <mc:Choice xmlns:a14="http://schemas.microsoft.com/office/drawing/2010/main" Requires="a14">
+      <mc:AlternateContent xmlns:mc="http://schemas.openxmlformats.org/markup-compatibility/2006" xmlns:a14="http://schemas.microsoft.com/office/drawing/2010/main">
+        <mc:Choice Requires="a14">
           <p:sp>
             <p:nvSpPr>
               <p:cNvPr id="7" name="TextBox 6">
@@ -29812,7 +29838,7 @@
             </p:txBody>
           </p:sp>
         </mc:Choice>
-        <mc:Fallback>
+        <mc:Fallback xmlns="">
           <p:sp>
             <p:nvSpPr>
               <p:cNvPr id="7" name="TextBox 6">
@@ -29915,11 +29941,1501 @@
           <a:p>
             <a:r>
               <a:rPr lang="en-US" dirty="0"/>
-              <a:t>Results</a:t>
+              <a:t>Sensitivity</a:t>
             </a:r>
           </a:p>
         </p:txBody>
       </p:sp>
+      <p:sp>
+        <p:nvSpPr>
+          <p:cNvPr id="2" name="TextBox 1">
+            <a:extLst>
+              <a:ext uri="{FF2B5EF4-FFF2-40B4-BE49-F238E27FC236}">
+                <a16:creationId xmlns:a16="http://schemas.microsoft.com/office/drawing/2014/main" id="{5D260C9A-99D7-DD80-1DC0-1A1F58A5D09E}"/>
+              </a:ext>
+            </a:extLst>
+          </p:cNvPr>
+          <p:cNvSpPr txBox="1"/>
+          <p:nvPr/>
+        </p:nvSpPr>
+        <p:spPr>
+          <a:xfrm>
+            <a:off x="5637276" y="2971800"/>
+            <a:ext cx="65" cy="276999"/>
+          </a:xfrm>
+          <a:prstGeom prst="rect">
+            <a:avLst/>
+          </a:prstGeom>
+          <a:noFill/>
+        </p:spPr>
+        <p:txBody>
+          <a:bodyPr wrap="none" lIns="0" tIns="0" rIns="0" bIns="0" rtlCol="0">
+            <a:spAutoFit/>
+          </a:bodyPr>
+          <a:lstStyle/>
+          <a:p>
+            <a:endParaRPr lang="en-US" dirty="0"/>
+          </a:p>
+        </p:txBody>
+      </p:sp>
+      <mc:AlternateContent xmlns:mc="http://schemas.openxmlformats.org/markup-compatibility/2006">
+        <mc:Choice xmlns:a14="http://schemas.microsoft.com/office/drawing/2010/main" Requires="a14">
+          <p:sp>
+            <p:nvSpPr>
+              <p:cNvPr id="4" name="TextBox 3">
+                <a:extLst>
+                  <a:ext uri="{FF2B5EF4-FFF2-40B4-BE49-F238E27FC236}">
+                    <a16:creationId xmlns:a16="http://schemas.microsoft.com/office/drawing/2014/main" id="{D9A7CD1F-D119-28C8-0094-4E82911D867E}"/>
+                  </a:ext>
+                </a:extLst>
+              </p:cNvPr>
+              <p:cNvSpPr txBox="1"/>
+              <p:nvPr/>
+            </p:nvSpPr>
+            <p:spPr>
+              <a:xfrm>
+                <a:off x="-1003554" y="1546987"/>
+                <a:ext cx="6243066" cy="2849626"/>
+              </a:xfrm>
+              <a:prstGeom prst="rect">
+                <a:avLst/>
+              </a:prstGeom>
+              <a:noFill/>
+            </p:spPr>
+            <p:txBody>
+              <a:bodyPr wrap="square">
+                <a:spAutoFit/>
+              </a:bodyPr>
+              <a:lstStyle/>
+              <a:p>
+                <a:pPr/>
+                <a14:m>
+                  <m:oMathPara xmlns:m="http://schemas.openxmlformats.org/officeDocument/2006/math">
+                    <m:oMathParaPr>
+                      <m:jc m:val="centerGroup"/>
+                    </m:oMathParaPr>
+                    <m:oMath xmlns:m="http://schemas.openxmlformats.org/officeDocument/2006/math">
+                      <m:sSubSup>
+                        <m:sSubSupPr>
+                          <m:ctrlPr>
+                            <a:rPr lang="en-US" sz="2400" b="0" i="1" smtClean="0">
+                              <a:latin typeface="Cambria Math" panose="02040503050406030204" pitchFamily="18" charset="0"/>
+                            </a:rPr>
+                          </m:ctrlPr>
+                        </m:sSubSupPr>
+                        <m:e>
+                          <m:r>
+                            <a:rPr lang="en-US" sz="2400" b="0" i="1" smtClean="0">
+                              <a:latin typeface="Cambria Math" panose="02040503050406030204" pitchFamily="18" charset="0"/>
+                            </a:rPr>
+                            <m:t>𝑆</m:t>
+                          </m:r>
+                        </m:e>
+                        <m:sub>
+                          <m:sSub>
+                            <m:sSubPr>
+                              <m:ctrlPr>
+                                <a:rPr lang="en-US" sz="2400" b="0" i="1" smtClean="0">
+                                  <a:latin typeface="Cambria Math" panose="02040503050406030204" pitchFamily="18" charset="0"/>
+                                </a:rPr>
+                              </m:ctrlPr>
+                            </m:sSubPr>
+                            <m:e>
+                              <m:r>
+                                <a:rPr lang="en-US" sz="2400" b="0" i="1" smtClean="0">
+                                  <a:latin typeface="Cambria Math" panose="02040503050406030204" pitchFamily="18" charset="0"/>
+                                </a:rPr>
+                                <m:t>𝑉</m:t>
+                              </m:r>
+                            </m:e>
+                            <m:sub>
+                              <m:r>
+                                <a:rPr lang="en-US" sz="2400" b="0" i="1" smtClean="0">
+                                  <a:latin typeface="Cambria Math" panose="02040503050406030204" pitchFamily="18" charset="0"/>
+                                </a:rPr>
+                                <m:t>𝑔</m:t>
+                              </m:r>
+                            </m:sub>
+                          </m:sSub>
+                        </m:sub>
+                        <m:sup>
+                          <m:r>
+                            <a:rPr lang="en-US" sz="2400" b="0" i="1" smtClean="0">
+                              <a:latin typeface="Cambria Math" panose="02040503050406030204" pitchFamily="18" charset="0"/>
+                            </a:rPr>
+                            <m:t>𝑇</m:t>
+                          </m:r>
+                        </m:sup>
+                      </m:sSubSup>
+                      <m:r>
+                        <a:rPr lang="en-US" sz="2400" b="0" i="1" smtClean="0">
+                          <a:latin typeface="Cambria Math" panose="02040503050406030204" pitchFamily="18" charset="0"/>
+                        </a:rPr>
+                        <m:t>=</m:t>
+                      </m:r>
+                      <m:f>
+                        <m:fPr>
+                          <m:ctrlPr>
+                            <a:rPr lang="en-US" sz="2400" b="0" i="1" smtClean="0">
+                              <a:latin typeface="Cambria Math" panose="02040503050406030204" pitchFamily="18" charset="0"/>
+                            </a:rPr>
+                          </m:ctrlPr>
+                        </m:fPr>
+                        <m:num>
+                          <m:r>
+                            <a:rPr lang="en-US" sz="2400" b="0" i="1" smtClean="0">
+                              <a:latin typeface="Cambria Math" panose="02040503050406030204" pitchFamily="18" charset="0"/>
+                            </a:rPr>
+                            <m:t>𝑠𝐿</m:t>
+                          </m:r>
+                          <m:r>
+                            <a:rPr lang="en-US" sz="2400" b="0" i="1" smtClean="0">
+                              <a:latin typeface="Cambria Math" panose="02040503050406030204" pitchFamily="18" charset="0"/>
+                            </a:rPr>
+                            <m:t>+</m:t>
+                          </m:r>
+                          <m:r>
+                            <a:rPr lang="en-US" sz="2400" b="0" i="1" smtClean="0">
+                              <a:latin typeface="Cambria Math" panose="02040503050406030204" pitchFamily="18" charset="0"/>
+                            </a:rPr>
+                            <m:t>𝑅</m:t>
+                          </m:r>
+                        </m:num>
+                        <m:den>
+                          <m:r>
+                            <a:rPr lang="en-US" sz="2400" b="0" i="1" smtClean="0">
+                              <a:latin typeface="Cambria Math" panose="02040503050406030204" pitchFamily="18" charset="0"/>
+                            </a:rPr>
+                            <m:t>𝑠𝐿</m:t>
+                          </m:r>
+                          <m:r>
+                            <a:rPr lang="en-US" sz="2400" b="0" i="1" smtClean="0">
+                              <a:latin typeface="Cambria Math" panose="02040503050406030204" pitchFamily="18" charset="0"/>
+                            </a:rPr>
+                            <m:t>+</m:t>
+                          </m:r>
+                          <m:r>
+                            <a:rPr lang="en-US" sz="2400" b="0" i="1" smtClean="0">
+                              <a:latin typeface="Cambria Math" panose="02040503050406030204" pitchFamily="18" charset="0"/>
+                            </a:rPr>
+                            <m:t>𝑅</m:t>
+                          </m:r>
+                          <m:r>
+                            <a:rPr lang="en-US" sz="2400" b="0" i="1" smtClean="0">
+                              <a:latin typeface="Cambria Math" panose="02040503050406030204" pitchFamily="18" charset="0"/>
+                            </a:rPr>
+                            <m:t>+</m:t>
+                          </m:r>
+                          <m:r>
+                            <a:rPr lang="en-US" sz="2400" b="0" i="1" smtClean="0">
+                              <a:latin typeface="Cambria Math" panose="02040503050406030204" pitchFamily="18" charset="0"/>
+                            </a:rPr>
+                            <m:t>𝐷</m:t>
+                          </m:r>
+                          <m:sSub>
+                            <m:sSubPr>
+                              <m:ctrlPr>
+                                <a:rPr lang="en-US" sz="2400" b="0" i="1" smtClean="0">
+                                  <a:latin typeface="Cambria Math" panose="02040503050406030204" pitchFamily="18" charset="0"/>
+                                </a:rPr>
+                              </m:ctrlPr>
+                            </m:sSubPr>
+                            <m:e>
+                              <m:r>
+                                <a:rPr lang="en-US" sz="2400" b="0" i="1" smtClean="0">
+                                  <a:latin typeface="Cambria Math" panose="02040503050406030204" pitchFamily="18" charset="0"/>
+                                </a:rPr>
+                                <m:t>𝑉</m:t>
+                              </m:r>
+                            </m:e>
+                            <m:sub>
+                              <m:r>
+                                <a:rPr lang="en-US" sz="2400" b="0" i="1" smtClean="0">
+                                  <a:latin typeface="Cambria Math" panose="02040503050406030204" pitchFamily="18" charset="0"/>
+                                </a:rPr>
+                                <m:t>𝑔</m:t>
+                              </m:r>
+                            </m:sub>
+                          </m:sSub>
+                        </m:den>
+                      </m:f>
+                    </m:oMath>
+                  </m:oMathPara>
+                </a14:m>
+                <a:endParaRPr lang="en-US" sz="2400" b="0" dirty="0"/>
+              </a:p>
+              <a:p>
+                <a:pPr/>
+                <a14:m>
+                  <m:oMathPara xmlns:m="http://schemas.openxmlformats.org/officeDocument/2006/math">
+                    <m:oMathParaPr>
+                      <m:jc m:val="centerGroup"/>
+                    </m:oMathParaPr>
+                    <m:oMath xmlns:m="http://schemas.openxmlformats.org/officeDocument/2006/math">
+                      <m:sSubSup>
+                        <m:sSubSupPr>
+                          <m:ctrlPr>
+                            <a:rPr lang="en-US" sz="2400" b="0" i="1" smtClean="0">
+                              <a:latin typeface="Cambria Math" panose="02040503050406030204" pitchFamily="18" charset="0"/>
+                            </a:rPr>
+                          </m:ctrlPr>
+                        </m:sSubSupPr>
+                        <m:e>
+                          <m:r>
+                            <a:rPr lang="en-US" sz="2400" b="0" i="1" smtClean="0">
+                              <a:latin typeface="Cambria Math" panose="02040503050406030204" pitchFamily="18" charset="0"/>
+                            </a:rPr>
+                            <m:t>𝑆</m:t>
+                          </m:r>
+                        </m:e>
+                        <m:sub>
+                          <m:r>
+                            <a:rPr lang="en-US" sz="2400" b="0" i="1" smtClean="0">
+                              <a:latin typeface="Cambria Math" panose="02040503050406030204" pitchFamily="18" charset="0"/>
+                            </a:rPr>
+                            <m:t>𝑅</m:t>
+                          </m:r>
+                        </m:sub>
+                        <m:sup>
+                          <m:r>
+                            <a:rPr lang="en-US" sz="2400" b="0" i="1" smtClean="0">
+                              <a:latin typeface="Cambria Math" panose="02040503050406030204" pitchFamily="18" charset="0"/>
+                            </a:rPr>
+                            <m:t>𝑇</m:t>
+                          </m:r>
+                        </m:sup>
+                      </m:sSubSup>
+                      <m:r>
+                        <a:rPr lang="en-US" sz="2400" b="0" i="1" smtClean="0">
+                          <a:latin typeface="Cambria Math" panose="02040503050406030204" pitchFamily="18" charset="0"/>
+                        </a:rPr>
+                        <m:t>=</m:t>
+                      </m:r>
+                      <m:f>
+                        <m:fPr>
+                          <m:ctrlPr>
+                            <a:rPr lang="en-US" sz="2400" b="0" i="1" smtClean="0">
+                              <a:latin typeface="Cambria Math" panose="02040503050406030204" pitchFamily="18" charset="0"/>
+                            </a:rPr>
+                          </m:ctrlPr>
+                        </m:fPr>
+                        <m:num>
+                          <m:r>
+                            <a:rPr lang="en-US" sz="2400" b="0" i="1" smtClean="0">
+                              <a:latin typeface="Cambria Math" panose="02040503050406030204" pitchFamily="18" charset="0"/>
+                            </a:rPr>
+                            <m:t>𝑅</m:t>
+                          </m:r>
+                        </m:num>
+                        <m:den>
+                          <m:r>
+                            <a:rPr lang="en-US" sz="2400" b="0" i="1" smtClean="0">
+                              <a:latin typeface="Cambria Math" panose="02040503050406030204" pitchFamily="18" charset="0"/>
+                            </a:rPr>
+                            <m:t>𝑠𝐿</m:t>
+                          </m:r>
+                          <m:r>
+                            <a:rPr lang="en-US" sz="2400" b="0" i="1" smtClean="0">
+                              <a:latin typeface="Cambria Math" panose="02040503050406030204" pitchFamily="18" charset="0"/>
+                            </a:rPr>
+                            <m:t>+</m:t>
+                          </m:r>
+                          <m:r>
+                            <a:rPr lang="en-US" sz="2400" b="0" i="1" smtClean="0">
+                              <a:latin typeface="Cambria Math" panose="02040503050406030204" pitchFamily="18" charset="0"/>
+                            </a:rPr>
+                            <m:t>𝑅</m:t>
+                          </m:r>
+                          <m:r>
+                            <a:rPr lang="en-US" sz="2400" b="0" i="1" smtClean="0">
+                              <a:latin typeface="Cambria Math" panose="02040503050406030204" pitchFamily="18" charset="0"/>
+                            </a:rPr>
+                            <m:t>+</m:t>
+                          </m:r>
+                          <m:r>
+                            <a:rPr lang="en-US" sz="2400" b="0" i="1" smtClean="0">
+                              <a:latin typeface="Cambria Math" panose="02040503050406030204" pitchFamily="18" charset="0"/>
+                            </a:rPr>
+                            <m:t>𝐷</m:t>
+                          </m:r>
+                          <m:sSub>
+                            <m:sSubPr>
+                              <m:ctrlPr>
+                                <a:rPr lang="en-US" sz="2400" b="0" i="1" smtClean="0">
+                                  <a:latin typeface="Cambria Math" panose="02040503050406030204" pitchFamily="18" charset="0"/>
+                                </a:rPr>
+                              </m:ctrlPr>
+                            </m:sSubPr>
+                            <m:e>
+                              <m:r>
+                                <a:rPr lang="en-US" sz="2400" b="0" i="1" smtClean="0">
+                                  <a:latin typeface="Cambria Math" panose="02040503050406030204" pitchFamily="18" charset="0"/>
+                                </a:rPr>
+                                <m:t>𝑉</m:t>
+                              </m:r>
+                            </m:e>
+                            <m:sub>
+                              <m:r>
+                                <a:rPr lang="en-US" sz="2400" b="0" i="1" smtClean="0">
+                                  <a:latin typeface="Cambria Math" panose="02040503050406030204" pitchFamily="18" charset="0"/>
+                                </a:rPr>
+                                <m:t>𝑔</m:t>
+                              </m:r>
+                            </m:sub>
+                          </m:sSub>
+                        </m:den>
+                      </m:f>
+                    </m:oMath>
+                  </m:oMathPara>
+                </a14:m>
+                <a:endParaRPr lang="en-US" sz="2400" b="0" dirty="0"/>
+              </a:p>
+              <a:p>
+                <a:pPr/>
+                <a14:m>
+                  <m:oMathPara xmlns:m="http://schemas.openxmlformats.org/officeDocument/2006/math">
+                    <m:oMathParaPr>
+                      <m:jc m:val="centerGroup"/>
+                    </m:oMathParaPr>
+                    <m:oMath xmlns:m="http://schemas.openxmlformats.org/officeDocument/2006/math">
+                      <m:sSubSup>
+                        <m:sSubSupPr>
+                          <m:ctrlPr>
+                            <a:rPr lang="en-US" sz="2400" b="0" i="1" smtClean="0">
+                              <a:latin typeface="Cambria Math" panose="02040503050406030204" pitchFamily="18" charset="0"/>
+                            </a:rPr>
+                          </m:ctrlPr>
+                        </m:sSubSupPr>
+                        <m:e>
+                          <m:r>
+                            <a:rPr lang="en-US" sz="2400" b="0" i="1" smtClean="0">
+                              <a:latin typeface="Cambria Math" panose="02040503050406030204" pitchFamily="18" charset="0"/>
+                            </a:rPr>
+                            <m:t>𝑆</m:t>
+                          </m:r>
+                        </m:e>
+                        <m:sub>
+                          <m:r>
+                            <a:rPr lang="en-US" sz="2400" b="0" i="1" smtClean="0">
+                              <a:latin typeface="Cambria Math" panose="02040503050406030204" pitchFamily="18" charset="0"/>
+                            </a:rPr>
+                            <m:t>𝐿</m:t>
+                          </m:r>
+                        </m:sub>
+                        <m:sup>
+                          <m:r>
+                            <a:rPr lang="en-US" sz="2400" b="0" i="1" smtClean="0">
+                              <a:latin typeface="Cambria Math" panose="02040503050406030204" pitchFamily="18" charset="0"/>
+                            </a:rPr>
+                            <m:t>𝑇</m:t>
+                          </m:r>
+                        </m:sup>
+                      </m:sSubSup>
+                      <m:r>
+                        <a:rPr lang="en-US" sz="2400" b="0" i="1" smtClean="0">
+                          <a:latin typeface="Cambria Math" panose="02040503050406030204" pitchFamily="18" charset="0"/>
+                        </a:rPr>
+                        <m:t>=</m:t>
+                      </m:r>
+                      <m:f>
+                        <m:fPr>
+                          <m:ctrlPr>
+                            <a:rPr lang="en-US" sz="2400" b="0" i="1" smtClean="0">
+                              <a:latin typeface="Cambria Math" panose="02040503050406030204" pitchFamily="18" charset="0"/>
+                            </a:rPr>
+                          </m:ctrlPr>
+                        </m:fPr>
+                        <m:num>
+                          <m:r>
+                            <a:rPr lang="en-US" sz="2400" b="0" i="1" smtClean="0">
+                              <a:latin typeface="Cambria Math" panose="02040503050406030204" pitchFamily="18" charset="0"/>
+                            </a:rPr>
+                            <m:t>𝑠𝐿</m:t>
+                          </m:r>
+                        </m:num>
+                        <m:den>
+                          <m:r>
+                            <a:rPr lang="en-US" sz="2400" b="0" i="1" smtClean="0">
+                              <a:latin typeface="Cambria Math" panose="02040503050406030204" pitchFamily="18" charset="0"/>
+                            </a:rPr>
+                            <m:t>𝑠𝐿</m:t>
+                          </m:r>
+                          <m:r>
+                            <a:rPr lang="en-US" sz="2400" b="0" i="1" smtClean="0">
+                              <a:latin typeface="Cambria Math" panose="02040503050406030204" pitchFamily="18" charset="0"/>
+                            </a:rPr>
+                            <m:t>+</m:t>
+                          </m:r>
+                          <m:r>
+                            <a:rPr lang="en-US" sz="2400" b="0" i="1" smtClean="0">
+                              <a:latin typeface="Cambria Math" panose="02040503050406030204" pitchFamily="18" charset="0"/>
+                            </a:rPr>
+                            <m:t>𝑅</m:t>
+                          </m:r>
+                          <m:r>
+                            <a:rPr lang="en-US" sz="2400" b="0" i="1" smtClean="0">
+                              <a:latin typeface="Cambria Math" panose="02040503050406030204" pitchFamily="18" charset="0"/>
+                            </a:rPr>
+                            <m:t>+</m:t>
+                          </m:r>
+                          <m:r>
+                            <a:rPr lang="en-US" sz="2400" b="0" i="1" smtClean="0">
+                              <a:latin typeface="Cambria Math" panose="02040503050406030204" pitchFamily="18" charset="0"/>
+                            </a:rPr>
+                            <m:t>𝐷</m:t>
+                          </m:r>
+                          <m:sSub>
+                            <m:sSubPr>
+                              <m:ctrlPr>
+                                <a:rPr lang="en-US" sz="2400" b="0" i="1" smtClean="0">
+                                  <a:latin typeface="Cambria Math" panose="02040503050406030204" pitchFamily="18" charset="0"/>
+                                </a:rPr>
+                              </m:ctrlPr>
+                            </m:sSubPr>
+                            <m:e>
+                              <m:r>
+                                <a:rPr lang="en-US" sz="2400" b="0" i="1" smtClean="0">
+                                  <a:latin typeface="Cambria Math" panose="02040503050406030204" pitchFamily="18" charset="0"/>
+                                </a:rPr>
+                                <m:t>𝑉</m:t>
+                              </m:r>
+                            </m:e>
+                            <m:sub>
+                              <m:r>
+                                <a:rPr lang="en-US" sz="2400" b="0" i="1" smtClean="0">
+                                  <a:latin typeface="Cambria Math" panose="02040503050406030204" pitchFamily="18" charset="0"/>
+                                </a:rPr>
+                                <m:t>𝑔</m:t>
+                              </m:r>
+                            </m:sub>
+                          </m:sSub>
+                        </m:den>
+                      </m:f>
+                    </m:oMath>
+                  </m:oMathPara>
+                </a14:m>
+                <a:endParaRPr lang="en-US" sz="2400" b="0" dirty="0"/>
+              </a:p>
+              <a:p>
+                <a:pPr/>
+                <a:endParaRPr lang="en-US" sz="2400" dirty="0"/>
+              </a:p>
+            </p:txBody>
+          </p:sp>
+        </mc:Choice>
+        <mc:Fallback>
+          <p:sp>
+            <p:nvSpPr>
+              <p:cNvPr id="4" name="TextBox 3">
+                <a:extLst>
+                  <a:ext uri="{FF2B5EF4-FFF2-40B4-BE49-F238E27FC236}">
+                    <a16:creationId xmlns:a16="http://schemas.microsoft.com/office/drawing/2014/main" id="{D9A7CD1F-D119-28C8-0094-4E82911D867E}"/>
+                  </a:ext>
+                </a:extLst>
+              </p:cNvPr>
+              <p:cNvSpPr txBox="1">
+                <a:spLocks noRot="1" noChangeAspect="1" noMove="1" noResize="1" noEditPoints="1" noAdjustHandles="1" noChangeArrowheads="1" noChangeShapeType="1" noTextEdit="1"/>
+              </p:cNvSpPr>
+              <p:nvPr/>
+            </p:nvSpPr>
+            <p:spPr>
+              <a:xfrm>
+                <a:off x="-1003554" y="1546987"/>
+                <a:ext cx="6243066" cy="2849626"/>
+              </a:xfrm>
+              <a:prstGeom prst="rect">
+                <a:avLst/>
+              </a:prstGeom>
+              <a:blipFill>
+                <a:blip r:embed="rId2"/>
+                <a:stretch>
+                  <a:fillRect/>
+                </a:stretch>
+              </a:blipFill>
+            </p:spPr>
+            <p:txBody>
+              <a:bodyPr/>
+              <a:lstStyle/>
+              <a:p>
+                <a:r>
+                  <a:rPr lang="en-US">
+                    <a:noFill/>
+                  </a:rPr>
+                  <a:t> </a:t>
+                </a:r>
+              </a:p>
+            </p:txBody>
+          </p:sp>
+        </mc:Fallback>
+      </mc:AlternateContent>
+      <mc:AlternateContent xmlns:mc="http://schemas.openxmlformats.org/markup-compatibility/2006">
+        <mc:Choice xmlns:a14="http://schemas.microsoft.com/office/drawing/2010/main" Requires="a14">
+          <p:sp>
+            <p:nvSpPr>
+              <p:cNvPr id="6" name="TextBox 5">
+                <a:extLst>
+                  <a:ext uri="{FF2B5EF4-FFF2-40B4-BE49-F238E27FC236}">
+                    <a16:creationId xmlns:a16="http://schemas.microsoft.com/office/drawing/2014/main" id="{25681706-545C-F9C4-0738-F05EF11F5B56}"/>
+                  </a:ext>
+                </a:extLst>
+              </p:cNvPr>
+              <p:cNvSpPr txBox="1"/>
+              <p:nvPr/>
+            </p:nvSpPr>
+            <p:spPr>
+              <a:xfrm>
+                <a:off x="838200" y="4330360"/>
+                <a:ext cx="1395603" cy="1961306"/>
+              </a:xfrm>
+              <a:prstGeom prst="rect">
+                <a:avLst/>
+              </a:prstGeom>
+              <a:noFill/>
+            </p:spPr>
+            <p:txBody>
+              <a:bodyPr wrap="square" lIns="0" tIns="0" rIns="0" bIns="0" rtlCol="0">
+                <a:spAutoFit/>
+              </a:bodyPr>
+              <a:lstStyle/>
+              <a:p>
+                <a14:m>
+                  <m:oMathPara xmlns:m="http://schemas.openxmlformats.org/officeDocument/2006/math">
+                    <m:oMathParaPr>
+                      <m:jc m:val="centerGroup"/>
+                    </m:oMathParaPr>
+                    <m:oMath xmlns:m="http://schemas.openxmlformats.org/officeDocument/2006/math">
+                      <m:sSub>
+                        <m:sSubPr>
+                          <m:ctrlPr>
+                            <a:rPr lang="en-US" sz="2400" b="0" i="1" smtClean="0">
+                              <a:latin typeface="Cambria Math" panose="02040503050406030204" pitchFamily="18" charset="0"/>
+                            </a:rPr>
+                          </m:ctrlPr>
+                        </m:sSubPr>
+                        <m:e>
+                          <m:r>
+                            <a:rPr lang="en-US" sz="2400" b="0" i="1" smtClean="0">
+                              <a:latin typeface="Cambria Math" panose="02040503050406030204" pitchFamily="18" charset="0"/>
+                            </a:rPr>
+                            <m:t>𝐸</m:t>
+                          </m:r>
+                        </m:e>
+                        <m:sub>
+                          <m:sSub>
+                            <m:sSubPr>
+                              <m:ctrlPr>
+                                <a:rPr lang="en-US" sz="2400" b="0" i="1" smtClean="0">
+                                  <a:latin typeface="Cambria Math" panose="02040503050406030204" pitchFamily="18" charset="0"/>
+                                </a:rPr>
+                              </m:ctrlPr>
+                            </m:sSubPr>
+                            <m:e>
+                              <m:r>
+                                <a:rPr lang="en-US" sz="2400" b="0" i="1" smtClean="0">
+                                  <a:latin typeface="Cambria Math" panose="02040503050406030204" pitchFamily="18" charset="0"/>
+                                </a:rPr>
+                                <m:t>𝑉</m:t>
+                              </m:r>
+                            </m:e>
+                            <m:sub>
+                              <m:r>
+                                <a:rPr lang="en-US" sz="2400" b="0" i="1" smtClean="0">
+                                  <a:latin typeface="Cambria Math" panose="02040503050406030204" pitchFamily="18" charset="0"/>
+                                </a:rPr>
+                                <m:t>𝑔</m:t>
+                              </m:r>
+                            </m:sub>
+                          </m:sSub>
+                        </m:sub>
+                      </m:sSub>
+                      <m:r>
+                        <a:rPr lang="en-US" sz="2400" b="0" i="1" smtClean="0">
+                          <a:latin typeface="Cambria Math" panose="02040503050406030204" pitchFamily="18" charset="0"/>
+                        </a:rPr>
+                        <m:t>=</m:t>
+                      </m:r>
+                      <m:f>
+                        <m:fPr>
+                          <m:ctrlPr>
+                            <a:rPr lang="en-US" sz="2400" b="0" i="1" smtClean="0">
+                              <a:latin typeface="Cambria Math" panose="02040503050406030204" pitchFamily="18" charset="0"/>
+                            </a:rPr>
+                          </m:ctrlPr>
+                        </m:fPr>
+                        <m:num>
+                          <m:r>
+                            <a:rPr lang="en-US" sz="2400" b="0" i="1" smtClean="0">
+                              <a:latin typeface="Cambria Math" panose="02040503050406030204" pitchFamily="18" charset="0"/>
+                            </a:rPr>
+                            <m:t>𝑅</m:t>
+                          </m:r>
+                        </m:num>
+                        <m:den>
+                          <m:sSub>
+                            <m:sSubPr>
+                              <m:ctrlPr>
+                                <a:rPr lang="en-US" sz="2400" b="0" i="1" smtClean="0">
+                                  <a:latin typeface="Cambria Math" panose="02040503050406030204" pitchFamily="18" charset="0"/>
+                                </a:rPr>
+                              </m:ctrlPr>
+                            </m:sSubPr>
+                            <m:e>
+                              <m:r>
+                                <a:rPr lang="en-US" sz="2400" b="0" i="1" smtClean="0">
+                                  <a:latin typeface="Cambria Math" panose="02040503050406030204" pitchFamily="18" charset="0"/>
+                                </a:rPr>
+                                <m:t>𝐾</m:t>
+                              </m:r>
+                            </m:e>
+                            <m:sub>
+                              <m:r>
+                                <a:rPr lang="en-US" sz="2400" b="0" i="1" smtClean="0">
+                                  <a:latin typeface="Cambria Math" panose="02040503050406030204" pitchFamily="18" charset="0"/>
+                                </a:rPr>
+                                <m:t>𝑖</m:t>
+                              </m:r>
+                            </m:sub>
+                          </m:sSub>
+                          <m:sSub>
+                            <m:sSubPr>
+                              <m:ctrlPr>
+                                <a:rPr lang="en-US" sz="2400" b="0" i="1" smtClean="0">
+                                  <a:latin typeface="Cambria Math" panose="02040503050406030204" pitchFamily="18" charset="0"/>
+                                </a:rPr>
+                              </m:ctrlPr>
+                            </m:sSubPr>
+                            <m:e>
+                              <m:r>
+                                <a:rPr lang="en-US" sz="2400" b="0" i="1" smtClean="0">
+                                  <a:latin typeface="Cambria Math" panose="02040503050406030204" pitchFamily="18" charset="0"/>
+                                </a:rPr>
+                                <m:t>𝑉</m:t>
+                              </m:r>
+                            </m:e>
+                            <m:sub>
+                              <m:r>
+                                <a:rPr lang="en-US" sz="2400" b="0" i="1" smtClean="0">
+                                  <a:latin typeface="Cambria Math" panose="02040503050406030204" pitchFamily="18" charset="0"/>
+                                </a:rPr>
+                                <m:t>𝑔</m:t>
+                              </m:r>
+                            </m:sub>
+                          </m:sSub>
+                        </m:den>
+                      </m:f>
+                    </m:oMath>
+                  </m:oMathPara>
+                </a14:m>
+                <a:endParaRPr lang="en-US" sz="2400" b="0" dirty="0"/>
+              </a:p>
+              <a:p>
+                <a14:m>
+                  <m:oMathPara xmlns:m="http://schemas.openxmlformats.org/officeDocument/2006/math">
+                    <m:oMathParaPr>
+                      <m:jc m:val="centerGroup"/>
+                    </m:oMathParaPr>
+                    <m:oMath xmlns:m="http://schemas.openxmlformats.org/officeDocument/2006/math">
+                      <m:sSub>
+                        <m:sSubPr>
+                          <m:ctrlPr>
+                            <a:rPr lang="en-US" sz="2400" b="0" i="1" smtClean="0">
+                              <a:latin typeface="Cambria Math" panose="02040503050406030204" pitchFamily="18" charset="0"/>
+                            </a:rPr>
+                          </m:ctrlPr>
+                        </m:sSubPr>
+                        <m:e>
+                          <m:r>
+                            <a:rPr lang="en-US" sz="2400" b="0" i="1" smtClean="0">
+                              <a:latin typeface="Cambria Math" panose="02040503050406030204" pitchFamily="18" charset="0"/>
+                            </a:rPr>
+                            <m:t>𝐸</m:t>
+                          </m:r>
+                        </m:e>
+                        <m:sub>
+                          <m:r>
+                            <a:rPr lang="en-US" sz="2400" b="0" i="1" smtClean="0">
+                              <a:latin typeface="Cambria Math" panose="02040503050406030204" pitchFamily="18" charset="0"/>
+                            </a:rPr>
+                            <m:t>𝑅</m:t>
+                          </m:r>
+                        </m:sub>
+                      </m:sSub>
+                      <m:r>
+                        <a:rPr lang="en-US" sz="2400" b="0" i="1" smtClean="0">
+                          <a:latin typeface="Cambria Math" panose="02040503050406030204" pitchFamily="18" charset="0"/>
+                        </a:rPr>
+                        <m:t>=</m:t>
+                      </m:r>
+                      <m:f>
+                        <m:fPr>
+                          <m:ctrlPr>
+                            <a:rPr lang="en-US" sz="2400" b="0" i="1" smtClean="0">
+                              <a:latin typeface="Cambria Math" panose="02040503050406030204" pitchFamily="18" charset="0"/>
+                            </a:rPr>
+                          </m:ctrlPr>
+                        </m:fPr>
+                        <m:num>
+                          <m:r>
+                            <a:rPr lang="en-US" sz="2400" b="0" i="1" smtClean="0">
+                              <a:latin typeface="Cambria Math" panose="02040503050406030204" pitchFamily="18" charset="0"/>
+                            </a:rPr>
+                            <m:t>𝑅</m:t>
+                          </m:r>
+                        </m:num>
+                        <m:den>
+                          <m:sSub>
+                            <m:sSubPr>
+                              <m:ctrlPr>
+                                <a:rPr lang="en-US" sz="2400" b="0" i="1" smtClean="0">
+                                  <a:latin typeface="Cambria Math" panose="02040503050406030204" pitchFamily="18" charset="0"/>
+                                </a:rPr>
+                              </m:ctrlPr>
+                            </m:sSubPr>
+                            <m:e>
+                              <m:r>
+                                <a:rPr lang="en-US" sz="2400" b="0" i="1" smtClean="0">
+                                  <a:latin typeface="Cambria Math" panose="02040503050406030204" pitchFamily="18" charset="0"/>
+                                </a:rPr>
+                                <m:t>𝐾</m:t>
+                              </m:r>
+                            </m:e>
+                            <m:sub>
+                              <m:r>
+                                <a:rPr lang="en-US" sz="2400" b="0" i="1" smtClean="0">
+                                  <a:latin typeface="Cambria Math" panose="02040503050406030204" pitchFamily="18" charset="0"/>
+                                </a:rPr>
+                                <m:t>𝑖</m:t>
+                              </m:r>
+                            </m:sub>
+                          </m:sSub>
+                          <m:sSub>
+                            <m:sSubPr>
+                              <m:ctrlPr>
+                                <a:rPr lang="en-US" sz="2400" b="0" i="1" smtClean="0">
+                                  <a:latin typeface="Cambria Math" panose="02040503050406030204" pitchFamily="18" charset="0"/>
+                                </a:rPr>
+                              </m:ctrlPr>
+                            </m:sSubPr>
+                            <m:e>
+                              <m:r>
+                                <a:rPr lang="en-US" sz="2400" b="0" i="1" smtClean="0">
+                                  <a:latin typeface="Cambria Math" panose="02040503050406030204" pitchFamily="18" charset="0"/>
+                                </a:rPr>
+                                <m:t>𝑉</m:t>
+                              </m:r>
+                            </m:e>
+                            <m:sub>
+                              <m:r>
+                                <a:rPr lang="en-US" sz="2400" b="0" i="1" smtClean="0">
+                                  <a:latin typeface="Cambria Math" panose="02040503050406030204" pitchFamily="18" charset="0"/>
+                                </a:rPr>
+                                <m:t>𝑔</m:t>
+                              </m:r>
+                            </m:sub>
+                          </m:sSub>
+                        </m:den>
+                      </m:f>
+                    </m:oMath>
+                  </m:oMathPara>
+                </a14:m>
+                <a:endParaRPr lang="en-US" sz="2400" b="0" dirty="0"/>
+              </a:p>
+              <a:p>
+                <a14:m>
+                  <m:oMathPara xmlns:m="http://schemas.openxmlformats.org/officeDocument/2006/math">
+                    <m:oMathParaPr>
+                      <m:jc m:val="centerGroup"/>
+                    </m:oMathParaPr>
+                    <m:oMath xmlns:m="http://schemas.openxmlformats.org/officeDocument/2006/math">
+                      <m:sSub>
+                        <m:sSubPr>
+                          <m:ctrlPr>
+                            <a:rPr lang="en-US" sz="2400" b="0" i="1" smtClean="0">
+                              <a:latin typeface="Cambria Math" panose="02040503050406030204" pitchFamily="18" charset="0"/>
+                            </a:rPr>
+                          </m:ctrlPr>
+                        </m:sSubPr>
+                        <m:e>
+                          <m:r>
+                            <a:rPr lang="en-US" sz="2400" b="0" i="1" smtClean="0">
+                              <a:latin typeface="Cambria Math" panose="02040503050406030204" pitchFamily="18" charset="0"/>
+                            </a:rPr>
+                            <m:t>𝐸</m:t>
+                          </m:r>
+                        </m:e>
+                        <m:sub>
+                          <m:r>
+                            <a:rPr lang="en-US" sz="2400" b="0" i="1" smtClean="0">
+                              <a:latin typeface="Cambria Math" panose="02040503050406030204" pitchFamily="18" charset="0"/>
+                            </a:rPr>
+                            <m:t>𝐿</m:t>
+                          </m:r>
+                        </m:sub>
+                      </m:sSub>
+                      <m:r>
+                        <a:rPr lang="en-US" sz="2400" b="0" i="1" smtClean="0">
+                          <a:latin typeface="Cambria Math" panose="02040503050406030204" pitchFamily="18" charset="0"/>
+                        </a:rPr>
+                        <m:t>=0</m:t>
+                      </m:r>
+                    </m:oMath>
+                  </m:oMathPara>
+                </a14:m>
+                <a:endParaRPr lang="en-US" sz="2400" b="0" dirty="0"/>
+              </a:p>
+            </p:txBody>
+          </p:sp>
+        </mc:Choice>
+        <mc:Fallback>
+          <p:sp>
+            <p:nvSpPr>
+              <p:cNvPr id="6" name="TextBox 5">
+                <a:extLst>
+                  <a:ext uri="{FF2B5EF4-FFF2-40B4-BE49-F238E27FC236}">
+                    <a16:creationId xmlns:a16="http://schemas.microsoft.com/office/drawing/2014/main" id="{25681706-545C-F9C4-0738-F05EF11F5B56}"/>
+                  </a:ext>
+                </a:extLst>
+              </p:cNvPr>
+              <p:cNvSpPr txBox="1">
+                <a:spLocks noRot="1" noChangeAspect="1" noMove="1" noResize="1" noEditPoints="1" noAdjustHandles="1" noChangeArrowheads="1" noChangeShapeType="1" noTextEdit="1"/>
+              </p:cNvSpPr>
+              <p:nvPr/>
+            </p:nvSpPr>
+            <p:spPr>
+              <a:xfrm>
+                <a:off x="838200" y="4330360"/>
+                <a:ext cx="1395603" cy="1961306"/>
+              </a:xfrm>
+              <a:prstGeom prst="rect">
+                <a:avLst/>
+              </a:prstGeom>
+              <a:blipFill>
+                <a:blip r:embed="rId3"/>
+                <a:stretch>
+                  <a:fillRect b="-1553"/>
+                </a:stretch>
+              </a:blipFill>
+            </p:spPr>
+            <p:txBody>
+              <a:bodyPr/>
+              <a:lstStyle/>
+              <a:p>
+                <a:r>
+                  <a:rPr lang="en-US">
+                    <a:noFill/>
+                  </a:rPr>
+                  <a:t> </a:t>
+                </a:r>
+              </a:p>
+            </p:txBody>
+          </p:sp>
+        </mc:Fallback>
+      </mc:AlternateContent>
+      <mc:AlternateContent xmlns:mc="http://schemas.openxmlformats.org/markup-compatibility/2006">
+        <mc:Choice xmlns:a14="http://schemas.microsoft.com/office/drawing/2010/main" Requires="a14">
+          <p:sp>
+            <p:nvSpPr>
+              <p:cNvPr id="7" name="TextBox 6">
+                <a:extLst>
+                  <a:ext uri="{FF2B5EF4-FFF2-40B4-BE49-F238E27FC236}">
+                    <a16:creationId xmlns:a16="http://schemas.microsoft.com/office/drawing/2014/main" id="{B45B785C-3E7E-47DB-B436-8AAC17C038FE}"/>
+                  </a:ext>
+                </a:extLst>
+              </p:cNvPr>
+              <p:cNvSpPr txBox="1"/>
+              <p:nvPr/>
+            </p:nvSpPr>
+            <p:spPr>
+              <a:xfrm>
+                <a:off x="5637276" y="1690688"/>
+                <a:ext cx="1957715" cy="2274597"/>
+              </a:xfrm>
+              <a:prstGeom prst="rect">
+                <a:avLst/>
+              </a:prstGeom>
+              <a:noFill/>
+            </p:spPr>
+            <p:txBody>
+              <a:bodyPr wrap="none" lIns="0" tIns="0" rIns="0" bIns="0" rtlCol="0">
+                <a:spAutoFit/>
+              </a:bodyPr>
+              <a:lstStyle/>
+              <a:p>
+                <a14:m>
+                  <m:oMathPara xmlns:m="http://schemas.openxmlformats.org/officeDocument/2006/math">
+                    <m:oMathParaPr>
+                      <m:jc m:val="centerGroup"/>
+                    </m:oMathParaPr>
+                    <m:oMath xmlns:m="http://schemas.openxmlformats.org/officeDocument/2006/math">
+                      <m:r>
+                        <a:rPr lang="en-US" sz="2400" b="0" i="1" smtClean="0">
+                          <a:latin typeface="Cambria Math" panose="02040503050406030204" pitchFamily="18" charset="0"/>
+                        </a:rPr>
+                        <m:t>𝑅</m:t>
+                      </m:r>
+                      <m:r>
+                        <a:rPr lang="en-US" sz="2400" b="0" i="1" smtClean="0">
+                          <a:latin typeface="Cambria Math" panose="02040503050406030204" pitchFamily="18" charset="0"/>
+                        </a:rPr>
+                        <m:t>=0.08233</m:t>
+                      </m:r>
+                      <m:r>
+                        <m:rPr>
+                          <m:sty m:val="p"/>
+                        </m:rPr>
+                        <a:rPr lang="el-GR" sz="2400" b="0" i="1" smtClean="0">
+                          <a:latin typeface="Cambria Math" panose="02040503050406030204" pitchFamily="18" charset="0"/>
+                          <a:ea typeface="Cambria Math" panose="02040503050406030204" pitchFamily="18" charset="0"/>
+                        </a:rPr>
+                        <m:t>Ω</m:t>
+                      </m:r>
+                    </m:oMath>
+                  </m:oMathPara>
+                </a14:m>
+                <a:endParaRPr lang="en-US" sz="2400" b="0" dirty="0">
+                  <a:ea typeface="Cambria Math" panose="02040503050406030204" pitchFamily="18" charset="0"/>
+                </a:endParaRPr>
+              </a:p>
+              <a:p>
+                <a14:m>
+                  <m:oMathPara xmlns:m="http://schemas.openxmlformats.org/officeDocument/2006/math">
+                    <m:oMathParaPr>
+                      <m:jc m:val="centerGroup"/>
+                    </m:oMathParaPr>
+                    <m:oMath xmlns:m="http://schemas.openxmlformats.org/officeDocument/2006/math">
+                      <m:sSub>
+                        <m:sSubPr>
+                          <m:ctrlPr>
+                            <a:rPr lang="en-US" sz="2400" b="0" i="1" smtClean="0">
+                              <a:latin typeface="Cambria Math" panose="02040503050406030204" pitchFamily="18" charset="0"/>
+                            </a:rPr>
+                          </m:ctrlPr>
+                        </m:sSubPr>
+                        <m:e>
+                          <m:r>
+                            <a:rPr lang="en-US" sz="2400" b="0" i="1" smtClean="0">
+                              <a:latin typeface="Cambria Math" panose="02040503050406030204" pitchFamily="18" charset="0"/>
+                            </a:rPr>
+                            <m:t>𝑉</m:t>
+                          </m:r>
+                        </m:e>
+                        <m:sub>
+                          <m:r>
+                            <a:rPr lang="en-US" sz="2400" b="0" i="1" smtClean="0">
+                              <a:latin typeface="Cambria Math" panose="02040503050406030204" pitchFamily="18" charset="0"/>
+                            </a:rPr>
+                            <m:t>𝑔</m:t>
+                          </m:r>
+                        </m:sub>
+                      </m:sSub>
+                      <m:r>
+                        <a:rPr lang="en-US" sz="2400" b="0" i="1" smtClean="0">
+                          <a:latin typeface="Cambria Math" panose="02040503050406030204" pitchFamily="18" charset="0"/>
+                        </a:rPr>
+                        <m:t>=24</m:t>
+                      </m:r>
+                      <m:r>
+                        <a:rPr lang="en-US" sz="2400" b="0" i="1" smtClean="0">
+                          <a:latin typeface="Cambria Math" panose="02040503050406030204" pitchFamily="18" charset="0"/>
+                        </a:rPr>
+                        <m:t>𝑉</m:t>
+                      </m:r>
+                    </m:oMath>
+                  </m:oMathPara>
+                </a14:m>
+                <a:endParaRPr lang="en-US" sz="2400" b="0" dirty="0"/>
+              </a:p>
+              <a:p>
+                <a14:m>
+                  <m:oMathPara xmlns:m="http://schemas.openxmlformats.org/officeDocument/2006/math">
+                    <m:oMathParaPr>
+                      <m:jc m:val="centerGroup"/>
+                    </m:oMathParaPr>
+                    <m:oMath xmlns:m="http://schemas.openxmlformats.org/officeDocument/2006/math">
+                      <m:r>
+                        <a:rPr lang="en-US" sz="2400" b="0" i="1" smtClean="0">
+                          <a:latin typeface="Cambria Math" panose="02040503050406030204" pitchFamily="18" charset="0"/>
+                        </a:rPr>
+                        <m:t>𝐿</m:t>
+                      </m:r>
+                      <m:r>
+                        <a:rPr lang="en-US" sz="2400" b="0" i="1" smtClean="0">
+                          <a:latin typeface="Cambria Math" panose="02040503050406030204" pitchFamily="18" charset="0"/>
+                        </a:rPr>
+                        <m:t>=28.306</m:t>
+                      </m:r>
+                      <m:r>
+                        <a:rPr lang="en-US" sz="2400" b="0" i="1" smtClean="0">
+                          <a:latin typeface="Cambria Math" panose="02040503050406030204" pitchFamily="18" charset="0"/>
+                          <a:ea typeface="Cambria Math" panose="02040503050406030204" pitchFamily="18" charset="0"/>
+                        </a:rPr>
+                        <m:t>𝜇</m:t>
+                      </m:r>
+                      <m:r>
+                        <a:rPr lang="en-US" sz="2400" b="0" i="1" smtClean="0">
+                          <a:latin typeface="Cambria Math" panose="02040503050406030204" pitchFamily="18" charset="0"/>
+                          <a:ea typeface="Cambria Math" panose="02040503050406030204" pitchFamily="18" charset="0"/>
+                        </a:rPr>
+                        <m:t>𝐹</m:t>
+                      </m:r>
+                    </m:oMath>
+                  </m:oMathPara>
+                </a14:m>
+                <a:endParaRPr lang="en-US" sz="2400" b="0" dirty="0">
+                  <a:ea typeface="Cambria Math" panose="02040503050406030204" pitchFamily="18" charset="0"/>
+                </a:endParaRPr>
+              </a:p>
+              <a:p>
+                <a14:m>
+                  <m:oMathPara xmlns:m="http://schemas.openxmlformats.org/officeDocument/2006/math">
+                    <m:oMathParaPr>
+                      <m:jc m:val="centerGroup"/>
+                    </m:oMathParaPr>
+                    <m:oMath xmlns:m="http://schemas.openxmlformats.org/officeDocument/2006/math">
+                      <m:sSub>
+                        <m:sSubPr>
+                          <m:ctrlPr>
+                            <a:rPr lang="en-US" sz="2400" b="0" i="1" smtClean="0">
+                              <a:latin typeface="Cambria Math" panose="02040503050406030204" pitchFamily="18" charset="0"/>
+                            </a:rPr>
+                          </m:ctrlPr>
+                        </m:sSubPr>
+                        <m:e>
+                          <m:r>
+                            <a:rPr lang="en-US" sz="2400" b="0" i="1" smtClean="0">
+                              <a:latin typeface="Cambria Math" panose="02040503050406030204" pitchFamily="18" charset="0"/>
+                            </a:rPr>
+                            <m:t>𝐾</m:t>
+                          </m:r>
+                        </m:e>
+                        <m:sub>
+                          <m:r>
+                            <a:rPr lang="en-US" sz="2400" b="0" i="1" smtClean="0">
+                              <a:latin typeface="Cambria Math" panose="02040503050406030204" pitchFamily="18" charset="0"/>
+                            </a:rPr>
+                            <m:t>𝑝</m:t>
+                          </m:r>
+                        </m:sub>
+                      </m:sSub>
+                      <m:r>
+                        <a:rPr lang="en-US" sz="2400" b="0" i="1" smtClean="0">
+                          <a:latin typeface="Cambria Math" panose="02040503050406030204" pitchFamily="18" charset="0"/>
+                        </a:rPr>
+                        <m:t>=2.13422</m:t>
+                      </m:r>
+                    </m:oMath>
+                  </m:oMathPara>
+                </a14:m>
+                <a:endParaRPr lang="en-US" sz="2400" b="0" dirty="0"/>
+              </a:p>
+              <a:p>
+                <a14:m>
+                  <m:oMathPara xmlns:m="http://schemas.openxmlformats.org/officeDocument/2006/math">
+                    <m:oMathParaPr>
+                      <m:jc m:val="centerGroup"/>
+                    </m:oMathParaPr>
+                    <m:oMath xmlns:m="http://schemas.openxmlformats.org/officeDocument/2006/math">
+                      <m:sSub>
+                        <m:sSubPr>
+                          <m:ctrlPr>
+                            <a:rPr lang="en-US" sz="2400" b="0" i="1" smtClean="0">
+                              <a:latin typeface="Cambria Math" panose="02040503050406030204" pitchFamily="18" charset="0"/>
+                            </a:rPr>
+                          </m:ctrlPr>
+                        </m:sSubPr>
+                        <m:e>
+                          <m:r>
+                            <a:rPr lang="en-US" sz="2400" b="0" i="1" smtClean="0">
+                              <a:latin typeface="Cambria Math" panose="02040503050406030204" pitchFamily="18" charset="0"/>
+                            </a:rPr>
+                            <m:t>𝐾</m:t>
+                          </m:r>
+                        </m:e>
+                        <m:sub>
+                          <m:r>
+                            <a:rPr lang="en-US" sz="2400" b="0" i="1" smtClean="0">
+                              <a:latin typeface="Cambria Math" panose="02040503050406030204" pitchFamily="18" charset="0"/>
+                            </a:rPr>
+                            <m:t>𝑖</m:t>
+                          </m:r>
+                        </m:sub>
+                      </m:sSub>
+                      <m:r>
+                        <a:rPr lang="en-US" sz="2400" b="0" i="1" smtClean="0">
+                          <a:latin typeface="Cambria Math" panose="02040503050406030204" pitchFamily="18" charset="0"/>
+                        </a:rPr>
+                        <m:t>=6207.54</m:t>
+                      </m:r>
+                    </m:oMath>
+                  </m:oMathPara>
+                </a14:m>
+                <a:endParaRPr lang="en-US" sz="2400" b="0" dirty="0"/>
+              </a:p>
+              <a:p>
+                <a:endParaRPr lang="en-US" sz="2400" dirty="0"/>
+              </a:p>
+            </p:txBody>
+          </p:sp>
+        </mc:Choice>
+        <mc:Fallback>
+          <p:sp>
+            <p:nvSpPr>
+              <p:cNvPr id="7" name="TextBox 6">
+                <a:extLst>
+                  <a:ext uri="{FF2B5EF4-FFF2-40B4-BE49-F238E27FC236}">
+                    <a16:creationId xmlns:a16="http://schemas.microsoft.com/office/drawing/2014/main" id="{B45B785C-3E7E-47DB-B436-8AAC17C038FE}"/>
+                  </a:ext>
+                </a:extLst>
+              </p:cNvPr>
+              <p:cNvSpPr txBox="1">
+                <a:spLocks noRot="1" noChangeAspect="1" noMove="1" noResize="1" noEditPoints="1" noAdjustHandles="1" noChangeArrowheads="1" noChangeShapeType="1" noTextEdit="1"/>
+              </p:cNvSpPr>
+              <p:nvPr/>
+            </p:nvSpPr>
+            <p:spPr>
+              <a:xfrm>
+                <a:off x="5637276" y="1690688"/>
+                <a:ext cx="1957715" cy="2274597"/>
+              </a:xfrm>
+              <a:prstGeom prst="rect">
+                <a:avLst/>
+              </a:prstGeom>
+              <a:blipFill>
+                <a:blip r:embed="rId4"/>
+                <a:stretch>
+                  <a:fillRect l="-3427" r="-3427"/>
+                </a:stretch>
+              </a:blipFill>
+            </p:spPr>
+            <p:txBody>
+              <a:bodyPr/>
+              <a:lstStyle/>
+              <a:p>
+                <a:r>
+                  <a:rPr lang="en-US">
+                    <a:noFill/>
+                  </a:rPr>
+                  <a:t> </a:t>
+                </a:r>
+              </a:p>
+            </p:txBody>
+          </p:sp>
+        </mc:Fallback>
+      </mc:AlternateContent>
+      <p:sp>
+        <p:nvSpPr>
+          <p:cNvPr id="8" name="TextBox 7">
+            <a:extLst>
+              <a:ext uri="{FF2B5EF4-FFF2-40B4-BE49-F238E27FC236}">
+                <a16:creationId xmlns:a16="http://schemas.microsoft.com/office/drawing/2014/main" id="{11A48824-CAE8-9513-0163-F478020AC08D}"/>
+              </a:ext>
+            </a:extLst>
+          </p:cNvPr>
+          <p:cNvSpPr txBox="1"/>
+          <p:nvPr/>
+        </p:nvSpPr>
+        <p:spPr>
+          <a:xfrm>
+            <a:off x="5134356" y="2971800"/>
+            <a:ext cx="65" cy="276999"/>
+          </a:xfrm>
+          <a:prstGeom prst="rect">
+            <a:avLst/>
+          </a:prstGeom>
+          <a:noFill/>
+        </p:spPr>
+        <p:txBody>
+          <a:bodyPr wrap="none" lIns="0" tIns="0" rIns="0" bIns="0" rtlCol="0">
+            <a:spAutoFit/>
+          </a:bodyPr>
+          <a:lstStyle/>
+          <a:p>
+            <a:endParaRPr lang="en-US" dirty="0"/>
+          </a:p>
+        </p:txBody>
+      </p:sp>
+      <mc:AlternateContent xmlns:mc="http://schemas.openxmlformats.org/markup-compatibility/2006">
+        <mc:Choice xmlns:a14="http://schemas.microsoft.com/office/drawing/2010/main" Requires="a14">
+          <p:sp>
+            <p:nvSpPr>
+              <p:cNvPr id="10" name="TextBox 9">
+                <a:extLst>
+                  <a:ext uri="{FF2B5EF4-FFF2-40B4-BE49-F238E27FC236}">
+                    <a16:creationId xmlns:a16="http://schemas.microsoft.com/office/drawing/2014/main" id="{0394ADEE-F7B5-EAFC-D0F3-8DD32E5FD6A5}"/>
+                  </a:ext>
+                </a:extLst>
+              </p:cNvPr>
+              <p:cNvSpPr txBox="1"/>
+              <p:nvPr/>
+            </p:nvSpPr>
+            <p:spPr>
+              <a:xfrm>
+                <a:off x="3425381" y="4330360"/>
+                <a:ext cx="6633972" cy="1648656"/>
+              </a:xfrm>
+              <a:prstGeom prst="rect">
+                <a:avLst/>
+              </a:prstGeom>
+              <a:noFill/>
+            </p:spPr>
+            <p:txBody>
+              <a:bodyPr wrap="square">
+                <a:spAutoFit/>
+              </a:bodyPr>
+              <a:lstStyle/>
+              <a:p>
+                <a:pPr/>
+                <a14:m>
+                  <m:oMathPara xmlns:m="http://schemas.openxmlformats.org/officeDocument/2006/math">
+                    <m:oMathParaPr>
+                      <m:jc m:val="centerGroup"/>
+                    </m:oMathParaPr>
+                    <m:oMath xmlns:m="http://schemas.openxmlformats.org/officeDocument/2006/math">
+                      <m:sSub>
+                        <m:sSubPr>
+                          <m:ctrlPr>
+                            <a:rPr lang="en-US" sz="2400" b="0" i="1" smtClean="0">
+                              <a:latin typeface="Cambria Math" panose="02040503050406030204" pitchFamily="18" charset="0"/>
+                            </a:rPr>
+                          </m:ctrlPr>
+                        </m:sSubPr>
+                        <m:e>
+                          <m:r>
+                            <a:rPr lang="en-US" sz="2400" b="0" i="1" smtClean="0">
+                              <a:latin typeface="Cambria Math" panose="02040503050406030204" pitchFamily="18" charset="0"/>
+                            </a:rPr>
+                            <m:t>𝐸</m:t>
+                          </m:r>
+                        </m:e>
+                        <m:sub>
+                          <m:sSub>
+                            <m:sSubPr>
+                              <m:ctrlPr>
+                                <a:rPr lang="en-US" sz="2400" b="0" i="1" smtClean="0">
+                                  <a:latin typeface="Cambria Math" panose="02040503050406030204" pitchFamily="18" charset="0"/>
+                                </a:rPr>
+                              </m:ctrlPr>
+                            </m:sSubPr>
+                            <m:e>
+                              <m:r>
+                                <a:rPr lang="en-US" sz="2400" b="0" i="1" smtClean="0">
+                                  <a:latin typeface="Cambria Math" panose="02040503050406030204" pitchFamily="18" charset="0"/>
+                                </a:rPr>
+                                <m:t>𝑉</m:t>
+                              </m:r>
+                            </m:e>
+                            <m:sub>
+                              <m:r>
+                                <a:rPr lang="en-US" sz="2400" b="0" i="1" smtClean="0">
+                                  <a:latin typeface="Cambria Math" panose="02040503050406030204" pitchFamily="18" charset="0"/>
+                                </a:rPr>
+                                <m:t>𝑔</m:t>
+                              </m:r>
+                            </m:sub>
+                          </m:sSub>
+                        </m:sub>
+                      </m:sSub>
+                      <m:r>
+                        <a:rPr lang="en-US" sz="2400" b="0" i="1" smtClean="0">
+                          <a:latin typeface="Cambria Math" panose="02040503050406030204" pitchFamily="18" charset="0"/>
+                        </a:rPr>
+                        <m:t>=0.55262∗</m:t>
+                      </m:r>
+                      <m:sSup>
+                        <m:sSupPr>
+                          <m:ctrlPr>
+                            <a:rPr lang="en-US" sz="2400" b="0" i="1" smtClean="0">
+                              <a:latin typeface="Cambria Math" panose="02040503050406030204" pitchFamily="18" charset="0"/>
+                            </a:rPr>
+                          </m:ctrlPr>
+                        </m:sSupPr>
+                        <m:e>
+                          <m:r>
+                            <a:rPr lang="en-US" sz="2400" b="0" i="1" smtClean="0">
+                              <a:latin typeface="Cambria Math" panose="02040503050406030204" pitchFamily="18" charset="0"/>
+                            </a:rPr>
+                            <m:t>10</m:t>
+                          </m:r>
+                        </m:e>
+                        <m:sup>
+                          <m:r>
+                            <a:rPr lang="en-US" sz="2400" b="0" i="1" smtClean="0">
+                              <a:latin typeface="Cambria Math" panose="02040503050406030204" pitchFamily="18" charset="0"/>
+                            </a:rPr>
+                            <m:t>−6</m:t>
+                          </m:r>
+                        </m:sup>
+                      </m:sSup>
+                    </m:oMath>
+                  </m:oMathPara>
+                </a14:m>
+                <a:endParaRPr lang="en-US" sz="2400" b="0" dirty="0"/>
+              </a:p>
+              <a:p>
+                <a:pPr/>
+                <a14:m>
+                  <m:oMathPara xmlns:m="http://schemas.openxmlformats.org/officeDocument/2006/math">
+                    <m:oMathParaPr>
+                      <m:jc m:val="centerGroup"/>
+                    </m:oMathParaPr>
+                    <m:oMath xmlns:m="http://schemas.openxmlformats.org/officeDocument/2006/math">
+                      <m:sSub>
+                        <m:sSubPr>
+                          <m:ctrlPr>
+                            <a:rPr lang="en-US" sz="2400" b="0" i="1" smtClean="0">
+                              <a:latin typeface="Cambria Math" panose="02040503050406030204" pitchFamily="18" charset="0"/>
+                            </a:rPr>
+                          </m:ctrlPr>
+                        </m:sSubPr>
+                        <m:e>
+                          <m:r>
+                            <a:rPr lang="en-US" sz="2400" b="0" i="1" smtClean="0">
+                              <a:latin typeface="Cambria Math" panose="02040503050406030204" pitchFamily="18" charset="0"/>
+                            </a:rPr>
+                            <m:t>𝐸</m:t>
+                          </m:r>
+                        </m:e>
+                        <m:sub>
+                          <m:r>
+                            <a:rPr lang="en-US" sz="2400" b="0" i="1" smtClean="0">
+                              <a:latin typeface="Cambria Math" panose="02040503050406030204" pitchFamily="18" charset="0"/>
+                            </a:rPr>
+                            <m:t>𝑅</m:t>
+                          </m:r>
+                        </m:sub>
+                      </m:sSub>
+                      <m:r>
+                        <a:rPr lang="en-US" sz="2400" b="0" i="1" smtClean="0">
+                          <a:latin typeface="Cambria Math" panose="02040503050406030204" pitchFamily="18" charset="0"/>
+                        </a:rPr>
+                        <m:t>=0.55262∗</m:t>
+                      </m:r>
+                      <m:sSup>
+                        <m:sSupPr>
+                          <m:ctrlPr>
+                            <a:rPr lang="en-US" sz="2400" b="0" i="1" smtClean="0">
+                              <a:latin typeface="Cambria Math" panose="02040503050406030204" pitchFamily="18" charset="0"/>
+                            </a:rPr>
+                          </m:ctrlPr>
+                        </m:sSupPr>
+                        <m:e>
+                          <m:r>
+                            <a:rPr lang="en-US" sz="2400" b="0" i="1" smtClean="0">
+                              <a:latin typeface="Cambria Math" panose="02040503050406030204" pitchFamily="18" charset="0"/>
+                            </a:rPr>
+                            <m:t>10</m:t>
+                          </m:r>
+                        </m:e>
+                        <m:sup>
+                          <m:r>
+                            <a:rPr lang="en-US" sz="2400" b="0" i="1" smtClean="0">
+                              <a:latin typeface="Cambria Math" panose="02040503050406030204" pitchFamily="18" charset="0"/>
+                            </a:rPr>
+                            <m:t>−6</m:t>
+                          </m:r>
+                        </m:sup>
+                      </m:sSup>
+                    </m:oMath>
+                  </m:oMathPara>
+                </a14:m>
+                <a:endParaRPr lang="en-US" sz="2400" b="0" dirty="0"/>
+              </a:p>
+              <a:p>
+                <a:pPr/>
+                <a14:m>
+                  <m:oMathPara xmlns:m="http://schemas.openxmlformats.org/officeDocument/2006/math">
+                    <m:oMathParaPr>
+                      <m:jc m:val="centerGroup"/>
+                    </m:oMathParaPr>
+                    <m:oMath xmlns:m="http://schemas.openxmlformats.org/officeDocument/2006/math">
+                      <m:sSub>
+                        <m:sSubPr>
+                          <m:ctrlPr>
+                            <a:rPr lang="en-US" sz="2400" b="0" i="1" smtClean="0">
+                              <a:latin typeface="Cambria Math" panose="02040503050406030204" pitchFamily="18" charset="0"/>
+                            </a:rPr>
+                          </m:ctrlPr>
+                        </m:sSubPr>
+                        <m:e>
+                          <m:r>
+                            <a:rPr lang="en-US" sz="2400" b="0" i="1" smtClean="0">
+                              <a:latin typeface="Cambria Math" panose="02040503050406030204" pitchFamily="18" charset="0"/>
+                            </a:rPr>
+                            <m:t>𝐸</m:t>
+                          </m:r>
+                        </m:e>
+                        <m:sub>
+                          <m:r>
+                            <a:rPr lang="en-US" sz="2400" b="0" i="1" smtClean="0">
+                              <a:latin typeface="Cambria Math" panose="02040503050406030204" pitchFamily="18" charset="0"/>
+                            </a:rPr>
+                            <m:t>𝐿</m:t>
+                          </m:r>
+                        </m:sub>
+                      </m:sSub>
+                      <m:r>
+                        <a:rPr lang="en-US" sz="2400" b="0" i="1" smtClean="0">
+                          <a:latin typeface="Cambria Math" panose="02040503050406030204" pitchFamily="18" charset="0"/>
+                        </a:rPr>
+                        <m:t>=0</m:t>
+                      </m:r>
+                    </m:oMath>
+                  </m:oMathPara>
+                </a14:m>
+                <a:endParaRPr lang="en-US" sz="2400" b="0" dirty="0"/>
+              </a:p>
+              <a:p>
+                <a:pPr/>
+                <a:endParaRPr lang="en-US" sz="2400" dirty="0"/>
+              </a:p>
+            </p:txBody>
+          </p:sp>
+        </mc:Choice>
+        <mc:Fallback>
+          <p:sp>
+            <p:nvSpPr>
+              <p:cNvPr id="10" name="TextBox 9">
+                <a:extLst>
+                  <a:ext uri="{FF2B5EF4-FFF2-40B4-BE49-F238E27FC236}">
+                    <a16:creationId xmlns:a16="http://schemas.microsoft.com/office/drawing/2014/main" id="{0394ADEE-F7B5-EAFC-D0F3-8DD32E5FD6A5}"/>
+                  </a:ext>
+                </a:extLst>
+              </p:cNvPr>
+              <p:cNvSpPr txBox="1">
+                <a:spLocks noRot="1" noChangeAspect="1" noMove="1" noResize="1" noEditPoints="1" noAdjustHandles="1" noChangeArrowheads="1" noChangeShapeType="1" noTextEdit="1"/>
+              </p:cNvSpPr>
+              <p:nvPr/>
+            </p:nvSpPr>
+            <p:spPr>
+              <a:xfrm>
+                <a:off x="3425381" y="4330360"/>
+                <a:ext cx="6633972" cy="1648656"/>
+              </a:xfrm>
+              <a:prstGeom prst="rect">
+                <a:avLst/>
+              </a:prstGeom>
+              <a:blipFill>
+                <a:blip r:embed="rId5"/>
+                <a:stretch>
+                  <a:fillRect/>
+                </a:stretch>
+              </a:blipFill>
+            </p:spPr>
+            <p:txBody>
+              <a:bodyPr/>
+              <a:lstStyle/>
+              <a:p>
+                <a:r>
+                  <a:rPr lang="en-US">
+                    <a:noFill/>
+                  </a:rPr>
+                  <a:t> </a:t>
+                </a:r>
+              </a:p>
+            </p:txBody>
+          </p:sp>
+        </mc:Fallback>
+      </mc:AlternateContent>
     </p:spTree>
     <p:extLst>
       <p:ext uri="{BB962C8B-B14F-4D97-AF65-F5344CB8AC3E}">
@@ -33903,8 +35419,8 @@
           </a:p>
         </p:txBody>
       </p:sp>
-      <mc:AlternateContent xmlns:mc="http://schemas.openxmlformats.org/markup-compatibility/2006">
-        <mc:Choice xmlns:a14="http://schemas.microsoft.com/office/drawing/2010/main" Requires="a14">
+      <mc:AlternateContent xmlns:mc="http://schemas.openxmlformats.org/markup-compatibility/2006" xmlns:a14="http://schemas.microsoft.com/office/drawing/2010/main">
+        <mc:Choice Requires="a14">
           <p:sp>
             <p:nvSpPr>
               <p:cNvPr id="4" name="Text Placeholder 3">
@@ -34445,7 +35961,7 @@
             </p:txBody>
           </p:sp>
         </mc:Choice>
-        <mc:Fallback>
+        <mc:Fallback xmlns="">
           <p:sp>
             <p:nvSpPr>
               <p:cNvPr id="4" name="Text Placeholder 3">

</xml_diff>

<commit_message>
Sensor White Noise Slide
</commit_message>
<xml_diff>
--- a/UT Robomasters – Supercap Power Stage Modeling.pptx
+++ b/UT Robomasters – Supercap Power Stage Modeling.pptx
@@ -33,6 +33,7 @@
     <p:sldId id="284" r:id="rId27"/>
     <p:sldId id="277" r:id="rId28"/>
     <p:sldId id="285" r:id="rId29"/>
+    <p:sldId id="287" r:id="rId30"/>
   </p:sldIdLst>
   <p:sldSz cx="12192000" cy="6858000"/>
   <p:notesSz cx="6858000" cy="9144000"/>
@@ -29978,8 +29979,8 @@
           </a:p>
         </p:txBody>
       </p:sp>
-      <mc:AlternateContent xmlns:mc="http://schemas.openxmlformats.org/markup-compatibility/2006">
-        <mc:Choice xmlns:a14="http://schemas.microsoft.com/office/drawing/2010/main" Requires="a14">
+      <mc:AlternateContent xmlns:mc="http://schemas.openxmlformats.org/markup-compatibility/2006" xmlns:a14="http://schemas.microsoft.com/office/drawing/2010/main">
+        <mc:Choice Requires="a14">
           <p:sp>
             <p:nvSpPr>
               <p:cNvPr id="4" name="TextBox 3">
@@ -30417,13 +30418,12 @@
                 <a:endParaRPr lang="en-US" sz="2400" b="0" dirty="0"/>
               </a:p>
               <a:p>
-                <a:pPr/>
                 <a:endParaRPr lang="en-US" sz="2400" dirty="0"/>
               </a:p>
             </p:txBody>
           </p:sp>
         </mc:Choice>
-        <mc:Fallback>
+        <mc:Fallback xmlns="">
           <p:sp>
             <p:nvSpPr>
               <p:cNvPr id="4" name="TextBox 3">
@@ -30468,8 +30468,8 @@
           </p:sp>
         </mc:Fallback>
       </mc:AlternateContent>
-      <mc:AlternateContent xmlns:mc="http://schemas.openxmlformats.org/markup-compatibility/2006">
-        <mc:Choice xmlns:a14="http://schemas.microsoft.com/office/drawing/2010/main" Requires="a14">
+      <mc:AlternateContent xmlns:mc="http://schemas.openxmlformats.org/markup-compatibility/2006" xmlns:a14="http://schemas.microsoft.com/office/drawing/2010/main">
+        <mc:Choice Requires="a14">
           <p:sp>
             <p:nvSpPr>
               <p:cNvPr id="6" name="TextBox 5">
@@ -30498,6 +30498,7 @@
               </a:bodyPr>
               <a:lstStyle/>
               <a:p>
+                <a:pPr/>
                 <a14:m>
                   <m:oMathPara xmlns:m="http://schemas.openxmlformats.org/officeDocument/2006/math">
                     <m:oMathParaPr>
@@ -30629,6 +30630,7 @@
                 <a:endParaRPr lang="en-US" sz="2400" b="0" dirty="0"/>
               </a:p>
               <a:p>
+                <a:pPr/>
                 <a14:m>
                   <m:oMathPara xmlns:m="http://schemas.openxmlformats.org/officeDocument/2006/math">
                     <m:oMathParaPr>
@@ -30741,6 +30743,7 @@
                 <a:endParaRPr lang="en-US" sz="2400" b="0" dirty="0"/>
               </a:p>
               <a:p>
+                <a:pPr/>
                 <a14:m>
                   <m:oMathPara xmlns:m="http://schemas.openxmlformats.org/officeDocument/2006/math">
                     <m:oMathParaPr>
@@ -30786,7 +30789,7 @@
             </p:txBody>
           </p:sp>
         </mc:Choice>
-        <mc:Fallback>
+        <mc:Fallback xmlns="">
           <p:sp>
             <p:nvSpPr>
               <p:cNvPr id="6" name="TextBox 5">
@@ -30831,8 +30834,8 @@
           </p:sp>
         </mc:Fallback>
       </mc:AlternateContent>
-      <mc:AlternateContent xmlns:mc="http://schemas.openxmlformats.org/markup-compatibility/2006">
-        <mc:Choice xmlns:a14="http://schemas.microsoft.com/office/drawing/2010/main" Requires="a14">
+      <mc:AlternateContent xmlns:mc="http://schemas.openxmlformats.org/markup-compatibility/2006" xmlns:a14="http://schemas.microsoft.com/office/drawing/2010/main">
+        <mc:Choice Requires="a14">
           <p:sp>
             <p:nvSpPr>
               <p:cNvPr id="7" name="TextBox 6">
@@ -30861,6 +30864,7 @@
               </a:bodyPr>
               <a:lstStyle/>
               <a:p>
+                <a:pPr/>
                 <a14:m>
                   <m:oMathPara xmlns:m="http://schemas.openxmlformats.org/officeDocument/2006/math">
                     <m:oMathParaPr>
@@ -30897,6 +30901,7 @@
                 </a:endParaRPr>
               </a:p>
               <a:p>
+                <a:pPr/>
                 <a14:m>
                   <m:oMathPara xmlns:m="http://schemas.openxmlformats.org/officeDocument/2006/math">
                     <m:oMathParaPr>
@@ -30946,6 +30951,7 @@
                 <a:endParaRPr lang="en-US" sz="2400" b="0" dirty="0"/>
               </a:p>
               <a:p>
+                <a:pPr/>
                 <a14:m>
                   <m:oMathPara xmlns:m="http://schemas.openxmlformats.org/officeDocument/2006/math">
                     <m:oMathParaPr>
@@ -30986,6 +30992,7 @@
                 </a:endParaRPr>
               </a:p>
               <a:p>
+                <a:pPr/>
                 <a14:m>
                   <m:oMathPara xmlns:m="http://schemas.openxmlformats.org/officeDocument/2006/math">
                     <m:oMathParaPr>
@@ -31029,6 +31036,7 @@
                 <a:endParaRPr lang="en-US" sz="2400" b="0" dirty="0"/>
               </a:p>
               <a:p>
+                <a:pPr/>
                 <a14:m>
                   <m:oMathPara xmlns:m="http://schemas.openxmlformats.org/officeDocument/2006/math">
                     <m:oMathParaPr>
@@ -31077,7 +31085,7 @@
             </p:txBody>
           </p:sp>
         </mc:Choice>
-        <mc:Fallback>
+        <mc:Fallback xmlns="">
           <p:sp>
             <p:nvSpPr>
               <p:cNvPr id="7" name="TextBox 6">
@@ -31154,8 +31162,8 @@
           </a:p>
         </p:txBody>
       </p:sp>
-      <mc:AlternateContent xmlns:mc="http://schemas.openxmlformats.org/markup-compatibility/2006">
-        <mc:Choice xmlns:a14="http://schemas.microsoft.com/office/drawing/2010/main" Requires="a14">
+      <mc:AlternateContent xmlns:mc="http://schemas.openxmlformats.org/markup-compatibility/2006" xmlns:a14="http://schemas.microsoft.com/office/drawing/2010/main">
+        <mc:Choice Requires="a14">
           <p:sp>
             <p:nvSpPr>
               <p:cNvPr id="10" name="TextBox 9">
@@ -31385,13 +31393,12 @@
                 <a:endParaRPr lang="en-US" sz="2400" b="0" dirty="0"/>
               </a:p>
               <a:p>
-                <a:pPr/>
                 <a:endParaRPr lang="en-US" sz="2400" dirty="0"/>
               </a:p>
             </p:txBody>
           </p:sp>
         </mc:Choice>
-        <mc:Fallback>
+        <mc:Fallback xmlns="">
           <p:sp>
             <p:nvSpPr>
               <p:cNvPr id="10" name="TextBox 9">
@@ -31440,6 +31447,1314 @@
     <p:extLst>
       <p:ext uri="{BB962C8B-B14F-4D97-AF65-F5344CB8AC3E}">
         <p14:creationId xmlns:p14="http://schemas.microsoft.com/office/powerpoint/2010/main" val="782043783"/>
+      </p:ext>
+    </p:extLst>
+  </p:cSld>
+  <p:clrMapOvr>
+    <a:masterClrMapping/>
+  </p:clrMapOvr>
+</p:sld>
+</file>
+
+<file path=ppt/slides/slide29.xml><?xml version="1.0" encoding="utf-8"?>
+<p:sld xmlns:a="http://schemas.openxmlformats.org/drawingml/2006/main" xmlns:r="http://schemas.openxmlformats.org/officeDocument/2006/relationships" xmlns:p="http://schemas.openxmlformats.org/presentationml/2006/main">
+  <p:cSld>
+    <p:spTree>
+      <p:nvGrpSpPr>
+        <p:cNvPr id="1" name=""/>
+        <p:cNvGrpSpPr/>
+        <p:nvPr/>
+      </p:nvGrpSpPr>
+      <p:grpSpPr>
+        <a:xfrm>
+          <a:off x="0" y="0"/>
+          <a:ext cx="0" cy="0"/>
+          <a:chOff x="0" y="0"/>
+          <a:chExt cx="0" cy="0"/>
+        </a:xfrm>
+      </p:grpSpPr>
+      <p:sp>
+        <p:nvSpPr>
+          <p:cNvPr id="3" name="Title 4">
+            <a:extLst>
+              <a:ext uri="{FF2B5EF4-FFF2-40B4-BE49-F238E27FC236}">
+                <a16:creationId xmlns:a16="http://schemas.microsoft.com/office/drawing/2014/main" id="{DE4739F1-6FA1-044B-350E-5337769C1EA3}"/>
+              </a:ext>
+            </a:extLst>
+          </p:cNvPr>
+          <p:cNvSpPr>
+            <a:spLocks noGrp="1"/>
+          </p:cNvSpPr>
+          <p:nvPr>
+            <p:ph type="title"/>
+          </p:nvPr>
+        </p:nvSpPr>
+        <p:spPr>
+          <a:xfrm>
+            <a:off x="838200" y="365125"/>
+            <a:ext cx="10515600" cy="1325563"/>
+          </a:xfrm>
+        </p:spPr>
+        <p:txBody>
+          <a:bodyPr/>
+          <a:lstStyle/>
+          <a:p>
+            <a:r>
+              <a:rPr lang="en-US" dirty="0"/>
+              <a:t>Sensor White Noise Noise</a:t>
+            </a:r>
+          </a:p>
+        </p:txBody>
+      </p:sp>
+      <p:sp>
+        <p:nvSpPr>
+          <p:cNvPr id="4" name="TextBox 3">
+            <a:extLst>
+              <a:ext uri="{FF2B5EF4-FFF2-40B4-BE49-F238E27FC236}">
+                <a16:creationId xmlns:a16="http://schemas.microsoft.com/office/drawing/2014/main" id="{019A21D5-DEBD-8323-DAE5-52F324203A55}"/>
+              </a:ext>
+            </a:extLst>
+          </p:cNvPr>
+          <p:cNvSpPr txBox="1"/>
+          <p:nvPr/>
+        </p:nvSpPr>
+        <p:spPr>
+          <a:xfrm>
+            <a:off x="838200" y="1472184"/>
+            <a:ext cx="5824728" cy="646331"/>
+          </a:xfrm>
+          <a:prstGeom prst="rect">
+            <a:avLst/>
+          </a:prstGeom>
+          <a:noFill/>
+        </p:spPr>
+        <p:txBody>
+          <a:bodyPr wrap="square" rtlCol="0">
+            <a:spAutoFit/>
+          </a:bodyPr>
+          <a:lstStyle/>
+          <a:p>
+            <a:r>
+              <a:rPr lang="en-US" dirty="0"/>
+              <a:t>It was empirically found that the MSPM0-G3507 12-bit ADC’s error has SD of 14 (decimal).</a:t>
+            </a:r>
+          </a:p>
+        </p:txBody>
+      </p:sp>
+      <mc:AlternateContent xmlns:mc="http://schemas.openxmlformats.org/markup-compatibility/2006">
+        <mc:Choice xmlns:a14="http://schemas.microsoft.com/office/drawing/2010/main" Requires="a14">
+          <p:sp>
+            <p:nvSpPr>
+              <p:cNvPr id="5" name="TextBox 4">
+                <a:extLst>
+                  <a:ext uri="{FF2B5EF4-FFF2-40B4-BE49-F238E27FC236}">
+                    <a16:creationId xmlns:a16="http://schemas.microsoft.com/office/drawing/2014/main" id="{1C19354B-340F-BB69-2C4A-4EF8E4414CA4}"/>
+                  </a:ext>
+                </a:extLst>
+              </p:cNvPr>
+              <p:cNvSpPr txBox="1"/>
+              <p:nvPr/>
+            </p:nvSpPr>
+            <p:spPr>
+              <a:xfrm>
+                <a:off x="838200" y="2118515"/>
+                <a:ext cx="4950330" cy="758669"/>
+              </a:xfrm>
+              <a:prstGeom prst="rect">
+                <a:avLst/>
+              </a:prstGeom>
+              <a:noFill/>
+            </p:spPr>
+            <p:txBody>
+              <a:bodyPr wrap="none" lIns="0" tIns="0" rIns="0" bIns="0" rtlCol="0">
+                <a:spAutoFit/>
+              </a:bodyPr>
+              <a:lstStyle/>
+              <a:p>
+                <a14:m>
+                  <m:oMathPara xmlns:m="http://schemas.openxmlformats.org/officeDocument/2006/math">
+                    <m:oMathParaPr>
+                      <m:jc m:val="centerGroup"/>
+                    </m:oMathParaPr>
+                    <m:oMath xmlns:m="http://schemas.openxmlformats.org/officeDocument/2006/math">
+                      <m:sSub>
+                        <m:sSubPr>
+                          <m:ctrlPr>
+                            <a:rPr lang="en-US" sz="2400" b="0" i="1" smtClean="0">
+                              <a:latin typeface="Cambria Math" panose="02040503050406030204" pitchFamily="18" charset="0"/>
+                            </a:rPr>
+                          </m:ctrlPr>
+                        </m:sSubPr>
+                        <m:e>
+                          <m:r>
+                            <a:rPr lang="en-US" sz="2400" b="0" i="1" smtClean="0">
+                              <a:latin typeface="Cambria Math" panose="02040503050406030204" pitchFamily="18" charset="0"/>
+                            </a:rPr>
+                            <m:t>𝑆</m:t>
+                          </m:r>
+                          <m:sSub>
+                            <m:sSubPr>
+                              <m:ctrlPr>
+                                <a:rPr lang="en-US" sz="2400" b="0" i="1" smtClean="0">
+                                  <a:latin typeface="Cambria Math" panose="02040503050406030204" pitchFamily="18" charset="0"/>
+                                </a:rPr>
+                              </m:ctrlPr>
+                            </m:sSubPr>
+                            <m:e>
+                              <m:r>
+                                <a:rPr lang="en-US" sz="2400" b="0" i="1" smtClean="0">
+                                  <a:latin typeface="Cambria Math" panose="02040503050406030204" pitchFamily="18" charset="0"/>
+                                </a:rPr>
+                                <m:t>𝐷</m:t>
+                              </m:r>
+                            </m:e>
+                            <m:sub>
+                              <m:r>
+                                <a:rPr lang="en-US" sz="2400" b="0" i="1" smtClean="0">
+                                  <a:latin typeface="Cambria Math" panose="02040503050406030204" pitchFamily="18" charset="0"/>
+                                </a:rPr>
+                                <m:t>𝐸</m:t>
+                              </m:r>
+                            </m:sub>
+                          </m:sSub>
+                        </m:e>
+                        <m:sub>
+                          <m:r>
+                            <a:rPr lang="en-US" sz="2400" b="0" i="1" smtClean="0">
+                              <a:latin typeface="Cambria Math" panose="02040503050406030204" pitchFamily="18" charset="0"/>
+                            </a:rPr>
+                            <m:t>𝑟𝑒𝑎𝑑𝑖𝑛𝑔</m:t>
+                          </m:r>
+                          <m:r>
+                            <a:rPr lang="en-US" sz="2400" b="0" i="1" smtClean="0">
+                              <a:latin typeface="Cambria Math" panose="02040503050406030204" pitchFamily="18" charset="0"/>
+                            </a:rPr>
+                            <m:t> </m:t>
+                          </m:r>
+                        </m:sub>
+                      </m:sSub>
+                      <m:r>
+                        <a:rPr lang="en-US" sz="2400" b="0" i="1" smtClean="0">
+                          <a:latin typeface="Cambria Math" panose="02040503050406030204" pitchFamily="18" charset="0"/>
+                        </a:rPr>
+                        <m:t>=</m:t>
+                      </m:r>
+                      <m:f>
+                        <m:fPr>
+                          <m:ctrlPr>
+                            <a:rPr lang="en-US" sz="2400" b="0" i="1" smtClean="0">
+                              <a:latin typeface="Cambria Math" panose="02040503050406030204" pitchFamily="18" charset="0"/>
+                            </a:rPr>
+                          </m:ctrlPr>
+                        </m:fPr>
+                        <m:num>
+                          <m:r>
+                            <a:rPr lang="en-US" sz="2400" b="0" i="1" smtClean="0">
+                              <a:latin typeface="Cambria Math" panose="02040503050406030204" pitchFamily="18" charset="0"/>
+                            </a:rPr>
+                            <m:t>1</m:t>
+                          </m:r>
+                        </m:num>
+                        <m:den>
+                          <m:r>
+                            <a:rPr lang="en-US" sz="2400" b="0" i="1" smtClean="0">
+                              <a:latin typeface="Cambria Math" panose="02040503050406030204" pitchFamily="18" charset="0"/>
+                            </a:rPr>
+                            <m:t>𝑔𝑎𝑖</m:t>
+                          </m:r>
+                          <m:sSub>
+                            <m:sSubPr>
+                              <m:ctrlPr>
+                                <a:rPr lang="en-US" sz="2400" b="0" i="1" smtClean="0">
+                                  <a:latin typeface="Cambria Math" panose="02040503050406030204" pitchFamily="18" charset="0"/>
+                                </a:rPr>
+                              </m:ctrlPr>
+                            </m:sSubPr>
+                            <m:e>
+                              <m:r>
+                                <a:rPr lang="en-US" sz="2400" b="0" i="1" smtClean="0">
+                                  <a:latin typeface="Cambria Math" panose="02040503050406030204" pitchFamily="18" charset="0"/>
+                                </a:rPr>
+                                <m:t>𝑛</m:t>
+                              </m:r>
+                            </m:e>
+                            <m:sub>
+                              <m:r>
+                                <a:rPr lang="en-US" sz="2400" b="0" i="1" smtClean="0">
+                                  <a:latin typeface="Cambria Math" panose="02040503050406030204" pitchFamily="18" charset="0"/>
+                                </a:rPr>
+                                <m:t>𝑠𝑒𝑛𝑠𝑜𝑟</m:t>
+                              </m:r>
+                            </m:sub>
+                          </m:sSub>
+                        </m:den>
+                      </m:f>
+                      <m:r>
+                        <a:rPr lang="en-US" sz="2400" b="0" i="1" smtClean="0">
+                          <a:latin typeface="Cambria Math" panose="02040503050406030204" pitchFamily="18" charset="0"/>
+                        </a:rPr>
+                        <m:t>∗</m:t>
+                      </m:r>
+                      <m:f>
+                        <m:fPr>
+                          <m:ctrlPr>
+                            <a:rPr lang="en-US" sz="2400" b="0" i="1" smtClean="0">
+                              <a:latin typeface="Cambria Math" panose="02040503050406030204" pitchFamily="18" charset="0"/>
+                            </a:rPr>
+                          </m:ctrlPr>
+                        </m:fPr>
+                        <m:num>
+                          <m:r>
+                            <a:rPr lang="en-US" sz="2400" b="0" i="1" smtClean="0">
+                              <a:latin typeface="Cambria Math" panose="02040503050406030204" pitchFamily="18" charset="0"/>
+                            </a:rPr>
+                            <m:t>3.3</m:t>
+                          </m:r>
+                        </m:num>
+                        <m:den>
+                          <m:r>
+                            <a:rPr lang="en-US" sz="2400" b="0" i="1" smtClean="0">
+                              <a:latin typeface="Cambria Math" panose="02040503050406030204" pitchFamily="18" charset="0"/>
+                            </a:rPr>
+                            <m:t>4095</m:t>
+                          </m:r>
+                        </m:den>
+                      </m:f>
+                      <m:r>
+                        <a:rPr lang="en-US" sz="2400" b="0" i="1" smtClean="0">
+                          <a:latin typeface="Cambria Math" panose="02040503050406030204" pitchFamily="18" charset="0"/>
+                        </a:rPr>
+                        <m:t>∗14</m:t>
+                      </m:r>
+                    </m:oMath>
+                  </m:oMathPara>
+                </a14:m>
+                <a:endParaRPr lang="en-US" sz="2400" dirty="0"/>
+              </a:p>
+            </p:txBody>
+          </p:sp>
+        </mc:Choice>
+        <mc:Fallback>
+          <p:sp>
+            <p:nvSpPr>
+              <p:cNvPr id="5" name="TextBox 4">
+                <a:extLst>
+                  <a:ext uri="{FF2B5EF4-FFF2-40B4-BE49-F238E27FC236}">
+                    <a16:creationId xmlns:a16="http://schemas.microsoft.com/office/drawing/2014/main" id="{1C19354B-340F-BB69-2C4A-4EF8E4414CA4}"/>
+                  </a:ext>
+                </a:extLst>
+              </p:cNvPr>
+              <p:cNvSpPr txBox="1">
+                <a:spLocks noRot="1" noChangeAspect="1" noMove="1" noResize="1" noEditPoints="1" noAdjustHandles="1" noChangeArrowheads="1" noChangeShapeType="1" noTextEdit="1"/>
+              </p:cNvSpPr>
+              <p:nvPr/>
+            </p:nvSpPr>
+            <p:spPr>
+              <a:xfrm>
+                <a:off x="838200" y="2118515"/>
+                <a:ext cx="4950330" cy="758669"/>
+              </a:xfrm>
+              <a:prstGeom prst="rect">
+                <a:avLst/>
+              </a:prstGeom>
+              <a:blipFill>
+                <a:blip r:embed="rId2"/>
+                <a:stretch>
+                  <a:fillRect/>
+                </a:stretch>
+              </a:blipFill>
+            </p:spPr>
+            <p:txBody>
+              <a:bodyPr/>
+              <a:lstStyle/>
+              <a:p>
+                <a:r>
+                  <a:rPr lang="en-US">
+                    <a:noFill/>
+                  </a:rPr>
+                  <a:t> </a:t>
+                </a:r>
+              </a:p>
+            </p:txBody>
+          </p:sp>
+        </mc:Fallback>
+      </mc:AlternateContent>
+      <mc:AlternateContent xmlns:mc="http://schemas.openxmlformats.org/markup-compatibility/2006">
+        <mc:Choice xmlns:a14="http://schemas.microsoft.com/office/drawing/2010/main" Requires="a14">
+          <p:sp>
+            <p:nvSpPr>
+              <p:cNvPr id="6" name="TextBox 5">
+                <a:extLst>
+                  <a:ext uri="{FF2B5EF4-FFF2-40B4-BE49-F238E27FC236}">
+                    <a16:creationId xmlns:a16="http://schemas.microsoft.com/office/drawing/2014/main" id="{18867713-DE91-A761-1995-ECF1F8329426}"/>
+                  </a:ext>
+                </a:extLst>
+              </p:cNvPr>
+              <p:cNvSpPr txBox="1"/>
+              <p:nvPr/>
+            </p:nvSpPr>
+            <p:spPr>
+              <a:xfrm>
+                <a:off x="928116" y="3529584"/>
+                <a:ext cx="4452309" cy="520463"/>
+              </a:xfrm>
+              <a:prstGeom prst="rect">
+                <a:avLst/>
+              </a:prstGeom>
+              <a:noFill/>
+            </p:spPr>
+            <p:txBody>
+              <a:bodyPr wrap="none" lIns="0" tIns="0" rIns="0" bIns="0" rtlCol="0">
+                <a:spAutoFit/>
+              </a:bodyPr>
+              <a:lstStyle/>
+              <a:p>
+                <a14:m>
+                  <m:oMathPara xmlns:m="http://schemas.openxmlformats.org/officeDocument/2006/math">
+                    <m:oMathParaPr>
+                      <m:jc m:val="centerGroup"/>
+                    </m:oMathParaPr>
+                    <m:oMath xmlns:m="http://schemas.openxmlformats.org/officeDocument/2006/math">
+                      <m:r>
+                        <a:rPr lang="en-US" b="0" i="1" smtClean="0">
+                          <a:latin typeface="Cambria Math" panose="02040503050406030204" pitchFamily="18" charset="0"/>
+                        </a:rPr>
+                        <m:t>𝑆</m:t>
+                      </m:r>
+                      <m:sSub>
+                        <m:sSubPr>
+                          <m:ctrlPr>
+                            <a:rPr lang="en-US" b="0" i="1" smtClean="0">
+                              <a:latin typeface="Cambria Math" panose="02040503050406030204" pitchFamily="18" charset="0"/>
+                            </a:rPr>
+                          </m:ctrlPr>
+                        </m:sSubPr>
+                        <m:e>
+                          <m:r>
+                            <a:rPr lang="en-US" b="0" i="1" smtClean="0">
+                              <a:latin typeface="Cambria Math" panose="02040503050406030204" pitchFamily="18" charset="0"/>
+                            </a:rPr>
+                            <m:t>𝐷</m:t>
+                          </m:r>
+                        </m:e>
+                        <m:sub>
+                          <m:sSub>
+                            <m:sSubPr>
+                              <m:ctrlPr>
+                                <a:rPr lang="en-US" b="0" i="1" smtClean="0">
+                                  <a:latin typeface="Cambria Math" panose="02040503050406030204" pitchFamily="18" charset="0"/>
+                                </a:rPr>
+                              </m:ctrlPr>
+                            </m:sSubPr>
+                            <m:e>
+                              <m:r>
+                                <a:rPr lang="en-US" b="0" i="1" smtClean="0">
+                                  <a:latin typeface="Cambria Math" panose="02040503050406030204" pitchFamily="18" charset="0"/>
+                                </a:rPr>
+                                <m:t>𝐸</m:t>
+                              </m:r>
+                            </m:e>
+                            <m:sub>
+                              <m:r>
+                                <a:rPr lang="en-US" b="0" i="1" smtClean="0">
+                                  <a:latin typeface="Cambria Math" panose="02040503050406030204" pitchFamily="18" charset="0"/>
+                                </a:rPr>
+                                <m:t>𝑖</m:t>
+                              </m:r>
+                              <m:r>
+                                <a:rPr lang="en-US" b="0" i="1" smtClean="0">
+                                  <a:latin typeface="Cambria Math" panose="02040503050406030204" pitchFamily="18" charset="0"/>
+                                </a:rPr>
+                                <m:t>, </m:t>
+                              </m:r>
+                              <m:r>
+                                <a:rPr lang="en-US" b="0" i="1" smtClean="0">
+                                  <a:latin typeface="Cambria Math" panose="02040503050406030204" pitchFamily="18" charset="0"/>
+                                </a:rPr>
+                                <m:t>𝐼𝑛𝑑𝑢𝑐𝑡𝑜𝑟</m:t>
+                              </m:r>
+                            </m:sub>
+                          </m:sSub>
+                        </m:sub>
+                      </m:sSub>
+                      <m:r>
+                        <a:rPr lang="en-US" b="0" i="1" smtClean="0">
+                          <a:latin typeface="Cambria Math" panose="02040503050406030204" pitchFamily="18" charset="0"/>
+                        </a:rPr>
+                        <m:t>=</m:t>
+                      </m:r>
+                      <m:f>
+                        <m:fPr>
+                          <m:ctrlPr>
+                            <a:rPr lang="en-US" b="0" i="1" smtClean="0">
+                              <a:latin typeface="Cambria Math" panose="02040503050406030204" pitchFamily="18" charset="0"/>
+                            </a:rPr>
+                          </m:ctrlPr>
+                        </m:fPr>
+                        <m:num>
+                          <m:r>
+                            <a:rPr lang="en-US" b="0" i="1" smtClean="0">
+                              <a:latin typeface="Cambria Math" panose="02040503050406030204" pitchFamily="18" charset="0"/>
+                            </a:rPr>
+                            <m:t>1000 </m:t>
+                          </m:r>
+                          <m:r>
+                            <a:rPr lang="en-US" b="0" i="1" smtClean="0">
+                              <a:latin typeface="Cambria Math" panose="02040503050406030204" pitchFamily="18" charset="0"/>
+                            </a:rPr>
+                            <m:t>𝐴</m:t>
+                          </m:r>
+                        </m:num>
+                        <m:den>
+                          <m:r>
+                            <a:rPr lang="en-US" b="0" i="1" smtClean="0">
+                              <a:latin typeface="Cambria Math" panose="02040503050406030204" pitchFamily="18" charset="0"/>
+                            </a:rPr>
+                            <m:t>80 </m:t>
+                          </m:r>
+                          <m:r>
+                            <a:rPr lang="en-US" b="0" i="1" smtClean="0">
+                              <a:latin typeface="Cambria Math" panose="02040503050406030204" pitchFamily="18" charset="0"/>
+                            </a:rPr>
+                            <m:t>𝑉</m:t>
+                          </m:r>
+                        </m:den>
+                      </m:f>
+                      <m:r>
+                        <a:rPr lang="en-US" b="0" i="1" smtClean="0">
+                          <a:latin typeface="Cambria Math" panose="02040503050406030204" pitchFamily="18" charset="0"/>
+                        </a:rPr>
+                        <m:t>∗</m:t>
+                      </m:r>
+                      <m:f>
+                        <m:fPr>
+                          <m:ctrlPr>
+                            <a:rPr lang="en-US" b="0" i="1" smtClean="0">
+                              <a:latin typeface="Cambria Math" panose="02040503050406030204" pitchFamily="18" charset="0"/>
+                            </a:rPr>
+                          </m:ctrlPr>
+                        </m:fPr>
+                        <m:num>
+                          <m:r>
+                            <a:rPr lang="en-US" b="0" i="1" smtClean="0">
+                              <a:latin typeface="Cambria Math" panose="02040503050406030204" pitchFamily="18" charset="0"/>
+                            </a:rPr>
+                            <m:t>3.3 </m:t>
+                          </m:r>
+                          <m:r>
+                            <a:rPr lang="en-US" b="0" i="1" smtClean="0">
+                              <a:latin typeface="Cambria Math" panose="02040503050406030204" pitchFamily="18" charset="0"/>
+                            </a:rPr>
+                            <m:t>𝑉</m:t>
+                          </m:r>
+                        </m:num>
+                        <m:den>
+                          <m:r>
+                            <a:rPr lang="en-US" b="0" i="1" smtClean="0">
+                              <a:latin typeface="Cambria Math" panose="02040503050406030204" pitchFamily="18" charset="0"/>
+                            </a:rPr>
+                            <m:t>4095</m:t>
+                          </m:r>
+                        </m:den>
+                      </m:f>
+                      <m:r>
+                        <a:rPr lang="en-US" b="0" i="1" smtClean="0">
+                          <a:latin typeface="Cambria Math" panose="02040503050406030204" pitchFamily="18" charset="0"/>
+                        </a:rPr>
+                        <m:t>∗14=0.141 </m:t>
+                      </m:r>
+                      <m:r>
+                        <a:rPr lang="en-US" b="0" i="1" smtClean="0">
+                          <a:latin typeface="Cambria Math" panose="02040503050406030204" pitchFamily="18" charset="0"/>
+                        </a:rPr>
+                        <m:t>𝐴</m:t>
+                      </m:r>
+                    </m:oMath>
+                  </m:oMathPara>
+                </a14:m>
+                <a:endParaRPr lang="en-US" dirty="0"/>
+              </a:p>
+            </p:txBody>
+          </p:sp>
+        </mc:Choice>
+        <mc:Fallback>
+          <p:sp>
+            <p:nvSpPr>
+              <p:cNvPr id="6" name="TextBox 5">
+                <a:extLst>
+                  <a:ext uri="{FF2B5EF4-FFF2-40B4-BE49-F238E27FC236}">
+                    <a16:creationId xmlns:a16="http://schemas.microsoft.com/office/drawing/2014/main" id="{18867713-DE91-A761-1995-ECF1F8329426}"/>
+                  </a:ext>
+                </a:extLst>
+              </p:cNvPr>
+              <p:cNvSpPr txBox="1">
+                <a:spLocks noRot="1" noChangeAspect="1" noMove="1" noResize="1" noEditPoints="1" noAdjustHandles="1" noChangeArrowheads="1" noChangeShapeType="1" noTextEdit="1"/>
+              </p:cNvSpPr>
+              <p:nvPr/>
+            </p:nvSpPr>
+            <p:spPr>
+              <a:xfrm>
+                <a:off x="928116" y="3529584"/>
+                <a:ext cx="4452309" cy="520463"/>
+              </a:xfrm>
+              <a:prstGeom prst="rect">
+                <a:avLst/>
+              </a:prstGeom>
+              <a:blipFill>
+                <a:blip r:embed="rId3"/>
+                <a:stretch>
+                  <a:fillRect/>
+                </a:stretch>
+              </a:blipFill>
+            </p:spPr>
+            <p:txBody>
+              <a:bodyPr/>
+              <a:lstStyle/>
+              <a:p>
+                <a:r>
+                  <a:rPr lang="en-US">
+                    <a:noFill/>
+                  </a:rPr>
+                  <a:t> </a:t>
+                </a:r>
+              </a:p>
+            </p:txBody>
+          </p:sp>
+        </mc:Fallback>
+      </mc:AlternateContent>
+      <mc:AlternateContent xmlns:mc="http://schemas.openxmlformats.org/markup-compatibility/2006">
+        <mc:Choice xmlns:a14="http://schemas.microsoft.com/office/drawing/2010/main" Requires="a14">
+          <p:sp>
+            <p:nvSpPr>
+              <p:cNvPr id="7" name="TextBox 6">
+                <a:extLst>
+                  <a:ext uri="{FF2B5EF4-FFF2-40B4-BE49-F238E27FC236}">
+                    <a16:creationId xmlns:a16="http://schemas.microsoft.com/office/drawing/2014/main" id="{93E622B5-E517-13D6-2F2A-3D05F0662FF9}"/>
+                  </a:ext>
+                </a:extLst>
+              </p:cNvPr>
+              <p:cNvSpPr txBox="1"/>
+              <p:nvPr/>
+            </p:nvSpPr>
+            <p:spPr>
+              <a:xfrm>
+                <a:off x="928116" y="4181984"/>
+                <a:ext cx="4508414" cy="520463"/>
+              </a:xfrm>
+              <a:prstGeom prst="rect">
+                <a:avLst/>
+              </a:prstGeom>
+              <a:noFill/>
+            </p:spPr>
+            <p:txBody>
+              <a:bodyPr wrap="none" lIns="0" tIns="0" rIns="0" bIns="0" rtlCol="0">
+                <a:spAutoFit/>
+              </a:bodyPr>
+              <a:lstStyle/>
+              <a:p>
+                <a14:m>
+                  <m:oMathPara xmlns:m="http://schemas.openxmlformats.org/officeDocument/2006/math">
+                    <m:oMathParaPr>
+                      <m:jc m:val="centerGroup"/>
+                    </m:oMathParaPr>
+                    <m:oMath xmlns:m="http://schemas.openxmlformats.org/officeDocument/2006/math">
+                      <m:r>
+                        <a:rPr lang="en-US" b="0" i="1" smtClean="0">
+                          <a:latin typeface="Cambria Math" panose="02040503050406030204" pitchFamily="18" charset="0"/>
+                        </a:rPr>
+                        <m:t>𝑆</m:t>
+                      </m:r>
+                      <m:sSub>
+                        <m:sSubPr>
+                          <m:ctrlPr>
+                            <a:rPr lang="en-US" b="0" i="1" smtClean="0">
+                              <a:latin typeface="Cambria Math" panose="02040503050406030204" pitchFamily="18" charset="0"/>
+                            </a:rPr>
+                          </m:ctrlPr>
+                        </m:sSubPr>
+                        <m:e>
+                          <m:r>
+                            <a:rPr lang="en-US" b="0" i="1" smtClean="0">
+                              <a:latin typeface="Cambria Math" panose="02040503050406030204" pitchFamily="18" charset="0"/>
+                            </a:rPr>
+                            <m:t>𝐷</m:t>
+                          </m:r>
+                        </m:e>
+                        <m:sub>
+                          <m:sSub>
+                            <m:sSubPr>
+                              <m:ctrlPr>
+                                <a:rPr lang="en-US" b="0" i="1" smtClean="0">
+                                  <a:latin typeface="Cambria Math" panose="02040503050406030204" pitchFamily="18" charset="0"/>
+                                </a:rPr>
+                              </m:ctrlPr>
+                            </m:sSubPr>
+                            <m:e>
+                              <m:r>
+                                <a:rPr lang="en-US" b="0" i="1" smtClean="0">
+                                  <a:latin typeface="Cambria Math" panose="02040503050406030204" pitchFamily="18" charset="0"/>
+                                </a:rPr>
+                                <m:t>𝐸</m:t>
+                              </m:r>
+                            </m:e>
+                            <m:sub>
+                              <m:r>
+                                <a:rPr lang="en-US" b="0" i="1" smtClean="0">
+                                  <a:latin typeface="Cambria Math" panose="02040503050406030204" pitchFamily="18" charset="0"/>
+                                </a:rPr>
+                                <m:t>𝑖</m:t>
+                              </m:r>
+                              <m:r>
+                                <a:rPr lang="en-US" b="0" i="1" smtClean="0">
+                                  <a:latin typeface="Cambria Math" panose="02040503050406030204" pitchFamily="18" charset="0"/>
+                                </a:rPr>
+                                <m:t>, </m:t>
+                              </m:r>
+                              <m:r>
+                                <a:rPr lang="en-US" b="0" i="1" smtClean="0">
+                                  <a:latin typeface="Cambria Math" panose="02040503050406030204" pitchFamily="18" charset="0"/>
+                                </a:rPr>
+                                <m:t>𝐵𝑎𝑡𝑡𝑒𝑟𝑦</m:t>
+                              </m:r>
+                            </m:sub>
+                          </m:sSub>
+                        </m:sub>
+                      </m:sSub>
+                      <m:r>
+                        <a:rPr lang="en-US" b="0" i="1" smtClean="0">
+                          <a:latin typeface="Cambria Math" panose="02040503050406030204" pitchFamily="18" charset="0"/>
+                        </a:rPr>
+                        <m:t>=</m:t>
+                      </m:r>
+                      <m:f>
+                        <m:fPr>
+                          <m:ctrlPr>
+                            <a:rPr lang="en-US" b="0" i="1" smtClean="0">
+                              <a:latin typeface="Cambria Math" panose="02040503050406030204" pitchFamily="18" charset="0"/>
+                            </a:rPr>
+                          </m:ctrlPr>
+                        </m:fPr>
+                        <m:num>
+                          <m:r>
+                            <a:rPr lang="en-US" b="0" i="1" smtClean="0">
+                              <a:latin typeface="Cambria Math" panose="02040503050406030204" pitchFamily="18" charset="0"/>
+                            </a:rPr>
+                            <m:t>1000 </m:t>
+                          </m:r>
+                          <m:r>
+                            <a:rPr lang="en-US" b="0" i="1" smtClean="0">
+                              <a:latin typeface="Cambria Math" panose="02040503050406030204" pitchFamily="18" charset="0"/>
+                            </a:rPr>
+                            <m:t>𝐴</m:t>
+                          </m:r>
+                        </m:num>
+                        <m:den>
+                          <m:r>
+                            <a:rPr lang="en-US" b="0" i="1" smtClean="0">
+                              <a:latin typeface="Cambria Math" panose="02040503050406030204" pitchFamily="18" charset="0"/>
+                            </a:rPr>
+                            <m:t>132 </m:t>
+                          </m:r>
+                          <m:r>
+                            <a:rPr lang="en-US" b="0" i="1" smtClean="0">
+                              <a:latin typeface="Cambria Math" panose="02040503050406030204" pitchFamily="18" charset="0"/>
+                            </a:rPr>
+                            <m:t>𝑉</m:t>
+                          </m:r>
+                        </m:den>
+                      </m:f>
+                      <m:r>
+                        <a:rPr lang="en-US" b="0" i="1" smtClean="0">
+                          <a:latin typeface="Cambria Math" panose="02040503050406030204" pitchFamily="18" charset="0"/>
+                        </a:rPr>
+                        <m:t>∗</m:t>
+                      </m:r>
+                      <m:f>
+                        <m:fPr>
+                          <m:ctrlPr>
+                            <a:rPr lang="en-US" b="0" i="1" smtClean="0">
+                              <a:latin typeface="Cambria Math" panose="02040503050406030204" pitchFamily="18" charset="0"/>
+                            </a:rPr>
+                          </m:ctrlPr>
+                        </m:fPr>
+                        <m:num>
+                          <m:r>
+                            <a:rPr lang="en-US" b="0" i="1" smtClean="0">
+                              <a:latin typeface="Cambria Math" panose="02040503050406030204" pitchFamily="18" charset="0"/>
+                            </a:rPr>
+                            <m:t>3.3 </m:t>
+                          </m:r>
+                          <m:r>
+                            <a:rPr lang="en-US" b="0" i="1" smtClean="0">
+                              <a:latin typeface="Cambria Math" panose="02040503050406030204" pitchFamily="18" charset="0"/>
+                            </a:rPr>
+                            <m:t>𝑉</m:t>
+                          </m:r>
+                        </m:num>
+                        <m:den>
+                          <m:r>
+                            <a:rPr lang="en-US" b="0" i="1" smtClean="0">
+                              <a:latin typeface="Cambria Math" panose="02040503050406030204" pitchFamily="18" charset="0"/>
+                            </a:rPr>
+                            <m:t>4095</m:t>
+                          </m:r>
+                        </m:den>
+                      </m:f>
+                      <m:r>
+                        <a:rPr lang="en-US" b="0" i="1" smtClean="0">
+                          <a:latin typeface="Cambria Math" panose="02040503050406030204" pitchFamily="18" charset="0"/>
+                        </a:rPr>
+                        <m:t>∗14=0.0855 </m:t>
+                      </m:r>
+                      <m:r>
+                        <a:rPr lang="en-US" b="0" i="1" smtClean="0">
+                          <a:latin typeface="Cambria Math" panose="02040503050406030204" pitchFamily="18" charset="0"/>
+                        </a:rPr>
+                        <m:t>𝐴</m:t>
+                      </m:r>
+                    </m:oMath>
+                  </m:oMathPara>
+                </a14:m>
+                <a:endParaRPr lang="en-US" dirty="0"/>
+              </a:p>
+            </p:txBody>
+          </p:sp>
+        </mc:Choice>
+        <mc:Fallback>
+          <p:sp>
+            <p:nvSpPr>
+              <p:cNvPr id="7" name="TextBox 6">
+                <a:extLst>
+                  <a:ext uri="{FF2B5EF4-FFF2-40B4-BE49-F238E27FC236}">
+                    <a16:creationId xmlns:a16="http://schemas.microsoft.com/office/drawing/2014/main" id="{93E622B5-E517-13D6-2F2A-3D05F0662FF9}"/>
+                  </a:ext>
+                </a:extLst>
+              </p:cNvPr>
+              <p:cNvSpPr txBox="1">
+                <a:spLocks noRot="1" noChangeAspect="1" noMove="1" noResize="1" noEditPoints="1" noAdjustHandles="1" noChangeArrowheads="1" noChangeShapeType="1" noTextEdit="1"/>
+              </p:cNvSpPr>
+              <p:nvPr/>
+            </p:nvSpPr>
+            <p:spPr>
+              <a:xfrm>
+                <a:off x="928116" y="4181984"/>
+                <a:ext cx="4508414" cy="520463"/>
+              </a:xfrm>
+              <a:prstGeom prst="rect">
+                <a:avLst/>
+              </a:prstGeom>
+              <a:blipFill>
+                <a:blip r:embed="rId4"/>
+                <a:stretch>
+                  <a:fillRect/>
+                </a:stretch>
+              </a:blipFill>
+            </p:spPr>
+            <p:txBody>
+              <a:bodyPr/>
+              <a:lstStyle/>
+              <a:p>
+                <a:r>
+                  <a:rPr lang="en-US">
+                    <a:noFill/>
+                  </a:rPr>
+                  <a:t> </a:t>
+                </a:r>
+              </a:p>
+            </p:txBody>
+          </p:sp>
+        </mc:Fallback>
+      </mc:AlternateContent>
+      <mc:AlternateContent xmlns:mc="http://schemas.openxmlformats.org/markup-compatibility/2006">
+        <mc:Choice xmlns:a14="http://schemas.microsoft.com/office/drawing/2010/main" Requires="a14">
+          <p:sp>
+            <p:nvSpPr>
+              <p:cNvPr id="8" name="TextBox 7">
+                <a:extLst>
+                  <a:ext uri="{FF2B5EF4-FFF2-40B4-BE49-F238E27FC236}">
+                    <a16:creationId xmlns:a16="http://schemas.microsoft.com/office/drawing/2014/main" id="{77FAEE5F-65E7-902E-F2C3-73D031A359C6}"/>
+                  </a:ext>
+                </a:extLst>
+              </p:cNvPr>
+              <p:cNvSpPr txBox="1"/>
+              <p:nvPr/>
+            </p:nvSpPr>
+            <p:spPr>
+              <a:xfrm>
+                <a:off x="928116" y="4834384"/>
+                <a:ext cx="4433586" cy="520463"/>
+              </a:xfrm>
+              <a:prstGeom prst="rect">
+                <a:avLst/>
+              </a:prstGeom>
+              <a:noFill/>
+            </p:spPr>
+            <p:txBody>
+              <a:bodyPr wrap="none" lIns="0" tIns="0" rIns="0" bIns="0" rtlCol="0">
+                <a:spAutoFit/>
+              </a:bodyPr>
+              <a:lstStyle/>
+              <a:p>
+                <a14:m>
+                  <m:oMathPara xmlns:m="http://schemas.openxmlformats.org/officeDocument/2006/math">
+                    <m:oMathParaPr>
+                      <m:jc m:val="centerGroup"/>
+                    </m:oMathParaPr>
+                    <m:oMath xmlns:m="http://schemas.openxmlformats.org/officeDocument/2006/math">
+                      <m:r>
+                        <a:rPr lang="en-US" b="0" i="1" smtClean="0">
+                          <a:latin typeface="Cambria Math" panose="02040503050406030204" pitchFamily="18" charset="0"/>
+                        </a:rPr>
+                        <m:t>𝑆</m:t>
+                      </m:r>
+                      <m:sSub>
+                        <m:sSubPr>
+                          <m:ctrlPr>
+                            <a:rPr lang="en-US" b="0" i="1" smtClean="0">
+                              <a:latin typeface="Cambria Math" panose="02040503050406030204" pitchFamily="18" charset="0"/>
+                            </a:rPr>
+                          </m:ctrlPr>
+                        </m:sSubPr>
+                        <m:e>
+                          <m:r>
+                            <a:rPr lang="en-US" b="0" i="1" smtClean="0">
+                              <a:latin typeface="Cambria Math" panose="02040503050406030204" pitchFamily="18" charset="0"/>
+                            </a:rPr>
+                            <m:t>𝐷</m:t>
+                          </m:r>
+                        </m:e>
+                        <m:sub>
+                          <m:sSub>
+                            <m:sSubPr>
+                              <m:ctrlPr>
+                                <a:rPr lang="en-US" b="0" i="1" smtClean="0">
+                                  <a:latin typeface="Cambria Math" panose="02040503050406030204" pitchFamily="18" charset="0"/>
+                                </a:rPr>
+                              </m:ctrlPr>
+                            </m:sSubPr>
+                            <m:e>
+                              <m:r>
+                                <a:rPr lang="en-US" b="0" i="1" smtClean="0">
+                                  <a:latin typeface="Cambria Math" panose="02040503050406030204" pitchFamily="18" charset="0"/>
+                                </a:rPr>
+                                <m:t>𝐸</m:t>
+                              </m:r>
+                            </m:e>
+                            <m:sub>
+                              <m:r>
+                                <a:rPr lang="en-US" b="0" i="1" smtClean="0">
+                                  <a:latin typeface="Cambria Math" panose="02040503050406030204" pitchFamily="18" charset="0"/>
+                                </a:rPr>
+                                <m:t>𝑣</m:t>
+                              </m:r>
+                              <m:r>
+                                <a:rPr lang="en-US" b="0" i="1" smtClean="0">
+                                  <a:latin typeface="Cambria Math" panose="02040503050406030204" pitchFamily="18" charset="0"/>
+                                </a:rPr>
+                                <m:t>,</m:t>
+                              </m:r>
+                              <m:r>
+                                <a:rPr lang="en-US" b="0" i="1" smtClean="0">
+                                  <a:latin typeface="Cambria Math" panose="02040503050406030204" pitchFamily="18" charset="0"/>
+                                </a:rPr>
+                                <m:t>𝐶𝑎𝑝𝑎𝑐𝑖𝑡𝑜𝑟</m:t>
+                              </m:r>
+                            </m:sub>
+                          </m:sSub>
+                        </m:sub>
+                      </m:sSub>
+                      <m:r>
+                        <a:rPr lang="en-US" b="0" i="1" smtClean="0">
+                          <a:latin typeface="Cambria Math" panose="02040503050406030204" pitchFamily="18" charset="0"/>
+                        </a:rPr>
+                        <m:t>=</m:t>
+                      </m:r>
+                      <m:f>
+                        <m:fPr>
+                          <m:ctrlPr>
+                            <a:rPr lang="en-US" b="0" i="1" smtClean="0">
+                              <a:latin typeface="Cambria Math" panose="02040503050406030204" pitchFamily="18" charset="0"/>
+                            </a:rPr>
+                          </m:ctrlPr>
+                        </m:fPr>
+                        <m:num>
+                          <m:r>
+                            <a:rPr lang="en-US" b="0" i="1" smtClean="0">
+                              <a:latin typeface="Cambria Math" panose="02040503050406030204" pitchFamily="18" charset="0"/>
+                            </a:rPr>
+                            <m:t>10 </m:t>
+                          </m:r>
+                          <m:r>
+                            <a:rPr lang="en-US" b="0" i="1" smtClean="0">
+                              <a:latin typeface="Cambria Math" panose="02040503050406030204" pitchFamily="18" charset="0"/>
+                            </a:rPr>
+                            <m:t>𝑉</m:t>
+                          </m:r>
+                        </m:num>
+                        <m:den>
+                          <m:r>
+                            <a:rPr lang="en-US" b="0" i="1" smtClean="0">
+                              <a:latin typeface="Cambria Math" panose="02040503050406030204" pitchFamily="18" charset="0"/>
+                            </a:rPr>
+                            <m:t>11 </m:t>
+                          </m:r>
+                          <m:r>
+                            <a:rPr lang="en-US" b="0" i="1" smtClean="0">
+                              <a:latin typeface="Cambria Math" panose="02040503050406030204" pitchFamily="18" charset="0"/>
+                            </a:rPr>
+                            <m:t>𝑉</m:t>
+                          </m:r>
+                        </m:den>
+                      </m:f>
+                      <m:r>
+                        <a:rPr lang="en-US" b="0" i="1" smtClean="0">
+                          <a:latin typeface="Cambria Math" panose="02040503050406030204" pitchFamily="18" charset="0"/>
+                        </a:rPr>
+                        <m:t>∗</m:t>
+                      </m:r>
+                      <m:f>
+                        <m:fPr>
+                          <m:ctrlPr>
+                            <a:rPr lang="en-US" b="0" i="1" smtClean="0">
+                              <a:latin typeface="Cambria Math" panose="02040503050406030204" pitchFamily="18" charset="0"/>
+                            </a:rPr>
+                          </m:ctrlPr>
+                        </m:fPr>
+                        <m:num>
+                          <m:r>
+                            <a:rPr lang="en-US" b="0" i="1" smtClean="0">
+                              <a:latin typeface="Cambria Math" panose="02040503050406030204" pitchFamily="18" charset="0"/>
+                            </a:rPr>
+                            <m:t>3.3</m:t>
+                          </m:r>
+                          <m:r>
+                            <a:rPr lang="en-US" b="0" i="1" smtClean="0">
+                              <a:latin typeface="Cambria Math" panose="02040503050406030204" pitchFamily="18" charset="0"/>
+                            </a:rPr>
+                            <m:t>𝑉</m:t>
+                          </m:r>
+                        </m:num>
+                        <m:den>
+                          <m:r>
+                            <a:rPr lang="en-US" b="0" i="1" smtClean="0">
+                              <a:latin typeface="Cambria Math" panose="02040503050406030204" pitchFamily="18" charset="0"/>
+                            </a:rPr>
+                            <m:t>4095</m:t>
+                          </m:r>
+                        </m:den>
+                      </m:f>
+                      <m:r>
+                        <a:rPr lang="en-US" b="0" i="1" smtClean="0">
+                          <a:latin typeface="Cambria Math" panose="02040503050406030204" pitchFamily="18" charset="0"/>
+                        </a:rPr>
+                        <m:t>∗14=0.0103 </m:t>
+                      </m:r>
+                      <m:r>
+                        <a:rPr lang="en-US" b="0" i="1" smtClean="0">
+                          <a:latin typeface="Cambria Math" panose="02040503050406030204" pitchFamily="18" charset="0"/>
+                        </a:rPr>
+                        <m:t>𝑉</m:t>
+                      </m:r>
+                    </m:oMath>
+                  </m:oMathPara>
+                </a14:m>
+                <a:endParaRPr lang="en-US" dirty="0"/>
+              </a:p>
+            </p:txBody>
+          </p:sp>
+        </mc:Choice>
+        <mc:Fallback>
+          <p:sp>
+            <p:nvSpPr>
+              <p:cNvPr id="8" name="TextBox 7">
+                <a:extLst>
+                  <a:ext uri="{FF2B5EF4-FFF2-40B4-BE49-F238E27FC236}">
+                    <a16:creationId xmlns:a16="http://schemas.microsoft.com/office/drawing/2014/main" id="{77FAEE5F-65E7-902E-F2C3-73D031A359C6}"/>
+                  </a:ext>
+                </a:extLst>
+              </p:cNvPr>
+              <p:cNvSpPr txBox="1">
+                <a:spLocks noRot="1" noChangeAspect="1" noMove="1" noResize="1" noEditPoints="1" noAdjustHandles="1" noChangeArrowheads="1" noChangeShapeType="1" noTextEdit="1"/>
+              </p:cNvSpPr>
+              <p:nvPr/>
+            </p:nvSpPr>
+            <p:spPr>
+              <a:xfrm>
+                <a:off x="928116" y="4834384"/>
+                <a:ext cx="4433586" cy="520463"/>
+              </a:xfrm>
+              <a:prstGeom prst="rect">
+                <a:avLst/>
+              </a:prstGeom>
+              <a:blipFill>
+                <a:blip r:embed="rId5"/>
+                <a:stretch>
+                  <a:fillRect/>
+                </a:stretch>
+              </a:blipFill>
+            </p:spPr>
+            <p:txBody>
+              <a:bodyPr/>
+              <a:lstStyle/>
+              <a:p>
+                <a:r>
+                  <a:rPr lang="en-US">
+                    <a:noFill/>
+                  </a:rPr>
+                  <a:t> </a:t>
+                </a:r>
+              </a:p>
+            </p:txBody>
+          </p:sp>
+        </mc:Fallback>
+      </mc:AlternateContent>
+      <mc:AlternateContent xmlns:mc="http://schemas.openxmlformats.org/markup-compatibility/2006">
+        <mc:Choice xmlns:a14="http://schemas.microsoft.com/office/drawing/2010/main" Requires="a14">
+          <p:sp>
+            <p:nvSpPr>
+              <p:cNvPr id="9" name="TextBox 8">
+                <a:extLst>
+                  <a:ext uri="{FF2B5EF4-FFF2-40B4-BE49-F238E27FC236}">
+                    <a16:creationId xmlns:a16="http://schemas.microsoft.com/office/drawing/2014/main" id="{E2491624-E69F-3EA5-2CD4-EC2C0B4F562D}"/>
+                  </a:ext>
+                </a:extLst>
+              </p:cNvPr>
+              <p:cNvSpPr txBox="1"/>
+              <p:nvPr/>
+            </p:nvSpPr>
+            <p:spPr>
+              <a:xfrm>
+                <a:off x="928116" y="5486784"/>
+                <a:ext cx="4159472" cy="520463"/>
+              </a:xfrm>
+              <a:prstGeom prst="rect">
+                <a:avLst/>
+              </a:prstGeom>
+              <a:noFill/>
+            </p:spPr>
+            <p:txBody>
+              <a:bodyPr wrap="none" lIns="0" tIns="0" rIns="0" bIns="0" rtlCol="0">
+                <a:spAutoFit/>
+              </a:bodyPr>
+              <a:lstStyle/>
+              <a:p>
+                <a14:m>
+                  <m:oMathPara xmlns:m="http://schemas.openxmlformats.org/officeDocument/2006/math">
+                    <m:oMathParaPr>
+                      <m:jc m:val="centerGroup"/>
+                    </m:oMathParaPr>
+                    <m:oMath xmlns:m="http://schemas.openxmlformats.org/officeDocument/2006/math">
+                      <m:r>
+                        <a:rPr lang="en-US" b="0" i="1" smtClean="0">
+                          <a:latin typeface="Cambria Math" panose="02040503050406030204" pitchFamily="18" charset="0"/>
+                        </a:rPr>
+                        <m:t>𝑆</m:t>
+                      </m:r>
+                      <m:sSub>
+                        <m:sSubPr>
+                          <m:ctrlPr>
+                            <a:rPr lang="en-US" b="0" i="1" smtClean="0">
+                              <a:latin typeface="Cambria Math" panose="02040503050406030204" pitchFamily="18" charset="0"/>
+                            </a:rPr>
+                          </m:ctrlPr>
+                        </m:sSubPr>
+                        <m:e>
+                          <m:r>
+                            <a:rPr lang="en-US" b="0" i="1" smtClean="0">
+                              <a:latin typeface="Cambria Math" panose="02040503050406030204" pitchFamily="18" charset="0"/>
+                            </a:rPr>
+                            <m:t>𝐷</m:t>
+                          </m:r>
+                        </m:e>
+                        <m:sub>
+                          <m:sSub>
+                            <m:sSubPr>
+                              <m:ctrlPr>
+                                <a:rPr lang="en-US" b="0" i="1" smtClean="0">
+                                  <a:latin typeface="Cambria Math" panose="02040503050406030204" pitchFamily="18" charset="0"/>
+                                </a:rPr>
+                              </m:ctrlPr>
+                            </m:sSubPr>
+                            <m:e>
+                              <m:r>
+                                <a:rPr lang="en-US" b="0" i="1" smtClean="0">
+                                  <a:latin typeface="Cambria Math" panose="02040503050406030204" pitchFamily="18" charset="0"/>
+                                </a:rPr>
+                                <m:t>𝐸</m:t>
+                              </m:r>
+                            </m:e>
+                            <m:sub>
+                              <m:r>
+                                <a:rPr lang="en-US" b="0" i="1" smtClean="0">
+                                  <a:latin typeface="Cambria Math" panose="02040503050406030204" pitchFamily="18" charset="0"/>
+                                </a:rPr>
+                                <m:t>𝑣</m:t>
+                              </m:r>
+                              <m:r>
+                                <a:rPr lang="en-US" b="0" i="1" smtClean="0">
+                                  <a:latin typeface="Cambria Math" panose="02040503050406030204" pitchFamily="18" charset="0"/>
+                                </a:rPr>
+                                <m:t>,</m:t>
+                              </m:r>
+                              <m:r>
+                                <a:rPr lang="en-US" b="0" i="1" smtClean="0">
+                                  <a:latin typeface="Cambria Math" panose="02040503050406030204" pitchFamily="18" charset="0"/>
+                                </a:rPr>
+                                <m:t>𝐵𝑎𝑡𝑡𝑒𝑟𝑦</m:t>
+                              </m:r>
+                            </m:sub>
+                          </m:sSub>
+                        </m:sub>
+                      </m:sSub>
+                      <m:r>
+                        <a:rPr lang="en-US" b="0" i="1" smtClean="0">
+                          <a:latin typeface="Cambria Math" panose="02040503050406030204" pitchFamily="18" charset="0"/>
+                        </a:rPr>
+                        <m:t>=</m:t>
+                      </m:r>
+                      <m:f>
+                        <m:fPr>
+                          <m:ctrlPr>
+                            <a:rPr lang="en-US" b="0" i="1" smtClean="0">
+                              <a:latin typeface="Cambria Math" panose="02040503050406030204" pitchFamily="18" charset="0"/>
+                            </a:rPr>
+                          </m:ctrlPr>
+                        </m:fPr>
+                        <m:num>
+                          <m:r>
+                            <a:rPr lang="en-US" b="0" i="1" smtClean="0">
+                              <a:latin typeface="Cambria Math" panose="02040503050406030204" pitchFamily="18" charset="0"/>
+                            </a:rPr>
+                            <m:t>8 </m:t>
+                          </m:r>
+                          <m:r>
+                            <a:rPr lang="en-US" b="0" i="1" smtClean="0">
+                              <a:latin typeface="Cambria Math" panose="02040503050406030204" pitchFamily="18" charset="0"/>
+                            </a:rPr>
+                            <m:t>𝑉</m:t>
+                          </m:r>
+                        </m:num>
+                        <m:den>
+                          <m:r>
+                            <a:rPr lang="en-US" b="0" i="1" smtClean="0">
+                              <a:latin typeface="Cambria Math" panose="02040503050406030204" pitchFamily="18" charset="0"/>
+                            </a:rPr>
+                            <m:t>1 </m:t>
+                          </m:r>
+                          <m:r>
+                            <a:rPr lang="en-US" b="0" i="1" smtClean="0">
+                              <a:latin typeface="Cambria Math" panose="02040503050406030204" pitchFamily="18" charset="0"/>
+                            </a:rPr>
+                            <m:t>𝑉</m:t>
+                          </m:r>
+                        </m:den>
+                      </m:f>
+                      <m:r>
+                        <a:rPr lang="en-US" b="0" i="1" smtClean="0">
+                          <a:latin typeface="Cambria Math" panose="02040503050406030204" pitchFamily="18" charset="0"/>
+                        </a:rPr>
+                        <m:t>∗</m:t>
+                      </m:r>
+                      <m:f>
+                        <m:fPr>
+                          <m:ctrlPr>
+                            <a:rPr lang="en-US" b="0" i="1" smtClean="0">
+                              <a:latin typeface="Cambria Math" panose="02040503050406030204" pitchFamily="18" charset="0"/>
+                            </a:rPr>
+                          </m:ctrlPr>
+                        </m:fPr>
+                        <m:num>
+                          <m:r>
+                            <a:rPr lang="en-US" b="0" i="1" smtClean="0">
+                              <a:latin typeface="Cambria Math" panose="02040503050406030204" pitchFamily="18" charset="0"/>
+                            </a:rPr>
+                            <m:t>3.3 </m:t>
+                          </m:r>
+                          <m:r>
+                            <a:rPr lang="en-US" b="0" i="1" smtClean="0">
+                              <a:latin typeface="Cambria Math" panose="02040503050406030204" pitchFamily="18" charset="0"/>
+                            </a:rPr>
+                            <m:t>𝑉</m:t>
+                          </m:r>
+                        </m:num>
+                        <m:den>
+                          <m:r>
+                            <a:rPr lang="en-US" b="0" i="1" smtClean="0">
+                              <a:latin typeface="Cambria Math" panose="02040503050406030204" pitchFamily="18" charset="0"/>
+                            </a:rPr>
+                            <m:t>4095</m:t>
+                          </m:r>
+                        </m:den>
+                      </m:f>
+                      <m:r>
+                        <a:rPr lang="en-US" b="0" i="1" smtClean="0">
+                          <a:latin typeface="Cambria Math" panose="02040503050406030204" pitchFamily="18" charset="0"/>
+                        </a:rPr>
+                        <m:t>∗14=0.0903 </m:t>
+                      </m:r>
+                      <m:r>
+                        <a:rPr lang="en-US" b="0" i="1" smtClean="0">
+                          <a:latin typeface="Cambria Math" panose="02040503050406030204" pitchFamily="18" charset="0"/>
+                        </a:rPr>
+                        <m:t>𝑉</m:t>
+                      </m:r>
+                    </m:oMath>
+                  </m:oMathPara>
+                </a14:m>
+                <a:endParaRPr lang="en-US" dirty="0"/>
+              </a:p>
+            </p:txBody>
+          </p:sp>
+        </mc:Choice>
+        <mc:Fallback>
+          <p:sp>
+            <p:nvSpPr>
+              <p:cNvPr id="9" name="TextBox 8">
+                <a:extLst>
+                  <a:ext uri="{FF2B5EF4-FFF2-40B4-BE49-F238E27FC236}">
+                    <a16:creationId xmlns:a16="http://schemas.microsoft.com/office/drawing/2014/main" id="{E2491624-E69F-3EA5-2CD4-EC2C0B4F562D}"/>
+                  </a:ext>
+                </a:extLst>
+              </p:cNvPr>
+              <p:cNvSpPr txBox="1">
+                <a:spLocks noRot="1" noChangeAspect="1" noMove="1" noResize="1" noEditPoints="1" noAdjustHandles="1" noChangeArrowheads="1" noChangeShapeType="1" noTextEdit="1"/>
+              </p:cNvSpPr>
+              <p:nvPr/>
+            </p:nvSpPr>
+            <p:spPr>
+              <a:xfrm>
+                <a:off x="928116" y="5486784"/>
+                <a:ext cx="4159472" cy="520463"/>
+              </a:xfrm>
+              <a:prstGeom prst="rect">
+                <a:avLst/>
+              </a:prstGeom>
+              <a:blipFill>
+                <a:blip r:embed="rId6"/>
+                <a:stretch>
+                  <a:fillRect/>
+                </a:stretch>
+              </a:blipFill>
+            </p:spPr>
+            <p:txBody>
+              <a:bodyPr/>
+              <a:lstStyle/>
+              <a:p>
+                <a:r>
+                  <a:rPr lang="en-US">
+                    <a:noFill/>
+                  </a:rPr>
+                  <a:t> </a:t>
+                </a:r>
+              </a:p>
+            </p:txBody>
+          </p:sp>
+        </mc:Fallback>
+      </mc:AlternateContent>
+    </p:spTree>
+    <p:extLst>
+      <p:ext uri="{BB962C8B-B14F-4D97-AF65-F5344CB8AC3E}">
+        <p14:creationId xmlns:p14="http://schemas.microsoft.com/office/powerpoint/2010/main" val="61919515"/>
       </p:ext>
     </p:extLst>
   </p:cSld>

</xml_diff>

<commit_message>
finished power stage modeling powerpoint
</commit_message>
<xml_diff>
--- a/UT Robomasters – Supercap Power Stage Modeling.pptx
+++ b/UT Robomasters – Supercap Power Stage Modeling.pptx
@@ -28,14 +28,15 @@
     <p:sldId id="281" r:id="rId22"/>
     <p:sldId id="289" r:id="rId23"/>
     <p:sldId id="282" r:id="rId24"/>
-    <p:sldId id="288" r:id="rId25"/>
-    <p:sldId id="274" r:id="rId26"/>
-    <p:sldId id="272" r:id="rId27"/>
-    <p:sldId id="283" r:id="rId28"/>
-    <p:sldId id="284" r:id="rId29"/>
-    <p:sldId id="277" r:id="rId30"/>
-    <p:sldId id="285" r:id="rId31"/>
-    <p:sldId id="287" r:id="rId32"/>
+    <p:sldId id="290" r:id="rId25"/>
+    <p:sldId id="288" r:id="rId26"/>
+    <p:sldId id="274" r:id="rId27"/>
+    <p:sldId id="272" r:id="rId28"/>
+    <p:sldId id="283" r:id="rId29"/>
+    <p:sldId id="284" r:id="rId30"/>
+    <p:sldId id="277" r:id="rId31"/>
+    <p:sldId id="285" r:id="rId32"/>
+    <p:sldId id="287" r:id="rId33"/>
   </p:sldIdLst>
   <p:sldSz cx="12192000" cy="6858000"/>
   <p:notesSz cx="6858000" cy="9144000"/>
@@ -325,7 +326,7 @@
           <a:p>
             <a:fld id="{116CDFA8-9B71-48D2-9BC8-093B5490E257}" type="datetimeFigureOut">
               <a:rPr lang="en-US" smtClean="0"/>
-              <a:t>4/12/2026</a:t>
+              <a:t>5/4/2026</a:t>
             </a:fld>
             <a:endParaRPr lang="en-US"/>
           </a:p>
@@ -495,7 +496,7 @@
           <a:p>
             <a:fld id="{116CDFA8-9B71-48D2-9BC8-093B5490E257}" type="datetimeFigureOut">
               <a:rPr lang="en-US" smtClean="0"/>
-              <a:t>4/12/2026</a:t>
+              <a:t>5/4/2026</a:t>
             </a:fld>
             <a:endParaRPr lang="en-US"/>
           </a:p>
@@ -675,7 +676,7 @@
           <a:p>
             <a:fld id="{116CDFA8-9B71-48D2-9BC8-093B5490E257}" type="datetimeFigureOut">
               <a:rPr lang="en-US" smtClean="0"/>
-              <a:t>4/12/2026</a:t>
+              <a:t>5/4/2026</a:t>
             </a:fld>
             <a:endParaRPr lang="en-US"/>
           </a:p>
@@ -845,7 +846,7 @@
           <a:p>
             <a:fld id="{116CDFA8-9B71-48D2-9BC8-093B5490E257}" type="datetimeFigureOut">
               <a:rPr lang="en-US" smtClean="0"/>
-              <a:t>4/12/2026</a:t>
+              <a:t>5/4/2026</a:t>
             </a:fld>
             <a:endParaRPr lang="en-US"/>
           </a:p>
@@ -1091,7 +1092,7 @@
           <a:p>
             <a:fld id="{116CDFA8-9B71-48D2-9BC8-093B5490E257}" type="datetimeFigureOut">
               <a:rPr lang="en-US" smtClean="0"/>
-              <a:t>4/12/2026</a:t>
+              <a:t>5/4/2026</a:t>
             </a:fld>
             <a:endParaRPr lang="en-US"/>
           </a:p>
@@ -1323,7 +1324,7 @@
           <a:p>
             <a:fld id="{116CDFA8-9B71-48D2-9BC8-093B5490E257}" type="datetimeFigureOut">
               <a:rPr lang="en-US" smtClean="0"/>
-              <a:t>4/12/2026</a:t>
+              <a:t>5/4/2026</a:t>
             </a:fld>
             <a:endParaRPr lang="en-US"/>
           </a:p>
@@ -1690,7 +1691,7 @@
           <a:p>
             <a:fld id="{116CDFA8-9B71-48D2-9BC8-093B5490E257}" type="datetimeFigureOut">
               <a:rPr lang="en-US" smtClean="0"/>
-              <a:t>4/12/2026</a:t>
+              <a:t>5/4/2026</a:t>
             </a:fld>
             <a:endParaRPr lang="en-US"/>
           </a:p>
@@ -1808,7 +1809,7 @@
           <a:p>
             <a:fld id="{116CDFA8-9B71-48D2-9BC8-093B5490E257}" type="datetimeFigureOut">
               <a:rPr lang="en-US" smtClean="0"/>
-              <a:t>4/12/2026</a:t>
+              <a:t>5/4/2026</a:t>
             </a:fld>
             <a:endParaRPr lang="en-US"/>
           </a:p>
@@ -1903,7 +1904,7 @@
           <a:p>
             <a:fld id="{116CDFA8-9B71-48D2-9BC8-093B5490E257}" type="datetimeFigureOut">
               <a:rPr lang="en-US" smtClean="0"/>
-              <a:t>4/12/2026</a:t>
+              <a:t>5/4/2026</a:t>
             </a:fld>
             <a:endParaRPr lang="en-US"/>
           </a:p>
@@ -2180,7 +2181,7 @@
           <a:p>
             <a:fld id="{116CDFA8-9B71-48D2-9BC8-093B5490E257}" type="datetimeFigureOut">
               <a:rPr lang="en-US" smtClean="0"/>
-              <a:t>4/12/2026</a:t>
+              <a:t>5/4/2026</a:t>
             </a:fld>
             <a:endParaRPr lang="en-US"/>
           </a:p>
@@ -2437,7 +2438,7 @@
           <a:p>
             <a:fld id="{116CDFA8-9B71-48D2-9BC8-093B5490E257}" type="datetimeFigureOut">
               <a:rPr lang="en-US" smtClean="0"/>
-              <a:t>4/12/2026</a:t>
+              <a:t>5/4/2026</a:t>
             </a:fld>
             <a:endParaRPr lang="en-US"/>
           </a:p>
@@ -2650,7 +2651,7 @@
           <a:p>
             <a:fld id="{116CDFA8-9B71-48D2-9BC8-093B5490E257}" type="datetimeFigureOut">
               <a:rPr lang="en-US" smtClean="0"/>
-              <a:t>4/12/2026</a:t>
+              <a:t>5/4/2026</a:t>
             </a:fld>
             <a:endParaRPr lang="en-US"/>
           </a:p>
@@ -19102,44 +19103,1368 @@
           <a:p>
             <a:r>
               <a:rPr lang="en-US" dirty="0"/>
-              <a:t>Reverse Current – Control Schema</a:t>
+              <a:t>Modeling Schema – State-Space Model</a:t>
             </a:r>
           </a:p>
         </p:txBody>
       </p:sp>
       <p:pic>
         <p:nvPicPr>
-          <p:cNvPr id="3" name="Online Media 2" title="guy screaming for help while holding a chick fil a drink">
-            <a:hlinkClick r:id="" action="ppaction://media"/>
+          <p:cNvPr id="5" name="Picture 4">
             <a:extLst>
               <a:ext uri="{FF2B5EF4-FFF2-40B4-BE49-F238E27FC236}">
-                <a16:creationId xmlns:a16="http://schemas.microsoft.com/office/drawing/2014/main" id="{3CDCB37F-614F-0266-D181-7E245E3C588F}"/>
+                <a16:creationId xmlns:a16="http://schemas.microsoft.com/office/drawing/2014/main" id="{5A315A72-DCD9-2E90-2133-7A5E96ECFD0C}"/>
               </a:ext>
             </a:extLst>
           </p:cNvPr>
           <p:cNvPicPr>
-            <a:picLocks noRot="1" noChangeAspect="1"/>
+            <a:picLocks noChangeAspect="1"/>
           </p:cNvPicPr>
-          <p:nvPr>
-            <a:videoFile r:link="rId1"/>
-          </p:nvPr>
+          <p:nvPr/>
         </p:nvPicPr>
         <p:blipFill>
-          <a:blip r:embed="rId3"/>
+          <a:blip r:embed="rId2"/>
           <a:stretch>
             <a:fillRect/>
           </a:stretch>
         </p:blipFill>
         <p:spPr>
           <a:xfrm>
-            <a:off x="2523565" y="1422676"/>
-            <a:ext cx="7144871" cy="5358653"/>
+            <a:off x="7804742" y="3429000"/>
+            <a:ext cx="3832732" cy="3294540"/>
           </a:xfrm>
           <a:prstGeom prst="rect">
             <a:avLst/>
           </a:prstGeom>
         </p:spPr>
       </p:pic>
+      <mc:AlternateContent xmlns:mc="http://schemas.openxmlformats.org/markup-compatibility/2006">
+        <mc:Choice xmlns:a14="http://schemas.microsoft.com/office/drawing/2010/main" Requires="a14">
+          <p:sp>
+            <p:nvSpPr>
+              <p:cNvPr id="6" name="TextBox 5">
+                <a:extLst>
+                  <a:ext uri="{FF2B5EF4-FFF2-40B4-BE49-F238E27FC236}">
+                    <a16:creationId xmlns:a16="http://schemas.microsoft.com/office/drawing/2014/main" id="{2233ADD0-2087-A2FE-E2E7-DD4FBE4B3985}"/>
+                  </a:ext>
+                </a:extLst>
+              </p:cNvPr>
+              <p:cNvSpPr txBox="1"/>
+              <p:nvPr/>
+            </p:nvSpPr>
+            <p:spPr>
+              <a:xfrm>
+                <a:off x="1039104" y="1488281"/>
+                <a:ext cx="6627078" cy="4442306"/>
+              </a:xfrm>
+              <a:prstGeom prst="rect">
+                <a:avLst/>
+              </a:prstGeom>
+              <a:noFill/>
+            </p:spPr>
+            <p:txBody>
+              <a:bodyPr wrap="square" rtlCol="0">
+                <a:spAutoFit/>
+              </a:bodyPr>
+              <a:lstStyle/>
+              <a:p>
+                <a:r>
+                  <a:rPr lang="en-US" dirty="0"/>
+                  <a:t>Start with KCL and KVL equations for RLC branch:</a:t>
+                </a:r>
+              </a:p>
+              <a:p>
+                <a14:m>
+                  <m:oMathPara xmlns:m="http://schemas.openxmlformats.org/officeDocument/2006/math">
+                    <m:oMathParaPr>
+                      <m:jc m:val="centerGroup"/>
+                    </m:oMathParaPr>
+                    <m:oMath xmlns:m="http://schemas.openxmlformats.org/officeDocument/2006/math">
+                      <m:r>
+                        <a:rPr lang="en-US" b="0" i="1" smtClean="0">
+                          <a:latin typeface="Cambria Math" panose="02040503050406030204" pitchFamily="18" charset="0"/>
+                        </a:rPr>
+                        <m:t>𝑀</m:t>
+                      </m:r>
+                      <m:d>
+                        <m:dPr>
+                          <m:ctrlPr>
+                            <a:rPr lang="en-US" b="0" i="1" smtClean="0">
+                              <a:latin typeface="Cambria Math" panose="02040503050406030204" pitchFamily="18" charset="0"/>
+                            </a:rPr>
+                          </m:ctrlPr>
+                        </m:dPr>
+                        <m:e>
+                          <m:r>
+                            <a:rPr lang="en-US" b="0" i="1" smtClean="0">
+                              <a:latin typeface="Cambria Math" panose="02040503050406030204" pitchFamily="18" charset="0"/>
+                            </a:rPr>
+                            <m:t>𝑡</m:t>
+                          </m:r>
+                        </m:e>
+                      </m:d>
+                      <m:r>
+                        <a:rPr lang="en-US" b="0" i="1" smtClean="0">
+                          <a:latin typeface="Cambria Math" panose="02040503050406030204" pitchFamily="18" charset="0"/>
+                        </a:rPr>
+                        <m:t>∗</m:t>
+                      </m:r>
+                      <m:sSub>
+                        <m:sSubPr>
+                          <m:ctrlPr>
+                            <a:rPr lang="en-US" b="0" i="1" smtClean="0">
+                              <a:latin typeface="Cambria Math" panose="02040503050406030204" pitchFamily="18" charset="0"/>
+                            </a:rPr>
+                          </m:ctrlPr>
+                        </m:sSubPr>
+                        <m:e>
+                          <m:r>
+                            <a:rPr lang="en-US" b="0" i="1" smtClean="0">
+                              <a:latin typeface="Cambria Math" panose="02040503050406030204" pitchFamily="18" charset="0"/>
+                            </a:rPr>
+                            <m:t>𝑉</m:t>
+                          </m:r>
+                        </m:e>
+                        <m:sub>
+                          <m:r>
+                            <a:rPr lang="en-US" b="0" i="1" smtClean="0">
+                              <a:latin typeface="Cambria Math" panose="02040503050406030204" pitchFamily="18" charset="0"/>
+                            </a:rPr>
+                            <m:t>𝑔</m:t>
+                          </m:r>
+                        </m:sub>
+                      </m:sSub>
+                      <m:d>
+                        <m:dPr>
+                          <m:ctrlPr>
+                            <a:rPr lang="en-US" b="0" i="1" smtClean="0">
+                              <a:latin typeface="Cambria Math" panose="02040503050406030204" pitchFamily="18" charset="0"/>
+                            </a:rPr>
+                          </m:ctrlPr>
+                        </m:dPr>
+                        <m:e>
+                          <m:r>
+                            <a:rPr lang="en-US" b="0" i="1" smtClean="0">
+                              <a:latin typeface="Cambria Math" panose="02040503050406030204" pitchFamily="18" charset="0"/>
+                            </a:rPr>
+                            <m:t>𝑡</m:t>
+                          </m:r>
+                        </m:e>
+                      </m:d>
+                      <m:r>
+                        <a:rPr lang="en-US" b="0" i="1" smtClean="0">
+                          <a:latin typeface="Cambria Math" panose="02040503050406030204" pitchFamily="18" charset="0"/>
+                        </a:rPr>
+                        <m:t>−</m:t>
+                      </m:r>
+                      <m:r>
+                        <a:rPr lang="en-US" b="0" i="1" smtClean="0">
+                          <a:latin typeface="Cambria Math" panose="02040503050406030204" pitchFamily="18" charset="0"/>
+                        </a:rPr>
+                        <m:t>𝑅</m:t>
+                      </m:r>
+                      <m:r>
+                        <a:rPr lang="en-US" b="0" i="1" smtClean="0">
+                          <a:latin typeface="Cambria Math" panose="02040503050406030204" pitchFamily="18" charset="0"/>
+                        </a:rPr>
+                        <m:t>∗</m:t>
+                      </m:r>
+                      <m:r>
+                        <a:rPr lang="en-US" b="0" i="1" smtClean="0">
+                          <a:latin typeface="Cambria Math" panose="02040503050406030204" pitchFamily="18" charset="0"/>
+                        </a:rPr>
+                        <m:t>𝑖</m:t>
+                      </m:r>
+                      <m:d>
+                        <m:dPr>
+                          <m:ctrlPr>
+                            <a:rPr lang="en-US" b="0" i="1" smtClean="0">
+                              <a:latin typeface="Cambria Math" panose="02040503050406030204" pitchFamily="18" charset="0"/>
+                            </a:rPr>
+                          </m:ctrlPr>
+                        </m:dPr>
+                        <m:e>
+                          <m:r>
+                            <a:rPr lang="en-US" b="0" i="1" smtClean="0">
+                              <a:latin typeface="Cambria Math" panose="02040503050406030204" pitchFamily="18" charset="0"/>
+                            </a:rPr>
+                            <m:t>𝑡</m:t>
+                          </m:r>
+                        </m:e>
+                      </m:d>
+                      <m:r>
+                        <a:rPr lang="en-US" b="0" i="1" smtClean="0">
+                          <a:latin typeface="Cambria Math" panose="02040503050406030204" pitchFamily="18" charset="0"/>
+                        </a:rPr>
+                        <m:t>−</m:t>
+                      </m:r>
+                      <m:sSub>
+                        <m:sSubPr>
+                          <m:ctrlPr>
+                            <a:rPr lang="en-US" b="0" i="1" smtClean="0">
+                              <a:latin typeface="Cambria Math" panose="02040503050406030204" pitchFamily="18" charset="0"/>
+                            </a:rPr>
+                          </m:ctrlPr>
+                        </m:sSubPr>
+                        <m:e>
+                          <m:r>
+                            <a:rPr lang="en-US" b="0" i="1" smtClean="0">
+                              <a:latin typeface="Cambria Math" panose="02040503050406030204" pitchFamily="18" charset="0"/>
+                            </a:rPr>
+                            <m:t>𝑣</m:t>
+                          </m:r>
+                        </m:e>
+                        <m:sub>
+                          <m:r>
+                            <a:rPr lang="en-US" b="0" i="1" smtClean="0">
+                              <a:latin typeface="Cambria Math" panose="02040503050406030204" pitchFamily="18" charset="0"/>
+                            </a:rPr>
+                            <m:t>𝑐</m:t>
+                          </m:r>
+                        </m:sub>
+                      </m:sSub>
+                      <m:d>
+                        <m:dPr>
+                          <m:ctrlPr>
+                            <a:rPr lang="en-US" b="0" i="1" smtClean="0">
+                              <a:latin typeface="Cambria Math" panose="02040503050406030204" pitchFamily="18" charset="0"/>
+                            </a:rPr>
+                          </m:ctrlPr>
+                        </m:dPr>
+                        <m:e>
+                          <m:r>
+                            <a:rPr lang="en-US" b="0" i="1" smtClean="0">
+                              <a:latin typeface="Cambria Math" panose="02040503050406030204" pitchFamily="18" charset="0"/>
+                            </a:rPr>
+                            <m:t>𝑡</m:t>
+                          </m:r>
+                        </m:e>
+                      </m:d>
+                      <m:r>
+                        <a:rPr lang="en-US" b="0" i="1" smtClean="0">
+                          <a:latin typeface="Cambria Math" panose="02040503050406030204" pitchFamily="18" charset="0"/>
+                        </a:rPr>
+                        <m:t>−</m:t>
+                      </m:r>
+                      <m:r>
+                        <a:rPr lang="en-US" b="0" i="1" smtClean="0">
+                          <a:latin typeface="Cambria Math" panose="02040503050406030204" pitchFamily="18" charset="0"/>
+                        </a:rPr>
+                        <m:t>𝐿</m:t>
+                      </m:r>
+                      <m:r>
+                        <a:rPr lang="en-US" b="0" i="1" smtClean="0">
+                          <a:latin typeface="Cambria Math" panose="02040503050406030204" pitchFamily="18" charset="0"/>
+                        </a:rPr>
+                        <m:t>∗</m:t>
+                      </m:r>
+                      <m:f>
+                        <m:fPr>
+                          <m:ctrlPr>
+                            <a:rPr lang="en-US" b="0" i="1" smtClean="0">
+                              <a:latin typeface="Cambria Math" panose="02040503050406030204" pitchFamily="18" charset="0"/>
+                            </a:rPr>
+                          </m:ctrlPr>
+                        </m:fPr>
+                        <m:num>
+                          <m:r>
+                            <a:rPr lang="en-US" b="0" i="1" smtClean="0">
+                              <a:latin typeface="Cambria Math" panose="02040503050406030204" pitchFamily="18" charset="0"/>
+                            </a:rPr>
+                            <m:t>𝑑𝑖</m:t>
+                          </m:r>
+                          <m:r>
+                            <a:rPr lang="en-US" b="0" i="1" smtClean="0">
+                              <a:latin typeface="Cambria Math" panose="02040503050406030204" pitchFamily="18" charset="0"/>
+                            </a:rPr>
+                            <m:t>(</m:t>
+                          </m:r>
+                          <m:r>
+                            <a:rPr lang="en-US" b="0" i="1" smtClean="0">
+                              <a:latin typeface="Cambria Math" panose="02040503050406030204" pitchFamily="18" charset="0"/>
+                            </a:rPr>
+                            <m:t>𝑡</m:t>
+                          </m:r>
+                          <m:r>
+                            <a:rPr lang="en-US" b="0" i="1" smtClean="0">
+                              <a:latin typeface="Cambria Math" panose="02040503050406030204" pitchFamily="18" charset="0"/>
+                            </a:rPr>
+                            <m:t>)</m:t>
+                          </m:r>
+                        </m:num>
+                        <m:den>
+                          <m:r>
+                            <a:rPr lang="en-US" b="0" i="1" smtClean="0">
+                              <a:latin typeface="Cambria Math" panose="02040503050406030204" pitchFamily="18" charset="0"/>
+                            </a:rPr>
+                            <m:t>𝑑𝑡</m:t>
+                          </m:r>
+                        </m:den>
+                      </m:f>
+                      <m:r>
+                        <a:rPr lang="en-US" b="0" i="1" smtClean="0">
+                          <a:latin typeface="Cambria Math" panose="02040503050406030204" pitchFamily="18" charset="0"/>
+                        </a:rPr>
+                        <m:t>=0</m:t>
+                      </m:r>
+                    </m:oMath>
+                  </m:oMathPara>
+                </a14:m>
+                <a:endParaRPr lang="en-US" dirty="0"/>
+              </a:p>
+              <a:p>
+                <a14:m>
+                  <m:oMathPara xmlns:m="http://schemas.openxmlformats.org/officeDocument/2006/math">
+                    <m:oMathParaPr>
+                      <m:jc m:val="centerGroup"/>
+                    </m:oMathParaPr>
+                    <m:oMath xmlns:m="http://schemas.openxmlformats.org/officeDocument/2006/math">
+                      <m:r>
+                        <a:rPr lang="en-US" b="0" i="1" smtClean="0">
+                          <a:latin typeface="Cambria Math" panose="02040503050406030204" pitchFamily="18" charset="0"/>
+                        </a:rPr>
+                        <m:t>𝑖</m:t>
+                      </m:r>
+                      <m:d>
+                        <m:dPr>
+                          <m:ctrlPr>
+                            <a:rPr lang="en-US" b="0" i="1" smtClean="0">
+                              <a:latin typeface="Cambria Math" panose="02040503050406030204" pitchFamily="18" charset="0"/>
+                            </a:rPr>
+                          </m:ctrlPr>
+                        </m:dPr>
+                        <m:e>
+                          <m:r>
+                            <a:rPr lang="en-US" b="0" i="1" smtClean="0">
+                              <a:latin typeface="Cambria Math" panose="02040503050406030204" pitchFamily="18" charset="0"/>
+                            </a:rPr>
+                            <m:t>𝑡</m:t>
+                          </m:r>
+                        </m:e>
+                      </m:d>
+                      <m:r>
+                        <a:rPr lang="en-US" b="0" i="1" smtClean="0">
+                          <a:latin typeface="Cambria Math" panose="02040503050406030204" pitchFamily="18" charset="0"/>
+                        </a:rPr>
+                        <m:t>=</m:t>
+                      </m:r>
+                      <m:r>
+                        <a:rPr lang="en-US" b="0" i="1" smtClean="0">
+                          <a:latin typeface="Cambria Math" panose="02040503050406030204" pitchFamily="18" charset="0"/>
+                        </a:rPr>
+                        <m:t>𝐶</m:t>
+                      </m:r>
+                      <m:r>
+                        <a:rPr lang="en-US" b="0" i="1" smtClean="0">
+                          <a:latin typeface="Cambria Math" panose="02040503050406030204" pitchFamily="18" charset="0"/>
+                        </a:rPr>
+                        <m:t>∗</m:t>
+                      </m:r>
+                      <m:f>
+                        <m:fPr>
+                          <m:ctrlPr>
+                            <a:rPr lang="en-US" b="0" i="1" smtClean="0">
+                              <a:latin typeface="Cambria Math" panose="02040503050406030204" pitchFamily="18" charset="0"/>
+                            </a:rPr>
+                          </m:ctrlPr>
+                        </m:fPr>
+                        <m:num>
+                          <m:r>
+                            <a:rPr lang="en-US" b="0" i="1" smtClean="0">
+                              <a:latin typeface="Cambria Math" panose="02040503050406030204" pitchFamily="18" charset="0"/>
+                            </a:rPr>
+                            <m:t>𝑑</m:t>
+                          </m:r>
+                          <m:sSub>
+                            <m:sSubPr>
+                              <m:ctrlPr>
+                                <a:rPr lang="en-US" b="0" i="1" smtClean="0">
+                                  <a:latin typeface="Cambria Math" panose="02040503050406030204" pitchFamily="18" charset="0"/>
+                                </a:rPr>
+                              </m:ctrlPr>
+                            </m:sSubPr>
+                            <m:e>
+                              <m:r>
+                                <a:rPr lang="en-US" b="0" i="1" smtClean="0">
+                                  <a:latin typeface="Cambria Math" panose="02040503050406030204" pitchFamily="18" charset="0"/>
+                                </a:rPr>
+                                <m:t>𝑣</m:t>
+                              </m:r>
+                            </m:e>
+                            <m:sub>
+                              <m:r>
+                                <a:rPr lang="en-US" b="0" i="1" smtClean="0">
+                                  <a:latin typeface="Cambria Math" panose="02040503050406030204" pitchFamily="18" charset="0"/>
+                                </a:rPr>
+                                <m:t>𝑐</m:t>
+                              </m:r>
+                            </m:sub>
+                          </m:sSub>
+                          <m:r>
+                            <a:rPr lang="en-US" b="0" i="1" smtClean="0">
+                              <a:latin typeface="Cambria Math" panose="02040503050406030204" pitchFamily="18" charset="0"/>
+                            </a:rPr>
+                            <m:t>(</m:t>
+                          </m:r>
+                          <m:r>
+                            <a:rPr lang="en-US" b="0" i="1" smtClean="0">
+                              <a:latin typeface="Cambria Math" panose="02040503050406030204" pitchFamily="18" charset="0"/>
+                            </a:rPr>
+                            <m:t>𝑡</m:t>
+                          </m:r>
+                          <m:r>
+                            <a:rPr lang="en-US" b="0" i="1" smtClean="0">
+                              <a:latin typeface="Cambria Math" panose="02040503050406030204" pitchFamily="18" charset="0"/>
+                            </a:rPr>
+                            <m:t>)</m:t>
+                          </m:r>
+                        </m:num>
+                        <m:den>
+                          <m:r>
+                            <a:rPr lang="en-US" b="0" i="1" smtClean="0">
+                              <a:latin typeface="Cambria Math" panose="02040503050406030204" pitchFamily="18" charset="0"/>
+                            </a:rPr>
+                            <m:t>𝑑𝑡</m:t>
+                          </m:r>
+                        </m:den>
+                      </m:f>
+                    </m:oMath>
+                  </m:oMathPara>
+                </a14:m>
+                <a:endParaRPr lang="en-US" dirty="0"/>
+              </a:p>
+              <a:p>
+                <a:r>
+                  <a:rPr lang="en-US" dirty="0"/>
+                  <a:t>Rearrange to solve for derivates of state variables (</a:t>
+                </a:r>
+                <a14:m>
+                  <m:oMath xmlns:m="http://schemas.openxmlformats.org/officeDocument/2006/math">
+                    <m:r>
+                      <a:rPr lang="en-US" b="0" i="1" smtClean="0">
+                        <a:latin typeface="Cambria Math" panose="02040503050406030204" pitchFamily="18" charset="0"/>
+                      </a:rPr>
+                      <m:t>𝑖</m:t>
+                    </m:r>
+                    <m:d>
+                      <m:dPr>
+                        <m:ctrlPr>
+                          <a:rPr lang="en-US" b="0" i="1" smtClean="0">
+                            <a:latin typeface="Cambria Math" panose="02040503050406030204" pitchFamily="18" charset="0"/>
+                          </a:rPr>
+                        </m:ctrlPr>
+                      </m:dPr>
+                      <m:e>
+                        <m:r>
+                          <a:rPr lang="en-US" b="0" i="1" smtClean="0">
+                            <a:latin typeface="Cambria Math" panose="02040503050406030204" pitchFamily="18" charset="0"/>
+                          </a:rPr>
+                          <m:t>𝑡</m:t>
+                        </m:r>
+                      </m:e>
+                    </m:d>
+                    <m:r>
+                      <a:rPr lang="en-US" b="0" i="1" smtClean="0">
+                        <a:latin typeface="Cambria Math" panose="02040503050406030204" pitchFamily="18" charset="0"/>
+                      </a:rPr>
+                      <m:t>, </m:t>
+                    </m:r>
+                    <m:sSub>
+                      <m:sSubPr>
+                        <m:ctrlPr>
+                          <a:rPr lang="en-US" b="0" i="1" smtClean="0">
+                            <a:latin typeface="Cambria Math" panose="02040503050406030204" pitchFamily="18" charset="0"/>
+                          </a:rPr>
+                        </m:ctrlPr>
+                      </m:sSubPr>
+                      <m:e>
+                        <m:r>
+                          <a:rPr lang="en-US" b="0" i="1" smtClean="0">
+                            <a:latin typeface="Cambria Math" panose="02040503050406030204" pitchFamily="18" charset="0"/>
+                          </a:rPr>
+                          <m:t>𝑣</m:t>
+                        </m:r>
+                      </m:e>
+                      <m:sub>
+                        <m:r>
+                          <a:rPr lang="en-US" b="0" i="1" smtClean="0">
+                            <a:latin typeface="Cambria Math" panose="02040503050406030204" pitchFamily="18" charset="0"/>
+                          </a:rPr>
+                          <m:t>𝑐</m:t>
+                        </m:r>
+                      </m:sub>
+                    </m:sSub>
+                    <m:r>
+                      <a:rPr lang="en-US" b="0" i="1" smtClean="0">
+                        <a:latin typeface="Cambria Math" panose="02040503050406030204" pitchFamily="18" charset="0"/>
+                      </a:rPr>
+                      <m:t>(</m:t>
+                    </m:r>
+                    <m:r>
+                      <a:rPr lang="en-US" b="0" i="1" smtClean="0">
+                        <a:latin typeface="Cambria Math" panose="02040503050406030204" pitchFamily="18" charset="0"/>
+                      </a:rPr>
+                      <m:t>𝑡</m:t>
+                    </m:r>
+                    <m:r>
+                      <a:rPr lang="en-US" b="0" i="1" smtClean="0">
+                        <a:latin typeface="Cambria Math" panose="02040503050406030204" pitchFamily="18" charset="0"/>
+                      </a:rPr>
+                      <m:t>)</m:t>
+                    </m:r>
+                  </m:oMath>
+                </a14:m>
+                <a:r>
+                  <a:rPr lang="en-US" dirty="0"/>
+                  <a:t>) and output </a:t>
+                </a:r>
+                <a14:m>
+                  <m:oMath xmlns:m="http://schemas.openxmlformats.org/officeDocument/2006/math">
+                    <m:sSub>
+                      <m:sSubPr>
+                        <m:ctrlPr>
+                          <a:rPr lang="en-US" b="0" i="1" smtClean="0">
+                            <a:latin typeface="Cambria Math" panose="02040503050406030204" pitchFamily="18" charset="0"/>
+                          </a:rPr>
+                        </m:ctrlPr>
+                      </m:sSubPr>
+                      <m:e>
+                        <m:r>
+                          <a:rPr lang="en-US" b="0" i="1" smtClean="0">
+                            <a:latin typeface="Cambria Math" panose="02040503050406030204" pitchFamily="18" charset="0"/>
+                          </a:rPr>
+                          <m:t>𝑖</m:t>
+                        </m:r>
+                      </m:e>
+                      <m:sub>
+                        <m:r>
+                          <a:rPr lang="en-US" b="0" i="1" smtClean="0">
+                            <a:latin typeface="Cambria Math" panose="02040503050406030204" pitchFamily="18" charset="0"/>
+                          </a:rPr>
+                          <m:t>𝑏𝑎𝑡</m:t>
+                        </m:r>
+                      </m:sub>
+                    </m:sSub>
+                    <m:r>
+                      <a:rPr lang="en-US" b="0" i="1" smtClean="0">
+                        <a:latin typeface="Cambria Math" panose="02040503050406030204" pitchFamily="18" charset="0"/>
+                      </a:rPr>
+                      <m:t>(</m:t>
+                    </m:r>
+                    <m:r>
+                      <a:rPr lang="en-US" b="0" i="1" smtClean="0">
+                        <a:latin typeface="Cambria Math" panose="02040503050406030204" pitchFamily="18" charset="0"/>
+                      </a:rPr>
+                      <m:t>𝑡</m:t>
+                    </m:r>
+                    <m:r>
+                      <a:rPr lang="en-US" b="0" i="1" smtClean="0">
+                        <a:latin typeface="Cambria Math" panose="02040503050406030204" pitchFamily="18" charset="0"/>
+                      </a:rPr>
+                      <m:t>)</m:t>
+                    </m:r>
+                  </m:oMath>
+                </a14:m>
+                <a:r>
+                  <a:rPr lang="en-US" dirty="0"/>
+                  <a:t>:</a:t>
+                </a:r>
+              </a:p>
+              <a:p>
+                <a14:m>
+                  <m:oMathPara xmlns:m="http://schemas.openxmlformats.org/officeDocument/2006/math">
+                    <m:oMathParaPr>
+                      <m:jc m:val="centerGroup"/>
+                    </m:oMathParaPr>
+                    <m:oMath xmlns:m="http://schemas.openxmlformats.org/officeDocument/2006/math">
+                      <m:f>
+                        <m:fPr>
+                          <m:ctrlPr>
+                            <a:rPr lang="en-US" b="0" i="1" smtClean="0">
+                              <a:latin typeface="Cambria Math" panose="02040503050406030204" pitchFamily="18" charset="0"/>
+                            </a:rPr>
+                          </m:ctrlPr>
+                        </m:fPr>
+                        <m:num>
+                          <m:r>
+                            <a:rPr lang="en-US" b="0" i="1" smtClean="0">
+                              <a:latin typeface="Cambria Math" panose="02040503050406030204" pitchFamily="18" charset="0"/>
+                            </a:rPr>
+                            <m:t>𝑑</m:t>
+                          </m:r>
+                        </m:num>
+                        <m:den>
+                          <m:r>
+                            <a:rPr lang="en-US" b="0" i="1" smtClean="0">
+                              <a:latin typeface="Cambria Math" panose="02040503050406030204" pitchFamily="18" charset="0"/>
+                            </a:rPr>
+                            <m:t>𝑑𝑡</m:t>
+                          </m:r>
+                        </m:den>
+                      </m:f>
+                      <m:d>
+                        <m:dPr>
+                          <m:begChr m:val="["/>
+                          <m:endChr m:val="]"/>
+                          <m:ctrlPr>
+                            <a:rPr lang="en-US" b="0" i="1" smtClean="0">
+                              <a:latin typeface="Cambria Math" panose="02040503050406030204" pitchFamily="18" charset="0"/>
+                            </a:rPr>
+                          </m:ctrlPr>
+                        </m:dPr>
+                        <m:e>
+                          <m:m>
+                            <m:mPr>
+                              <m:mcs>
+                                <m:mc>
+                                  <m:mcPr>
+                                    <m:count m:val="1"/>
+                                    <m:mcJc m:val="center"/>
+                                  </m:mcPr>
+                                </m:mc>
+                              </m:mcs>
+                              <m:ctrlPr>
+                                <a:rPr lang="en-US" i="1" smtClean="0">
+                                  <a:latin typeface="Cambria Math" panose="02040503050406030204" pitchFamily="18" charset="0"/>
+                                </a:rPr>
+                              </m:ctrlPr>
+                            </m:mPr>
+                            <m:mr>
+                              <m:e>
+                                <m:r>
+                                  <m:rPr>
+                                    <m:brk m:alnAt="7"/>
+                                  </m:rPr>
+                                  <a:rPr lang="en-US" b="0" i="1" smtClean="0">
+                                    <a:latin typeface="Cambria Math" panose="02040503050406030204" pitchFamily="18" charset="0"/>
+                                  </a:rPr>
+                                  <m:t>𝑖</m:t>
+                                </m:r>
+                                <m:r>
+                                  <a:rPr lang="en-US" b="0" i="1" smtClean="0">
+                                    <a:latin typeface="Cambria Math" panose="02040503050406030204" pitchFamily="18" charset="0"/>
+                                  </a:rPr>
+                                  <m:t>(</m:t>
+                                </m:r>
+                                <m:r>
+                                  <a:rPr lang="en-US" b="0" i="1" smtClean="0">
+                                    <a:latin typeface="Cambria Math" panose="02040503050406030204" pitchFamily="18" charset="0"/>
+                                  </a:rPr>
+                                  <m:t>𝑡</m:t>
+                                </m:r>
+                                <m:r>
+                                  <a:rPr lang="en-US" b="0" i="1" smtClean="0">
+                                    <a:latin typeface="Cambria Math" panose="02040503050406030204" pitchFamily="18" charset="0"/>
+                                  </a:rPr>
+                                  <m:t>)</m:t>
+                                </m:r>
+                              </m:e>
+                            </m:mr>
+                            <m:mr>
+                              <m:e>
+                                <m:sSub>
+                                  <m:sSubPr>
+                                    <m:ctrlPr>
+                                      <a:rPr lang="en-US" b="0" i="1" smtClean="0">
+                                        <a:latin typeface="Cambria Math" panose="02040503050406030204" pitchFamily="18" charset="0"/>
+                                      </a:rPr>
+                                    </m:ctrlPr>
+                                  </m:sSubPr>
+                                  <m:e>
+                                    <m:r>
+                                      <a:rPr lang="en-US" b="0" i="1" smtClean="0">
+                                        <a:latin typeface="Cambria Math" panose="02040503050406030204" pitchFamily="18" charset="0"/>
+                                      </a:rPr>
+                                      <m:t>𝑣</m:t>
+                                    </m:r>
+                                  </m:e>
+                                  <m:sub>
+                                    <m:r>
+                                      <a:rPr lang="en-US" b="0" i="1" smtClean="0">
+                                        <a:latin typeface="Cambria Math" panose="02040503050406030204" pitchFamily="18" charset="0"/>
+                                      </a:rPr>
+                                      <m:t>𝑐</m:t>
+                                    </m:r>
+                                  </m:sub>
+                                </m:sSub>
+                                <m:r>
+                                  <a:rPr lang="en-US" b="0" i="1" smtClean="0">
+                                    <a:latin typeface="Cambria Math" panose="02040503050406030204" pitchFamily="18" charset="0"/>
+                                  </a:rPr>
+                                  <m:t>(</m:t>
+                                </m:r>
+                                <m:r>
+                                  <a:rPr lang="en-US" b="0" i="1" smtClean="0">
+                                    <a:latin typeface="Cambria Math" panose="02040503050406030204" pitchFamily="18" charset="0"/>
+                                  </a:rPr>
+                                  <m:t>𝑡</m:t>
+                                </m:r>
+                                <m:r>
+                                  <a:rPr lang="en-US" b="0" i="1" smtClean="0">
+                                    <a:latin typeface="Cambria Math" panose="02040503050406030204" pitchFamily="18" charset="0"/>
+                                  </a:rPr>
+                                  <m:t>)</m:t>
+                                </m:r>
+                              </m:e>
+                            </m:mr>
+                          </m:m>
+                        </m:e>
+                      </m:d>
+                      <m:r>
+                        <a:rPr lang="en-US" b="0" i="1" smtClean="0">
+                          <a:latin typeface="Cambria Math" panose="02040503050406030204" pitchFamily="18" charset="0"/>
+                        </a:rPr>
+                        <m:t>=</m:t>
+                      </m:r>
+                      <m:d>
+                        <m:dPr>
+                          <m:begChr m:val="["/>
+                          <m:endChr m:val="]"/>
+                          <m:ctrlPr>
+                            <a:rPr lang="en-US" b="0" i="1" smtClean="0">
+                              <a:latin typeface="Cambria Math" panose="02040503050406030204" pitchFamily="18" charset="0"/>
+                            </a:rPr>
+                          </m:ctrlPr>
+                        </m:dPr>
+                        <m:e>
+                          <m:m>
+                            <m:mPr>
+                              <m:mcs>
+                                <m:mc>
+                                  <m:mcPr>
+                                    <m:count m:val="1"/>
+                                    <m:mcJc m:val="center"/>
+                                  </m:mcPr>
+                                </m:mc>
+                              </m:mcs>
+                              <m:ctrlPr>
+                                <a:rPr lang="en-US" b="0" i="1" smtClean="0">
+                                  <a:latin typeface="Cambria Math" panose="02040503050406030204" pitchFamily="18" charset="0"/>
+                                </a:rPr>
+                              </m:ctrlPr>
+                            </m:mPr>
+                            <m:mr>
+                              <m:e>
+                                <m:f>
+                                  <m:fPr>
+                                    <m:ctrlPr>
+                                      <a:rPr lang="en-US" b="0" i="1" smtClean="0">
+                                        <a:latin typeface="Cambria Math" panose="02040503050406030204" pitchFamily="18" charset="0"/>
+                                      </a:rPr>
+                                    </m:ctrlPr>
+                                  </m:fPr>
+                                  <m:num>
+                                    <m:r>
+                                      <m:rPr>
+                                        <m:brk m:alnAt="7"/>
+                                      </m:rPr>
+                                      <a:rPr lang="en-US" b="0" i="1" smtClean="0">
+                                        <a:latin typeface="Cambria Math" panose="02040503050406030204" pitchFamily="18" charset="0"/>
+                                      </a:rPr>
+                                      <m:t>1</m:t>
+                                    </m:r>
+                                  </m:num>
+                                  <m:den>
+                                    <m:r>
+                                      <m:rPr>
+                                        <m:brk m:alnAt="7"/>
+                                      </m:rPr>
+                                      <a:rPr lang="en-US" b="0" i="1" smtClean="0">
+                                        <a:latin typeface="Cambria Math" panose="02040503050406030204" pitchFamily="18" charset="0"/>
+                                      </a:rPr>
+                                      <m:t>𝐿</m:t>
+                                    </m:r>
+                                  </m:den>
+                                </m:f>
+                                <m:r>
+                                  <m:rPr>
+                                    <m:brk m:alnAt="7"/>
+                                  </m:rPr>
+                                  <a:rPr lang="en-US" b="0" i="1" smtClean="0">
+                                    <a:latin typeface="Cambria Math" panose="02040503050406030204" pitchFamily="18" charset="0"/>
+                                  </a:rPr>
+                                  <m:t>∗</m:t>
+                                </m:r>
+                                <m:d>
+                                  <m:dPr>
+                                    <m:ctrlPr>
+                                      <a:rPr lang="en-US" b="0" i="1" smtClean="0">
+                                        <a:latin typeface="Cambria Math" panose="02040503050406030204" pitchFamily="18" charset="0"/>
+                                      </a:rPr>
+                                    </m:ctrlPr>
+                                  </m:dPr>
+                                  <m:e>
+                                    <m:r>
+                                      <m:rPr>
+                                        <m:brk m:alnAt="7"/>
+                                      </m:rPr>
+                                      <a:rPr lang="en-US" b="0" i="1" smtClean="0">
+                                        <a:latin typeface="Cambria Math" panose="02040503050406030204" pitchFamily="18" charset="0"/>
+                                      </a:rPr>
+                                      <m:t>𝑀</m:t>
+                                    </m:r>
+                                    <m:d>
+                                      <m:dPr>
+                                        <m:ctrlPr>
+                                          <a:rPr lang="en-US" b="0" i="1" smtClean="0">
+                                            <a:latin typeface="Cambria Math" panose="02040503050406030204" pitchFamily="18" charset="0"/>
+                                          </a:rPr>
+                                        </m:ctrlPr>
+                                      </m:dPr>
+                                      <m:e>
+                                        <m:r>
+                                          <m:rPr>
+                                            <m:brk m:alnAt="7"/>
+                                          </m:rPr>
+                                          <a:rPr lang="en-US" b="0" i="1" smtClean="0">
+                                            <a:latin typeface="Cambria Math" panose="02040503050406030204" pitchFamily="18" charset="0"/>
+                                          </a:rPr>
+                                          <m:t>𝑡</m:t>
+                                        </m:r>
+                                      </m:e>
+                                    </m:d>
+                                    <m:r>
+                                      <m:rPr>
+                                        <m:brk m:alnAt="7"/>
+                                      </m:rPr>
+                                      <a:rPr lang="en-US" b="0" i="1" smtClean="0">
+                                        <a:latin typeface="Cambria Math" panose="02040503050406030204" pitchFamily="18" charset="0"/>
+                                      </a:rPr>
+                                      <m:t>∗</m:t>
+                                    </m:r>
+                                    <m:sSub>
+                                      <m:sSubPr>
+                                        <m:ctrlPr>
+                                          <a:rPr lang="en-US" b="0" i="1" smtClean="0">
+                                            <a:latin typeface="Cambria Math" panose="02040503050406030204" pitchFamily="18" charset="0"/>
+                                          </a:rPr>
+                                        </m:ctrlPr>
+                                      </m:sSubPr>
+                                      <m:e>
+                                        <m:r>
+                                          <m:rPr>
+                                            <m:brk m:alnAt="7"/>
+                                          </m:rPr>
+                                          <a:rPr lang="en-US" b="0" i="1" smtClean="0">
+                                            <a:latin typeface="Cambria Math" panose="02040503050406030204" pitchFamily="18" charset="0"/>
+                                          </a:rPr>
+                                          <m:t>𝑉</m:t>
+                                        </m:r>
+                                      </m:e>
+                                      <m:sub>
+                                        <m:r>
+                                          <m:rPr>
+                                            <m:brk m:alnAt="7"/>
+                                          </m:rPr>
+                                          <a:rPr lang="en-US" b="0" i="1" smtClean="0">
+                                            <a:latin typeface="Cambria Math" panose="02040503050406030204" pitchFamily="18" charset="0"/>
+                                          </a:rPr>
+                                          <m:t>𝑔</m:t>
+                                        </m:r>
+                                      </m:sub>
+                                    </m:sSub>
+                                    <m:d>
+                                      <m:dPr>
+                                        <m:ctrlPr>
+                                          <a:rPr lang="en-US" b="0" i="1" smtClean="0">
+                                            <a:latin typeface="Cambria Math" panose="02040503050406030204" pitchFamily="18" charset="0"/>
+                                          </a:rPr>
+                                        </m:ctrlPr>
+                                      </m:dPr>
+                                      <m:e>
+                                        <m:r>
+                                          <m:rPr>
+                                            <m:brk m:alnAt="7"/>
+                                          </m:rPr>
+                                          <a:rPr lang="en-US" b="0" i="1" smtClean="0">
+                                            <a:latin typeface="Cambria Math" panose="02040503050406030204" pitchFamily="18" charset="0"/>
+                                          </a:rPr>
+                                          <m:t>𝑡</m:t>
+                                        </m:r>
+                                      </m:e>
+                                    </m:d>
+                                    <m:r>
+                                      <m:rPr>
+                                        <m:brk m:alnAt="7"/>
+                                      </m:rPr>
+                                      <a:rPr lang="en-US" b="0" i="1" smtClean="0">
+                                        <a:latin typeface="Cambria Math" panose="02040503050406030204" pitchFamily="18" charset="0"/>
+                                      </a:rPr>
+                                      <m:t>−</m:t>
+                                    </m:r>
+                                    <m:r>
+                                      <a:rPr lang="en-US" b="0" i="1" smtClean="0">
+                                        <a:latin typeface="Cambria Math" panose="02040503050406030204" pitchFamily="18" charset="0"/>
+                                      </a:rPr>
+                                      <m:t>𝑅</m:t>
+                                    </m:r>
+                                    <m:r>
+                                      <a:rPr lang="en-US" b="0" i="1" smtClean="0">
+                                        <a:latin typeface="Cambria Math" panose="02040503050406030204" pitchFamily="18" charset="0"/>
+                                      </a:rPr>
+                                      <m:t>∗</m:t>
+                                    </m:r>
+                                    <m:r>
+                                      <a:rPr lang="en-US" b="0" i="1" smtClean="0">
+                                        <a:latin typeface="Cambria Math" panose="02040503050406030204" pitchFamily="18" charset="0"/>
+                                      </a:rPr>
+                                      <m:t>𝑖</m:t>
+                                    </m:r>
+                                    <m:d>
+                                      <m:dPr>
+                                        <m:ctrlPr>
+                                          <a:rPr lang="en-US" b="0" i="1" smtClean="0">
+                                            <a:latin typeface="Cambria Math" panose="02040503050406030204" pitchFamily="18" charset="0"/>
+                                          </a:rPr>
+                                        </m:ctrlPr>
+                                      </m:dPr>
+                                      <m:e>
+                                        <m:r>
+                                          <m:rPr>
+                                            <m:brk m:alnAt="7"/>
+                                          </m:rPr>
+                                          <a:rPr lang="en-US" b="0" i="1" smtClean="0">
+                                            <a:latin typeface="Cambria Math" panose="02040503050406030204" pitchFamily="18" charset="0"/>
+                                          </a:rPr>
+                                          <m:t>𝑡</m:t>
+                                        </m:r>
+                                      </m:e>
+                                    </m:d>
+                                    <m:r>
+                                      <m:rPr>
+                                        <m:brk m:alnAt="7"/>
+                                      </m:rPr>
+                                      <a:rPr lang="en-US" b="0" i="1" smtClean="0">
+                                        <a:latin typeface="Cambria Math" panose="02040503050406030204" pitchFamily="18" charset="0"/>
+                                      </a:rPr>
+                                      <m:t>−</m:t>
+                                    </m:r>
+                                    <m:sSub>
+                                      <m:sSubPr>
+                                        <m:ctrlPr>
+                                          <a:rPr lang="en-US" b="0" i="1" smtClean="0">
+                                            <a:latin typeface="Cambria Math" panose="02040503050406030204" pitchFamily="18" charset="0"/>
+                                          </a:rPr>
+                                        </m:ctrlPr>
+                                      </m:sSubPr>
+                                      <m:e>
+                                        <m:r>
+                                          <m:rPr>
+                                            <m:brk m:alnAt="7"/>
+                                          </m:rPr>
+                                          <a:rPr lang="en-US" b="0" i="1" smtClean="0">
+                                            <a:latin typeface="Cambria Math" panose="02040503050406030204" pitchFamily="18" charset="0"/>
+                                          </a:rPr>
+                                          <m:t>𝑣</m:t>
+                                        </m:r>
+                                      </m:e>
+                                      <m:sub>
+                                        <m:r>
+                                          <m:rPr>
+                                            <m:brk m:alnAt="7"/>
+                                          </m:rPr>
+                                          <a:rPr lang="en-US" b="0" i="1" smtClean="0">
+                                            <a:latin typeface="Cambria Math" panose="02040503050406030204" pitchFamily="18" charset="0"/>
+                                          </a:rPr>
+                                          <m:t>𝑐</m:t>
+                                        </m:r>
+                                      </m:sub>
+                                    </m:sSub>
+                                    <m:r>
+                                      <m:rPr>
+                                        <m:brk m:alnAt="7"/>
+                                      </m:rPr>
+                                      <a:rPr lang="en-US" b="0" i="1" smtClean="0">
+                                        <a:latin typeface="Cambria Math" panose="02040503050406030204" pitchFamily="18" charset="0"/>
+                                      </a:rPr>
+                                      <m:t>(</m:t>
+                                    </m:r>
+                                    <m:r>
+                                      <a:rPr lang="en-US" b="0" i="1" smtClean="0">
+                                        <a:latin typeface="Cambria Math" panose="02040503050406030204" pitchFamily="18" charset="0"/>
+                                      </a:rPr>
+                                      <m:t>𝑡</m:t>
+                                    </m:r>
+                                    <m:r>
+                                      <a:rPr lang="en-US" b="0" i="1" smtClean="0">
+                                        <a:latin typeface="Cambria Math" panose="02040503050406030204" pitchFamily="18" charset="0"/>
+                                      </a:rPr>
+                                      <m:t>)</m:t>
+                                    </m:r>
+                                  </m:e>
+                                </m:d>
+                              </m:e>
+                            </m:mr>
+                            <m:mr>
+                              <m:e>
+                                <m:f>
+                                  <m:fPr>
+                                    <m:ctrlPr>
+                                      <a:rPr lang="en-US" b="0" i="1" smtClean="0">
+                                        <a:latin typeface="Cambria Math" panose="02040503050406030204" pitchFamily="18" charset="0"/>
+                                      </a:rPr>
+                                    </m:ctrlPr>
+                                  </m:fPr>
+                                  <m:num>
+                                    <m:r>
+                                      <a:rPr lang="en-US" b="0" i="1" smtClean="0">
+                                        <a:latin typeface="Cambria Math" panose="02040503050406030204" pitchFamily="18" charset="0"/>
+                                      </a:rPr>
+                                      <m:t>1</m:t>
+                                    </m:r>
+                                  </m:num>
+                                  <m:den>
+                                    <m:r>
+                                      <a:rPr lang="en-US" b="0" i="1" smtClean="0">
+                                        <a:latin typeface="Cambria Math" panose="02040503050406030204" pitchFamily="18" charset="0"/>
+                                      </a:rPr>
+                                      <m:t>𝐶</m:t>
+                                    </m:r>
+                                  </m:den>
+                                </m:f>
+                                <m:r>
+                                  <a:rPr lang="en-US" b="0" i="1" smtClean="0">
+                                    <a:latin typeface="Cambria Math" panose="02040503050406030204" pitchFamily="18" charset="0"/>
+                                  </a:rPr>
+                                  <m:t>∗</m:t>
+                                </m:r>
+                                <m:r>
+                                  <a:rPr lang="en-US" b="0" i="1" smtClean="0">
+                                    <a:latin typeface="Cambria Math" panose="02040503050406030204" pitchFamily="18" charset="0"/>
+                                  </a:rPr>
+                                  <m:t>𝑖</m:t>
+                                </m:r>
+                                <m:d>
+                                  <m:dPr>
+                                    <m:ctrlPr>
+                                      <a:rPr lang="en-US" b="0" i="1" smtClean="0">
+                                        <a:latin typeface="Cambria Math" panose="02040503050406030204" pitchFamily="18" charset="0"/>
+                                      </a:rPr>
+                                    </m:ctrlPr>
+                                  </m:dPr>
+                                  <m:e>
+                                    <m:r>
+                                      <a:rPr lang="en-US" b="0" i="1" smtClean="0">
+                                        <a:latin typeface="Cambria Math" panose="02040503050406030204" pitchFamily="18" charset="0"/>
+                                      </a:rPr>
+                                      <m:t>𝑡</m:t>
+                                    </m:r>
+                                  </m:e>
+                                </m:d>
+                              </m:e>
+                            </m:mr>
+                          </m:m>
+                        </m:e>
+                      </m:d>
+                    </m:oMath>
+                  </m:oMathPara>
+                </a14:m>
+                <a:endParaRPr lang="en-US" dirty="0"/>
+              </a:p>
+              <a:p>
+                <a14:m>
+                  <m:oMathPara xmlns:m="http://schemas.openxmlformats.org/officeDocument/2006/math">
+                    <m:oMathParaPr>
+                      <m:jc m:val="centerGroup"/>
+                    </m:oMathParaPr>
+                    <m:oMath xmlns:m="http://schemas.openxmlformats.org/officeDocument/2006/math">
+                      <m:sSub>
+                        <m:sSubPr>
+                          <m:ctrlPr>
+                            <a:rPr lang="en-US" b="0" i="1" smtClean="0">
+                              <a:latin typeface="Cambria Math" panose="02040503050406030204" pitchFamily="18" charset="0"/>
+                            </a:rPr>
+                          </m:ctrlPr>
+                        </m:sSubPr>
+                        <m:e>
+                          <m:r>
+                            <a:rPr lang="en-US" b="0" i="1" smtClean="0">
+                              <a:latin typeface="Cambria Math" panose="02040503050406030204" pitchFamily="18" charset="0"/>
+                            </a:rPr>
+                            <m:t>𝑖</m:t>
+                          </m:r>
+                        </m:e>
+                        <m:sub>
+                          <m:r>
+                            <a:rPr lang="en-US" b="0" i="1" smtClean="0">
+                              <a:latin typeface="Cambria Math" panose="02040503050406030204" pitchFamily="18" charset="0"/>
+                            </a:rPr>
+                            <m:t>𝑏𝑎𝑡</m:t>
+                          </m:r>
+                        </m:sub>
+                      </m:sSub>
+                      <m:r>
+                        <a:rPr lang="en-US" b="0" i="1" smtClean="0">
+                          <a:latin typeface="Cambria Math" panose="02040503050406030204" pitchFamily="18" charset="0"/>
+                        </a:rPr>
+                        <m:t>=</m:t>
+                      </m:r>
+                      <m:r>
+                        <a:rPr lang="en-US" b="0" i="1" smtClean="0">
+                          <a:latin typeface="Cambria Math" panose="02040503050406030204" pitchFamily="18" charset="0"/>
+                        </a:rPr>
+                        <m:t>𝑀</m:t>
+                      </m:r>
+                      <m:d>
+                        <m:dPr>
+                          <m:ctrlPr>
+                            <a:rPr lang="en-US" b="0" i="1" smtClean="0">
+                              <a:latin typeface="Cambria Math" panose="02040503050406030204" pitchFamily="18" charset="0"/>
+                            </a:rPr>
+                          </m:ctrlPr>
+                        </m:dPr>
+                        <m:e>
+                          <m:r>
+                            <a:rPr lang="en-US" b="0" i="1" smtClean="0">
+                              <a:latin typeface="Cambria Math" panose="02040503050406030204" pitchFamily="18" charset="0"/>
+                            </a:rPr>
+                            <m:t>𝑡</m:t>
+                          </m:r>
+                        </m:e>
+                      </m:d>
+                      <m:r>
+                        <a:rPr lang="en-US" b="0" i="1" smtClean="0">
+                          <a:latin typeface="Cambria Math" panose="02040503050406030204" pitchFamily="18" charset="0"/>
+                        </a:rPr>
+                        <m:t>∗</m:t>
+                      </m:r>
+                      <m:r>
+                        <a:rPr lang="en-US" b="0" i="1" smtClean="0">
+                          <a:latin typeface="Cambria Math" panose="02040503050406030204" pitchFamily="18" charset="0"/>
+                        </a:rPr>
+                        <m:t>𝑖</m:t>
+                      </m:r>
+                      <m:d>
+                        <m:dPr>
+                          <m:ctrlPr>
+                            <a:rPr lang="en-US" b="0" i="1" smtClean="0">
+                              <a:latin typeface="Cambria Math" panose="02040503050406030204" pitchFamily="18" charset="0"/>
+                            </a:rPr>
+                          </m:ctrlPr>
+                        </m:dPr>
+                        <m:e>
+                          <m:r>
+                            <a:rPr lang="en-US" b="0" i="1" smtClean="0">
+                              <a:latin typeface="Cambria Math" panose="02040503050406030204" pitchFamily="18" charset="0"/>
+                            </a:rPr>
+                            <m:t>𝑡</m:t>
+                          </m:r>
+                        </m:e>
+                      </m:d>
+                    </m:oMath>
+                  </m:oMathPara>
+                </a14:m>
+                <a:endParaRPr lang="en-US" dirty="0"/>
+              </a:p>
+              <a:p>
+                <a:r>
+                  <a:rPr lang="en-US" dirty="0"/>
+                  <a:t>Note the combination of state variables into a </a:t>
+                </a:r>
+                <a:r>
+                  <a:rPr lang="en-US" u="sng" dirty="0"/>
+                  <a:t>state vector</a:t>
+                </a:r>
+                <a:r>
+                  <a:rPr lang="en-US" dirty="0"/>
+                  <a:t> – this forms the </a:t>
+                </a:r>
+                <a:r>
+                  <a:rPr lang="en-US" u="sng" dirty="0"/>
+                  <a:t>state-space model</a:t>
+                </a:r>
+                <a:r>
+                  <a:rPr lang="en-US" dirty="0"/>
+                  <a:t>. Take integral of both sides of first equation to arrive at new mathematical model of system (bottom image)</a:t>
+                </a:r>
+              </a:p>
+            </p:txBody>
+          </p:sp>
+        </mc:Choice>
+        <mc:Fallback>
+          <p:sp>
+            <p:nvSpPr>
+              <p:cNvPr id="6" name="TextBox 5">
+                <a:extLst>
+                  <a:ext uri="{FF2B5EF4-FFF2-40B4-BE49-F238E27FC236}">
+                    <a16:creationId xmlns:a16="http://schemas.microsoft.com/office/drawing/2014/main" id="{2233ADD0-2087-A2FE-E2E7-DD4FBE4B3985}"/>
+                  </a:ext>
+                </a:extLst>
+              </p:cNvPr>
+              <p:cNvSpPr txBox="1">
+                <a:spLocks noRot="1" noChangeAspect="1" noMove="1" noResize="1" noEditPoints="1" noAdjustHandles="1" noChangeArrowheads="1" noChangeShapeType="1" noTextEdit="1"/>
+              </p:cNvSpPr>
+              <p:nvPr/>
+            </p:nvSpPr>
+            <p:spPr>
+              <a:xfrm>
+                <a:off x="1039104" y="1488281"/>
+                <a:ext cx="6627078" cy="4442306"/>
+              </a:xfrm>
+              <a:prstGeom prst="rect">
+                <a:avLst/>
+              </a:prstGeom>
+              <a:blipFill>
+                <a:blip r:embed="rId3"/>
+                <a:stretch>
+                  <a:fillRect l="-735" t="-549" b="-1235"/>
+                </a:stretch>
+              </a:blipFill>
+            </p:spPr>
+            <p:txBody>
+              <a:bodyPr/>
+              <a:lstStyle/>
+              <a:p>
+                <a:r>
+                  <a:rPr lang="en-US">
+                    <a:noFill/>
+                  </a:rPr>
+                  <a:t> </a:t>
+                </a:r>
+              </a:p>
+            </p:txBody>
+          </p:sp>
+        </mc:Fallback>
+      </mc:AlternateContent>
+      <p:pic>
+        <p:nvPicPr>
+          <p:cNvPr id="8" name="Picture 7">
+            <a:extLst>
+              <a:ext uri="{FF2B5EF4-FFF2-40B4-BE49-F238E27FC236}">
+                <a16:creationId xmlns:a16="http://schemas.microsoft.com/office/drawing/2014/main" id="{D3347C35-645C-E016-AFB9-9650585E8019}"/>
+              </a:ext>
+            </a:extLst>
+          </p:cNvPr>
+          <p:cNvPicPr>
+            <a:picLocks noChangeAspect="1"/>
+          </p:cNvPicPr>
+          <p:nvPr/>
+        </p:nvPicPr>
+        <p:blipFill>
+          <a:blip r:embed="rId4"/>
+          <a:stretch>
+            <a:fillRect/>
+          </a:stretch>
+        </p:blipFill>
+        <p:spPr>
+          <a:xfrm>
+            <a:off x="7804742" y="1406610"/>
+            <a:ext cx="3832732" cy="1537266"/>
+          </a:xfrm>
+          <a:prstGeom prst="rect">
+            <a:avLst/>
+          </a:prstGeom>
+        </p:spPr>
+      </p:pic>
+      <p:cxnSp>
+        <p:nvCxnSpPr>
+          <p:cNvPr id="10" name="Straight Arrow Connector 9">
+            <a:extLst>
+              <a:ext uri="{FF2B5EF4-FFF2-40B4-BE49-F238E27FC236}">
+                <a16:creationId xmlns:a16="http://schemas.microsoft.com/office/drawing/2014/main" id="{01E412F2-5169-E401-2D71-3FBB778DAC61}"/>
+              </a:ext>
+            </a:extLst>
+          </p:cNvPr>
+          <p:cNvCxnSpPr>
+            <a:stCxn id="8" idx="2"/>
+            <a:endCxn id="5" idx="0"/>
+          </p:cNvCxnSpPr>
+          <p:nvPr/>
+        </p:nvCxnSpPr>
+        <p:spPr>
+          <a:xfrm>
+            <a:off x="9721108" y="2943876"/>
+            <a:ext cx="0" cy="485124"/>
+          </a:xfrm>
+          <a:prstGeom prst="straightConnector1">
+            <a:avLst/>
+          </a:prstGeom>
+          <a:ln w="38100">
+            <a:solidFill>
+              <a:schemeClr val="tx1"/>
+            </a:solidFill>
+            <a:tailEnd type="triangle"/>
+          </a:ln>
+        </p:spPr>
+        <p:style>
+          <a:lnRef idx="2">
+            <a:schemeClr val="accent1"/>
+          </a:lnRef>
+          <a:fillRef idx="0">
+            <a:schemeClr val="accent1"/>
+          </a:fillRef>
+          <a:effectRef idx="1">
+            <a:schemeClr val="accent1"/>
+          </a:effectRef>
+          <a:fontRef idx="minor">
+            <a:schemeClr val="tx1"/>
+          </a:fontRef>
+        </p:style>
+      </p:cxnSp>
+      <p:sp>
+        <p:nvSpPr>
+          <p:cNvPr id="11" name="Callout: Bent Line 10">
+            <a:extLst>
+              <a:ext uri="{FF2B5EF4-FFF2-40B4-BE49-F238E27FC236}">
+                <a16:creationId xmlns:a16="http://schemas.microsoft.com/office/drawing/2014/main" id="{86CF0671-1006-38CC-3DD7-11D6DD8FCCB9}"/>
+              </a:ext>
+            </a:extLst>
+          </p:cNvPr>
+          <p:cNvSpPr/>
+          <p:nvPr/>
+        </p:nvSpPr>
+        <p:spPr>
+          <a:xfrm>
+            <a:off x="10243127" y="4008582"/>
+            <a:ext cx="831273" cy="369454"/>
+          </a:xfrm>
+          <a:prstGeom prst="borderCallout2">
+            <a:avLst>
+              <a:gd name="adj1" fmla="val 18750"/>
+              <a:gd name="adj2" fmla="val -8333"/>
+              <a:gd name="adj3" fmla="val 18750"/>
+              <a:gd name="adj4" fmla="val -16667"/>
+              <a:gd name="adj5" fmla="val 140000"/>
+              <a:gd name="adj6" fmla="val -47778"/>
+            </a:avLst>
+          </a:prstGeom>
+          <a:solidFill>
+            <a:schemeClr val="bg1"/>
+          </a:solidFill>
+          <a:ln>
+            <a:solidFill>
+              <a:schemeClr val="tx1"/>
+            </a:solidFill>
+          </a:ln>
+        </p:spPr>
+        <p:style>
+          <a:lnRef idx="2">
+            <a:schemeClr val="accent1">
+              <a:shade val="15000"/>
+            </a:schemeClr>
+          </a:lnRef>
+          <a:fillRef idx="1">
+            <a:schemeClr val="accent1"/>
+          </a:fillRef>
+          <a:effectRef idx="0">
+            <a:schemeClr val="accent1"/>
+          </a:effectRef>
+          <a:fontRef idx="minor">
+            <a:schemeClr val="lt1"/>
+          </a:fontRef>
+        </p:style>
+        <p:txBody>
+          <a:bodyPr rtlCol="0" anchor="ctr"/>
+          <a:lstStyle/>
+          <a:p>
+            <a:pPr algn="ctr"/>
+            <a:r>
+              <a:rPr lang="en-US" dirty="0"/>
+              <a:t>KVL</a:t>
+            </a:r>
+          </a:p>
+        </p:txBody>
+      </p:sp>
     </p:spTree>
     <p:extLst>
       <p:ext uri="{BB962C8B-B14F-4D97-AF65-F5344CB8AC3E}">
@@ -19150,145 +20475,133 @@
   <p:clrMapOvr>
     <a:masterClrMapping/>
   </p:clrMapOvr>
-  <p:timing>
-    <p:tnLst>
-      <p:par>
-        <p:cTn id="1" dur="indefinite" restart="never" nodeType="tmRoot">
-          <p:childTnLst>
-            <p:seq concurrent="1" nextAc="seek">
-              <p:cTn id="2" dur="indefinite" nodeType="mainSeq">
-                <p:childTnLst>
-                  <p:par>
-                    <p:cTn id="3" fill="hold">
-                      <p:stCondLst>
-                        <p:cond delay="indefinite"/>
-                      </p:stCondLst>
-                      <p:childTnLst>
-                        <p:par>
-                          <p:cTn id="4" fill="hold">
-                            <p:stCondLst>
-                              <p:cond delay="0"/>
-                            </p:stCondLst>
-                            <p:childTnLst>
-                              <p:par>
-                                <p:cTn id="5" presetID="1" presetClass="mediacall" presetSubtype="0" fill="hold" nodeType="clickEffect">
-                                  <p:stCondLst>
-                                    <p:cond delay="0"/>
-                                  </p:stCondLst>
-                                  <p:childTnLst>
-                                    <p:cmd type="call" cmd="playFrom(0.0)">
-                                      <p:cBhvr>
-                                        <p:cTn id="6" dur="1" fill="hold"/>
-                                        <p:tgtEl>
-                                          <p:spTgt spid="3"/>
-                                        </p:tgtEl>
-                                      </p:cBhvr>
-                                    </p:cmd>
-                                  </p:childTnLst>
-                                </p:cTn>
-                              </p:par>
-                            </p:childTnLst>
-                          </p:cTn>
-                        </p:par>
-                      </p:childTnLst>
-                    </p:cTn>
-                  </p:par>
-                </p:childTnLst>
-              </p:cTn>
-              <p:prevCondLst>
-                <p:cond evt="onPrev" delay="0">
-                  <p:tgtEl>
-                    <p:sldTgt/>
-                  </p:tgtEl>
-                </p:cond>
-              </p:prevCondLst>
-              <p:nextCondLst>
-                <p:cond evt="onNext" delay="0">
-                  <p:tgtEl>
-                    <p:sldTgt/>
-                  </p:tgtEl>
-                </p:cond>
-              </p:nextCondLst>
-            </p:seq>
-            <p:video>
-              <p:cMediaNode vol="80000">
-                <p:cTn id="7" fill="hold" display="0">
-                  <p:stCondLst>
-                    <p:cond delay="indefinite"/>
-                  </p:stCondLst>
-                </p:cTn>
-                <p:tgtEl>
-                  <p:spTgt spid="3"/>
-                </p:tgtEl>
-              </p:cMediaNode>
-            </p:video>
-            <p:seq concurrent="1" nextAc="seek">
-              <p:cTn id="8" restart="whenNotActive" fill="hold" evtFilter="cancelBubble" nodeType="interactiveSeq">
-                <p:stCondLst>
-                  <p:cond evt="onClick" delay="0">
-                    <p:tgtEl>
-                      <p:spTgt spid="3"/>
-                    </p:tgtEl>
-                  </p:cond>
-                </p:stCondLst>
-                <p:endSync evt="end" delay="0">
-                  <p:rtn val="all"/>
-                </p:endSync>
-                <p:childTnLst>
-                  <p:par>
-                    <p:cTn id="9" fill="hold">
-                      <p:stCondLst>
-                        <p:cond delay="0"/>
-                      </p:stCondLst>
-                      <p:childTnLst>
-                        <p:par>
-                          <p:cTn id="10" fill="hold">
-                            <p:stCondLst>
-                              <p:cond delay="0"/>
-                            </p:stCondLst>
-                            <p:childTnLst>
-                              <p:par>
-                                <p:cTn id="11" presetID="2" presetClass="mediacall" presetSubtype="0" fill="hold" nodeType="clickEffect">
-                                  <p:stCondLst>
-                                    <p:cond delay="0"/>
-                                  </p:stCondLst>
-                                  <p:childTnLst>
-                                    <p:cmd type="call" cmd="togglePause">
-                                      <p:cBhvr>
-                                        <p:cTn id="12" dur="1" fill="hold"/>
-                                        <p:tgtEl>
-                                          <p:spTgt spid="3"/>
-                                        </p:tgtEl>
-                                      </p:cBhvr>
-                                    </p:cmd>
-                                  </p:childTnLst>
-                                </p:cTn>
-                              </p:par>
-                            </p:childTnLst>
-                          </p:cTn>
-                        </p:par>
-                      </p:childTnLst>
-                    </p:cTn>
-                  </p:par>
-                </p:childTnLst>
-              </p:cTn>
-              <p:nextCondLst>
-                <p:cond evt="onClick" delay="0">
-                  <p:tgtEl>
-                    <p:spTgt spid="3"/>
-                  </p:tgtEl>
-                </p:cond>
-              </p:nextCondLst>
-            </p:seq>
-          </p:childTnLst>
-        </p:cTn>
-      </p:par>
-    </p:tnLst>
-  </p:timing>
 </p:sld>
 </file>
 
 <file path=ppt/slides/slide24.xml><?xml version="1.0" encoding="utf-8"?>
+<p:sld xmlns:a="http://schemas.openxmlformats.org/drawingml/2006/main" xmlns:r="http://schemas.openxmlformats.org/officeDocument/2006/relationships" xmlns:p="http://schemas.openxmlformats.org/presentationml/2006/main">
+  <p:cSld>
+    <p:spTree>
+      <p:nvGrpSpPr>
+        <p:cNvPr id="1" name=""/>
+        <p:cNvGrpSpPr/>
+        <p:nvPr/>
+      </p:nvGrpSpPr>
+      <p:grpSpPr>
+        <a:xfrm>
+          <a:off x="0" y="0"/>
+          <a:ext cx="0" cy="0"/>
+          <a:chOff x="0" y="0"/>
+          <a:chExt cx="0" cy="0"/>
+        </a:xfrm>
+      </p:grpSpPr>
+      <p:sp>
+        <p:nvSpPr>
+          <p:cNvPr id="2" name="Title 1">
+            <a:extLst>
+              <a:ext uri="{FF2B5EF4-FFF2-40B4-BE49-F238E27FC236}">
+                <a16:creationId xmlns:a16="http://schemas.microsoft.com/office/drawing/2014/main" id="{2F50CA32-3921-CC71-956F-CEAD974A5A41}"/>
+              </a:ext>
+            </a:extLst>
+          </p:cNvPr>
+          <p:cNvSpPr>
+            <a:spLocks noGrp="1"/>
+          </p:cNvSpPr>
+          <p:nvPr>
+            <p:ph type="title"/>
+          </p:nvPr>
+        </p:nvSpPr>
+        <p:spPr/>
+        <p:txBody>
+          <a:bodyPr/>
+          <a:lstStyle/>
+          <a:p>
+            <a:r>
+              <a:rPr lang="en-US" dirty="0"/>
+              <a:t>New Time-Domain Simulation (0&lt;t&lt;100)</a:t>
+            </a:r>
+          </a:p>
+        </p:txBody>
+      </p:sp>
+      <p:pic>
+        <p:nvPicPr>
+          <p:cNvPr id="4" name="Picture 3">
+            <a:extLst>
+              <a:ext uri="{FF2B5EF4-FFF2-40B4-BE49-F238E27FC236}">
+                <a16:creationId xmlns:a16="http://schemas.microsoft.com/office/drawing/2014/main" id="{5373C478-8297-CC13-E1AD-2FF93FBAF58A}"/>
+              </a:ext>
+            </a:extLst>
+          </p:cNvPr>
+          <p:cNvPicPr>
+            <a:picLocks noChangeAspect="1"/>
+          </p:cNvPicPr>
+          <p:nvPr/>
+        </p:nvPicPr>
+        <p:blipFill>
+          <a:blip r:embed="rId2"/>
+          <a:stretch>
+            <a:fillRect/>
+          </a:stretch>
+        </p:blipFill>
+        <p:spPr>
+          <a:xfrm>
+            <a:off x="960922" y="1690688"/>
+            <a:ext cx="10270156" cy="4100558"/>
+          </a:xfrm>
+          <a:prstGeom prst="rect">
+            <a:avLst/>
+          </a:prstGeom>
+        </p:spPr>
+      </p:pic>
+      <p:sp>
+        <p:nvSpPr>
+          <p:cNvPr id="5" name="TextBox 4">
+            <a:extLst>
+              <a:ext uri="{FF2B5EF4-FFF2-40B4-BE49-F238E27FC236}">
+                <a16:creationId xmlns:a16="http://schemas.microsoft.com/office/drawing/2014/main" id="{0D8E6D70-4DF5-09F4-3DE4-9E9A003BD61D}"/>
+              </a:ext>
+            </a:extLst>
+          </p:cNvPr>
+          <p:cNvSpPr txBox="1"/>
+          <p:nvPr/>
+        </p:nvSpPr>
+        <p:spPr>
+          <a:xfrm>
+            <a:off x="4073587" y="5890661"/>
+            <a:ext cx="4044825" cy="369332"/>
+          </a:xfrm>
+          <a:prstGeom prst="rect">
+            <a:avLst/>
+          </a:prstGeom>
+          <a:noFill/>
+        </p:spPr>
+        <p:txBody>
+          <a:bodyPr wrap="none" rtlCol="0">
+            <a:spAutoFit/>
+          </a:bodyPr>
+          <a:lstStyle/>
+          <a:p>
+            <a:r>
+              <a:rPr lang="en-US" dirty="0"/>
+              <a:t>With this new model, everything works!</a:t>
+            </a:r>
+          </a:p>
+        </p:txBody>
+      </p:sp>
+    </p:spTree>
+    <p:extLst>
+      <p:ext uri="{BB962C8B-B14F-4D97-AF65-F5344CB8AC3E}">
+        <p14:creationId xmlns:p14="http://schemas.microsoft.com/office/powerpoint/2010/main" val="1837795743"/>
+      </p:ext>
+    </p:extLst>
+  </p:cSld>
+  <p:clrMapOvr>
+    <a:masterClrMapping/>
+  </p:clrMapOvr>
+</p:sld>
+</file>
+
+<file path=ppt/slides/slide25.xml><?xml version="1.0" encoding="utf-8"?>
 <p:sld xmlns:a="http://schemas.openxmlformats.org/drawingml/2006/main" xmlns:r="http://schemas.openxmlformats.org/officeDocument/2006/relationships" xmlns:p="http://schemas.openxmlformats.org/presentationml/2006/main">
   <p:cSld>
     <p:spTree>
@@ -19743,7 +21056,7 @@
 </p:sld>
 </file>
 
-<file path=ppt/slides/slide25.xml><?xml version="1.0" encoding="utf-8"?>
+<file path=ppt/slides/slide26.xml><?xml version="1.0" encoding="utf-8"?>
 <p:sld xmlns:a="http://schemas.openxmlformats.org/drawingml/2006/main" xmlns:r="http://schemas.openxmlformats.org/officeDocument/2006/relationships" xmlns:p="http://schemas.openxmlformats.org/presentationml/2006/main">
   <p:cSld>
     <p:spTree>
@@ -19843,7 +21156,7 @@
 </p:sld>
 </file>
 
-<file path=ppt/slides/slide26.xml><?xml version="1.0" encoding="utf-8"?>
+<file path=ppt/slides/slide27.xml><?xml version="1.0" encoding="utf-8"?>
 <p:sld xmlns:a="http://schemas.openxmlformats.org/drawingml/2006/main" xmlns:r="http://schemas.openxmlformats.org/officeDocument/2006/relationships" xmlns:p="http://schemas.openxmlformats.org/presentationml/2006/main">
   <p:cSld>
     <p:spTree>
@@ -22033,7 +23346,7 @@
 </p:sld>
 </file>
 
-<file path=ppt/slides/slide27.xml><?xml version="1.0" encoding="utf-8"?>
+<file path=ppt/slides/slide28.xml><?xml version="1.0" encoding="utf-8"?>
 <p:sld xmlns:a="http://schemas.openxmlformats.org/drawingml/2006/main" xmlns:r="http://schemas.openxmlformats.org/officeDocument/2006/relationships" xmlns:p="http://schemas.openxmlformats.org/presentationml/2006/main">
   <p:cSld>
     <p:spTree>
@@ -26553,7 +27866,7 @@
 </p:sld>
 </file>
 
-<file path=ppt/slides/slide28.xml><?xml version="1.0" encoding="utf-8"?>
+<file path=ppt/slides/slide29.xml><?xml version="1.0" encoding="utf-8"?>
 <p:sld xmlns:a="http://schemas.openxmlformats.org/drawingml/2006/main" xmlns:r="http://schemas.openxmlformats.org/officeDocument/2006/relationships" xmlns:p="http://schemas.openxmlformats.org/presentationml/2006/main">
   <p:cSld>
     <p:spTree>
@@ -29863,7 +31176,157 @@
 </p:sld>
 </file>
 
-<file path=ppt/slides/slide29.xml><?xml version="1.0" encoding="utf-8"?>
+<file path=ppt/slides/slide3.xml><?xml version="1.0" encoding="utf-8"?>
+<p:sld xmlns:a="http://schemas.openxmlformats.org/drawingml/2006/main" xmlns:r="http://schemas.openxmlformats.org/officeDocument/2006/relationships" xmlns:p="http://schemas.openxmlformats.org/presentationml/2006/main">
+  <p:cSld>
+    <p:spTree>
+      <p:nvGrpSpPr>
+        <p:cNvPr id="1" name=""/>
+        <p:cNvGrpSpPr/>
+        <p:nvPr/>
+      </p:nvGrpSpPr>
+      <p:grpSpPr>
+        <a:xfrm>
+          <a:off x="0" y="0"/>
+          <a:ext cx="0" cy="0"/>
+          <a:chOff x="0" y="0"/>
+          <a:chExt cx="0" cy="0"/>
+        </a:xfrm>
+      </p:grpSpPr>
+      <p:sp>
+        <p:nvSpPr>
+          <p:cNvPr id="2" name="Title 1">
+            <a:extLst>
+              <a:ext uri="{FF2B5EF4-FFF2-40B4-BE49-F238E27FC236}">
+                <a16:creationId xmlns:a16="http://schemas.microsoft.com/office/drawing/2014/main" id="{BC075C05-D53A-EB7B-0259-F9E892597A12}"/>
+              </a:ext>
+            </a:extLst>
+          </p:cNvPr>
+          <p:cNvSpPr>
+            <a:spLocks noGrp="1"/>
+          </p:cNvSpPr>
+          <p:nvPr>
+            <p:ph type="title"/>
+          </p:nvPr>
+        </p:nvSpPr>
+        <p:spPr/>
+        <p:txBody>
+          <a:bodyPr/>
+          <a:lstStyle/>
+          <a:p>
+            <a:r>
+              <a:rPr lang="en-US" dirty="0"/>
+              <a:t>List of Topics Relevant to This Presentation</a:t>
+            </a:r>
+          </a:p>
+        </p:txBody>
+      </p:sp>
+      <p:sp>
+        <p:nvSpPr>
+          <p:cNvPr id="3" name="Content Placeholder 2">
+            <a:extLst>
+              <a:ext uri="{FF2B5EF4-FFF2-40B4-BE49-F238E27FC236}">
+                <a16:creationId xmlns:a16="http://schemas.microsoft.com/office/drawing/2014/main" id="{A04F342F-E6CE-DD03-4519-3357C6F9C431}"/>
+              </a:ext>
+            </a:extLst>
+          </p:cNvPr>
+          <p:cNvSpPr>
+            <a:spLocks noGrp="1"/>
+          </p:cNvSpPr>
+          <p:nvPr>
+            <p:ph idx="1"/>
+          </p:nvPr>
+        </p:nvSpPr>
+        <p:spPr/>
+        <p:txBody>
+          <a:bodyPr>
+            <a:normAutofit fontScale="92500" lnSpcReduction="10000"/>
+          </a:bodyPr>
+          <a:lstStyle/>
+          <a:p>
+            <a:pPr marL="0" indent="0">
+              <a:buNone/>
+            </a:pPr>
+            <a:r>
+              <a:rPr lang="en-US" dirty="0"/>
+              <a:t>Make sure you have at least basic knowledge of these concepts so that you can understand the content in this presentation:</a:t>
+            </a:r>
+          </a:p>
+          <a:p>
+            <a:r>
+              <a:rPr lang="en-US" dirty="0"/>
+              <a:t>SRA calculations</a:t>
+            </a:r>
+          </a:p>
+          <a:p>
+            <a:r>
+              <a:rPr lang="en-US" dirty="0"/>
+              <a:t>Ideal transformer modeling</a:t>
+            </a:r>
+          </a:p>
+          <a:p>
+            <a:r>
+              <a:rPr lang="en-US" dirty="0"/>
+              <a:t>Laplace transforms</a:t>
+            </a:r>
+          </a:p>
+          <a:p>
+            <a:r>
+              <a:rPr lang="en-US" dirty="0"/>
+              <a:t>Transfer functions and closed-loop systems</a:t>
+            </a:r>
+          </a:p>
+          <a:p>
+            <a:pPr marL="0" indent="0">
+              <a:buNone/>
+            </a:pPr>
+            <a:r>
+              <a:rPr lang="en-US" dirty="0"/>
+              <a:t>Make sure you are </a:t>
+            </a:r>
+            <a:r>
+              <a:rPr lang="en-US" b="1" dirty="0"/>
+              <a:t>very familiar </a:t>
+            </a:r>
+            <a:r>
+              <a:rPr lang="en-US" dirty="0"/>
+              <a:t>with these concepts:</a:t>
+            </a:r>
+          </a:p>
+          <a:p>
+            <a:r>
+              <a:rPr lang="en-US" dirty="0"/>
+              <a:t>KVL and KCL</a:t>
+            </a:r>
+          </a:p>
+          <a:p>
+            <a:r>
+              <a:rPr lang="en-US" dirty="0"/>
+              <a:t>Algebraic manipulation</a:t>
+            </a:r>
+          </a:p>
+          <a:p>
+            <a:r>
+              <a:rPr lang="en-US" dirty="0"/>
+              <a:t>Differential and integral calculus</a:t>
+            </a:r>
+          </a:p>
+        </p:txBody>
+      </p:sp>
+    </p:spTree>
+    <p:extLst>
+      <p:ext uri="{BB962C8B-B14F-4D97-AF65-F5344CB8AC3E}">
+        <p14:creationId xmlns:p14="http://schemas.microsoft.com/office/powerpoint/2010/main" val="3259269306"/>
+      </p:ext>
+    </p:extLst>
+  </p:cSld>
+  <p:clrMapOvr>
+    <a:masterClrMapping/>
+  </p:clrMapOvr>
+</p:sld>
+</file>
+
+<file path=ppt/slides/slide30.xml><?xml version="1.0" encoding="utf-8"?>
 <p:sld xmlns:a="http://schemas.openxmlformats.org/drawingml/2006/main" xmlns:r="http://schemas.openxmlformats.org/officeDocument/2006/relationships" xmlns:p="http://schemas.openxmlformats.org/presentationml/2006/main">
   <p:cSld>
     <p:spTree>
@@ -30607,157 +32070,7 @@
 </p:sld>
 </file>
 
-<file path=ppt/slides/slide3.xml><?xml version="1.0" encoding="utf-8"?>
-<p:sld xmlns:a="http://schemas.openxmlformats.org/drawingml/2006/main" xmlns:r="http://schemas.openxmlformats.org/officeDocument/2006/relationships" xmlns:p="http://schemas.openxmlformats.org/presentationml/2006/main">
-  <p:cSld>
-    <p:spTree>
-      <p:nvGrpSpPr>
-        <p:cNvPr id="1" name=""/>
-        <p:cNvGrpSpPr/>
-        <p:nvPr/>
-      </p:nvGrpSpPr>
-      <p:grpSpPr>
-        <a:xfrm>
-          <a:off x="0" y="0"/>
-          <a:ext cx="0" cy="0"/>
-          <a:chOff x="0" y="0"/>
-          <a:chExt cx="0" cy="0"/>
-        </a:xfrm>
-      </p:grpSpPr>
-      <p:sp>
-        <p:nvSpPr>
-          <p:cNvPr id="2" name="Title 1">
-            <a:extLst>
-              <a:ext uri="{FF2B5EF4-FFF2-40B4-BE49-F238E27FC236}">
-                <a16:creationId xmlns:a16="http://schemas.microsoft.com/office/drawing/2014/main" id="{BC075C05-D53A-EB7B-0259-F9E892597A12}"/>
-              </a:ext>
-            </a:extLst>
-          </p:cNvPr>
-          <p:cNvSpPr>
-            <a:spLocks noGrp="1"/>
-          </p:cNvSpPr>
-          <p:nvPr>
-            <p:ph type="title"/>
-          </p:nvPr>
-        </p:nvSpPr>
-        <p:spPr/>
-        <p:txBody>
-          <a:bodyPr/>
-          <a:lstStyle/>
-          <a:p>
-            <a:r>
-              <a:rPr lang="en-US" dirty="0"/>
-              <a:t>List of Topics Relevant to This Presentation</a:t>
-            </a:r>
-          </a:p>
-        </p:txBody>
-      </p:sp>
-      <p:sp>
-        <p:nvSpPr>
-          <p:cNvPr id="3" name="Content Placeholder 2">
-            <a:extLst>
-              <a:ext uri="{FF2B5EF4-FFF2-40B4-BE49-F238E27FC236}">
-                <a16:creationId xmlns:a16="http://schemas.microsoft.com/office/drawing/2014/main" id="{A04F342F-E6CE-DD03-4519-3357C6F9C431}"/>
-              </a:ext>
-            </a:extLst>
-          </p:cNvPr>
-          <p:cNvSpPr>
-            <a:spLocks noGrp="1"/>
-          </p:cNvSpPr>
-          <p:nvPr>
-            <p:ph idx="1"/>
-          </p:nvPr>
-        </p:nvSpPr>
-        <p:spPr/>
-        <p:txBody>
-          <a:bodyPr>
-            <a:normAutofit fontScale="92500" lnSpcReduction="10000"/>
-          </a:bodyPr>
-          <a:lstStyle/>
-          <a:p>
-            <a:pPr marL="0" indent="0">
-              <a:buNone/>
-            </a:pPr>
-            <a:r>
-              <a:rPr lang="en-US" dirty="0"/>
-              <a:t>Make sure you have at least basic knowledge of these concepts so that you can understand the content in this presentation:</a:t>
-            </a:r>
-          </a:p>
-          <a:p>
-            <a:r>
-              <a:rPr lang="en-US" dirty="0"/>
-              <a:t>SRA calculations</a:t>
-            </a:r>
-          </a:p>
-          <a:p>
-            <a:r>
-              <a:rPr lang="en-US" dirty="0"/>
-              <a:t>Ideal transformer modeling</a:t>
-            </a:r>
-          </a:p>
-          <a:p>
-            <a:r>
-              <a:rPr lang="en-US" dirty="0"/>
-              <a:t>Laplace transforms</a:t>
-            </a:r>
-          </a:p>
-          <a:p>
-            <a:r>
-              <a:rPr lang="en-US" dirty="0"/>
-              <a:t>Transfer functions and closed-loop systems</a:t>
-            </a:r>
-          </a:p>
-          <a:p>
-            <a:pPr marL="0" indent="0">
-              <a:buNone/>
-            </a:pPr>
-            <a:r>
-              <a:rPr lang="en-US" dirty="0"/>
-              <a:t>Make sure you are </a:t>
-            </a:r>
-            <a:r>
-              <a:rPr lang="en-US" b="1" dirty="0"/>
-              <a:t>very familiar </a:t>
-            </a:r>
-            <a:r>
-              <a:rPr lang="en-US" dirty="0"/>
-              <a:t>with these concepts:</a:t>
-            </a:r>
-          </a:p>
-          <a:p>
-            <a:r>
-              <a:rPr lang="en-US" dirty="0"/>
-              <a:t>KVL and KCL</a:t>
-            </a:r>
-          </a:p>
-          <a:p>
-            <a:r>
-              <a:rPr lang="en-US" dirty="0"/>
-              <a:t>Algebraic manipulation</a:t>
-            </a:r>
-          </a:p>
-          <a:p>
-            <a:r>
-              <a:rPr lang="en-US" dirty="0"/>
-              <a:t>Differential and integral calculus</a:t>
-            </a:r>
-          </a:p>
-        </p:txBody>
-      </p:sp>
-    </p:spTree>
-    <p:extLst>
-      <p:ext uri="{BB962C8B-B14F-4D97-AF65-F5344CB8AC3E}">
-        <p14:creationId xmlns:p14="http://schemas.microsoft.com/office/powerpoint/2010/main" val="3259269306"/>
-      </p:ext>
-    </p:extLst>
-  </p:cSld>
-  <p:clrMapOvr>
-    <a:masterClrMapping/>
-  </p:clrMapOvr>
-</p:sld>
-</file>
-
-<file path=ppt/slides/slide30.xml><?xml version="1.0" encoding="utf-8"?>
+<file path=ppt/slides/slide31.xml><?xml version="1.0" encoding="utf-8"?>
 <p:sld xmlns:a="http://schemas.openxmlformats.org/drawingml/2006/main" xmlns:r="http://schemas.openxmlformats.org/officeDocument/2006/relationships" xmlns:p="http://schemas.openxmlformats.org/presentationml/2006/main">
   <p:cSld>
     <p:spTree>
@@ -32311,7 +33624,7 @@
 </p:sld>
 </file>
 
-<file path=ppt/slides/slide31.xml><?xml version="1.0" encoding="utf-8"?>
+<file path=ppt/slides/slide32.xml><?xml version="1.0" encoding="utf-8"?>
 <p:sld xmlns:a="http://schemas.openxmlformats.org/drawingml/2006/main" xmlns:r="http://schemas.openxmlformats.org/officeDocument/2006/relationships" xmlns:p="http://schemas.openxmlformats.org/presentationml/2006/main">
   <p:cSld>
     <p:spTree>

</xml_diff>

<commit_message>
minor tweaks from jed to fix up problem statement presentation
</commit_message>
<xml_diff>
--- a/UT Robomasters – Supercap Power Stage Modeling.pptx
+++ b/UT Robomasters – Supercap Power Stage Modeling.pptx
@@ -326,7 +326,7 @@
           <a:p>
             <a:fld id="{116CDFA8-9B71-48D2-9BC8-093B5490E257}" type="datetimeFigureOut">
               <a:rPr lang="en-US" smtClean="0"/>
-              <a:t>5/4/2026</a:t>
+              <a:t>8/19/2026</a:t>
             </a:fld>
             <a:endParaRPr lang="en-US"/>
           </a:p>
@@ -496,7 +496,7 @@
           <a:p>
             <a:fld id="{116CDFA8-9B71-48D2-9BC8-093B5490E257}" type="datetimeFigureOut">
               <a:rPr lang="en-US" smtClean="0"/>
-              <a:t>5/4/2026</a:t>
+              <a:t>8/19/2026</a:t>
             </a:fld>
             <a:endParaRPr lang="en-US"/>
           </a:p>
@@ -676,7 +676,7 @@
           <a:p>
             <a:fld id="{116CDFA8-9B71-48D2-9BC8-093B5490E257}" type="datetimeFigureOut">
               <a:rPr lang="en-US" smtClean="0"/>
-              <a:t>5/4/2026</a:t>
+              <a:t>8/19/2026</a:t>
             </a:fld>
             <a:endParaRPr lang="en-US"/>
           </a:p>
@@ -846,7 +846,7 @@
           <a:p>
             <a:fld id="{116CDFA8-9B71-48D2-9BC8-093B5490E257}" type="datetimeFigureOut">
               <a:rPr lang="en-US" smtClean="0"/>
-              <a:t>5/4/2026</a:t>
+              <a:t>8/19/2026</a:t>
             </a:fld>
             <a:endParaRPr lang="en-US"/>
           </a:p>
@@ -1092,7 +1092,7 @@
           <a:p>
             <a:fld id="{116CDFA8-9B71-48D2-9BC8-093B5490E257}" type="datetimeFigureOut">
               <a:rPr lang="en-US" smtClean="0"/>
-              <a:t>5/4/2026</a:t>
+              <a:t>8/19/2026</a:t>
             </a:fld>
             <a:endParaRPr lang="en-US"/>
           </a:p>
@@ -1324,7 +1324,7 @@
           <a:p>
             <a:fld id="{116CDFA8-9B71-48D2-9BC8-093B5490E257}" type="datetimeFigureOut">
               <a:rPr lang="en-US" smtClean="0"/>
-              <a:t>5/4/2026</a:t>
+              <a:t>8/19/2026</a:t>
             </a:fld>
             <a:endParaRPr lang="en-US"/>
           </a:p>
@@ -1691,7 +1691,7 @@
           <a:p>
             <a:fld id="{116CDFA8-9B71-48D2-9BC8-093B5490E257}" type="datetimeFigureOut">
               <a:rPr lang="en-US" smtClean="0"/>
-              <a:t>5/4/2026</a:t>
+              <a:t>8/19/2026</a:t>
             </a:fld>
             <a:endParaRPr lang="en-US"/>
           </a:p>
@@ -1809,7 +1809,7 @@
           <a:p>
             <a:fld id="{116CDFA8-9B71-48D2-9BC8-093B5490E257}" type="datetimeFigureOut">
               <a:rPr lang="en-US" smtClean="0"/>
-              <a:t>5/4/2026</a:t>
+              <a:t>8/19/2026</a:t>
             </a:fld>
             <a:endParaRPr lang="en-US"/>
           </a:p>
@@ -1904,7 +1904,7 @@
           <a:p>
             <a:fld id="{116CDFA8-9B71-48D2-9BC8-093B5490E257}" type="datetimeFigureOut">
               <a:rPr lang="en-US" smtClean="0"/>
-              <a:t>5/4/2026</a:t>
+              <a:t>8/19/2026</a:t>
             </a:fld>
             <a:endParaRPr lang="en-US"/>
           </a:p>
@@ -2181,7 +2181,7 @@
           <a:p>
             <a:fld id="{116CDFA8-9B71-48D2-9BC8-093B5490E257}" type="datetimeFigureOut">
               <a:rPr lang="en-US" smtClean="0"/>
-              <a:t>5/4/2026</a:t>
+              <a:t>8/19/2026</a:t>
             </a:fld>
             <a:endParaRPr lang="en-US"/>
           </a:p>
@@ -2438,7 +2438,7 @@
           <a:p>
             <a:fld id="{116CDFA8-9B71-48D2-9BC8-093B5490E257}" type="datetimeFigureOut">
               <a:rPr lang="en-US" smtClean="0"/>
-              <a:t>5/4/2026</a:t>
+              <a:t>8/19/2026</a:t>
             </a:fld>
             <a:endParaRPr lang="en-US"/>
           </a:p>
@@ -2651,7 +2651,7 @@
           <a:p>
             <a:fld id="{116CDFA8-9B71-48D2-9BC8-093B5490E257}" type="datetimeFigureOut">
               <a:rPr lang="en-US" smtClean="0"/>
-              <a:t>5/4/2026</a:t>
+              <a:t>8/19/2026</a:t>
             </a:fld>
             <a:endParaRPr lang="en-US"/>
           </a:p>
@@ -3225,10 +3225,7 @@
                 <a:pPr/>
                 <a14:m>
                   <m:oMathPara xmlns:m="http://schemas.openxmlformats.org/officeDocument/2006/math">
-                    <m:oMathParaPr>
-                      <m:jc m:val="centerGroup"/>
-                    </m:oMathParaPr>
-                    <m:oMath xmlns:m="http://schemas.openxmlformats.org/officeDocument/2006/math">
+                    <m:oMath>
                       <m:r>
                         <a:rPr lang="en-US" b="0" i="1" smtClean="0">
                           <a:latin typeface="Cambria Math" panose="02040503050406030204" pitchFamily="18" charset="0"/>
@@ -3573,10 +3570,7 @@
                 <a:pPr/>
                 <a14:m>
                   <m:oMathPara xmlns:m="http://schemas.openxmlformats.org/officeDocument/2006/math">
-                    <m:oMathParaPr>
-                      <m:jc m:val="centerGroup"/>
-                    </m:oMathParaPr>
-                    <m:oMath xmlns:m="http://schemas.openxmlformats.org/officeDocument/2006/math">
+                    <m:oMath>
                       <m:r>
                         <a:rPr lang="en-US" i="1">
                           <a:latin typeface="Cambria Math" panose="02040503050406030204" pitchFamily="18" charset="0"/>
@@ -3586,7 +3580,7 @@
                       <m:sSup>
                         <m:sSupPr>
                           <m:ctrlPr>
-                            <a:rPr lang="en-US" b="0" i="1" smtClean="0">
+                            <a:rPr lang="en-US" i="1">
                               <a:latin typeface="Cambria Math" panose="02040503050406030204" pitchFamily="18" charset="0"/>
                             </a:rPr>
                           </m:ctrlPr>
@@ -3890,10 +3884,7 @@
                 <a:pPr/>
                 <a14:m>
                   <m:oMathPara xmlns:m="http://schemas.openxmlformats.org/officeDocument/2006/math">
-                    <m:oMathParaPr>
-                      <m:jc m:val="centerGroup"/>
-                    </m:oMathParaPr>
-                    <m:oMath xmlns:m="http://schemas.openxmlformats.org/officeDocument/2006/math">
+                    <m:oMath>
                       <m:sSub>
                         <m:sSubPr>
                           <m:ctrlPr>
@@ -4022,7 +4013,7 @@
                       <m:f>
                         <m:fPr>
                           <m:ctrlPr>
-                            <a:rPr lang="en-US" b="0" i="1" smtClean="0">
+                            <a:rPr lang="en-US" i="1">
                               <a:latin typeface="Cambria Math" panose="02040503050406030204" pitchFamily="18" charset="0"/>
                             </a:rPr>
                           </m:ctrlPr>
@@ -4145,10 +4136,7 @@
                 <a:pPr/>
                 <a14:m>
                   <m:oMathPara xmlns:m="http://schemas.openxmlformats.org/officeDocument/2006/math">
-                    <m:oMathParaPr>
-                      <m:jc m:val="centerGroup"/>
-                    </m:oMathParaPr>
-                    <m:oMath xmlns:m="http://schemas.openxmlformats.org/officeDocument/2006/math">
+                    <m:oMath>
                       <m:sSub>
                         <m:sSubPr>
                           <m:ctrlPr>
@@ -4209,7 +4197,7 @@
                           <m:d>
                             <m:dPr>
                               <m:ctrlPr>
-                                <a:rPr lang="en-US" b="0" i="1" smtClean="0">
+                                <a:rPr lang="en-US" i="1">
                                   <a:latin typeface="Cambria Math" panose="02040503050406030204" pitchFamily="18" charset="0"/>
                                 </a:rPr>
                               </m:ctrlPr>
@@ -4343,7 +4331,7 @@
                           <m:d>
                             <m:dPr>
                               <m:ctrlPr>
-                                <a:rPr lang="en-US" b="0" i="1" smtClean="0">
+                                <a:rPr lang="en-US" i="1">
                                   <a:latin typeface="Cambria Math" panose="02040503050406030204" pitchFamily="18" charset="0"/>
                                 </a:rPr>
                               </m:ctrlPr>
@@ -4573,10 +4561,7 @@
                 <a:pPr/>
                 <a14:m>
                   <m:oMathPara xmlns:m="http://schemas.openxmlformats.org/officeDocument/2006/math">
-                    <m:oMathParaPr>
-                      <m:jc m:val="centerGroup"/>
-                    </m:oMathParaPr>
-                    <m:oMath xmlns:m="http://schemas.openxmlformats.org/officeDocument/2006/math">
+                    <m:oMath>
                       <m:sSub>
                         <m:sSubPr>
                           <m:ctrlPr>
@@ -4873,10 +4858,7 @@
                 <a:pPr/>
                 <a14:m>
                   <m:oMathPara xmlns:m="http://schemas.openxmlformats.org/officeDocument/2006/math">
-                    <m:oMathParaPr>
-                      <m:jc m:val="centerGroup"/>
-                    </m:oMathParaPr>
-                    <m:oMath xmlns:m="http://schemas.openxmlformats.org/officeDocument/2006/math">
+                    <m:oMath>
                       <m:sSub>
                         <m:sSubPr>
                           <m:ctrlPr>
@@ -4911,7 +4893,7 @@
                       <m:sSub>
                         <m:sSubPr>
                           <m:ctrlPr>
-                            <a:rPr lang="en-US" b="0" i="1" smtClean="0">
+                            <a:rPr lang="en-US" i="1" smtClean="0">
                               <a:latin typeface="Cambria Math" panose="02040503050406030204" pitchFamily="18" charset="0"/>
                             </a:rPr>
                           </m:ctrlPr>
@@ -5125,10 +5107,7 @@
                 <a:pPr/>
                 <a14:m>
                   <m:oMathPara xmlns:m="http://schemas.openxmlformats.org/officeDocument/2006/math">
-                    <m:oMathParaPr>
-                      <m:jc m:val="centerGroup"/>
-                    </m:oMathParaPr>
-                    <m:oMath xmlns:m="http://schemas.openxmlformats.org/officeDocument/2006/math">
+                    <m:oMath>
                       <m:sSub>
                         <m:sSubPr>
                           <m:ctrlPr>
@@ -5267,7 +5246,7 @@
                       <m:d>
                         <m:dPr>
                           <m:ctrlPr>
-                            <a:rPr lang="en-US" i="1">
+                            <a:rPr lang="en-US" b="0" i="1" smtClean="0">
                               <a:latin typeface="Cambria Math" panose="02040503050406030204" pitchFamily="18" charset="0"/>
                             </a:rPr>
                           </m:ctrlPr>
@@ -5368,14 +5347,11 @@
                 <a:pPr/>
                 <a14:m>
                   <m:oMathPara xmlns:m="http://schemas.openxmlformats.org/officeDocument/2006/math">
-                    <m:oMathParaPr>
-                      <m:jc m:val="centerGroup"/>
-                    </m:oMathParaPr>
-                    <m:oMath xmlns:m="http://schemas.openxmlformats.org/officeDocument/2006/math">
+                    <m:oMath>
                       <m:sSub>
                         <m:sSubPr>
                           <m:ctrlPr>
-                            <a:rPr lang="en-US" b="0" i="1" smtClean="0">
+                            <a:rPr lang="en-US" i="1" smtClean="0">
                               <a:latin typeface="Cambria Math" panose="02040503050406030204" pitchFamily="18" charset="0"/>
                             </a:rPr>
                           </m:ctrlPr>
@@ -5770,10 +5746,7 @@
                 <a:pPr/>
                 <a14:m>
                   <m:oMathPara xmlns:m="http://schemas.openxmlformats.org/officeDocument/2006/math">
-                    <m:oMathParaPr>
-                      <m:jc m:val="centerGroup"/>
-                    </m:oMathParaPr>
-                    <m:oMath xmlns:m="http://schemas.openxmlformats.org/officeDocument/2006/math">
+                    <m:oMath>
                       <m:sSub>
                         <m:sSubPr>
                           <m:ctrlPr>
@@ -5872,7 +5845,7 @@
                               <m:sSub>
                                 <m:sSubPr>
                                   <m:ctrlPr>
-                                    <a:rPr lang="en-US" b="0" i="1" smtClean="0">
+                                    <a:rPr lang="en-US" i="1">
                                       <a:latin typeface="Cambria Math" panose="02040503050406030204" pitchFamily="18" charset="0"/>
                                     </a:rPr>
                                   </m:ctrlPr>
@@ -5915,7 +5888,7 @@
                       <m:sSubSup>
                         <m:sSubSupPr>
                           <m:ctrlPr>
-                            <a:rPr lang="en-US" b="0" i="1" smtClean="0">
+                            <a:rPr lang="en-US" i="1">
                               <a:latin typeface="Cambria Math" panose="02040503050406030204" pitchFamily="18" charset="0"/>
                             </a:rPr>
                           </m:ctrlPr>
@@ -6073,10 +6046,7 @@
                 <a:pPr/>
                 <a14:m>
                   <m:oMathPara xmlns:m="http://schemas.openxmlformats.org/officeDocument/2006/math">
-                    <m:oMathParaPr>
-                      <m:jc m:val="centerGroup"/>
-                    </m:oMathParaPr>
-                    <m:oMath xmlns:m="http://schemas.openxmlformats.org/officeDocument/2006/math">
+                    <m:oMath>
                       <m:r>
                         <a:rPr lang="en-US" i="1">
                           <a:latin typeface="Cambria Math" panose="02040503050406030204" pitchFamily="18" charset="0"/>
@@ -6200,7 +6170,7 @@
                           <m:sSubSup>
                             <m:sSubSupPr>
                               <m:ctrlPr>
-                                <a:rPr lang="en-US" b="0" i="1" smtClean="0">
+                                <a:rPr lang="en-US" i="1">
                                   <a:latin typeface="Cambria Math" panose="02040503050406030204" pitchFamily="18" charset="0"/>
                                 </a:rPr>
                               </m:ctrlPr>
@@ -6470,10 +6440,7 @@
                 <a:pPr/>
                 <a14:m>
                   <m:oMathPara xmlns:m="http://schemas.openxmlformats.org/officeDocument/2006/math">
-                    <m:oMathParaPr>
-                      <m:jc m:val="centerGroup"/>
-                    </m:oMathParaPr>
-                    <m:oMath xmlns:m="http://schemas.openxmlformats.org/officeDocument/2006/math">
+                    <m:oMath>
                       <m:r>
                         <a:rPr lang="en-US" sz="2400" b="0" i="1" smtClean="0">
                           <a:latin typeface="Cambria Math" panose="02040503050406030204" pitchFamily="18" charset="0"/>
@@ -6687,10 +6654,7 @@
                 <a:pPr/>
                 <a14:m>
                   <m:oMathPara xmlns:m="http://schemas.openxmlformats.org/officeDocument/2006/math">
-                    <m:oMathParaPr>
-                      <m:jc m:val="centerGroup"/>
-                    </m:oMathParaPr>
-                    <m:oMath xmlns:m="http://schemas.openxmlformats.org/officeDocument/2006/math">
+                    <m:oMath>
                       <m:sSub>
                         <m:sSubPr>
                           <m:ctrlPr>
@@ -6750,10 +6714,7 @@
                 <a:pPr/>
                 <a14:m>
                   <m:oMathPara xmlns:m="http://schemas.openxmlformats.org/officeDocument/2006/math">
-                    <m:oMathParaPr>
-                      <m:jc m:val="centerGroup"/>
-                    </m:oMathParaPr>
-                    <m:oMath xmlns:m="http://schemas.openxmlformats.org/officeDocument/2006/math">
+                    <m:oMath>
                       <m:r>
                         <a:rPr lang="en-US" sz="2400" b="0" i="1" smtClean="0">
                           <a:latin typeface="Cambria Math" panose="02040503050406030204" pitchFamily="18" charset="0"/>
@@ -6913,10 +6874,7 @@
                 <a:pPr/>
                 <a14:m>
                   <m:oMathPara xmlns:m="http://schemas.openxmlformats.org/officeDocument/2006/math">
-                    <m:oMathParaPr>
-                      <m:jc m:val="centerGroup"/>
-                    </m:oMathParaPr>
-                    <m:oMath xmlns:m="http://schemas.openxmlformats.org/officeDocument/2006/math">
+                    <m:oMath>
                       <m:r>
                         <a:rPr lang="en-US" sz="2400" i="1">
                           <a:latin typeface="Cambria Math" panose="02040503050406030204" pitchFamily="18" charset="0"/>
@@ -7264,10 +7222,7 @@
                 <a:pPr/>
                 <a14:m>
                   <m:oMathPara xmlns:m="http://schemas.openxmlformats.org/officeDocument/2006/math">
-                    <m:oMathParaPr>
-                      <m:jc m:val="centerGroup"/>
-                    </m:oMathParaPr>
-                    <m:oMath xmlns:m="http://schemas.openxmlformats.org/officeDocument/2006/math">
+                    <m:oMath>
                       <m:r>
                         <a:rPr lang="en-US" sz="1200" i="1">
                           <a:latin typeface="Cambria Math" panose="02040503050406030204" pitchFamily="18" charset="0"/>
@@ -8268,10 +8223,7 @@
                 <a:pPr/>
                 <a14:m>
                   <m:oMathPara xmlns:m="http://schemas.openxmlformats.org/officeDocument/2006/math">
-                    <m:oMathParaPr>
-                      <m:jc m:val="centerGroup"/>
-                    </m:oMathParaPr>
-                    <m:oMath xmlns:m="http://schemas.openxmlformats.org/officeDocument/2006/math">
+                    <m:oMath>
                       <m:r>
                         <a:rPr lang="en-US" sz="1400" i="1">
                           <a:latin typeface="Cambria Math" panose="02040503050406030204" pitchFamily="18" charset="0"/>
@@ -8571,7 +8523,7 @@
                       <m:f>
                         <m:fPr>
                           <m:ctrlPr>
-                            <a:rPr lang="en-US" sz="1400" i="1">
+                            <a:rPr lang="en-US" sz="1400" b="0" i="1" smtClean="0">
                               <a:latin typeface="Cambria Math" panose="02040503050406030204" pitchFamily="18" charset="0"/>
                             </a:rPr>
                           </m:ctrlPr>
@@ -8709,10 +8661,7 @@
                 <a:pPr/>
                 <a14:m>
                   <m:oMathPara xmlns:m="http://schemas.openxmlformats.org/officeDocument/2006/math">
-                    <m:oMathParaPr>
-                      <m:jc m:val="centerGroup"/>
-                    </m:oMathParaPr>
-                    <m:oMath xmlns:m="http://schemas.openxmlformats.org/officeDocument/2006/math">
+                    <m:oMath>
                       <m:r>
                         <a:rPr lang="en-US" sz="1600" i="1">
                           <a:latin typeface="Cambria Math" panose="02040503050406030204" pitchFamily="18" charset="0"/>
@@ -8722,7 +8671,7 @@
                       <m:sSup>
                         <m:sSupPr>
                           <m:ctrlPr>
-                            <a:rPr lang="en-US" sz="1600" b="0" i="1" smtClean="0">
+                            <a:rPr lang="en-US" sz="1600" i="1">
                               <a:latin typeface="Cambria Math" panose="02040503050406030204" pitchFamily="18" charset="0"/>
                             </a:rPr>
                           </m:ctrlPr>
@@ -9060,10 +9009,7 @@
                 <a:pPr/>
                 <a14:m>
                   <m:oMathPara xmlns:m="http://schemas.openxmlformats.org/officeDocument/2006/math">
-                    <m:oMathParaPr>
-                      <m:jc m:val="centerGroup"/>
-                    </m:oMathParaPr>
-                    <m:oMath xmlns:m="http://schemas.openxmlformats.org/officeDocument/2006/math">
+                    <m:oMath>
                       <m:sSub>
                         <m:sSubPr>
                           <m:ctrlPr>
@@ -9267,10 +9213,7 @@
                 <a:pPr/>
                 <a14:m>
                   <m:oMathPara xmlns:m="http://schemas.openxmlformats.org/officeDocument/2006/math">
-                    <m:oMathParaPr>
-                      <m:jc m:val="centerGroup"/>
-                    </m:oMathParaPr>
-                    <m:oMath xmlns:m="http://schemas.openxmlformats.org/officeDocument/2006/math">
+                    <m:oMath>
                       <m:sSub>
                         <m:sSubPr>
                           <m:ctrlPr>
@@ -9610,10 +9553,7 @@
                 <a:pPr/>
                 <a14:m>
                   <m:oMathPara xmlns:m="http://schemas.openxmlformats.org/officeDocument/2006/math">
-                    <m:oMathParaPr>
-                      <m:jc m:val="centerGroup"/>
-                    </m:oMathParaPr>
-                    <m:oMath xmlns:m="http://schemas.openxmlformats.org/officeDocument/2006/math">
+                    <m:oMath>
                       <m:sSub>
                         <m:sSubPr>
                           <m:ctrlPr>
@@ -10045,14 +9985,11 @@
                 <a:pPr/>
                 <a14:m>
                   <m:oMathPara xmlns:m="http://schemas.openxmlformats.org/officeDocument/2006/math">
-                    <m:oMathParaPr>
-                      <m:jc m:val="centerGroup"/>
-                    </m:oMathParaPr>
-                    <m:oMath xmlns:m="http://schemas.openxmlformats.org/officeDocument/2006/math">
+                    <m:oMath>
                       <m:sSub>
                         <m:sSubPr>
                           <m:ctrlPr>
-                            <a:rPr lang="en-US" b="0" i="1" smtClean="0">
+                            <a:rPr lang="en-US" i="1" smtClean="0">
                               <a:latin typeface="Cambria Math" panose="02040503050406030204" pitchFamily="18" charset="0"/>
                             </a:rPr>
                           </m:ctrlPr>
@@ -10795,10 +10732,7 @@
                 <a:pPr/>
                 <a14:m>
                   <m:oMathPara xmlns:m="http://schemas.openxmlformats.org/officeDocument/2006/math">
-                    <m:oMathParaPr>
-                      <m:jc m:val="centerGroup"/>
-                    </m:oMathParaPr>
-                    <m:oMath xmlns:m="http://schemas.openxmlformats.org/officeDocument/2006/math">
+                    <m:oMath>
                       <m:f>
                         <m:fPr>
                           <m:ctrlPr>
@@ -12362,10 +12296,7 @@
                 <a:pPr/>
                 <a14:m>
                   <m:oMathPara xmlns:m="http://schemas.openxmlformats.org/officeDocument/2006/math">
-                    <m:oMathParaPr>
-                      <m:jc m:val="centerGroup"/>
-                    </m:oMathParaPr>
-                    <m:oMath xmlns:m="http://schemas.openxmlformats.org/officeDocument/2006/math">
+                    <m:oMath>
                       <m:r>
                         <a:rPr lang="en-US" i="1">
                           <a:latin typeface="Cambria Math" panose="02040503050406030204" pitchFamily="18" charset="0"/>
@@ -12725,7 +12656,7 @@
                     <m:sSub>
                       <m:sSubPr>
                         <m:ctrlPr>
-                          <a:rPr lang="en-US" b="0" i="1" smtClean="0">
+                          <a:rPr lang="en-US" i="1">
                             <a:latin typeface="Cambria Math" panose="02040503050406030204" pitchFamily="18" charset="0"/>
                           </a:rPr>
                         </m:ctrlPr>
@@ -14517,10 +14448,7 @@
                 <a:pPr/>
                 <a14:m>
                   <m:oMathPara xmlns:m="http://schemas.openxmlformats.org/officeDocument/2006/math">
-                    <m:oMathParaPr>
-                      <m:jc m:val="centerGroup"/>
-                    </m:oMathParaPr>
-                    <m:oMath xmlns:m="http://schemas.openxmlformats.org/officeDocument/2006/math">
+                    <m:oMath>
                       <m:sSub>
                         <m:sSubPr>
                           <m:ctrlPr>
@@ -14774,7 +14702,7 @@
                     <m:sSub>
                       <m:sSubPr>
                         <m:ctrlPr>
-                          <a:rPr lang="en-US" sz="1400" b="0" i="1" dirty="0" smtClean="0">
+                          <a:rPr lang="en-US" sz="1400" b="0" i="0" dirty="0" smtClean="0">
                             <a:latin typeface="Cambria Math" panose="02040503050406030204" pitchFamily="18" charset="0"/>
                           </a:rPr>
                         </m:ctrlPr>
@@ -17558,8 +17486,8 @@
           </a:p>
         </p:txBody>
       </p:sp>
-      <mc:AlternateContent xmlns:mc="http://schemas.openxmlformats.org/markup-compatibility/2006" xmlns:a14="http://schemas.microsoft.com/office/drawing/2010/main">
-        <mc:Choice Requires="a14">
+      <mc:AlternateContent xmlns:mc="http://schemas.openxmlformats.org/markup-compatibility/2006">
+        <mc:Choice xmlns:a14="http://schemas.microsoft.com/office/drawing/2010/main" Requires="a14">
           <p:sp>
             <p:nvSpPr>
               <p:cNvPr id="6" name="Text Placeholder 5">
@@ -17602,10 +17530,7 @@
                 </a:pPr>
                 <a14:m>
                   <m:oMathPara xmlns:m="http://schemas.openxmlformats.org/officeDocument/2006/math">
-                    <m:oMathParaPr>
-                      <m:jc m:val="centerGroup"/>
-                    </m:oMathParaPr>
-                    <m:oMath xmlns:m="http://schemas.openxmlformats.org/officeDocument/2006/math">
+                    <m:oMath>
                       <m:sSub>
                         <m:sSubPr>
                           <m:ctrlPr>
@@ -17827,10 +17752,7 @@
                 </a:pPr>
                 <a14:m>
                   <m:oMathPara xmlns:m="http://schemas.openxmlformats.org/officeDocument/2006/math">
-                    <m:oMathParaPr>
-                      <m:jc m:val="centerGroup"/>
-                    </m:oMathParaPr>
-                    <m:oMath xmlns:m="http://schemas.openxmlformats.org/officeDocument/2006/math">
+                    <m:oMath>
                       <m:sSub>
                         <m:sSubPr>
                           <m:ctrlPr>
@@ -17904,7 +17826,7 @@
                                 <a:rPr lang="en-US" sz="1800" b="0" i="1" smtClean="0">
                                   <a:latin typeface="Cambria Math" panose="02040503050406030204" pitchFamily="18" charset="0"/>
                                 </a:rPr>
-                                <m:t>𝑐</m:t>
+                                <m:t>𝐶</m:t>
                               </m:r>
                             </m:sub>
                             <m:sup>
@@ -17945,7 +17867,7 @@
                                 <a:rPr lang="en-US" sz="1800" b="0" i="1" smtClean="0">
                                   <a:latin typeface="Cambria Math" panose="02040503050406030204" pitchFamily="18" charset="0"/>
                                 </a:rPr>
-                                <m:t>𝑔</m:t>
+                                <m:t>𝐺</m:t>
                               </m:r>
                             </m:sub>
                           </m:sSub>
@@ -18022,7 +17944,7 @@
                                 <a:rPr lang="en-US" sz="1800" b="0" i="1" smtClean="0">
                                   <a:latin typeface="Cambria Math" panose="02040503050406030204" pitchFamily="18" charset="0"/>
                                 </a:rPr>
-                                <m:t>𝑐</m:t>
+                                <m:t>𝐶</m:t>
                               </m:r>
                             </m:sub>
                           </m:sSub>
@@ -18055,7 +17977,7 @@
                                 <a:rPr lang="en-US" sz="1800" b="0" i="1" smtClean="0">
                                   <a:latin typeface="Cambria Math" panose="02040503050406030204" pitchFamily="18" charset="0"/>
                                 </a:rPr>
-                                <m:t>𝑔</m:t>
+                                <m:t>𝐺</m:t>
                               </m:r>
                             </m:sub>
                           </m:sSub>
@@ -18144,10 +18066,7 @@
                 </a:pPr>
                 <a14:m>
                   <m:oMathPara xmlns:m="http://schemas.openxmlformats.org/officeDocument/2006/math">
-                    <m:oMathParaPr>
-                      <m:jc m:val="centerGroup"/>
-                    </m:oMathParaPr>
-                    <m:oMath xmlns:m="http://schemas.openxmlformats.org/officeDocument/2006/math">
+                    <m:oMath>
                       <m:sSub>
                         <m:sSubPr>
                           <m:ctrlPr>
@@ -18330,10 +18249,7 @@
                 </a:pPr>
                 <a14:m>
                   <m:oMathPara xmlns:m="http://schemas.openxmlformats.org/officeDocument/2006/math">
-                    <m:oMathParaPr>
-                      <m:jc m:val="centerGroup"/>
-                    </m:oMathParaPr>
-                    <m:oMath xmlns:m="http://schemas.openxmlformats.org/officeDocument/2006/math">
+                    <m:oMath>
                       <m:r>
                         <a:rPr lang="en-US" sz="1800" i="1" smtClean="0">
                           <a:latin typeface="Cambria Math" panose="02040503050406030204" pitchFamily="18" charset="0"/>
@@ -18439,7 +18355,7 @@
             </p:txBody>
           </p:sp>
         </mc:Choice>
-        <mc:Fallback xmlns="">
+        <mc:Fallback>
           <p:sp>
             <p:nvSpPr>
               <p:cNvPr id="6" name="Text Placeholder 5">
@@ -18464,7 +18380,7 @@
               <a:blipFill>
                 <a:blip r:embed="rId2"/>
                 <a:stretch>
-                  <a:fillRect l="-1100" t="-1272" r="-611" b="-1272"/>
+                  <a:fillRect l="-1100" t="-1272" r="-611" b="-763"/>
                 </a:stretch>
               </a:blipFill>
             </p:spPr>
@@ -19138,8 +19054,8 @@
           </a:prstGeom>
         </p:spPr>
       </p:pic>
-      <mc:AlternateContent xmlns:mc="http://schemas.openxmlformats.org/markup-compatibility/2006">
-        <mc:Choice xmlns:a14="http://schemas.microsoft.com/office/drawing/2010/main" Requires="a14">
+      <mc:AlternateContent xmlns:mc="http://schemas.openxmlformats.org/markup-compatibility/2006" xmlns:a14="http://schemas.microsoft.com/office/drawing/2010/main">
+        <mc:Choice Requires="a14">
           <p:sp>
             <p:nvSpPr>
               <p:cNvPr id="6" name="TextBox 5">
@@ -19174,12 +19090,10 @@
                 </a:r>
               </a:p>
               <a:p>
+                <a:pPr/>
                 <a14:m>
                   <m:oMathPara xmlns:m="http://schemas.openxmlformats.org/officeDocument/2006/math">
-                    <m:oMathParaPr>
-                      <m:jc m:val="centerGroup"/>
-                    </m:oMathParaPr>
-                    <m:oMath xmlns:m="http://schemas.openxmlformats.org/officeDocument/2006/math">
+                    <m:oMath>
                       <m:r>
                         <a:rPr lang="en-US" b="0" i="1" smtClean="0">
                           <a:latin typeface="Cambria Math" panose="02040503050406030204" pitchFamily="18" charset="0"/>
@@ -19413,12 +19327,10 @@
                 <a:endParaRPr lang="en-US" dirty="0"/>
               </a:p>
               <a:p>
+                <a:pPr/>
                 <a14:m>
                   <m:oMathPara xmlns:m="http://schemas.openxmlformats.org/officeDocument/2006/math">
-                    <m:oMathParaPr>
-                      <m:jc m:val="centerGroup"/>
-                    </m:oMathParaPr>
-                    <m:oMath xmlns:m="http://schemas.openxmlformats.org/officeDocument/2006/math">
+                    <m:oMath>
                       <m:r>
                         <a:rPr lang="en-US" b="0" i="1" smtClean="0">
                           <a:latin typeface="Cambria Math" panose="02040503050406030204" pitchFamily="18" charset="0"/>
@@ -19671,12 +19583,10 @@
                 </a:r>
               </a:p>
               <a:p>
+                <a:pPr/>
                 <a14:m>
                   <m:oMathPara xmlns:m="http://schemas.openxmlformats.org/officeDocument/2006/math">
-                    <m:oMathParaPr>
-                      <m:jc m:val="centerGroup"/>
-                    </m:oMathParaPr>
-                    <m:oMath xmlns:m="http://schemas.openxmlformats.org/officeDocument/2006/math">
+                    <m:oMath>
                       <m:f>
                         <m:fPr>
                           <m:ctrlPr>
@@ -19707,7 +19617,7 @@
                           <m:begChr m:val="["/>
                           <m:endChr m:val="]"/>
                           <m:ctrlPr>
-                            <a:rPr lang="en-US" b="0" i="1" smtClean="0">
+                            <a:rPr lang="en-US" i="1" smtClean="0">
                               <a:latin typeface="Cambria Math" panose="02040503050406030204" pitchFamily="18" charset="0"/>
                             </a:rPr>
                           </m:ctrlPr>
@@ -20162,12 +20072,10 @@
                 <a:endParaRPr lang="en-US" dirty="0"/>
               </a:p>
               <a:p>
+                <a:pPr/>
                 <a14:m>
                   <m:oMathPara xmlns:m="http://schemas.openxmlformats.org/officeDocument/2006/math">
-                    <m:oMathParaPr>
-                      <m:jc m:val="centerGroup"/>
-                    </m:oMathParaPr>
-                    <m:oMath xmlns:m="http://schemas.openxmlformats.org/officeDocument/2006/math">
+                    <m:oMath>
                       <m:sSub>
                         <m:sSubPr>
                           <m:ctrlPr>
@@ -20281,7 +20189,7 @@
             </p:txBody>
           </p:sp>
         </mc:Choice>
-        <mc:Fallback>
+        <mc:Fallback xmlns="">
           <p:sp>
             <p:nvSpPr>
               <p:cNvPr id="6" name="TextBox 5">
@@ -21326,10 +21234,7 @@
                 <a:pPr algn="ctr"/>
                 <a14:m>
                   <m:oMathPara xmlns:m="http://schemas.openxmlformats.org/officeDocument/2006/math">
-                    <m:oMathParaPr>
-                      <m:jc m:val="centerGroup"/>
-                    </m:oMathParaPr>
-                    <m:oMath xmlns:m="http://schemas.openxmlformats.org/officeDocument/2006/math">
+                    <m:oMath>
                       <m:sSub>
                         <m:sSubPr>
                           <m:ctrlPr>
@@ -23391,8 +23296,8 @@
           </a:p>
         </p:txBody>
       </p:sp>
-      <mc:AlternateContent xmlns:mc="http://schemas.openxmlformats.org/markup-compatibility/2006" xmlns:a14="http://schemas.microsoft.com/office/drawing/2010/main">
-        <mc:Choice Requires="a14">
+      <mc:AlternateContent xmlns:mc="http://schemas.openxmlformats.org/markup-compatibility/2006">
+        <mc:Choice xmlns:a14="http://schemas.microsoft.com/office/drawing/2010/main" Requires="a14">
           <p:sp>
             <p:nvSpPr>
               <p:cNvPr id="4" name="Text Placeholder 3">
@@ -23558,7 +23463,7 @@
                 </a:pPr>
                 <a:r>
                   <a:rPr lang="en-US" dirty="0"/>
-                  <a:t>Note that controller cannot tell a difference between </a:t>
+                  <a:t>Note that controller cannot tell the difference between </a:t>
                 </a:r>
                 <a14:m>
                   <m:oMath xmlns:m="http://schemas.openxmlformats.org/officeDocument/2006/math">
@@ -23654,7 +23559,7 @@
             </p:txBody>
           </p:sp>
         </mc:Choice>
-        <mc:Fallback xmlns="">
+        <mc:Fallback>
           <p:sp>
             <p:nvSpPr>
               <p:cNvPr id="4" name="Text Placeholder 3">
@@ -23755,10 +23660,7 @@
                 <a:pPr algn="ctr"/>
                 <a14:m>
                   <m:oMathPara xmlns:m="http://schemas.openxmlformats.org/officeDocument/2006/math">
-                    <m:oMathParaPr>
-                      <m:jc m:val="centerGroup"/>
-                    </m:oMathParaPr>
-                    <m:oMath xmlns:m="http://schemas.openxmlformats.org/officeDocument/2006/math">
+                    <m:oMath>
                       <m:r>
                         <a:rPr lang="en-US" sz="1600" b="0" i="1" smtClean="0">
                           <a:latin typeface="Cambria Math" panose="02040503050406030204" pitchFamily="18" charset="0"/>
@@ -23902,10 +23804,7 @@
                 <a:pPr algn="ctr"/>
                 <a14:m>
                   <m:oMathPara xmlns:m="http://schemas.openxmlformats.org/officeDocument/2006/math">
-                    <m:oMathParaPr>
-                      <m:jc m:val="centerGroup"/>
-                    </m:oMathParaPr>
-                    <m:oMath xmlns:m="http://schemas.openxmlformats.org/officeDocument/2006/math">
+                    <m:oMath>
                       <m:r>
                         <a:rPr lang="en-US" sz="1600" b="0" i="1" smtClean="0">
                           <a:latin typeface="Cambria Math" panose="02040503050406030204" pitchFamily="18" charset="0"/>
@@ -24153,10 +24052,7 @@
                 <a:pPr algn="ctr"/>
                 <a14:m>
                   <m:oMathPara xmlns:m="http://schemas.openxmlformats.org/officeDocument/2006/math">
-                    <m:oMathParaPr>
-                      <m:jc m:val="centerGroup"/>
-                    </m:oMathParaPr>
-                    <m:oMath xmlns:m="http://schemas.openxmlformats.org/officeDocument/2006/math">
+                    <m:oMath>
                       <m:sSup>
                         <m:sSupPr>
                           <m:ctrlPr>
@@ -24291,10 +24187,7 @@
                 <a:pPr/>
                 <a14:m>
                   <m:oMathPara xmlns:m="http://schemas.openxmlformats.org/officeDocument/2006/math">
-                    <m:oMathParaPr>
-                      <m:jc m:val="centerGroup"/>
-                    </m:oMathParaPr>
-                    <m:oMath xmlns:m="http://schemas.openxmlformats.org/officeDocument/2006/math">
+                    <m:oMath>
                       <m:r>
                         <a:rPr lang="en-US" b="0" i="1" smtClean="0">
                           <a:latin typeface="Cambria Math" panose="02040503050406030204" pitchFamily="18" charset="0"/>
@@ -24405,10 +24298,7 @@
                 <a:pPr/>
                 <a14:m>
                   <m:oMathPara xmlns:m="http://schemas.openxmlformats.org/officeDocument/2006/math">
-                    <m:oMathParaPr>
-                      <m:jc m:val="centerGroup"/>
-                    </m:oMathParaPr>
-                    <m:oMath xmlns:m="http://schemas.openxmlformats.org/officeDocument/2006/math">
+                    <m:oMath>
                       <m:r>
                         <a:rPr lang="en-US" b="0" i="1" smtClean="0">
                           <a:latin typeface="Cambria Math" panose="02040503050406030204" pitchFamily="18" charset="0"/>
@@ -24753,10 +24643,7 @@
                 <a:pPr algn="ctr"/>
                 <a14:m>
                   <m:oMathPara xmlns:m="http://schemas.openxmlformats.org/officeDocument/2006/math">
-                    <m:oMathParaPr>
-                      <m:jc m:val="centerGroup"/>
-                    </m:oMathParaPr>
-                    <m:oMath xmlns:m="http://schemas.openxmlformats.org/officeDocument/2006/math">
+                    <m:oMath>
                       <m:r>
                         <a:rPr lang="en-US" sz="1400" b="0" i="1" smtClean="0">
                           <a:latin typeface="Cambria Math" panose="02040503050406030204" pitchFamily="18" charset="0"/>
@@ -25657,10 +25544,7 @@
                 <a:pPr/>
                 <a14:m>
                   <m:oMathPara xmlns:m="http://schemas.openxmlformats.org/officeDocument/2006/math">
-                    <m:oMathParaPr>
-                      <m:jc m:val="centerGroup"/>
-                    </m:oMathParaPr>
-                    <m:oMath xmlns:m="http://schemas.openxmlformats.org/officeDocument/2006/math">
+                    <m:oMath>
                       <m:r>
                         <a:rPr lang="en-US" b="0" i="1" smtClean="0">
                           <a:latin typeface="Cambria Math" panose="02040503050406030204" pitchFamily="18" charset="0"/>
@@ -25771,10 +25655,7 @@
                 <a:pPr/>
                 <a14:m>
                   <m:oMathPara xmlns:m="http://schemas.openxmlformats.org/officeDocument/2006/math">
-                    <m:oMathParaPr>
-                      <m:jc m:val="centerGroup"/>
-                    </m:oMathParaPr>
-                    <m:oMath xmlns:m="http://schemas.openxmlformats.org/officeDocument/2006/math">
+                    <m:oMath>
                       <m:r>
                         <a:rPr lang="en-US" b="0" i="1" smtClean="0">
                           <a:latin typeface="Cambria Math" panose="02040503050406030204" pitchFamily="18" charset="0"/>
@@ -26037,10 +25918,7 @@
                 <a:pPr/>
                 <a14:m>
                   <m:oMathPara xmlns:m="http://schemas.openxmlformats.org/officeDocument/2006/math">
-                    <m:oMathParaPr>
-                      <m:jc m:val="centerGroup"/>
-                    </m:oMathParaPr>
-                    <m:oMath xmlns:m="http://schemas.openxmlformats.org/officeDocument/2006/math">
+                    <m:oMath>
                       <m:r>
                         <a:rPr lang="en-US" b="0" i="1" smtClean="0">
                           <a:latin typeface="Cambria Math" panose="02040503050406030204" pitchFamily="18" charset="0"/>
@@ -26179,10 +26057,7 @@
                 <a:pPr algn="ctr"/>
                 <a14:m>
                   <m:oMathPara xmlns:m="http://schemas.openxmlformats.org/officeDocument/2006/math">
-                    <m:oMathParaPr>
-                      <m:jc m:val="centerGroup"/>
-                    </m:oMathParaPr>
-                    <m:oMath xmlns:m="http://schemas.openxmlformats.org/officeDocument/2006/math">
+                    <m:oMath>
                       <m:r>
                         <a:rPr lang="en-US" sz="2400" b="0" i="1" smtClean="0">
                           <a:latin typeface="Cambria Math" panose="02040503050406030204" pitchFamily="18" charset="0"/>
@@ -26326,10 +26201,7 @@
                 <a:pPr algn="ctr"/>
                 <a14:m>
                   <m:oMathPara xmlns:m="http://schemas.openxmlformats.org/officeDocument/2006/math">
-                    <m:oMathParaPr>
-                      <m:jc m:val="centerGroup"/>
-                    </m:oMathParaPr>
-                    <m:oMath xmlns:m="http://schemas.openxmlformats.org/officeDocument/2006/math">
+                    <m:oMath>
                       <m:r>
                         <a:rPr lang="en-US" sz="2400" b="0" i="1" smtClean="0">
                           <a:latin typeface="Cambria Math" panose="02040503050406030204" pitchFamily="18" charset="0"/>
@@ -26549,10 +26421,7 @@
                 <a:pPr/>
                 <a14:m>
                   <m:oMathPara xmlns:m="http://schemas.openxmlformats.org/officeDocument/2006/math">
-                    <m:oMathParaPr>
-                      <m:jc m:val="centerGroup"/>
-                    </m:oMathParaPr>
-                    <m:oMath xmlns:m="http://schemas.openxmlformats.org/officeDocument/2006/math">
+                    <m:oMath>
                       <m:r>
                         <a:rPr lang="en-US" b="0" i="1" smtClean="0">
                           <a:latin typeface="Cambria Math" panose="02040503050406030204" pitchFamily="18" charset="0"/>
@@ -26663,10 +26532,7 @@
                 <a:pPr/>
                 <a14:m>
                   <m:oMathPara xmlns:m="http://schemas.openxmlformats.org/officeDocument/2006/math">
-                    <m:oMathParaPr>
-                      <m:jc m:val="centerGroup"/>
-                    </m:oMathParaPr>
-                    <m:oMath xmlns:m="http://schemas.openxmlformats.org/officeDocument/2006/math">
+                    <m:oMath>
                       <m:r>
                         <a:rPr lang="en-US" b="0" i="1" smtClean="0">
                           <a:latin typeface="Cambria Math" panose="02040503050406030204" pitchFamily="18" charset="0"/>
@@ -27584,10 +27450,7 @@
                 <a:pPr/>
                 <a14:m>
                   <m:oMathPara xmlns:m="http://schemas.openxmlformats.org/officeDocument/2006/math">
-                    <m:oMathParaPr>
-                      <m:jc m:val="centerGroup"/>
-                    </m:oMathParaPr>
-                    <m:oMath xmlns:m="http://schemas.openxmlformats.org/officeDocument/2006/math">
+                    <m:oMath>
                       <m:r>
                         <a:rPr lang="en-US" b="0" i="1" smtClean="0">
                           <a:latin typeface="Cambria Math" panose="02040503050406030204" pitchFamily="18" charset="0"/>
@@ -27701,7 +27564,7 @@
                     <m:oMathParaPr>
                       <m:jc m:val="right"/>
                     </m:oMathParaPr>
-                    <m:oMath xmlns:m="http://schemas.openxmlformats.org/officeDocument/2006/math">
+                    <m:oMath>
                       <m:r>
                         <a:rPr lang="en-US" b="0" i="1" smtClean="0">
                           <a:latin typeface="Cambria Math" panose="02040503050406030204" pitchFamily="18" charset="0"/>
@@ -27992,10 +27855,7 @@
                   <a:pPr algn="ctr"/>
                   <a14:m>
                     <m:oMathPara xmlns:m="http://schemas.openxmlformats.org/officeDocument/2006/math">
-                      <m:oMathParaPr>
-                        <m:jc m:val="centerGroup"/>
-                      </m:oMathParaPr>
-                      <m:oMath xmlns:m="http://schemas.openxmlformats.org/officeDocument/2006/math">
+                      <m:oMath>
                         <m:r>
                           <a:rPr lang="en-US" sz="2400" b="0" i="1" smtClean="0">
                             <a:latin typeface="Cambria Math" panose="02040503050406030204" pitchFamily="18" charset="0"/>
@@ -28139,10 +27999,7 @@
                   <a:pPr algn="ctr"/>
                   <a14:m>
                     <m:oMathPara xmlns:m="http://schemas.openxmlformats.org/officeDocument/2006/math">
-                      <m:oMathParaPr>
-                        <m:jc m:val="centerGroup"/>
-                      </m:oMathParaPr>
-                      <m:oMath xmlns:m="http://schemas.openxmlformats.org/officeDocument/2006/math">
+                      <m:oMath>
                         <m:sSub>
                           <m:sSubPr>
                             <m:ctrlPr>
@@ -28381,10 +28238,7 @@
                   <a:pPr/>
                   <a14:m>
                     <m:oMathPara xmlns:m="http://schemas.openxmlformats.org/officeDocument/2006/math">
-                      <m:oMathParaPr>
-                        <m:jc m:val="centerGroup"/>
-                      </m:oMathParaPr>
-                      <m:oMath xmlns:m="http://schemas.openxmlformats.org/officeDocument/2006/math">
+                      <m:oMath>
                         <m:sSub>
                           <m:sSubPr>
                             <m:ctrlPr>
@@ -28514,10 +28368,7 @@
                   <a:pPr/>
                   <a14:m>
                     <m:oMathPara xmlns:m="http://schemas.openxmlformats.org/officeDocument/2006/math">
-                      <m:oMathParaPr>
-                        <m:jc m:val="centerGroup"/>
-                      </m:oMathParaPr>
-                      <m:oMath xmlns:m="http://schemas.openxmlformats.org/officeDocument/2006/math">
+                      <m:oMath>
                         <m:sSub>
                           <m:sSubPr>
                             <m:ctrlPr>
@@ -29123,10 +28974,7 @@
                   <a:pPr/>
                   <a14:m>
                     <m:oMathPara xmlns:m="http://schemas.openxmlformats.org/officeDocument/2006/math">
-                      <m:oMathParaPr>
-                        <m:jc m:val="centerGroup"/>
-                      </m:oMathParaPr>
-                      <m:oMath xmlns:m="http://schemas.openxmlformats.org/officeDocument/2006/math">
+                      <m:oMath>
                         <m:r>
                           <a:rPr lang="en-US" b="0" i="1" smtClean="0">
                             <a:latin typeface="Cambria Math" panose="02040503050406030204" pitchFamily="18" charset="0"/>
@@ -29240,7 +29088,7 @@
                       <m:oMathParaPr>
                         <m:jc m:val="left"/>
                       </m:oMathParaPr>
-                      <m:oMath xmlns:m="http://schemas.openxmlformats.org/officeDocument/2006/math">
+                      <m:oMath>
                         <m:r>
                           <a:rPr lang="en-US" b="0" i="1" smtClean="0">
                             <a:latin typeface="Cambria Math" panose="02040503050406030204" pitchFamily="18" charset="0"/>
@@ -29461,10 +29309,7 @@
                   <a:pPr algn="ctr"/>
                   <a14:m>
                     <m:oMathPara xmlns:m="http://schemas.openxmlformats.org/officeDocument/2006/math">
-                      <m:oMathParaPr>
-                        <m:jc m:val="centerGroup"/>
-                      </m:oMathParaPr>
-                      <m:oMath xmlns:m="http://schemas.openxmlformats.org/officeDocument/2006/math">
+                      <m:oMath>
                         <m:sSub>
                           <m:sSubPr>
                             <m:ctrlPr>
@@ -29636,10 +29481,7 @@
                   <a:pPr algn="ctr"/>
                   <a14:m>
                     <m:oMathPara xmlns:m="http://schemas.openxmlformats.org/officeDocument/2006/math">
-                      <m:oMathParaPr>
-                        <m:jc m:val="centerGroup"/>
-                      </m:oMathParaPr>
-                      <m:oMath xmlns:m="http://schemas.openxmlformats.org/officeDocument/2006/math">
+                      <m:oMath>
                         <m:sSub>
                           <m:sSubPr>
                             <m:ctrlPr>
@@ -30211,10 +30053,7 @@
                   <a:pPr/>
                   <a14:m>
                     <m:oMathPara xmlns:m="http://schemas.openxmlformats.org/officeDocument/2006/math">
-                      <m:oMathParaPr>
-                        <m:jc m:val="centerGroup"/>
-                      </m:oMathParaPr>
-                      <m:oMath xmlns:m="http://schemas.openxmlformats.org/officeDocument/2006/math">
+                      <m:oMath>
                         <m:r>
                           <a:rPr lang="en-US" sz="1200" b="0" i="1" smtClean="0">
                             <a:latin typeface="Cambria Math" panose="02040503050406030204" pitchFamily="18" charset="0"/>
@@ -30325,10 +30164,7 @@
                   <a:pPr/>
                   <a14:m>
                     <m:oMathPara xmlns:m="http://schemas.openxmlformats.org/officeDocument/2006/math">
-                      <m:oMathParaPr>
-                        <m:jc m:val="centerGroup"/>
-                      </m:oMathParaPr>
-                      <m:oMath xmlns:m="http://schemas.openxmlformats.org/officeDocument/2006/math">
+                      <m:oMath>
                         <m:sSub>
                           <m:sSubPr>
                             <m:ctrlPr>
@@ -30470,10 +30306,7 @@
                   <a:pPr/>
                   <a14:m>
                     <m:oMathPara xmlns:m="http://schemas.openxmlformats.org/officeDocument/2006/math">
-                      <m:oMathParaPr>
-                        <m:jc m:val="centerGroup"/>
-                      </m:oMathParaPr>
-                      <m:oMath xmlns:m="http://schemas.openxmlformats.org/officeDocument/2006/math">
+                      <m:oMath>
                         <m:sSub>
                           <m:sSubPr>
                             <m:ctrlPr>
@@ -30603,10 +30436,7 @@
                   <a:pPr/>
                   <a14:m>
                     <m:oMathPara xmlns:m="http://schemas.openxmlformats.org/officeDocument/2006/math">
-                      <m:oMathParaPr>
-                        <m:jc m:val="centerGroup"/>
-                      </m:oMathParaPr>
-                      <m:oMath xmlns:m="http://schemas.openxmlformats.org/officeDocument/2006/math">
+                      <m:oMath>
                         <m:r>
                           <a:rPr lang="en-US" sz="1200" b="0" i="1" smtClean="0">
                             <a:latin typeface="Cambria Math" panose="02040503050406030204" pitchFamily="18" charset="0"/>
@@ -31468,10 +31298,7 @@
                 <a:pPr/>
                 <a14:m>
                   <m:oMathPara xmlns:m="http://schemas.openxmlformats.org/officeDocument/2006/math">
-                    <m:oMathParaPr>
-                      <m:jc m:val="centerGroup"/>
-                    </m:oMathParaPr>
-                    <m:oMath xmlns:m="http://schemas.openxmlformats.org/officeDocument/2006/math">
+                    <m:oMath>
                       <m:sSubSup>
                         <m:sSubSupPr>
                           <m:ctrlPr>
@@ -31523,8 +31350,9 @@
                           <m:f>
                             <m:fPr>
                               <m:ctrlPr>
-                                <a:rPr lang="en-US" sz="3600" b="0" i="1" smtClean="0">
+                                <a:rPr lang="el-GR" sz="3600" b="0" i="1" smtClean="0">
                                   <a:latin typeface="Cambria Math" panose="02040503050406030204" pitchFamily="18" charset="0"/>
+                                  <a:ea typeface="Cambria Math" panose="02040503050406030204" pitchFamily="18" charset="0"/>
                                 </a:rPr>
                               </m:ctrlPr>
                             </m:fPr>
@@ -31561,8 +31389,9 @@
                           <m:f>
                             <m:fPr>
                               <m:ctrlPr>
-                                <a:rPr lang="en-US" sz="3600" b="0" i="1" smtClean="0">
+                                <a:rPr lang="el-GR" sz="3600" b="0" i="1" smtClean="0">
                                   <a:latin typeface="Cambria Math" panose="02040503050406030204" pitchFamily="18" charset="0"/>
+                                  <a:ea typeface="Cambria Math" panose="02040503050406030204" pitchFamily="18" charset="0"/>
                                 </a:rPr>
                               </m:ctrlPr>
                             </m:fPr>
@@ -31610,10 +31439,7 @@
                 <a:pPr/>
                 <a14:m>
                   <m:oMathPara xmlns:m="http://schemas.openxmlformats.org/officeDocument/2006/math">
-                    <m:oMathParaPr>
-                      <m:jc m:val="centerGroup"/>
-                    </m:oMathParaPr>
-                    <m:oMath xmlns:m="http://schemas.openxmlformats.org/officeDocument/2006/math">
+                    <m:oMath>
                       <m:sSubSup>
                         <m:sSubSupPr>
                           <m:ctrlPr>
@@ -31656,8 +31482,9 @@
                       <m:f>
                         <m:fPr>
                           <m:ctrlPr>
-                            <a:rPr lang="en-US" sz="3600" b="0" i="1" smtClean="0">
-                              <a:latin typeface="Cambria Math" panose="02040503050406030204" pitchFamily="18" charset="0"/>
+                            <a:rPr lang="el-GR" sz="3600" b="0" i="1" smtClean="0">
+                              <a:latin typeface="Cambria Math" panose="02040503050406030204" pitchFamily="18" charset="0"/>
+                              <a:ea typeface="Cambria Math" panose="02040503050406030204" pitchFamily="18" charset="0"/>
                             </a:rPr>
                           </m:ctrlPr>
                         </m:fPr>
@@ -31745,10 +31572,7 @@
                 <a:pPr/>
                 <a14:m>
                   <m:oMathPara xmlns:m="http://schemas.openxmlformats.org/officeDocument/2006/math">
-                    <m:oMathParaPr>
-                      <m:jc m:val="centerGroup"/>
-                    </m:oMathParaPr>
-                    <m:oMath xmlns:m="http://schemas.openxmlformats.org/officeDocument/2006/math">
+                    <m:oMath>
                       <m:sSubSup>
                         <m:sSubSupPr>
                           <m:ctrlPr>
@@ -32180,10 +32004,7 @@
                 <a:pPr/>
                 <a14:m>
                   <m:oMathPara xmlns:m="http://schemas.openxmlformats.org/officeDocument/2006/math">
-                    <m:oMathParaPr>
-                      <m:jc m:val="centerGroup"/>
-                    </m:oMathParaPr>
-                    <m:oMath xmlns:m="http://schemas.openxmlformats.org/officeDocument/2006/math">
+                    <m:oMath>
                       <m:sSubSup>
                         <m:sSubSupPr>
                           <m:ctrlPr>
@@ -32337,10 +32158,7 @@
                 <a:pPr/>
                 <a14:m>
                   <m:oMathPara xmlns:m="http://schemas.openxmlformats.org/officeDocument/2006/math">
-                    <m:oMathParaPr>
-                      <m:jc m:val="centerGroup"/>
-                    </m:oMathParaPr>
-                    <m:oMath xmlns:m="http://schemas.openxmlformats.org/officeDocument/2006/math">
+                    <m:oMath>
                       <m:sSubSup>
                         <m:sSubSupPr>
                           <m:ctrlPr>
@@ -32463,10 +32281,7 @@
                 <a:pPr/>
                 <a14:m>
                   <m:oMathPara xmlns:m="http://schemas.openxmlformats.org/officeDocument/2006/math">
-                    <m:oMathParaPr>
-                      <m:jc m:val="centerGroup"/>
-                    </m:oMathParaPr>
-                    <m:oMath xmlns:m="http://schemas.openxmlformats.org/officeDocument/2006/math">
+                    <m:oMath>
                       <m:sSubSup>
                         <m:sSubSupPr>
                           <m:ctrlPr>
@@ -32669,10 +32484,7 @@
                 <a:pPr/>
                 <a14:m>
                   <m:oMathPara xmlns:m="http://schemas.openxmlformats.org/officeDocument/2006/math">
-                    <m:oMathParaPr>
-                      <m:jc m:val="centerGroup"/>
-                    </m:oMathParaPr>
-                    <m:oMath xmlns:m="http://schemas.openxmlformats.org/officeDocument/2006/math">
+                    <m:oMath>
                       <m:sSub>
                         <m:sSubPr>
                           <m:ctrlPr>
@@ -32801,10 +32613,7 @@
                 <a:pPr/>
                 <a14:m>
                   <m:oMathPara xmlns:m="http://schemas.openxmlformats.org/officeDocument/2006/math">
-                    <m:oMathParaPr>
-                      <m:jc m:val="centerGroup"/>
-                    </m:oMathParaPr>
-                    <m:oMath xmlns:m="http://schemas.openxmlformats.org/officeDocument/2006/math">
+                    <m:oMath>
                       <m:sSub>
                         <m:sSubPr>
                           <m:ctrlPr>
@@ -32914,10 +32723,7 @@
                 <a:pPr/>
                 <a14:m>
                   <m:oMathPara xmlns:m="http://schemas.openxmlformats.org/officeDocument/2006/math">
-                    <m:oMathParaPr>
-                      <m:jc m:val="centerGroup"/>
-                    </m:oMathParaPr>
-                    <m:oMath xmlns:m="http://schemas.openxmlformats.org/officeDocument/2006/math">
+                    <m:oMath>
                       <m:sSub>
                         <m:sSubPr>
                           <m:ctrlPr>
@@ -33035,10 +32841,7 @@
                 <a:pPr/>
                 <a14:m>
                   <m:oMathPara xmlns:m="http://schemas.openxmlformats.org/officeDocument/2006/math">
-                    <m:oMathParaPr>
-                      <m:jc m:val="centerGroup"/>
-                    </m:oMathParaPr>
-                    <m:oMath xmlns:m="http://schemas.openxmlformats.org/officeDocument/2006/math">
+                    <m:oMath>
                       <m:r>
                         <a:rPr lang="en-US" sz="2400" b="0" i="1" smtClean="0">
                           <a:latin typeface="Cambria Math" panose="02040503050406030204" pitchFamily="18" charset="0"/>
@@ -33072,10 +32875,7 @@
                 <a:pPr/>
                 <a14:m>
                   <m:oMathPara xmlns:m="http://schemas.openxmlformats.org/officeDocument/2006/math">
-                    <m:oMathParaPr>
-                      <m:jc m:val="centerGroup"/>
-                    </m:oMathParaPr>
-                    <m:oMath xmlns:m="http://schemas.openxmlformats.org/officeDocument/2006/math">
+                    <m:oMath>
                       <m:sSub>
                         <m:sSubPr>
                           <m:ctrlPr>
@@ -33122,10 +32922,7 @@
                 <a:pPr/>
                 <a14:m>
                   <m:oMathPara xmlns:m="http://schemas.openxmlformats.org/officeDocument/2006/math">
-                    <m:oMathParaPr>
-                      <m:jc m:val="centerGroup"/>
-                    </m:oMathParaPr>
-                    <m:oMath xmlns:m="http://schemas.openxmlformats.org/officeDocument/2006/math">
+                    <m:oMath>
                       <m:r>
                         <a:rPr lang="en-US" sz="2400" b="0" i="1" smtClean="0">
                           <a:latin typeface="Cambria Math" panose="02040503050406030204" pitchFamily="18" charset="0"/>
@@ -33163,10 +32960,7 @@
                 <a:pPr/>
                 <a14:m>
                   <m:oMathPara xmlns:m="http://schemas.openxmlformats.org/officeDocument/2006/math">
-                    <m:oMathParaPr>
-                      <m:jc m:val="centerGroup"/>
-                    </m:oMathParaPr>
-                    <m:oMath xmlns:m="http://schemas.openxmlformats.org/officeDocument/2006/math">
+                    <m:oMath>
                       <m:sSub>
                         <m:sSubPr>
                           <m:ctrlPr>
@@ -33207,10 +33001,7 @@
                 <a:pPr/>
                 <a14:m>
                   <m:oMathPara xmlns:m="http://schemas.openxmlformats.org/officeDocument/2006/math">
-                    <m:oMathParaPr>
-                      <m:jc m:val="centerGroup"/>
-                    </m:oMathParaPr>
-                    <m:oMath xmlns:m="http://schemas.openxmlformats.org/officeDocument/2006/math">
+                    <m:oMath>
                       <m:sSub>
                         <m:sSubPr>
                           <m:ctrlPr>
@@ -33363,10 +33154,7 @@
                 <a:pPr/>
                 <a14:m>
                   <m:oMathPara xmlns:m="http://schemas.openxmlformats.org/officeDocument/2006/math">
-                    <m:oMathParaPr>
-                      <m:jc m:val="centerGroup"/>
-                    </m:oMathParaPr>
-                    <m:oMath xmlns:m="http://schemas.openxmlformats.org/officeDocument/2006/math">
+                    <m:oMath>
                       <m:sSub>
                         <m:sSubPr>
                           <m:ctrlPr>
@@ -33451,10 +33239,7 @@
                 <a:pPr/>
                 <a14:m>
                   <m:oMathPara xmlns:m="http://schemas.openxmlformats.org/officeDocument/2006/math">
-                    <m:oMathParaPr>
-                      <m:jc m:val="centerGroup"/>
-                    </m:oMathParaPr>
-                    <m:oMath xmlns:m="http://schemas.openxmlformats.org/officeDocument/2006/math">
+                    <m:oMath>
                       <m:sSub>
                         <m:sSubPr>
                           <m:ctrlPr>
@@ -33520,10 +33305,7 @@
                 <a:pPr/>
                 <a14:m>
                   <m:oMathPara xmlns:m="http://schemas.openxmlformats.org/officeDocument/2006/math">
-                    <m:oMathParaPr>
-                      <m:jc m:val="centerGroup"/>
-                    </m:oMathParaPr>
-                    <m:oMath xmlns:m="http://schemas.openxmlformats.org/officeDocument/2006/math">
+                    <m:oMath>
                       <m:sSub>
                         <m:sSubPr>
                           <m:ctrlPr>
@@ -33669,7 +33451,7 @@
           <a:p>
             <a:r>
               <a:rPr lang="en-US" dirty="0"/>
-              <a:t>Sensor White Noise Noise</a:t>
+              <a:t>Sensor White Noise</a:t>
             </a:r>
           </a:p>
         </p:txBody>
@@ -33742,10 +33524,7 @@
                 <a:pPr/>
                 <a14:m>
                   <m:oMathPara xmlns:m="http://schemas.openxmlformats.org/officeDocument/2006/math">
-                    <m:oMathParaPr>
-                      <m:jc m:val="centerGroup"/>
-                    </m:oMathParaPr>
-                    <m:oMath xmlns:m="http://schemas.openxmlformats.org/officeDocument/2006/math">
+                    <m:oMath>
                       <m:sSub>
                         <m:sSubPr>
                           <m:ctrlPr>
@@ -33981,10 +33760,7 @@
                 <a:pPr/>
                 <a14:m>
                   <m:oMathPara xmlns:m="http://schemas.openxmlformats.org/officeDocument/2006/math">
-                    <m:oMathParaPr>
-                      <m:jc m:val="centerGroup"/>
-                    </m:oMathParaPr>
-                    <m:oMath xmlns:m="http://schemas.openxmlformats.org/officeDocument/2006/math">
+                    <m:oMath>
                       <m:r>
                         <a:rPr lang="en-US" b="0" i="1" smtClean="0">
                           <a:latin typeface="Cambria Math" panose="02040503050406030204" pitchFamily="18" charset="0"/>
@@ -34225,10 +34001,7 @@
                 <a:pPr/>
                 <a14:m>
                   <m:oMathPara xmlns:m="http://schemas.openxmlformats.org/officeDocument/2006/math">
-                    <m:oMathParaPr>
-                      <m:jc m:val="centerGroup"/>
-                    </m:oMathParaPr>
-                    <m:oMath xmlns:m="http://schemas.openxmlformats.org/officeDocument/2006/math">
+                    <m:oMath>
                       <m:r>
                         <a:rPr lang="en-US" b="0" i="1" smtClean="0">
                           <a:latin typeface="Cambria Math" panose="02040503050406030204" pitchFamily="18" charset="0"/>
@@ -34469,10 +34242,7 @@
                 <a:pPr/>
                 <a14:m>
                   <m:oMathPara xmlns:m="http://schemas.openxmlformats.org/officeDocument/2006/math">
-                    <m:oMathParaPr>
-                      <m:jc m:val="centerGroup"/>
-                    </m:oMathParaPr>
-                    <m:oMath xmlns:m="http://schemas.openxmlformats.org/officeDocument/2006/math">
+                    <m:oMath>
                       <m:r>
                         <a:rPr lang="en-US" b="0" i="1" smtClean="0">
                           <a:latin typeface="Cambria Math" panose="02040503050406030204" pitchFamily="18" charset="0"/>
@@ -34713,10 +34483,7 @@
                 <a:pPr/>
                 <a14:m>
                   <m:oMathPara xmlns:m="http://schemas.openxmlformats.org/officeDocument/2006/math">
-                    <m:oMathParaPr>
-                      <m:jc m:val="centerGroup"/>
-                    </m:oMathParaPr>
-                    <m:oMath xmlns:m="http://schemas.openxmlformats.org/officeDocument/2006/math">
+                    <m:oMath>
                       <m:r>
                         <a:rPr lang="en-US" b="0" i="1" smtClean="0">
                           <a:latin typeface="Cambria Math" panose="02040503050406030204" pitchFamily="18" charset="0"/>
@@ -38835,10 +38602,7 @@
                 <a:pPr/>
                 <a14:m>
                   <m:oMathPara xmlns:m="http://schemas.openxmlformats.org/officeDocument/2006/math">
-                    <m:oMathParaPr>
-                      <m:jc m:val="centerGroup"/>
-                    </m:oMathParaPr>
-                    <m:oMath xmlns:m="http://schemas.openxmlformats.org/officeDocument/2006/math">
+                    <m:oMath>
                       <m:r>
                         <a:rPr lang="en-US" b="0" i="1" smtClean="0">
                           <a:latin typeface="Cambria Math" panose="02040503050406030204" pitchFamily="18" charset="0"/>

</xml_diff>